<commit_message>
feat: add speaker notes with talking points to all decks
Add notes= parameter to theme.py slide builders to write PowerPoint
presenter notes, then populate talking points for all 120 slides
across the 7 decks (bloque0-3, CardingForums, HackingForums, IronMarch).
</commit_message>
<xml_diff>
--- a/CardingForums/csbc26_caso_cardingforums.pptx
+++ b/CardingForums/csbc26_caso_cardingforums.pptx
@@ -6,26 +6,26 @@
   </p:sldMasterIdLst>
   <p:sldIdLst>
     <p:sldId id="256" r:id="rId7"/>
-    <p:sldId id="257" r:id="rId8"/>
-    <p:sldId id="258" r:id="rId9"/>
-    <p:sldId id="259" r:id="rId10"/>
-    <p:sldId id="260" r:id="rId11"/>
-    <p:sldId id="261" r:id="rId12"/>
-    <p:sldId id="262" r:id="rId13"/>
-    <p:sldId id="263" r:id="rId14"/>
-    <p:sldId id="264" r:id="rId15"/>
-    <p:sldId id="265" r:id="rId16"/>
-    <p:sldId id="266" r:id="rId17"/>
-    <p:sldId id="267" r:id="rId18"/>
-    <p:sldId id="268" r:id="rId19"/>
-    <p:sldId id="269" r:id="rId20"/>
-    <p:sldId id="270" r:id="rId21"/>
-    <p:sldId id="271" r:id="rId22"/>
-    <p:sldId id="272" r:id="rId23"/>
-    <p:sldId id="273" r:id="rId24"/>
-    <p:sldId id="274" r:id="rId25"/>
-    <p:sldId id="275" r:id="rId26"/>
-    <p:sldId id="276" r:id="rId27"/>
+    <p:sldId id="257" r:id="rId9"/>
+    <p:sldId id="258" r:id="rId10"/>
+    <p:sldId id="259" r:id="rId11"/>
+    <p:sldId id="260" r:id="rId12"/>
+    <p:sldId id="261" r:id="rId13"/>
+    <p:sldId id="262" r:id="rId14"/>
+    <p:sldId id="263" r:id="rId15"/>
+    <p:sldId id="264" r:id="rId16"/>
+    <p:sldId id="265" r:id="rId17"/>
+    <p:sldId id="266" r:id="rId18"/>
+    <p:sldId id="267" r:id="rId19"/>
+    <p:sldId id="268" r:id="rId20"/>
+    <p:sldId id="269" r:id="rId21"/>
+    <p:sldId id="270" r:id="rId22"/>
+    <p:sldId id="271" r:id="rId23"/>
+    <p:sldId id="272" r:id="rId24"/>
+    <p:sldId id="273" r:id="rId25"/>
+    <p:sldId id="274" r:id="rId26"/>
+    <p:sldId id="275" r:id="rId27"/>
+    <p:sldId id="276" r:id="rId28"/>
   </p:sldIdLst>
   <p:sldSz cx="12188952" cy="6858000" type="screen4x3"/>
   <p:notesSz cx="6858000" cy="9144000"/>
@@ -125,6 +125,1826 @@
     </a:lvl9pPr>
   </p:defaultTextStyle>
 </p:presentation>
+</file>
+
+<file path=ppt/notesMasters/notesMaster1.xml><?xml version="1.0" encoding="utf-8"?>
+<p:notesMaster xmlns:a="http://schemas.openxmlformats.org/drawingml/2006/main" xmlns:p="http://schemas.openxmlformats.org/presentationml/2006/main" xmlns:r="http://schemas.openxmlformats.org/officeDocument/2006/relationships">
+  <p:cSld>
+    <p:bg>
+      <p:bgRef idx="1001">
+        <a:schemeClr val="bg1"/>
+      </p:bgRef>
+    </p:bg>
+    <p:spTree>
+      <p:nvGrpSpPr>
+        <p:cNvPr id="1" name=""/>
+        <p:cNvGrpSpPr/>
+        <p:nvPr/>
+      </p:nvGrpSpPr>
+      <p:grpSpPr>
+        <a:xfrm>
+          <a:off x="0" y="0"/>
+          <a:ext cx="0" cy="0"/>
+          <a:chOff x="0" y="0"/>
+          <a:chExt cx="0" cy="0"/>
+        </a:xfrm>
+      </p:grpSpPr>
+      <p:sp>
+        <p:nvSpPr>
+          <p:cNvPr id="2" name="Header Placeholder 1"/>
+          <p:cNvSpPr>
+            <a:spLocks noGrp="1"/>
+          </p:cNvSpPr>
+          <p:nvPr>
+            <p:ph type="hdr" sz="quarter"/>
+          </p:nvPr>
+        </p:nvSpPr>
+        <p:spPr>
+          <a:xfrm>
+            <a:off x="0" y="0"/>
+            <a:ext cx="2971800" cy="457200"/>
+          </a:xfrm>
+          <a:prstGeom prst="rect">
+            <a:avLst/>
+          </a:prstGeom>
+        </p:spPr>
+        <p:txBody>
+          <a:bodyPr vert="horz" lIns="91440" tIns="45720" rIns="91440" bIns="45720" rtlCol="0"/>
+          <a:lstStyle>
+            <a:lvl1pPr algn="l">
+              <a:defRPr sz="1200"/>
+            </a:lvl1pPr>
+          </a:lstStyle>
+          <a:p>
+            <a:endParaRPr lang="en-US"/>
+          </a:p>
+        </p:txBody>
+      </p:sp>
+      <p:sp>
+        <p:nvSpPr>
+          <p:cNvPr id="3" name="Date Placeholder 2"/>
+          <p:cNvSpPr>
+            <a:spLocks noGrp="1"/>
+          </p:cNvSpPr>
+          <p:nvPr>
+            <p:ph type="dt" idx="1"/>
+          </p:nvPr>
+        </p:nvSpPr>
+        <p:spPr>
+          <a:xfrm>
+            <a:off x="3884613" y="0"/>
+            <a:ext cx="2971800" cy="457200"/>
+          </a:xfrm>
+          <a:prstGeom prst="rect">
+            <a:avLst/>
+          </a:prstGeom>
+        </p:spPr>
+        <p:txBody>
+          <a:bodyPr vert="horz" lIns="91440" tIns="45720" rIns="91440" bIns="45720" rtlCol="0"/>
+          <a:lstStyle>
+            <a:lvl1pPr algn="r">
+              <a:defRPr sz="1200"/>
+            </a:lvl1pPr>
+          </a:lstStyle>
+          <a:p>
+            <a:fld id="{0F89C1C7-3DCD-1040-A9CF-14679D8B5DDD}" type="datetimeFigureOut">
+              <a:rPr lang="en-US" smtClean="0"/>
+              <a:t>10/17/16</a:t>
+            </a:fld>
+            <a:endParaRPr lang="en-US"/>
+          </a:p>
+        </p:txBody>
+      </p:sp>
+      <p:sp>
+        <p:nvSpPr>
+          <p:cNvPr id="4" name="Slide Image Placeholder 3"/>
+          <p:cNvSpPr>
+            <a:spLocks noGrp="1" noRot="1" noChangeAspect="1"/>
+          </p:cNvSpPr>
+          <p:nvPr>
+            <p:ph type="sldImg" idx="2"/>
+          </p:nvPr>
+        </p:nvSpPr>
+        <p:spPr>
+          <a:xfrm>
+            <a:off x="1143000" y="685800"/>
+            <a:ext cx="4572000" cy="3429000"/>
+          </a:xfrm>
+          <a:prstGeom prst="rect">
+            <a:avLst/>
+          </a:prstGeom>
+          <a:noFill/>
+          <a:ln w="12700">
+            <a:solidFill>
+              <a:prstClr val="black"/>
+            </a:solidFill>
+          </a:ln>
+        </p:spPr>
+        <p:txBody>
+          <a:bodyPr vert="horz" lIns="91440" tIns="45720" rIns="91440" bIns="45720" rtlCol="0" anchor="ctr"/>
+          <a:lstStyle/>
+          <a:p>
+            <a:endParaRPr lang="en-US"/>
+          </a:p>
+        </p:txBody>
+      </p:sp>
+      <p:sp>
+        <p:nvSpPr>
+          <p:cNvPr id="5" name="Notes Placeholder 4"/>
+          <p:cNvSpPr>
+            <a:spLocks noGrp="1"/>
+          </p:cNvSpPr>
+          <p:nvPr>
+            <p:ph type="body" sz="quarter" idx="3"/>
+          </p:nvPr>
+        </p:nvSpPr>
+        <p:spPr>
+          <a:xfrm>
+            <a:off x="685800" y="4343400"/>
+            <a:ext cx="5486400" cy="4114800"/>
+          </a:xfrm>
+          <a:prstGeom prst="rect">
+            <a:avLst/>
+          </a:prstGeom>
+        </p:spPr>
+        <p:txBody>
+          <a:bodyPr vert="horz" lIns="91440" tIns="45720" rIns="91440" bIns="45720" rtlCol="0"/>
+          <a:lstStyle/>
+          <a:p>
+            <a:pPr lvl="0"/>
+            <a:r>
+              <a:rPr lang="en-US" smtClean="0"/>
+              <a:t>Click to edit Master text styles</a:t>
+            </a:r>
+          </a:p>
+          <a:p>
+            <a:pPr lvl="1"/>
+            <a:r>
+              <a:rPr lang="en-US" smtClean="0"/>
+              <a:t>Second level</a:t>
+            </a:r>
+          </a:p>
+          <a:p>
+            <a:pPr lvl="2"/>
+            <a:r>
+              <a:rPr lang="en-US" smtClean="0"/>
+              <a:t>Third level</a:t>
+            </a:r>
+          </a:p>
+          <a:p>
+            <a:pPr lvl="3"/>
+            <a:r>
+              <a:rPr lang="en-US" smtClean="0"/>
+              <a:t>Fourth level</a:t>
+            </a:r>
+          </a:p>
+          <a:p>
+            <a:pPr lvl="4"/>
+            <a:r>
+              <a:rPr lang="en-US" smtClean="0"/>
+              <a:t>Fifth level</a:t>
+            </a:r>
+            <a:endParaRPr lang="en-US"/>
+          </a:p>
+        </p:txBody>
+      </p:sp>
+      <p:sp>
+        <p:nvSpPr>
+          <p:cNvPr id="6" name="Footer Placeholder 5"/>
+          <p:cNvSpPr>
+            <a:spLocks noGrp="1"/>
+          </p:cNvSpPr>
+          <p:nvPr>
+            <p:ph type="ftr" sz="quarter" idx="4"/>
+          </p:nvPr>
+        </p:nvSpPr>
+        <p:spPr>
+          <a:xfrm>
+            <a:off x="0" y="8685213"/>
+            <a:ext cx="2971800" cy="457200"/>
+          </a:xfrm>
+          <a:prstGeom prst="rect">
+            <a:avLst/>
+          </a:prstGeom>
+        </p:spPr>
+        <p:txBody>
+          <a:bodyPr vert="horz" lIns="91440" tIns="45720" rIns="91440" bIns="45720" rtlCol="0" anchor="b"/>
+          <a:lstStyle>
+            <a:lvl1pPr algn="l">
+              <a:defRPr sz="1200"/>
+            </a:lvl1pPr>
+          </a:lstStyle>
+          <a:p>
+            <a:endParaRPr lang="en-US"/>
+          </a:p>
+        </p:txBody>
+      </p:sp>
+      <p:sp>
+        <p:nvSpPr>
+          <p:cNvPr id="7" name="Slide Number Placeholder 6"/>
+          <p:cNvSpPr>
+            <a:spLocks noGrp="1"/>
+          </p:cNvSpPr>
+          <p:nvPr>
+            <p:ph type="sldNum" sz="quarter" idx="5"/>
+          </p:nvPr>
+        </p:nvSpPr>
+        <p:spPr>
+          <a:xfrm>
+            <a:off x="3884613" y="8685213"/>
+            <a:ext cx="2971800" cy="457200"/>
+          </a:xfrm>
+          <a:prstGeom prst="rect">
+            <a:avLst/>
+          </a:prstGeom>
+        </p:spPr>
+        <p:txBody>
+          <a:bodyPr vert="horz" lIns="91440" tIns="45720" rIns="91440" bIns="45720" rtlCol="0" anchor="b"/>
+          <a:lstStyle>
+            <a:lvl1pPr algn="r">
+              <a:defRPr sz="1200"/>
+            </a:lvl1pPr>
+          </a:lstStyle>
+          <a:p>
+            <a:fld id="{BB5E49A5-4136-284D-997B-48E1D791AD67}" type="slidenum">
+              <a:rPr lang="en-US" smtClean="0"/>
+              <a:t>‹#›</a:t>
+            </a:fld>
+            <a:endParaRPr lang="en-US"/>
+          </a:p>
+        </p:txBody>
+      </p:sp>
+    </p:spTree>
+    <p:extLst>
+      <p:ext uri="{BB962C8B-B14F-4D97-AF65-F5344CB8AC3E}">
+        <p14:creationId xmlns:p14="http://schemas.microsoft.com/office/powerpoint/2010/main" val="2623252185"/>
+      </p:ext>
+    </p:extLst>
+  </p:cSld>
+  <p:clrMap bg1="lt1" tx1="dk1" bg2="lt2" tx2="dk2" accent1="accent1" accent2="accent2" accent3="accent3" accent4="accent4" accent5="accent5" accent6="accent6" hlink="hlink" folHlink="folHlink"/>
+  <p:notesStyle>
+    <a:lvl1pPr marL="0" algn="l" defTabSz="457200" rtl="0" eaLnBrk="1" latinLnBrk="0" hangingPunct="1">
+      <a:defRPr sz="1200" kern="1200">
+        <a:solidFill>
+          <a:schemeClr val="tx1"/>
+        </a:solidFill>
+        <a:latin typeface="+mn-lt"/>
+        <a:ea typeface="+mn-ea"/>
+        <a:cs typeface="+mn-cs"/>
+      </a:defRPr>
+    </a:lvl1pPr>
+    <a:lvl2pPr marL="457200" algn="l" defTabSz="457200" rtl="0" eaLnBrk="1" latinLnBrk="0" hangingPunct="1">
+      <a:defRPr sz="1200" kern="1200">
+        <a:solidFill>
+          <a:schemeClr val="tx1"/>
+        </a:solidFill>
+        <a:latin typeface="+mn-lt"/>
+        <a:ea typeface="+mn-ea"/>
+        <a:cs typeface="+mn-cs"/>
+      </a:defRPr>
+    </a:lvl2pPr>
+    <a:lvl3pPr marL="914400" algn="l" defTabSz="457200" rtl="0" eaLnBrk="1" latinLnBrk="0" hangingPunct="1">
+      <a:defRPr sz="1200" kern="1200">
+        <a:solidFill>
+          <a:schemeClr val="tx1"/>
+        </a:solidFill>
+        <a:latin typeface="+mn-lt"/>
+        <a:ea typeface="+mn-ea"/>
+        <a:cs typeface="+mn-cs"/>
+      </a:defRPr>
+    </a:lvl3pPr>
+    <a:lvl4pPr marL="1371600" algn="l" defTabSz="457200" rtl="0" eaLnBrk="1" latinLnBrk="0" hangingPunct="1">
+      <a:defRPr sz="1200" kern="1200">
+        <a:solidFill>
+          <a:schemeClr val="tx1"/>
+        </a:solidFill>
+        <a:latin typeface="+mn-lt"/>
+        <a:ea typeface="+mn-ea"/>
+        <a:cs typeface="+mn-cs"/>
+      </a:defRPr>
+    </a:lvl4pPr>
+    <a:lvl5pPr marL="1828800" algn="l" defTabSz="457200" rtl="0" eaLnBrk="1" latinLnBrk="0" hangingPunct="1">
+      <a:defRPr sz="1200" kern="1200">
+        <a:solidFill>
+          <a:schemeClr val="tx1"/>
+        </a:solidFill>
+        <a:latin typeface="+mn-lt"/>
+        <a:ea typeface="+mn-ea"/>
+        <a:cs typeface="+mn-cs"/>
+      </a:defRPr>
+    </a:lvl5pPr>
+    <a:lvl6pPr marL="2286000" algn="l" defTabSz="457200" rtl="0" eaLnBrk="1" latinLnBrk="0" hangingPunct="1">
+      <a:defRPr sz="1200" kern="1200">
+        <a:solidFill>
+          <a:schemeClr val="tx1"/>
+        </a:solidFill>
+        <a:latin typeface="+mn-lt"/>
+        <a:ea typeface="+mn-ea"/>
+        <a:cs typeface="+mn-cs"/>
+      </a:defRPr>
+    </a:lvl6pPr>
+    <a:lvl7pPr marL="2743200" algn="l" defTabSz="457200" rtl="0" eaLnBrk="1" latinLnBrk="0" hangingPunct="1">
+      <a:defRPr sz="1200" kern="1200">
+        <a:solidFill>
+          <a:schemeClr val="tx1"/>
+        </a:solidFill>
+        <a:latin typeface="+mn-lt"/>
+        <a:ea typeface="+mn-ea"/>
+        <a:cs typeface="+mn-cs"/>
+      </a:defRPr>
+    </a:lvl7pPr>
+    <a:lvl8pPr marL="3200400" algn="l" defTabSz="457200" rtl="0" eaLnBrk="1" latinLnBrk="0" hangingPunct="1">
+      <a:defRPr sz="1200" kern="1200">
+        <a:solidFill>
+          <a:schemeClr val="tx1"/>
+        </a:solidFill>
+        <a:latin typeface="+mn-lt"/>
+        <a:ea typeface="+mn-ea"/>
+        <a:cs typeface="+mn-cs"/>
+      </a:defRPr>
+    </a:lvl8pPr>
+    <a:lvl9pPr marL="3657600" algn="l" defTabSz="457200" rtl="0" eaLnBrk="1" latinLnBrk="0" hangingPunct="1">
+      <a:defRPr sz="1200" kern="1200">
+        <a:solidFill>
+          <a:schemeClr val="tx1"/>
+        </a:solidFill>
+        <a:latin typeface="+mn-lt"/>
+        <a:ea typeface="+mn-ea"/>
+        <a:cs typeface="+mn-cs"/>
+      </a:defRPr>
+    </a:lvl9pPr>
+  </p:notesStyle>
+</p:notesMaster>
+</file>
+
+<file path=ppt/notesSlides/notesSlide1.xml><?xml version="1.0" encoding="utf-8"?>
+<p:notes xmlns:a="http://schemas.openxmlformats.org/drawingml/2006/main" xmlns:p="http://schemas.openxmlformats.org/presentationml/2006/main" xmlns:r="http://schemas.openxmlformats.org/officeDocument/2006/relationships">
+  <p:cSld>
+    <p:spTree>
+      <p:nvGrpSpPr>
+        <p:cNvPr id="1" name=""/>
+        <p:cNvGrpSpPr/>
+        <p:nvPr/>
+      </p:nvGrpSpPr>
+      <p:grpSpPr>
+        <a:xfrm>
+          <a:off x="0" y="0"/>
+          <a:ext cx="0" cy="0"/>
+          <a:chOff x="0" y="0"/>
+          <a:chExt cx="0" cy="0"/>
+        </a:xfrm>
+      </p:grpSpPr>
+      <p:sp>
+        <p:nvSpPr>
+          <p:cNvPr id="2" name="Slide Image Placeholder 1"/>
+          <p:cNvSpPr>
+            <a:spLocks noGrp="1"/>
+          </p:cNvSpPr>
+          <p:nvPr>
+            <p:ph type="sldImg" idx="2"/>
+          </p:nvPr>
+        </p:nvSpPr>
+        <p:spPr/>
+      </p:sp>
+      <p:sp>
+        <p:nvSpPr>
+          <p:cNvPr id="3" name="Notes Placeholder 2"/>
+          <p:cNvSpPr>
+            <a:spLocks noGrp="1"/>
+          </p:cNvSpPr>
+          <p:nvPr>
+            <p:ph type="body" idx="3" sz="quarter"/>
+          </p:nvPr>
+        </p:nvSpPr>
+        <p:spPr/>
+        <p:txBody>
+          <a:bodyPr/>
+          <a:lstStyle/>
+          <a:p>
+            <a:r>
+              <a:t>Bienvenida al caso más grande del curso en volumen de usuarios: casi un millón de cuentas repartidas en diez dumps de foros de carding entre 2009 y 2021. La pregunta que vamos a responder no es solo 'qué hay en estos dumps', sino si podemos reconstruir quién era quién en ese mercado usando solo ingeniería de datos, análisis de redes y un LLM local, sin depender de ninguna API externa. Este caso también sirve como prueba de escala: todo lo que vimos en foros más chicos, acá tiene que sostenerse con casi un millón y medio de posts. Arrancamos por lo menos glamoroso pero más importante: los datasets y sus formatos.</a:t>
+            </a:r>
+          </a:p>
+        </p:txBody>
+      </p:sp>
+      <p:sp>
+        <p:nvSpPr>
+          <p:cNvPr id="4" name="Slide Number Placeholder 3"/>
+          <p:cNvSpPr>
+            <a:spLocks noGrp="1"/>
+          </p:cNvSpPr>
+          <p:nvPr>
+            <p:ph type="sldNum" idx="5" sz="quarter"/>
+          </p:nvPr>
+        </p:nvSpPr>
+        <p:spPr/>
+      </p:sp>
+    </p:spTree>
+  </p:cSld>
+  <p:clrMapOvr>
+    <a:masterClrMapping/>
+  </p:clrMapOvr>
+</p:notes>
+</file>
+
+<file path=ppt/notesSlides/notesSlide10.xml><?xml version="1.0" encoding="utf-8"?>
+<p:notes xmlns:a="http://schemas.openxmlformats.org/drawingml/2006/main" xmlns:p="http://schemas.openxmlformats.org/presentationml/2006/main" xmlns:r="http://schemas.openxmlformats.org/officeDocument/2006/relationships">
+  <p:cSld>
+    <p:spTree>
+      <p:nvGrpSpPr>
+        <p:cNvPr id="1" name=""/>
+        <p:cNvGrpSpPr/>
+        <p:nvPr/>
+      </p:nvGrpSpPr>
+      <p:grpSpPr>
+        <a:xfrm>
+          <a:off x="0" y="0"/>
+          <a:ext cx="0" cy="0"/>
+          <a:chOff x="0" y="0"/>
+          <a:chExt cx="0" cy="0"/>
+        </a:xfrm>
+      </p:grpSpPr>
+      <p:sp>
+        <p:nvSpPr>
+          <p:cNvPr id="2" name="Slide Image Placeholder 1"/>
+          <p:cNvSpPr>
+            <a:spLocks noGrp="1"/>
+          </p:cNvSpPr>
+          <p:nvPr>
+            <p:ph type="sldImg" idx="2"/>
+          </p:nvPr>
+        </p:nvSpPr>
+        <p:spPr/>
+      </p:sp>
+      <p:sp>
+        <p:nvSpPr>
+          <p:cNvPr id="3" name="Notes Placeholder 2"/>
+          <p:cNvSpPr>
+            <a:spLocks noGrp="1"/>
+          </p:cNvSpPr>
+          <p:nvPr>
+            <p:ph type="body" idx="3" sz="quarter"/>
+          </p:nvPr>
+        </p:nvSpPr>
+        <p:spPr/>
+        <p:txBody>
+          <a:bodyPr/>
+          <a:lstStyle/>
+          <a:p>
+            <a:r>
+              <a:t>Con los datos ya limpios podemos empezar a hacer preguntas más interesantes: quién interactúa con quién en estos foros, y si esas interacciones forman grupos identificables. Todo esto es estadística de grafos pura, nada de modelos generativos todavía, así que sirve como base sólida antes de meter LLM en la siguiente sección.</a:t>
+            </a:r>
+          </a:p>
+        </p:txBody>
+      </p:sp>
+      <p:sp>
+        <p:nvSpPr>
+          <p:cNvPr id="4" name="Slide Number Placeholder 3"/>
+          <p:cNvSpPr>
+            <a:spLocks noGrp="1"/>
+          </p:cNvSpPr>
+          <p:nvPr>
+            <p:ph type="sldNum" idx="5" sz="quarter"/>
+          </p:nvPr>
+        </p:nvSpPr>
+        <p:spPr/>
+      </p:sp>
+    </p:spTree>
+  </p:cSld>
+  <p:clrMapOvr>
+    <a:masterClrMapping/>
+  </p:clrMapOvr>
+</p:notes>
+</file>
+
+<file path=ppt/notesSlides/notesSlide11.xml><?xml version="1.0" encoding="utf-8"?>
+<p:notes xmlns:a="http://schemas.openxmlformats.org/drawingml/2006/main" xmlns:p="http://schemas.openxmlformats.org/presentationml/2006/main" xmlns:r="http://schemas.openxmlformats.org/officeDocument/2006/relationships">
+  <p:cSld>
+    <p:spTree>
+      <p:nvGrpSpPr>
+        <p:cNvPr id="1" name=""/>
+        <p:cNvGrpSpPr/>
+        <p:nvPr/>
+      </p:nvGrpSpPr>
+      <p:grpSpPr>
+        <a:xfrm>
+          <a:off x="0" y="0"/>
+          <a:ext cx="0" cy="0"/>
+          <a:chOff x="0" y="0"/>
+          <a:chExt cx="0" cy="0"/>
+        </a:xfrm>
+      </p:grpSpPr>
+      <p:sp>
+        <p:nvSpPr>
+          <p:cNvPr id="2" name="Slide Image Placeholder 1"/>
+          <p:cNvSpPr>
+            <a:spLocks noGrp="1"/>
+          </p:cNvSpPr>
+          <p:nvPr>
+            <p:ph type="sldImg" idx="2"/>
+          </p:nvPr>
+        </p:nvSpPr>
+        <p:spPr/>
+      </p:sp>
+      <p:sp>
+        <p:nvSpPr>
+          <p:cNvPr id="3" name="Notes Placeholder 2"/>
+          <p:cNvSpPr>
+            <a:spLocks noGrp="1"/>
+          </p:cNvSpPr>
+          <p:nvPr>
+            <p:ph type="body" idx="3" sz="quarter"/>
+          </p:nvPr>
+        </p:nvSpPr>
+        <p:spPr/>
+        <p:txBody>
+          <a:bodyPr/>
+          <a:lstStyle/>
+          <a:p>
+            <a:r>
+              <a:t>La definición del grafo es simple pero la decisión de filtrar aristas de un solo thread compartido es la que realmente determina qué tan limpia queda la red: sin ese filtro, el ruido de coincidencias puntuales infla artificialmente la conectividad. Con el filtro aplicado, la componente gigante queda en 11,113 nodos, un tamaño manejable pero todavía grande para cálculos exactos. Por eso betweenness centrality se calcula por muestreo con k=500 en vez de exacto, porque el cálculo exacto en un grafo de este tamaño simplemente no termina en tiempo razonable. Vale aclarar esto en voz alta porque es una limitación técnica real, no una elección arbitraria: estamos aproximando, no midiendo con precisión perfecta.</a:t>
+            </a:r>
+          </a:p>
+        </p:txBody>
+      </p:sp>
+      <p:sp>
+        <p:nvSpPr>
+          <p:cNvPr id="4" name="Slide Number Placeholder 3"/>
+          <p:cNvSpPr>
+            <a:spLocks noGrp="1"/>
+          </p:cNvSpPr>
+          <p:nvPr>
+            <p:ph type="sldNum" idx="5" sz="quarter"/>
+          </p:nvPr>
+        </p:nvSpPr>
+        <p:spPr/>
+      </p:sp>
+    </p:spTree>
+  </p:cSld>
+  <p:clrMapOvr>
+    <a:masterClrMapping/>
+  </p:clrMapOvr>
+</p:notes>
+</file>
+
+<file path=ppt/notesSlides/notesSlide12.xml><?xml version="1.0" encoding="utf-8"?>
+<p:notes xmlns:a="http://schemas.openxmlformats.org/drawingml/2006/main" xmlns:p="http://schemas.openxmlformats.org/presentationml/2006/main" xmlns:r="http://schemas.openxmlformats.org/officeDocument/2006/relationships">
+  <p:cSld>
+    <p:spTree>
+      <p:nvGrpSpPr>
+        <p:cNvPr id="1" name=""/>
+        <p:cNvGrpSpPr/>
+        <p:nvPr/>
+      </p:nvGrpSpPr>
+      <p:grpSpPr>
+        <a:xfrm>
+          <a:off x="0" y="0"/>
+          <a:ext cx="0" cy="0"/>
+          <a:chOff x="0" y="0"/>
+          <a:chExt cx="0" cy="0"/>
+        </a:xfrm>
+      </p:grpSpPr>
+      <p:sp>
+        <p:nvSpPr>
+          <p:cNvPr id="2" name="Slide Image Placeholder 1"/>
+          <p:cNvSpPr>
+            <a:spLocks noGrp="1"/>
+          </p:cNvSpPr>
+          <p:nvPr>
+            <p:ph type="sldImg" idx="2"/>
+          </p:nvPr>
+        </p:nvSpPr>
+        <p:spPr/>
+      </p:sp>
+      <p:sp>
+        <p:nvSpPr>
+          <p:cNvPr id="3" name="Notes Placeholder 2"/>
+          <p:cNvSpPr>
+            <a:spLocks noGrp="1"/>
+          </p:cNvSpPr>
+          <p:nvPr>
+            <p:ph type="body" idx="3" sz="quarter"/>
+          </p:nvPr>
+        </p:nvSpPr>
+        <p:spPr/>
+        <p:txBody>
+          <a:bodyPr/>
+          <a:lstStyle/>
+          <a:p>
+            <a:r>
+              <a:t>Veintiuna comunidades es un número manejable para inspección manual, y ahí es donde aparece lo interesante: no todas las comunidades cuentan la misma historia. Una comunidad homogénea, concentrada en un solo foro, probablemente refleja un círculo cerrado propio de ese mercado específico. Pero una comunidad mixta, con usuarios de varios foros, es la que más me interesa señalar, porque sugiere que los mismos actores operan en múltiples plataformas, algo valioso para cualquier análisis de inteligencia. El TF-IDF por subforo ayuda a poner nombre a cada sección temática, y quiero remarcar que todo este análisis corre sin GPU y sin LLM: es estadística de grafos y frecuencias de términos, completamente reproducible en cualquier máquina.</a:t>
+            </a:r>
+          </a:p>
+        </p:txBody>
+      </p:sp>
+      <p:sp>
+        <p:nvSpPr>
+          <p:cNvPr id="4" name="Slide Number Placeholder 3"/>
+          <p:cNvSpPr>
+            <a:spLocks noGrp="1"/>
+          </p:cNvSpPr>
+          <p:nvPr>
+            <p:ph type="sldNum" idx="5" sz="quarter"/>
+          </p:nvPr>
+        </p:nvSpPr>
+        <p:spPr/>
+      </p:sp>
+    </p:spTree>
+  </p:cSld>
+  <p:clrMapOvr>
+    <a:masterClrMapping/>
+  </p:clrMapOvr>
+</p:notes>
+</file>
+
+<file path=ppt/notesSlides/notesSlide13.xml><?xml version="1.0" encoding="utf-8"?>
+<p:notes xmlns:a="http://schemas.openxmlformats.org/drawingml/2006/main" xmlns:p="http://schemas.openxmlformats.org/presentationml/2006/main" xmlns:r="http://schemas.openxmlformats.org/officeDocument/2006/relationships">
+  <p:cSld>
+    <p:spTree>
+      <p:nvGrpSpPr>
+        <p:cNvPr id="1" name=""/>
+        <p:cNvGrpSpPr/>
+        <p:nvPr/>
+      </p:nvGrpSpPr>
+      <p:grpSpPr>
+        <a:xfrm>
+          <a:off x="0" y="0"/>
+          <a:ext cx="0" cy="0"/>
+          <a:chOff x="0" y="0"/>
+          <a:chExt cx="0" cy="0"/>
+        </a:xfrm>
+      </p:grpSpPr>
+      <p:sp>
+        <p:nvSpPr>
+          <p:cNvPr id="2" name="Slide Image Placeholder 1"/>
+          <p:cNvSpPr>
+            <a:spLocks noGrp="1"/>
+          </p:cNvSpPr>
+          <p:nvPr>
+            <p:ph type="sldImg" idx="2"/>
+          </p:nvPr>
+        </p:nvSpPr>
+        <p:spPr/>
+      </p:sp>
+      <p:sp>
+        <p:nvSpPr>
+          <p:cNvPr id="3" name="Notes Placeholder 2"/>
+          <p:cNvSpPr>
+            <a:spLocks noGrp="1"/>
+          </p:cNvSpPr>
+          <p:nvPr>
+            <p:ph type="body" idx="3" sz="quarter"/>
+          </p:nvPr>
+        </p:nvSpPr>
+        <p:spPr/>
+        <p:txBody>
+          <a:bodyPr/>
+          <a:lstStyle/>
+          <a:p>
+            <a:r>
+              <a:t>Abrimos el notebook 02 y empezamos por el scatter de degree versus betweenness, que es una buena forma visual de distinguir a los nodos muy conectados de los que actúan como puentes entre grupos, no siempre son los mismos usuarios. En la sección 4 miramos la composición de comunidades por foro, que es donde se distingue a simple vista cuáles son homogéneas y cuáles mixtas. Cerramos con la visualización interactiva de los top-150 nodos, que ayuda a que la audiencia vea la estructura de la red en vivo en vez de solo en una tabla de números.</a:t>
+            </a:r>
+          </a:p>
+        </p:txBody>
+      </p:sp>
+      <p:sp>
+        <p:nvSpPr>
+          <p:cNvPr id="4" name="Slide Number Placeholder 3"/>
+          <p:cNvSpPr>
+            <a:spLocks noGrp="1"/>
+          </p:cNvSpPr>
+          <p:nvPr>
+            <p:ph type="sldNum" idx="5" sz="quarter"/>
+          </p:nvPr>
+        </p:nvSpPr>
+        <p:spPr/>
+      </p:sp>
+    </p:spTree>
+  </p:cSld>
+  <p:clrMapOvr>
+    <a:masterClrMapping/>
+  </p:clrMapOvr>
+</p:notes>
+</file>
+
+<file path=ppt/notesSlides/notesSlide14.xml><?xml version="1.0" encoding="utf-8"?>
+<p:notes xmlns:a="http://schemas.openxmlformats.org/drawingml/2006/main" xmlns:p="http://schemas.openxmlformats.org/presentationml/2006/main" xmlns:r="http://schemas.openxmlformats.org/officeDocument/2006/relationships">
+  <p:cSld>
+    <p:spTree>
+      <p:nvGrpSpPr>
+        <p:cNvPr id="1" name=""/>
+        <p:cNvGrpSpPr/>
+        <p:nvPr/>
+      </p:nvGrpSpPr>
+      <p:grpSpPr>
+        <a:xfrm>
+          <a:off x="0" y="0"/>
+          <a:ext cx="0" cy="0"/>
+          <a:chOff x="0" y="0"/>
+          <a:chExt cx="0" cy="0"/>
+        </a:xfrm>
+      </p:grpSpPr>
+      <p:sp>
+        <p:nvSpPr>
+          <p:cNvPr id="2" name="Slide Image Placeholder 1"/>
+          <p:cNvSpPr>
+            <a:spLocks noGrp="1"/>
+          </p:cNvSpPr>
+          <p:nvPr>
+            <p:ph type="sldImg" idx="2"/>
+          </p:nvPr>
+        </p:nvSpPr>
+        <p:spPr/>
+      </p:sp>
+      <p:sp>
+        <p:nvSpPr>
+          <p:cNvPr id="3" name="Notes Placeholder 2"/>
+          <p:cNvSpPr>
+            <a:spLocks noGrp="1"/>
+          </p:cNvSpPr>
+          <p:nvPr>
+            <p:ph type="body" idx="3" sz="quarter"/>
+          </p:nvPr>
+        </p:nvSpPr>
+        <p:spPr/>
+        <p:txBody>
+          <a:bodyPr/>
+          <a:lstStyle/>
+          <a:p>
+            <a:r>
+              <a:t>Ahora sí entra el LLM local en escena: vamos a convertir texto en vectores, extraer entidades de dominio y finalmente pedirle a un modelo que infiera roles de actor. Esta es la sección más ambiciosa del caso, y también la que trae más matices y limitaciones que hay que comunicar con honestidad.</a:t>
+            </a:r>
+          </a:p>
+        </p:txBody>
+      </p:sp>
+      <p:sp>
+        <p:nvSpPr>
+          <p:cNvPr id="4" name="Slide Number Placeholder 3"/>
+          <p:cNvSpPr>
+            <a:spLocks noGrp="1"/>
+          </p:cNvSpPr>
+          <p:nvPr>
+            <p:ph type="sldNum" idx="5" sz="quarter"/>
+          </p:nvPr>
+        </p:nvSpPr>
+        <p:spPr/>
+      </p:sp>
+    </p:spTree>
+  </p:cSld>
+  <p:clrMapOvr>
+    <a:masterClrMapping/>
+  </p:clrMapOvr>
+</p:notes>
+</file>
+
+<file path=ppt/notesSlides/notesSlide15.xml><?xml version="1.0" encoding="utf-8"?>
+<p:notes xmlns:a="http://schemas.openxmlformats.org/drawingml/2006/main" xmlns:p="http://schemas.openxmlformats.org/presentationml/2006/main" xmlns:r="http://schemas.openxmlformats.org/officeDocument/2006/relationships">
+  <p:cSld>
+    <p:spTree>
+      <p:nvGrpSpPr>
+        <p:cNvPr id="1" name=""/>
+        <p:cNvGrpSpPr/>
+        <p:nvPr/>
+      </p:nvGrpSpPr>
+      <p:grpSpPr>
+        <a:xfrm>
+          <a:off x="0" y="0"/>
+          <a:ext cx="0" cy="0"/>
+          <a:chOff x="0" y="0"/>
+          <a:chExt cx="0" cy="0"/>
+        </a:xfrm>
+      </p:grpSpPr>
+      <p:sp>
+        <p:nvSpPr>
+          <p:cNvPr id="2" name="Slide Image Placeholder 1"/>
+          <p:cNvSpPr>
+            <a:spLocks noGrp="1"/>
+          </p:cNvSpPr>
+          <p:nvPr>
+            <p:ph type="sldImg" idx="2"/>
+          </p:nvPr>
+        </p:nvSpPr>
+        <p:spPr/>
+      </p:sp>
+      <p:sp>
+        <p:nvSpPr>
+          <p:cNvPr id="3" name="Notes Placeholder 2"/>
+          <p:cNvSpPr>
+            <a:spLocks noGrp="1"/>
+          </p:cNvSpPr>
+          <p:nvPr>
+            <p:ph type="body" idx="3" sz="quarter"/>
+          </p:nvPr>
+        </p:nvSpPr>
+        <p:spPr/>
+        <p:txBody>
+          <a:bodyPr/>
+          <a:lstStyle/>
+          <a:p>
+            <a:r>
+              <a:t>La primera decisión importante acá es el umbral de 10 posts mínimos para generar un embedding confiable: de casi un millón de usuarios, solo 9,550 pasan ese filtro, porque con menos texto el vector no representa nada útil, es puro ruido. También hay un límite práctico de 50 mil caracteres por usuario antes de concatenar los posts, pensado para que Ollama no se cuelgue con los pocos usuarios que escribieron miles de mensajes. Todo corre local con qwen3-embedding en 4096 dimensiones, ni un byte de texto sale hacia una API externa. Con esos vectores aplicamos UMAP y HDBSCAN para agrupar por estilo de escritura, y BERTopic en paralelo para ver qué temas dominan cada cluster — dos vistas complementarias sobre el mismo corpus.</a:t>
+            </a:r>
+          </a:p>
+        </p:txBody>
+      </p:sp>
+      <p:sp>
+        <p:nvSpPr>
+          <p:cNvPr id="4" name="Slide Number Placeholder 3"/>
+          <p:cNvSpPr>
+            <a:spLocks noGrp="1"/>
+          </p:cNvSpPr>
+          <p:nvPr>
+            <p:ph type="sldNum" idx="5" sz="quarter"/>
+          </p:nvPr>
+        </p:nvSpPr>
+        <p:spPr/>
+      </p:sp>
+    </p:spTree>
+  </p:cSld>
+  <p:clrMapOvr>
+    <a:masterClrMapping/>
+  </p:clrMapOvr>
+</p:notes>
+</file>
+
+<file path=ppt/notesSlides/notesSlide16.xml><?xml version="1.0" encoding="utf-8"?>
+<p:notes xmlns:a="http://schemas.openxmlformats.org/drawingml/2006/main" xmlns:p="http://schemas.openxmlformats.org/presentationml/2006/main" xmlns:r="http://schemas.openxmlformats.org/officeDocument/2006/relationships">
+  <p:cSld>
+    <p:spTree>
+      <p:nvGrpSpPr>
+        <p:cNvPr id="1" name=""/>
+        <p:cNvGrpSpPr/>
+        <p:nvPr/>
+      </p:nvGrpSpPr>
+      <p:grpSpPr>
+        <a:xfrm>
+          <a:off x="0" y="0"/>
+          <a:ext cx="0" cy="0"/>
+          <a:chOff x="0" y="0"/>
+          <a:chExt cx="0" cy="0"/>
+        </a:xfrm>
+      </p:grpSpPr>
+      <p:sp>
+        <p:nvSpPr>
+          <p:cNvPr id="2" name="Slide Image Placeholder 1"/>
+          <p:cNvSpPr>
+            <a:spLocks noGrp="1"/>
+          </p:cNvSpPr>
+          <p:nvPr>
+            <p:ph type="sldImg" idx="2"/>
+          </p:nvPr>
+        </p:nvSpPr>
+        <p:spPr/>
+      </p:sp>
+      <p:sp>
+        <p:nvSpPr>
+          <p:cNvPr id="3" name="Notes Placeholder 2"/>
+          <p:cNvSpPr>
+            <a:spLocks noGrp="1"/>
+          </p:cNvSpPr>
+          <p:nvPr>
+            <p:ph type="body" idx="3" sz="quarter"/>
+          </p:nvPr>
+        </p:nvSpPr>
+        <p:spPr/>
+        <p:txBody>
+          <a:bodyPr/>
+          <a:lstStyle/>
+          <a:p>
+            <a:r>
+              <a:t>Acá el modelo qwen2.5:14b entra a hacer un trabajo bastante más ambicioso que extraer entidades: recibe centralidad de red, cluster semántico, entidades de dominio y una muestra de posts, y con todo eso infiere un rol probable. Quiero que quede claro que esto es perfilado limitado a los 100 usuarios más activos según el propio contador del foro, una elección de alcance, no un análisis exhaustivo de todo el dataset. Las categorías de rol van desde vendedor de dumps hasta simple lurker, pasando por intermediarios de escrow, que es una figura clásica en estos mercados de fraude. Y el punto que quiero remarcar antes de pasar a los números: son 30 perfiles con una confianza asociada, es decir, inferencia razonada del modelo, no un dato verificado de campo.</a:t>
+            </a:r>
+          </a:p>
+        </p:txBody>
+      </p:sp>
+      <p:sp>
+        <p:nvSpPr>
+          <p:cNvPr id="4" name="Slide Number Placeholder 3"/>
+          <p:cNvSpPr>
+            <a:spLocks noGrp="1"/>
+          </p:cNvSpPr>
+          <p:nvPr>
+            <p:ph type="sldNum" idx="5" sz="quarter"/>
+          </p:nvPr>
+        </p:nvSpPr>
+        <p:spPr/>
+      </p:sp>
+    </p:spTree>
+  </p:cSld>
+  <p:clrMapOvr>
+    <a:masterClrMapping/>
+  </p:clrMapOvr>
+</p:notes>
+</file>
+
+<file path=ppt/notesSlides/notesSlide17.xml><?xml version="1.0" encoding="utf-8"?>
+<p:notes xmlns:a="http://schemas.openxmlformats.org/drawingml/2006/main" xmlns:p="http://schemas.openxmlformats.org/presentationml/2006/main" xmlns:r="http://schemas.openxmlformats.org/officeDocument/2006/relationships">
+  <p:cSld>
+    <p:spTree>
+      <p:nvGrpSpPr>
+        <p:cNvPr id="1" name=""/>
+        <p:cNvGrpSpPr/>
+        <p:nvPr/>
+      </p:nvGrpSpPr>
+      <p:grpSpPr>
+        <a:xfrm>
+          <a:off x="0" y="0"/>
+          <a:ext cx="0" cy="0"/>
+          <a:chOff x="0" y="0"/>
+          <a:chExt cx="0" cy="0"/>
+        </a:xfrm>
+      </p:grpSpPr>
+      <p:sp>
+        <p:nvSpPr>
+          <p:cNvPr id="2" name="Slide Image Placeholder 1"/>
+          <p:cNvSpPr>
+            <a:spLocks noGrp="1"/>
+          </p:cNvSpPr>
+          <p:nvPr>
+            <p:ph type="sldImg" idx="2"/>
+          </p:nvPr>
+        </p:nvSpPr>
+        <p:spPr/>
+      </p:sp>
+      <p:sp>
+        <p:nvSpPr>
+          <p:cNvPr id="3" name="Notes Placeholder 2"/>
+          <p:cNvSpPr>
+            <a:spLocks noGrp="1"/>
+          </p:cNvSpPr>
+          <p:nvPr>
+            <p:ph type="body" idx="3" sz="quarter"/>
+          </p:nvPr>
+        </p:nvSpPr>
+        <p:spPr/>
+        <p:txBody>
+          <a:bodyPr/>
+          <a:lstStyle/>
+          <a:p>
+            <a:r>
+              <a:t>Miren el número que salta: 20 de 30 perfiles, dos tercios, terminan clasificados como lurker con confianza alta, entre 0.85 y 0.95. Para gente supuestamente elegida por ser los 100 usuarios más activos del foro, encontrar que la mayoría queda etiquetada como lurker es, como mínimo, contraintuitivo. ¿No debería un usuario 'top' por definición ser todo menos un lurker? Esa contradicción es justamente el gancho para la próxima slide, donde vamos a explicar por qué pasa esto, y no es un error del LLM, es un problema de los datos que le dimos de entrada.</a:t>
+            </a:r>
+          </a:p>
+        </p:txBody>
+      </p:sp>
+      <p:sp>
+        <p:nvSpPr>
+          <p:cNvPr id="4" name="Slide Number Placeholder 3"/>
+          <p:cNvSpPr>
+            <a:spLocks noGrp="1"/>
+          </p:cNvSpPr>
+          <p:nvPr>
+            <p:ph type="sldNum" idx="5" sz="quarter"/>
+          </p:nvPr>
+        </p:nvSpPr>
+        <p:spPr/>
+      </p:sp>
+    </p:spTree>
+  </p:cSld>
+  <p:clrMapOvr>
+    <a:masterClrMapping/>
+  </p:clrMapOvr>
+</p:notes>
+</file>
+
+<file path=ppt/notesSlides/notesSlide18.xml><?xml version="1.0" encoding="utf-8"?>
+<p:notes xmlns:a="http://schemas.openxmlformats.org/drawingml/2006/main" xmlns:p="http://schemas.openxmlformats.org/presentationml/2006/main" xmlns:r="http://schemas.openxmlformats.org/officeDocument/2006/relationships">
+  <p:cSld>
+    <p:spTree>
+      <p:nvGrpSpPr>
+        <p:cNvPr id="1" name=""/>
+        <p:cNvGrpSpPr/>
+        <p:nvPr/>
+      </p:nvGrpSpPr>
+      <p:grpSpPr>
+        <a:xfrm>
+          <a:off x="0" y="0"/>
+          <a:ext cx="0" cy="0"/>
+          <a:chOff x="0" y="0"/>
+          <a:chExt cx="0" cy="0"/>
+        </a:xfrm>
+      </p:grpSpPr>
+      <p:sp>
+        <p:nvSpPr>
+          <p:cNvPr id="2" name="Slide Image Placeholder 1"/>
+          <p:cNvSpPr>
+            <a:spLocks noGrp="1"/>
+          </p:cNvSpPr>
+          <p:nvPr>
+            <p:ph type="sldImg" idx="2"/>
+          </p:nvPr>
+        </p:nvSpPr>
+        <p:spPr/>
+      </p:sp>
+      <p:sp>
+        <p:nvSpPr>
+          <p:cNvPr id="3" name="Notes Placeholder 2"/>
+          <p:cNvSpPr>
+            <a:spLocks noGrp="1"/>
+          </p:cNvSpPr>
+          <p:nvPr>
+            <p:ph type="body" idx="3" sz="quarter"/>
+          </p:nvPr>
+        </p:nvSpPr>
+        <p:spPr/>
+        <p:txBody>
+          <a:bodyPr/>
+          <a:lstStyle/>
+          <a:p>
+            <a:r>
+              <a:t>Acá está la respuesta a la pregunta que dejamos abierta: el campo posts de la tabla user de vBulletin es un contador que el propio foro mantiene, no un recuento verificado contra la tabla post real que nosotros limpiamos. El resultado es que varios de esos 'top 100 más activos' aparecen en nuestro corpus limpio con cero posts extraídos, probablemente porque sus mensajes originales se perdieron, fueron borrados por moderación o el contador simplemente quedó desactualizado. El LLM no tiene forma de saber eso, así que clasifica como lurker con alta confianza a alguien que en realidad puede haber sido muy activo en su momento, solo que nosotros no tenemos evidencia textual de eso. La lección de fondo, y esto aplica mucho más allá de este caso: cualquier contador de actividad que venga del sistema origen hay que tratarlo como sospechoso hasta que se verifique contra los datos reales, nunca como verdad absoluta.</a:t>
+            </a:r>
+          </a:p>
+        </p:txBody>
+      </p:sp>
+      <p:sp>
+        <p:nvSpPr>
+          <p:cNvPr id="4" name="Slide Number Placeholder 3"/>
+          <p:cNvSpPr>
+            <a:spLocks noGrp="1"/>
+          </p:cNvSpPr>
+          <p:nvPr>
+            <p:ph type="sldNum" idx="5" sz="quarter"/>
+          </p:nvPr>
+        </p:nvSpPr>
+        <p:spPr/>
+      </p:sp>
+    </p:spTree>
+  </p:cSld>
+  <p:clrMapOvr>
+    <a:masterClrMapping/>
+  </p:clrMapOvr>
+</p:notes>
+</file>
+
+<file path=ppt/notesSlides/notesSlide19.xml><?xml version="1.0" encoding="utf-8"?>
+<p:notes xmlns:a="http://schemas.openxmlformats.org/drawingml/2006/main" xmlns:p="http://schemas.openxmlformats.org/presentationml/2006/main" xmlns:r="http://schemas.openxmlformats.org/officeDocument/2006/relationships">
+  <p:cSld>
+    <p:spTree>
+      <p:nvGrpSpPr>
+        <p:cNvPr id="1" name=""/>
+        <p:cNvGrpSpPr/>
+        <p:nvPr/>
+      </p:nvGrpSpPr>
+      <p:grpSpPr>
+        <a:xfrm>
+          <a:off x="0" y="0"/>
+          <a:ext cx="0" cy="0"/>
+          <a:chOff x="0" y="0"/>
+          <a:chExt cx="0" cy="0"/>
+        </a:xfrm>
+      </p:grpSpPr>
+      <p:sp>
+        <p:nvSpPr>
+          <p:cNvPr id="2" name="Slide Image Placeholder 1"/>
+          <p:cNvSpPr>
+            <a:spLocks noGrp="1"/>
+          </p:cNvSpPr>
+          <p:nvPr>
+            <p:ph type="sldImg" idx="2"/>
+          </p:nvPr>
+        </p:nvSpPr>
+        <p:spPr/>
+      </p:sp>
+      <p:sp>
+        <p:nvSpPr>
+          <p:cNvPr id="3" name="Notes Placeholder 2"/>
+          <p:cNvSpPr>
+            <a:spLocks noGrp="1"/>
+          </p:cNvSpPr>
+          <p:nvPr>
+            <p:ph type="body" idx="3" sz="quarter"/>
+          </p:nvPr>
+        </p:nvSpPr>
+        <p:spPr/>
+        <p:txBody>
+          <a:bodyPr/>
+          <a:lstStyle/>
+          <a:p>
+            <a:r>
+              <a:t>Llegamos al cierre: repasamos todo el recorrido, del dump crudo al perfilado de actores, y sacamos las conclusiones que se pueden llevar a otros casos del curso o a trabajo futuro. La idea es dejar claro qué de esto es técnica reutilizable y qué es específico de este dataset.</a:t>
+            </a:r>
+          </a:p>
+        </p:txBody>
+      </p:sp>
+      <p:sp>
+        <p:nvSpPr>
+          <p:cNvPr id="4" name="Slide Number Placeholder 3"/>
+          <p:cNvSpPr>
+            <a:spLocks noGrp="1"/>
+          </p:cNvSpPr>
+          <p:nvPr>
+            <p:ph type="sldNum" idx="5" sz="quarter"/>
+          </p:nvPr>
+        </p:nvSpPr>
+        <p:spPr/>
+      </p:sp>
+    </p:spTree>
+  </p:cSld>
+  <p:clrMapOvr>
+    <a:masterClrMapping/>
+  </p:clrMapOvr>
+</p:notes>
+</file>
+
+<file path=ppt/notesSlides/notesSlide2.xml><?xml version="1.0" encoding="utf-8"?>
+<p:notes xmlns:a="http://schemas.openxmlformats.org/drawingml/2006/main" xmlns:p="http://schemas.openxmlformats.org/presentationml/2006/main" xmlns:r="http://schemas.openxmlformats.org/officeDocument/2006/relationships">
+  <p:cSld>
+    <p:spTree>
+      <p:nvGrpSpPr>
+        <p:cNvPr id="1" name=""/>
+        <p:cNvGrpSpPr/>
+        <p:nvPr/>
+      </p:nvGrpSpPr>
+      <p:grpSpPr>
+        <a:xfrm>
+          <a:off x="0" y="0"/>
+          <a:ext cx="0" cy="0"/>
+          <a:chOff x="0" y="0"/>
+          <a:chExt cx="0" cy="0"/>
+        </a:xfrm>
+      </p:grpSpPr>
+      <p:sp>
+        <p:nvSpPr>
+          <p:cNvPr id="2" name="Slide Image Placeholder 1"/>
+          <p:cNvSpPr>
+            <a:spLocks noGrp="1"/>
+          </p:cNvSpPr>
+          <p:nvPr>
+            <p:ph type="sldImg" idx="2"/>
+          </p:nvPr>
+        </p:nvSpPr>
+        <p:spPr/>
+      </p:sp>
+      <p:sp>
+        <p:nvSpPr>
+          <p:cNvPr id="3" name="Notes Placeholder 2"/>
+          <p:cNvSpPr>
+            <a:spLocks noGrp="1"/>
+          </p:cNvSpPr>
+          <p:nvPr>
+            <p:ph type="body" idx="3" sz="quarter"/>
+          </p:nvPr>
+        </p:nvSpPr>
+        <p:spPr/>
+        <p:txBody>
+          <a:bodyPr/>
+          <a:lstStyle/>
+          <a:p>
+            <a:r>
+              <a:t>Antes de tocar un solo post hay que entender qué tenemos entre manos: diez archivos que no son diez foros distintos, y no todos están en el mismo formato. Vamos a ver un dump duplicado bajo dos nombres y un archivo que no es SQL aunque el zip lo sugiera. Esta sección es la base de todo lo que viene después.</a:t>
+            </a:r>
+          </a:p>
+        </p:txBody>
+      </p:sp>
+      <p:sp>
+        <p:nvSpPr>
+          <p:cNvPr id="4" name="Slide Number Placeholder 3"/>
+          <p:cNvSpPr>
+            <a:spLocks noGrp="1"/>
+          </p:cNvSpPr>
+          <p:nvPr>
+            <p:ph type="sldNum" idx="5" sz="quarter"/>
+          </p:nvPr>
+        </p:nvSpPr>
+        <p:spPr/>
+      </p:sp>
+    </p:spTree>
+  </p:cSld>
+  <p:clrMapOvr>
+    <a:masterClrMapping/>
+  </p:clrMapOvr>
+</p:notes>
+</file>
+
+<file path=ppt/notesSlides/notesSlide20.xml><?xml version="1.0" encoding="utf-8"?>
+<p:notes xmlns:a="http://schemas.openxmlformats.org/drawingml/2006/main" xmlns:p="http://schemas.openxmlformats.org/presentationml/2006/main" xmlns:r="http://schemas.openxmlformats.org/officeDocument/2006/relationships">
+  <p:cSld>
+    <p:spTree>
+      <p:nvGrpSpPr>
+        <p:cNvPr id="1" name=""/>
+        <p:cNvGrpSpPr/>
+        <p:nvPr/>
+      </p:nvGrpSpPr>
+      <p:grpSpPr>
+        <a:xfrm>
+          <a:off x="0" y="0"/>
+          <a:ext cx="0" cy="0"/>
+          <a:chOff x="0" y="0"/>
+          <a:chExt cx="0" cy="0"/>
+        </a:xfrm>
+      </p:grpSpPr>
+      <p:sp>
+        <p:nvSpPr>
+          <p:cNvPr id="2" name="Slide Image Placeholder 1"/>
+          <p:cNvSpPr>
+            <a:spLocks noGrp="1"/>
+          </p:cNvSpPr>
+          <p:nvPr>
+            <p:ph type="sldImg" idx="2"/>
+          </p:nvPr>
+        </p:nvSpPr>
+        <p:spPr/>
+      </p:sp>
+      <p:sp>
+        <p:nvSpPr>
+          <p:cNvPr id="3" name="Notes Placeholder 2"/>
+          <p:cNvSpPr>
+            <a:spLocks noGrp="1"/>
+          </p:cNvSpPr>
+          <p:nvPr>
+            <p:ph type="body" idx="3" sz="quarter"/>
+          </p:nvPr>
+        </p:nvSpPr>
+        <p:spPr/>
+        <p:txBody>
+          <a:bodyPr/>
+          <a:lstStyle/>
+          <a:p>
+            <a:r>
+              <a:t>Del lado técnico, quiero que se lleven dos cosas: el dump duplicado y el flat file escondido son recordatorios de que la verificación de datos de entrada no es un paso opcional, es donde se evitan los errores más caros. Del lado metodológico, la idea central es que ninguna automatización reemplaza la validación: auto-detectar formato, validar rangos de fecha, deduplicar, todo eso tiene que pasar antes de calcular una sola métrica de red o mandar un post a un LLM. Y quiero remarcar el último punto de la derecha, porque es una decisión de diseño deliberada: todo este pipeline corre local, sin mandar un solo post a una API externa, algo relevante cuando estamos trabajando con datos de un mercado de fraude financiero.</a:t>
+            </a:r>
+          </a:p>
+        </p:txBody>
+      </p:sp>
+      <p:sp>
+        <p:nvSpPr>
+          <p:cNvPr id="4" name="Slide Number Placeholder 3"/>
+          <p:cNvSpPr>
+            <a:spLocks noGrp="1"/>
+          </p:cNvSpPr>
+          <p:nvPr>
+            <p:ph type="sldNum" idx="5" sz="quarter"/>
+          </p:nvPr>
+        </p:nvSpPr>
+        <p:spPr/>
+      </p:sp>
+    </p:spTree>
+  </p:cSld>
+  <p:clrMapOvr>
+    <a:masterClrMapping/>
+  </p:clrMapOvr>
+</p:notes>
+</file>
+
+<file path=ppt/notesSlides/notesSlide21.xml><?xml version="1.0" encoding="utf-8"?>
+<p:notes xmlns:a="http://schemas.openxmlformats.org/drawingml/2006/main" xmlns:p="http://schemas.openxmlformats.org/presentationml/2006/main" xmlns:r="http://schemas.openxmlformats.org/officeDocument/2006/relationships">
+  <p:cSld>
+    <p:spTree>
+      <p:nvGrpSpPr>
+        <p:cNvPr id="1" name=""/>
+        <p:cNvGrpSpPr/>
+        <p:nvPr/>
+      </p:nvGrpSpPr>
+      <p:grpSpPr>
+        <a:xfrm>
+          <a:off x="0" y="0"/>
+          <a:ext cx="0" cy="0"/>
+          <a:chOff x="0" y="0"/>
+          <a:chExt cx="0" cy="0"/>
+        </a:xfrm>
+      </p:grpSpPr>
+      <p:sp>
+        <p:nvSpPr>
+          <p:cNvPr id="2" name="Slide Image Placeholder 1"/>
+          <p:cNvSpPr>
+            <a:spLocks noGrp="1"/>
+          </p:cNvSpPr>
+          <p:nvPr>
+            <p:ph type="sldImg" idx="2"/>
+          </p:nvPr>
+        </p:nvSpPr>
+        <p:spPr/>
+      </p:sp>
+      <p:sp>
+        <p:nvSpPr>
+          <p:cNvPr id="3" name="Notes Placeholder 2"/>
+          <p:cNvSpPr>
+            <a:spLocks noGrp="1"/>
+          </p:cNvSpPr>
+          <p:nvPr>
+            <p:ph type="body" idx="3" sz="quarter"/>
+          </p:nvPr>
+        </p:nvSpPr>
+        <p:spPr/>
+        <p:txBody>
+          <a:bodyPr/>
+          <a:lstStyle/>
+          <a:p>
+            <a:r>
+              <a:t>Para cerrar, la pregunta que planteo a la audiencia es: si tuvieran que elegir un solo caso del curso para mostrarle a alguien que dude de que esto escala, ¿no sería este? Casi un millón de usuarios, tres formatos distintos conviviendo en el mismo lote, y aun así el pipeline sostiene el análisis de punta a punta. Pero el mensaje más importante no es el volumen, es que la calidad de todo lo que viene después, red, embeddings, perfilado, depende enteramente de decisiones de ingeniería de datos que parecen aburridas: deduplicar, validar, detectar el formato correcto. Y el perfilado con LLM local es el ejemplo perfecto de esa tensión: funciona, genera valor, pero solo es tan bueno como los datos que le damos de entrada, ni más ni menos. Con esto cerramos el caso Carding Forums.</a:t>
+            </a:r>
+          </a:p>
+        </p:txBody>
+      </p:sp>
+      <p:sp>
+        <p:nvSpPr>
+          <p:cNvPr id="4" name="Slide Number Placeholder 3"/>
+          <p:cNvSpPr>
+            <a:spLocks noGrp="1"/>
+          </p:cNvSpPr>
+          <p:nvPr>
+            <p:ph type="sldNum" idx="5" sz="quarter"/>
+          </p:nvPr>
+        </p:nvSpPr>
+        <p:spPr/>
+      </p:sp>
+    </p:spTree>
+  </p:cSld>
+  <p:clrMapOvr>
+    <a:masterClrMapping/>
+  </p:clrMapOvr>
+</p:notes>
+</file>
+
+<file path=ppt/notesSlides/notesSlide3.xml><?xml version="1.0" encoding="utf-8"?>
+<p:notes xmlns:a="http://schemas.openxmlformats.org/drawingml/2006/main" xmlns:p="http://schemas.openxmlformats.org/presentationml/2006/main" xmlns:r="http://schemas.openxmlformats.org/officeDocument/2006/relationships">
+  <p:cSld>
+    <p:spTree>
+      <p:nvGrpSpPr>
+        <p:cNvPr id="1" name=""/>
+        <p:cNvGrpSpPr/>
+        <p:nvPr/>
+      </p:nvGrpSpPr>
+      <p:grpSpPr>
+        <a:xfrm>
+          <a:off x="0" y="0"/>
+          <a:ext cx="0" cy="0"/>
+          <a:chOff x="0" y="0"/>
+          <a:chExt cx="0" cy="0"/>
+        </a:xfrm>
+      </p:grpSpPr>
+      <p:sp>
+        <p:nvSpPr>
+          <p:cNvPr id="2" name="Slide Image Placeholder 1"/>
+          <p:cNvSpPr>
+            <a:spLocks noGrp="1"/>
+          </p:cNvSpPr>
+          <p:nvPr>
+            <p:ph type="sldImg" idx="2"/>
+          </p:nvPr>
+        </p:nvSpPr>
+        <p:spPr/>
+      </p:sp>
+      <p:sp>
+        <p:nvSpPr>
+          <p:cNvPr id="3" name="Notes Placeholder 2"/>
+          <p:cNvSpPr>
+            <a:spLocks noGrp="1"/>
+          </p:cNvSpPr>
+          <p:nvPr>
+            <p:ph type="body" idx="3" sz="quarter"/>
+          </p:nvPr>
+        </p:nvSpPr>
+        <p:spPr/>
+        <p:txBody>
+          <a:bodyPr/>
+          <a:lstStyle/>
+          <a:p>
+            <a:r>
+              <a:t>Fíjense en la columna de fechas: esto cubre doce años de actividad de carding, desde 2009 hasta 2021, y ya ahí hay una pista de que dos de estos foros van a dar problemas. Carder.pro merece mención aparte porque viene en cp1251, encoding cirílico, algo que ya vimos en otros casos del curso y que si no se detecta bien, el parser simplemente rompe o produce basura. Y ojo con las dos últimas filas, CardingMafia y Cardmafia.cc, ambas de 2021-03: parecen dos foros distintos pero en la próxima slide vamos a demostrar que no lo son. La pregunta que quiero que se hagan es: ¿cuántas veces confiamos en el nombre de un archivo sin verificar su contenido?</a:t>
+            </a:r>
+          </a:p>
+        </p:txBody>
+      </p:sp>
+      <p:sp>
+        <p:nvSpPr>
+          <p:cNvPr id="4" name="Slide Number Placeholder 3"/>
+          <p:cNvSpPr>
+            <a:spLocks noGrp="1"/>
+          </p:cNvSpPr>
+          <p:nvPr>
+            <p:ph type="sldNum" idx="5" sz="quarter"/>
+          </p:nvPr>
+        </p:nvSpPr>
+        <p:spPr/>
+      </p:sp>
+    </p:spTree>
+  </p:cSld>
+  <p:clrMapOvr>
+    <a:masterClrMapping/>
+  </p:clrMapOvr>
+</p:notes>
+</file>
+
+<file path=ppt/notesSlides/notesSlide4.xml><?xml version="1.0" encoding="utf-8"?>
+<p:notes xmlns:a="http://schemas.openxmlformats.org/drawingml/2006/main" xmlns:p="http://schemas.openxmlformats.org/presentationml/2006/main" xmlns:r="http://schemas.openxmlformats.org/officeDocument/2006/relationships">
+  <p:cSld>
+    <p:spTree>
+      <p:nvGrpSpPr>
+        <p:cNvPr id="1" name=""/>
+        <p:cNvGrpSpPr/>
+        <p:nvPr/>
+      </p:nvGrpSpPr>
+      <p:grpSpPr>
+        <a:xfrm>
+          <a:off x="0" y="0"/>
+          <a:ext cx="0" cy="0"/>
+          <a:chOff x="0" y="0"/>
+          <a:chExt cx="0" cy="0"/>
+        </a:xfrm>
+      </p:grpSpPr>
+      <p:sp>
+        <p:nvSpPr>
+          <p:cNvPr id="2" name="Slide Image Placeholder 1"/>
+          <p:cNvSpPr>
+            <a:spLocks noGrp="1"/>
+          </p:cNvSpPr>
+          <p:nvPr>
+            <p:ph type="sldImg" idx="2"/>
+          </p:nvPr>
+        </p:nvSpPr>
+        <p:spPr/>
+      </p:sp>
+      <p:sp>
+        <p:nvSpPr>
+          <p:cNvPr id="3" name="Notes Placeholder 2"/>
+          <p:cNvSpPr>
+            <a:spLocks noGrp="1"/>
+          </p:cNvSpPr>
+          <p:nvPr>
+            <p:ph type="body" idx="3" sz="quarter"/>
+          </p:nvPr>
+        </p:nvSpPr>
+        <p:spPr/>
+        <p:txBody>
+          <a:bodyPr/>
+          <a:lstStyle/>
+          <a:p>
+            <a:r>
+              <a:t>Esto es exactamente el tipo de cosa que un análisis apurado se pasa por alto: dos zips con nombre distinto, mismo tamaño en bytes hasta el último dígito, 175,674,160. Cuando el tamaño coincide así de exacto, la sospecha tiene que ser inmediata, y la verificación byte a byte lo confirmó: mismo INSERT INTO user, mismas 296,909 filas. Es el mismo leak subido dos veces, probablemente para inflar el catálogo de quien lo vendía o compartía. Un detalle importante para la siguiente sección: ninguno de los dos incluye tabla de posts, solo usuarios, así que ese leak no aporta texto para el análisis semántico más adelante. La lección de fondo es simple: el nombre del archivo no es una fuente de verdad, el contenido sí.</a:t>
+            </a:r>
+          </a:p>
+        </p:txBody>
+      </p:sp>
+      <p:sp>
+        <p:nvSpPr>
+          <p:cNvPr id="4" name="Slide Number Placeholder 3"/>
+          <p:cNvSpPr>
+            <a:spLocks noGrp="1"/>
+          </p:cNvSpPr>
+          <p:nvPr>
+            <p:ph type="sldNum" idx="5" sz="quarter"/>
+          </p:nvPr>
+        </p:nvSpPr>
+        <p:spPr/>
+      </p:sp>
+    </p:spTree>
+  </p:cSld>
+  <p:clrMapOvr>
+    <a:masterClrMapping/>
+  </p:clrMapOvr>
+</p:notes>
+</file>
+
+<file path=ppt/notesSlides/notesSlide5.xml><?xml version="1.0" encoding="utf-8"?>
+<p:notes xmlns:a="http://schemas.openxmlformats.org/drawingml/2006/main" xmlns:p="http://schemas.openxmlformats.org/presentationml/2006/main" xmlns:r="http://schemas.openxmlformats.org/officeDocument/2006/relationships">
+  <p:cSld>
+    <p:spTree>
+      <p:nvGrpSpPr>
+        <p:cNvPr id="1" name=""/>
+        <p:cNvGrpSpPr/>
+        <p:nvPr/>
+      </p:nvGrpSpPr>
+      <p:grpSpPr>
+        <a:xfrm>
+          <a:off x="0" y="0"/>
+          <a:ext cx="0" cy="0"/>
+          <a:chOff x="0" y="0"/>
+          <a:chExt cx="0" cy="0"/>
+        </a:xfrm>
+      </p:grpSpPr>
+      <p:sp>
+        <p:nvSpPr>
+          <p:cNvPr id="2" name="Slide Image Placeholder 1"/>
+          <p:cNvSpPr>
+            <a:spLocks noGrp="1"/>
+          </p:cNvSpPr>
+          <p:nvPr>
+            <p:ph type="sldImg" idx="2"/>
+          </p:nvPr>
+        </p:nvSpPr>
+        <p:spPr/>
+      </p:sp>
+      <p:sp>
+        <p:nvSpPr>
+          <p:cNvPr id="3" name="Notes Placeholder 2"/>
+          <p:cNvSpPr>
+            <a:spLocks noGrp="1"/>
+          </p:cNvSpPr>
+          <p:nvPr>
+            <p:ph type="body" idx="3" sz="quarter"/>
+          </p:nvPr>
+        </p:nvSpPr>
+        <p:spPr/>
+        <p:txBody>
+          <a:bodyPr/>
+          <a:lstStyle/>
+          <a:p>
+            <a:r>
+              <a:t>Este es el típico error silencioso: load_forum() no tira excepción, simplemente devuelve cero filas y uno podría pensar que el foro está vacío o corrupto. La realidad es que el zip de Cardingmafia.ws no trae un dump SQL sino un único txt delimitado por dos puntos, un formato de exportación totalmente distinto. Por suerte el proyecto ya tenía un parser para ese formato exacto, solo faltaba que load_forum() lo detectara antes de asumir vBulletin por default. El resultado habla solo: casi 178 mil usuarios que se hubieran perdido si nos quedábamos con el cero filas inicial y seguíamos de largo. La moraleja para cualquier pipeline de este tipo: cero resultados no siempre significa dataset vacío, a veces significa parser equivocado.</a:t>
+            </a:r>
+          </a:p>
+        </p:txBody>
+      </p:sp>
+      <p:sp>
+        <p:nvSpPr>
+          <p:cNvPr id="4" name="Slide Number Placeholder 3"/>
+          <p:cNvSpPr>
+            <a:spLocks noGrp="1"/>
+          </p:cNvSpPr>
+          <p:nvPr>
+            <p:ph type="sldNum" idx="5" sz="quarter"/>
+          </p:nvPr>
+        </p:nvSpPr>
+        <p:spPr/>
+      </p:sp>
+    </p:spTree>
+  </p:cSld>
+  <p:clrMapOvr>
+    <a:masterClrMapping/>
+  </p:clrMapOvr>
+</p:notes>
+</file>
+
+<file path=ppt/notesSlides/notesSlide6.xml><?xml version="1.0" encoding="utf-8"?>
+<p:notes xmlns:a="http://schemas.openxmlformats.org/drawingml/2006/main" xmlns:p="http://schemas.openxmlformats.org/presentationml/2006/main" xmlns:r="http://schemas.openxmlformats.org/officeDocument/2006/relationships">
+  <p:cSld>
+    <p:spTree>
+      <p:nvGrpSpPr>
+        <p:cNvPr id="1" name=""/>
+        <p:cNvGrpSpPr/>
+        <p:nvPr/>
+      </p:nvGrpSpPr>
+      <p:grpSpPr>
+        <a:xfrm>
+          <a:off x="0" y="0"/>
+          <a:ext cx="0" cy="0"/>
+          <a:chOff x="0" y="0"/>
+          <a:chExt cx="0" cy="0"/>
+        </a:xfrm>
+      </p:grpSpPr>
+      <p:sp>
+        <p:nvSpPr>
+          <p:cNvPr id="2" name="Slide Image Placeholder 1"/>
+          <p:cNvSpPr>
+            <a:spLocks noGrp="1"/>
+          </p:cNvSpPr>
+          <p:nvPr>
+            <p:ph type="sldImg" idx="2"/>
+          </p:nvPr>
+        </p:nvSpPr>
+        <p:spPr/>
+      </p:sp>
+      <p:sp>
+        <p:nvSpPr>
+          <p:cNvPr id="3" name="Notes Placeholder 2"/>
+          <p:cNvSpPr>
+            <a:spLocks noGrp="1"/>
+          </p:cNvSpPr>
+          <p:nvPr>
+            <p:ph type="body" idx="3" sz="quarter"/>
+          </p:nvPr>
+        </p:nvSpPr>
+        <p:spPr/>
+        <p:txBody>
+          <a:bodyPr/>
+          <a:lstStyle/>
+          <a:p>
+            <a:r>
+              <a:t>Ya sabemos qué archivos tenemos y en qué formato vienen; ahora toca ponerle números al dataset completo y limpiarlo antes de confiar en él. Vamos a ver la escala real, casi un millón de usuarios, y los mismos problemas de siempre — timestamps corruptos, texto vacío, duplicados — pero a una escala que exige más cuidado, no menos.</a:t>
+            </a:r>
+          </a:p>
+        </p:txBody>
+      </p:sp>
+      <p:sp>
+        <p:nvSpPr>
+          <p:cNvPr id="4" name="Slide Number Placeholder 3"/>
+          <p:cNvSpPr>
+            <a:spLocks noGrp="1"/>
+          </p:cNvSpPr>
+          <p:nvPr>
+            <p:ph type="sldNum" idx="5" sz="quarter"/>
+          </p:nvPr>
+        </p:nvSpPr>
+        <p:spPr/>
+      </p:sp>
+    </p:spTree>
+  </p:cSld>
+  <p:clrMapOvr>
+    <a:masterClrMapping/>
+  </p:clrMapOvr>
+</p:notes>
+</file>
+
+<file path=ppt/notesSlides/notesSlide7.xml><?xml version="1.0" encoding="utf-8"?>
+<p:notes xmlns:a="http://schemas.openxmlformats.org/drawingml/2006/main" xmlns:p="http://schemas.openxmlformats.org/presentationml/2006/main" xmlns:r="http://schemas.openxmlformats.org/officeDocument/2006/relationships">
+  <p:cSld>
+    <p:spTree>
+      <p:nvGrpSpPr>
+        <p:cNvPr id="1" name=""/>
+        <p:cNvGrpSpPr/>
+        <p:nvPr/>
+      </p:nvGrpSpPr>
+      <p:grpSpPr>
+        <a:xfrm>
+          <a:off x="0" y="0"/>
+          <a:ext cx="0" cy="0"/>
+          <a:chOff x="0" y="0"/>
+          <a:chExt cx="0" cy="0"/>
+        </a:xfrm>
+      </p:grpSpPr>
+      <p:sp>
+        <p:nvSpPr>
+          <p:cNvPr id="2" name="Slide Image Placeholder 1"/>
+          <p:cNvSpPr>
+            <a:spLocks noGrp="1"/>
+          </p:cNvSpPr>
+          <p:nvPr>
+            <p:ph type="sldImg" idx="2"/>
+          </p:nvPr>
+        </p:nvSpPr>
+        <p:spPr/>
+      </p:sp>
+      <p:sp>
+        <p:nvSpPr>
+          <p:cNvPr id="3" name="Notes Placeholder 2"/>
+          <p:cNvSpPr>
+            <a:spLocks noGrp="1"/>
+          </p:cNvSpPr>
+          <p:nvPr>
+            <p:ph type="body" idx="3" sz="quarter"/>
+          </p:nvPr>
+        </p:nvSpPr>
+        <p:spPr/>
+        <p:txBody>
+          <a:bodyPr/>
+          <a:lstStyle/>
+          <a:p>
+            <a:r>
+              <a:t>Casi un millón de usuarios y un millón y medio de posts es una escala que obliga a repensar cómo validamos: no podemos revisar fila por fila, necesitamos reglas y filtros que se apliquen de forma sistemática. El rango temporal dice 2009 a 2016, pero remarco lo de 'con timestamps corruptos que hay que filtrar' porque ese matiz es clave, ya lo vamos a cuantificar en la próxima slide. Vale la pena notar que vBulletin domina el dataset, así que el trabajo de parseo ya hecho en foros anteriores del curso se reutiliza directamente acá. Y de nuevo aparece el tema del encoding con Carder.pro: cp1251 no se asume, se detecta, porque asumir mal el encoding rompe silenciosamente los datos de texto.</a:t>
+            </a:r>
+          </a:p>
+        </p:txBody>
+      </p:sp>
+      <p:sp>
+        <p:nvSpPr>
+          <p:cNvPr id="4" name="Slide Number Placeholder 3"/>
+          <p:cNvSpPr>
+            <a:spLocks noGrp="1"/>
+          </p:cNvSpPr>
+          <p:nvPr>
+            <p:ph type="sldNum" idx="5" sz="quarter"/>
+          </p:nvPr>
+        </p:nvSpPr>
+        <p:spPr/>
+      </p:sp>
+    </p:spTree>
+  </p:cSld>
+  <p:clrMapOvr>
+    <a:masterClrMapping/>
+  </p:clrMapOvr>
+</p:notes>
+</file>
+
+<file path=ppt/notesSlides/notesSlide8.xml><?xml version="1.0" encoding="utf-8"?>
+<p:notes xmlns:a="http://schemas.openxmlformats.org/drawingml/2006/main" xmlns:p="http://schemas.openxmlformats.org/presentationml/2006/main" xmlns:r="http://schemas.openxmlformats.org/officeDocument/2006/relationships">
+  <p:cSld>
+    <p:spTree>
+      <p:nvGrpSpPr>
+        <p:cNvPr id="1" name=""/>
+        <p:cNvGrpSpPr/>
+        <p:nvPr/>
+      </p:nvGrpSpPr>
+      <p:grpSpPr>
+        <a:xfrm>
+          <a:off x="0" y="0"/>
+          <a:ext cx="0" cy="0"/>
+          <a:chOff x="0" y="0"/>
+          <a:chExt cx="0" cy="0"/>
+        </a:xfrm>
+      </p:grpSpPr>
+      <p:sp>
+        <p:nvSpPr>
+          <p:cNvPr id="2" name="Slide Image Placeholder 1"/>
+          <p:cNvSpPr>
+            <a:spLocks noGrp="1"/>
+          </p:cNvSpPr>
+          <p:nvPr>
+            <p:ph type="sldImg" idx="2"/>
+          </p:nvPr>
+        </p:nvSpPr>
+        <p:spPr/>
+      </p:sp>
+      <p:sp>
+        <p:nvSpPr>
+          <p:cNvPr id="3" name="Notes Placeholder 2"/>
+          <p:cNvSpPr>
+            <a:spLocks noGrp="1"/>
+          </p:cNvSpPr>
+          <p:nvPr>
+            <p:ph type="body" idx="3" sz="quarter"/>
+          </p:nvPr>
+        </p:nvSpPr>
+        <p:spPr/>
+        <p:txBody>
+          <a:bodyPr/>
+          <a:lstStyle/>
+          <a:p>
+            <a:r>
+              <a:t>Casi el 19% de los usuarios tiene una fecha de alta inválida, ya sea epoch-0 o directamente nula, y eso no es un detalle menor, es casi uno de cada cinco registros. Esto conecta directo con lo que vimos en HackingForums: el mismo patrón de epoch-0 aparece de nuevo, lo cual sugiere que no es casualidad sino un bug o comportamiento típico de cómo estos foros exportan o migran datos. También hay que remarcar los 58,939 posts vacíos o casi vacíos, que probablemente son contenido borrado por moderación y no aporta nada al análisis semántico posterior. Al final del día, del millón y medio de posts original, descartamos un 4% antes de tocar embeddings o NER, y ese 4% descartado bien vale la pena porque evita que ruido contamine todo lo que viene después.</a:t>
+            </a:r>
+          </a:p>
+        </p:txBody>
+      </p:sp>
+      <p:sp>
+        <p:nvSpPr>
+          <p:cNvPr id="4" name="Slide Number Placeholder 3"/>
+          <p:cNvSpPr>
+            <a:spLocks noGrp="1"/>
+          </p:cNvSpPr>
+          <p:nvPr>
+            <p:ph type="sldNum" idx="5" sz="quarter"/>
+          </p:nvPr>
+        </p:nvSpPr>
+        <p:spPr/>
+      </p:sp>
+    </p:spTree>
+  </p:cSld>
+  <p:clrMapOvr>
+    <a:masterClrMapping/>
+  </p:clrMapOvr>
+</p:notes>
+</file>
+
+<file path=ppt/notesSlides/notesSlide9.xml><?xml version="1.0" encoding="utf-8"?>
+<p:notes xmlns:a="http://schemas.openxmlformats.org/drawingml/2006/main" xmlns:p="http://schemas.openxmlformats.org/presentationml/2006/main" xmlns:r="http://schemas.openxmlformats.org/officeDocument/2006/relationships">
+  <p:cSld>
+    <p:spTree>
+      <p:nvGrpSpPr>
+        <p:cNvPr id="1" name=""/>
+        <p:cNvGrpSpPr/>
+        <p:nvPr/>
+      </p:nvGrpSpPr>
+      <p:grpSpPr>
+        <a:xfrm>
+          <a:off x="0" y="0"/>
+          <a:ext cx="0" cy="0"/>
+          <a:chOff x="0" y="0"/>
+          <a:chExt cx="0" cy="0"/>
+        </a:xfrm>
+      </p:grpSpPr>
+      <p:sp>
+        <p:nvSpPr>
+          <p:cNvPr id="2" name="Slide Image Placeholder 1"/>
+          <p:cNvSpPr>
+            <a:spLocks noGrp="1"/>
+          </p:cNvSpPr>
+          <p:nvPr>
+            <p:ph type="sldImg" idx="2"/>
+          </p:nvPr>
+        </p:nvSpPr>
+        <p:spPr/>
+      </p:sp>
+      <p:sp>
+        <p:nvSpPr>
+          <p:cNvPr id="3" name="Notes Placeholder 2"/>
+          <p:cNvSpPr>
+            <a:spLocks noGrp="1"/>
+          </p:cNvSpPr>
+          <p:nvPr>
+            <p:ph type="body" idx="3" sz="quarter"/>
+          </p:nvPr>
+        </p:nvSpPr>
+        <p:spPr/>
+        <p:txBody>
+          <a:bodyPr/>
+          <a:lstStyle/>
+          <a:p>
+            <a:r>
+              <a:t>Vamos a la práctica: abrimos el notebook 00 y miramos primero la tabla de usuarios y posts por foro para que la escala que acabamos de mencionar se vea en números concretos, no solo en una slide. Después el timeline de registros, donde se nota a simple vista dónde aparecen los saltos raros que después vamos a atribuir a timestamps corruptos. En la sección 7 revisamos completitud de campos de contacto, que es un buen proxy de qué tan bien exportado está cada dump. Y cerramos con el notebook 01, sección 5, donde se ve el resumen de limpieza con los conteos antes y después que acabamos de repasar en la slide anterior.</a:t>
+            </a:r>
+          </a:p>
+        </p:txBody>
+      </p:sp>
+      <p:sp>
+        <p:nvSpPr>
+          <p:cNvPr id="4" name="Slide Number Placeholder 3"/>
+          <p:cNvSpPr>
+            <a:spLocks noGrp="1"/>
+          </p:cNvSpPr>
+          <p:nvPr>
+            <p:ph type="sldNum" idx="5" sz="quarter"/>
+          </p:nvPr>
+        </p:nvSpPr>
+        <p:spPr/>
+      </p:sp>
+    </p:spTree>
+  </p:cSld>
+  <p:clrMapOvr>
+    <a:masterClrMapping/>
+  </p:clrMapOvr>
+</p:notes>
 </file>
 
 <file path=ppt/slideLayouts/slideLayout1.xml><?xml version="1.0" encoding="utf-8"?>
@@ -10777,4 +12597,324 @@
   </a:objectDefaults>
   <a:extraClrSchemeLst/>
 </a:theme>
+</file>
+
+<file path=ppt/theme/theme2.xml><?xml version="1.0" encoding="utf-8"?>
+<a:theme xmlns:a="http://schemas.openxmlformats.org/drawingml/2006/main" name="Office Theme">
+  <a:themeElements>
+    <a:clrScheme name="Office">
+      <a:dk1>
+        <a:sysClr val="windowText" lastClr="000000"/>
+      </a:dk1>
+      <a:lt1>
+        <a:sysClr val="window" lastClr="FFFFFF"/>
+      </a:lt1>
+      <a:dk2>
+        <a:srgbClr val="1F497D"/>
+      </a:dk2>
+      <a:lt2>
+        <a:srgbClr val="EEECE1"/>
+      </a:lt2>
+      <a:accent1>
+        <a:srgbClr val="4F81BD"/>
+      </a:accent1>
+      <a:accent2>
+        <a:srgbClr val="C0504D"/>
+      </a:accent2>
+      <a:accent3>
+        <a:srgbClr val="9BBB59"/>
+      </a:accent3>
+      <a:accent4>
+        <a:srgbClr val="8064A2"/>
+      </a:accent4>
+      <a:accent5>
+        <a:srgbClr val="4BACC6"/>
+      </a:accent5>
+      <a:accent6>
+        <a:srgbClr val="F79646"/>
+      </a:accent6>
+      <a:hlink>
+        <a:srgbClr val="0000FF"/>
+      </a:hlink>
+      <a:folHlink>
+        <a:srgbClr val="800080"/>
+      </a:folHlink>
+    </a:clrScheme>
+    <a:fontScheme name="Office">
+      <a:majorFont>
+        <a:latin typeface="Calibri"/>
+        <a:ea typeface=""/>
+        <a:cs typeface=""/>
+        <a:font script="Jpan" typeface="ＭＳ Ｐゴシック"/>
+        <a:font script="Hang" typeface="맑은 고딕"/>
+        <a:font script="Hans" typeface="宋体"/>
+        <a:font script="Hant" typeface="新細明體"/>
+        <a:font script="Arab" typeface="Times New Roman"/>
+        <a:font script="Hebr" typeface="Times New Roman"/>
+        <a:font script="Thai" typeface="Angsana New"/>
+        <a:font script="Ethi" typeface="Nyala"/>
+        <a:font script="Beng" typeface="Vrinda"/>
+        <a:font script="Gujr" typeface="Shruti"/>
+        <a:font script="Khmr" typeface="MoolBoran"/>
+        <a:font script="Knda" typeface="Tunga"/>
+        <a:font script="Guru" typeface="Raavi"/>
+        <a:font script="Cans" typeface="Euphemia"/>
+        <a:font script="Cher" typeface="Plantagenet Cherokee"/>
+        <a:font script="Yiii" typeface="Microsoft Yi Baiti"/>
+        <a:font script="Tibt" typeface="Microsoft Himalaya"/>
+        <a:font script="Thaa" typeface="MV Boli"/>
+        <a:font script="Deva" typeface="Mangal"/>
+        <a:font script="Telu" typeface="Gautami"/>
+        <a:font script="Taml" typeface="Latha"/>
+        <a:font script="Syrc" typeface="Estrangelo Edessa"/>
+        <a:font script="Orya" typeface="Kalinga"/>
+        <a:font script="Mlym" typeface="Kartika"/>
+        <a:font script="Laoo" typeface="DokChampa"/>
+        <a:font script="Sinh" typeface="Iskoola Pota"/>
+        <a:font script="Mong" typeface="Mongolian Baiti"/>
+        <a:font script="Viet" typeface="Times New Roman"/>
+        <a:font script="Uigh" typeface="Microsoft Uighur"/>
+        <a:font script="Geor" typeface="Sylfaen"/>
+      </a:majorFont>
+      <a:minorFont>
+        <a:latin typeface="Calibri"/>
+        <a:ea typeface=""/>
+        <a:cs typeface=""/>
+        <a:font script="Jpan" typeface="ＭＳ Ｐゴシック"/>
+        <a:font script="Hang" typeface="맑은 고딕"/>
+        <a:font script="Hans" typeface="宋体"/>
+        <a:font script="Hant" typeface="新細明體"/>
+        <a:font script="Arab" typeface="Arial"/>
+        <a:font script="Hebr" typeface="Arial"/>
+        <a:font script="Thai" typeface="Cordia New"/>
+        <a:font script="Ethi" typeface="Nyala"/>
+        <a:font script="Beng" typeface="Vrinda"/>
+        <a:font script="Gujr" typeface="Shruti"/>
+        <a:font script="Khmr" typeface="DaunPenh"/>
+        <a:font script="Knda" typeface="Tunga"/>
+        <a:font script="Guru" typeface="Raavi"/>
+        <a:font script="Cans" typeface="Euphemia"/>
+        <a:font script="Cher" typeface="Plantagenet Cherokee"/>
+        <a:font script="Yiii" typeface="Microsoft Yi Baiti"/>
+        <a:font script="Tibt" typeface="Microsoft Himalaya"/>
+        <a:font script="Thaa" typeface="MV Boli"/>
+        <a:font script="Deva" typeface="Mangal"/>
+        <a:font script="Telu" typeface="Gautami"/>
+        <a:font script="Taml" typeface="Latha"/>
+        <a:font script="Syrc" typeface="Estrangelo Edessa"/>
+        <a:font script="Orya" typeface="Kalinga"/>
+        <a:font script="Mlym" typeface="Kartika"/>
+        <a:font script="Laoo" typeface="DokChampa"/>
+        <a:font script="Sinh" typeface="Iskoola Pota"/>
+        <a:font script="Mong" typeface="Mongolian Baiti"/>
+        <a:font script="Viet" typeface="Arial"/>
+        <a:font script="Uigh" typeface="Microsoft Uighur"/>
+        <a:font script="Geor" typeface="Sylfaen"/>
+      </a:minorFont>
+    </a:fontScheme>
+    <a:fmtScheme name="Office">
+      <a:fillStyleLst>
+        <a:solidFill>
+          <a:schemeClr val="phClr"/>
+        </a:solidFill>
+        <a:gradFill rotWithShape="1">
+          <a:gsLst>
+            <a:gs pos="0">
+              <a:schemeClr val="phClr">
+                <a:tint val="50000"/>
+                <a:satMod val="300000"/>
+              </a:schemeClr>
+            </a:gs>
+            <a:gs pos="35000">
+              <a:schemeClr val="phClr">
+                <a:tint val="37000"/>
+                <a:satMod val="300000"/>
+              </a:schemeClr>
+            </a:gs>
+            <a:gs pos="100000">
+              <a:schemeClr val="phClr">
+                <a:tint val="15000"/>
+                <a:satMod val="350000"/>
+              </a:schemeClr>
+            </a:gs>
+          </a:gsLst>
+          <a:lin ang="16200000" scaled="1"/>
+        </a:gradFill>
+        <a:gradFill rotWithShape="1">
+          <a:gsLst>
+            <a:gs pos="0">
+              <a:schemeClr val="phClr">
+                <a:tint val="100000"/>
+                <a:shade val="100000"/>
+                <a:satMod val="130000"/>
+              </a:schemeClr>
+            </a:gs>
+            <a:gs pos="100000">
+              <a:schemeClr val="phClr">
+                <a:tint val="50000"/>
+                <a:shade val="100000"/>
+                <a:satMod val="350000"/>
+              </a:schemeClr>
+            </a:gs>
+          </a:gsLst>
+          <a:lin ang="16200000" scaled="0"/>
+        </a:gradFill>
+      </a:fillStyleLst>
+      <a:lnStyleLst>
+        <a:ln w="9525" cap="flat" cmpd="sng" algn="ctr">
+          <a:solidFill>
+            <a:schemeClr val="phClr">
+              <a:shade val="95000"/>
+              <a:satMod val="105000"/>
+            </a:schemeClr>
+          </a:solidFill>
+          <a:prstDash val="solid"/>
+        </a:ln>
+        <a:ln w="25400" cap="flat" cmpd="sng" algn="ctr">
+          <a:solidFill>
+            <a:schemeClr val="phClr"/>
+          </a:solidFill>
+          <a:prstDash val="solid"/>
+        </a:ln>
+        <a:ln w="38100" cap="flat" cmpd="sng" algn="ctr">
+          <a:solidFill>
+            <a:schemeClr val="phClr"/>
+          </a:solidFill>
+          <a:prstDash val="solid"/>
+        </a:ln>
+      </a:lnStyleLst>
+      <a:effectStyleLst>
+        <a:effectStyle>
+          <a:effectLst>
+            <a:outerShdw blurRad="40000" dist="20000" dir="5400000" rotWithShape="0">
+              <a:srgbClr val="000000">
+                <a:alpha val="38000"/>
+              </a:srgbClr>
+            </a:outerShdw>
+          </a:effectLst>
+        </a:effectStyle>
+        <a:effectStyle>
+          <a:effectLst>
+            <a:outerShdw blurRad="40000" dist="23000" dir="5400000" rotWithShape="0">
+              <a:srgbClr val="000000">
+                <a:alpha val="35000"/>
+              </a:srgbClr>
+            </a:outerShdw>
+          </a:effectLst>
+        </a:effectStyle>
+        <a:effectStyle>
+          <a:effectLst>
+            <a:outerShdw blurRad="40000" dist="23000" dir="5400000" rotWithShape="0">
+              <a:srgbClr val="000000">
+                <a:alpha val="35000"/>
+              </a:srgbClr>
+            </a:outerShdw>
+          </a:effectLst>
+          <a:scene3d>
+            <a:camera prst="orthographicFront">
+              <a:rot lat="0" lon="0" rev="0"/>
+            </a:camera>
+            <a:lightRig rig="threePt" dir="t">
+              <a:rot lat="0" lon="0" rev="1200000"/>
+            </a:lightRig>
+          </a:scene3d>
+          <a:sp3d>
+            <a:bevelT w="63500" h="25400"/>
+          </a:sp3d>
+        </a:effectStyle>
+      </a:effectStyleLst>
+      <a:bgFillStyleLst>
+        <a:solidFill>
+          <a:schemeClr val="phClr"/>
+        </a:solidFill>
+        <a:gradFill rotWithShape="1">
+          <a:gsLst>
+            <a:gs pos="0">
+              <a:schemeClr val="phClr">
+                <a:tint val="40000"/>
+                <a:satMod val="350000"/>
+              </a:schemeClr>
+            </a:gs>
+            <a:gs pos="40000">
+              <a:schemeClr val="phClr">
+                <a:tint val="45000"/>
+                <a:shade val="99000"/>
+                <a:satMod val="350000"/>
+              </a:schemeClr>
+            </a:gs>
+            <a:gs pos="100000">
+              <a:schemeClr val="phClr">
+                <a:shade val="20000"/>
+                <a:satMod val="255000"/>
+              </a:schemeClr>
+            </a:gs>
+          </a:gsLst>
+          <a:path path="circle">
+            <a:fillToRect l="50000" t="-80000" r="50000" b="180000"/>
+          </a:path>
+        </a:gradFill>
+        <a:gradFill rotWithShape="1">
+          <a:gsLst>
+            <a:gs pos="0">
+              <a:schemeClr val="phClr">
+                <a:tint val="80000"/>
+                <a:satMod val="300000"/>
+              </a:schemeClr>
+            </a:gs>
+            <a:gs pos="100000">
+              <a:schemeClr val="phClr">
+                <a:shade val="30000"/>
+                <a:satMod val="200000"/>
+              </a:schemeClr>
+            </a:gs>
+          </a:gsLst>
+          <a:path path="circle">
+            <a:fillToRect l="50000" t="50000" r="50000" b="50000"/>
+          </a:path>
+        </a:gradFill>
+      </a:bgFillStyleLst>
+    </a:fmtScheme>
+  </a:themeElements>
+  <a:objectDefaults>
+    <a:spDef>
+      <a:spPr/>
+      <a:bodyPr/>
+      <a:lstStyle/>
+      <a:style>
+        <a:lnRef idx="1">
+          <a:schemeClr val="accent1"/>
+        </a:lnRef>
+        <a:fillRef idx="3">
+          <a:schemeClr val="accent1"/>
+        </a:fillRef>
+        <a:effectRef idx="2">
+          <a:schemeClr val="accent1"/>
+        </a:effectRef>
+        <a:fontRef idx="minor">
+          <a:schemeClr val="lt1"/>
+        </a:fontRef>
+      </a:style>
+    </a:spDef>
+    <a:lnDef>
+      <a:spPr/>
+      <a:bodyPr/>
+      <a:lstStyle/>
+      <a:style>
+        <a:lnRef idx="2">
+          <a:schemeClr val="accent1"/>
+        </a:lnRef>
+        <a:fillRef idx="0">
+          <a:schemeClr val="accent1"/>
+        </a:fillRef>
+        <a:effectRef idx="1">
+          <a:schemeClr val="accent1"/>
+        </a:effectRef>
+        <a:fontRef idx="minor">
+          <a:schemeClr val="tx1"/>
+        </a:fontRef>
+      </a:style>
+    </a:lnDef>
+  </a:objectDefaults>
+  <a:extraClrSchemeLst/>
+</a:theme>
 </file>
</xml_diff>

<commit_message>
fix: use template's actual font/color styles instead of invented ones
Inherit the real per-placeholder styles baked into the brand template's
layouts (Arial, brand red CD2D37 title, slate-gray body, native bullet
image) instead of hand-picked colors. Fixes two bugs surfaced by the
larger inherited title size: word-wrap-aware spacing so long titles no
longer collide with body text, and a python-pptx placeholder-resize bug
that was zeroing out shape width and hiding bullets.
</commit_message>
<xml_diff>
--- a/CardingForums/csbc26_caso_cardingforums.pptx
+++ b/CardingForums/csbc26_caso_cardingforums.pptx
@@ -6101,12 +6101,6 @@
           <a:lstStyle/>
           <a:p>
             <a:r>
-              <a:rPr sz="3400" b="1">
-                <a:solidFill>
-                  <a:srgbClr val="FFFFFF"/>
-                </a:solidFill>
-                <a:latin typeface="Calibri"/>
-              </a:rPr>
               <a:t>Caso Carding Forums</a:t>
             </a:r>
           </a:p>
@@ -6116,7 +6110,7 @@
                 <a:solidFill>
                   <a:srgbClr val="D6DAE2"/>
                 </a:solidFill>
-                <a:latin typeface="Calibri"/>
+                <a:latin typeface="Arial"/>
               </a:rPr>
               <a:t>Del dump SQL al perfilado de actores en un mercado de fraude financiero (2009–2021)</a:t>
             </a:r>
@@ -6127,7 +6121,7 @@
                 <a:solidFill>
                   <a:srgbClr val="9AA3B5"/>
                 </a:solidFill>
-                <a:latin typeface="Calibri"/>
+                <a:latin typeface="Arial"/>
               </a:rPr>
               <a:t>CSBC26 · Análisis de Leaks Underground</a:t>
             </a:r>
@@ -6167,34 +6161,31 @@
           <a:bodyPr wrap="square"/>
           <a:lstStyle/>
           <a:p>
+            <a:pPr algn="ctr"/>
             <a:r>
               <a:rPr sz="1300" b="1">
                 <a:solidFill>
-                  <a:srgbClr val="E32B3D"/>
-                </a:solidFill>
-                <a:latin typeface="Calibri"/>
+                  <a:srgbClr val="CD2D37"/>
+                </a:solidFill>
+                <a:latin typeface="Arial"/>
               </a:rPr>
               <a:t>SECCIÓN 3</a:t>
             </a:r>
           </a:p>
           <a:p>
-            <a:r>
-              <a:rPr sz="3000" b="1">
-                <a:solidFill>
-                  <a:srgbClr val="FFFFFF"/>
-                </a:solidFill>
-                <a:latin typeface="Calibri"/>
-              </a:rPr>
+            <a:pPr algn="ctr"/>
+            <a:r>
               <a:t>Red de co-participación y comunidades</a:t>
             </a:r>
           </a:p>
           <a:p>
+            <a:pPr algn="ctr"/>
             <a:r>
               <a:rPr sz="1600">
                 <a:solidFill>
                   <a:srgbClr val="D6DAE2"/>
                 </a:solidFill>
-                <a:latin typeface="Calibri"/>
+                <a:latin typeface="Arial"/>
               </a:rPr>
               <a:t>Notebook 02 — quién habla con quién, sin IA generativa</a:t>
             </a:r>
@@ -6235,12 +6226,6 @@
           <a:lstStyle/>
           <a:p>
             <a:r>
-              <a:rPr sz="2400" b="1">
-                <a:solidFill>
-                  <a:srgbClr val="1A1A2E"/>
-                </a:solidFill>
-                <a:latin typeface="Calibri"/>
-              </a:rPr>
               <a:t>Construcción del grafo</a:t>
             </a:r>
           </a:p>
@@ -6261,73 +6246,28 @@
           <a:bodyPr wrap="square"/>
           <a:lstStyle/>
           <a:p>
-            <a:pPr algn="l" marL="0" indent="-228600">
-              <a:buNone/>
-            </a:pPr>
-            <a:r>
-              <a:rPr sz="1900" b="0">
-                <a:solidFill>
-                  <a:srgbClr val="333844"/>
-                </a:solidFill>
-                <a:latin typeface="Calibri"/>
-              </a:rPr>
-              <a:t>▸  Nodo = usuario. Arista = co-participación en el mismo thread, peso = threads compartidos</a:t>
-            </a:r>
-          </a:p>
-          <a:p>
-            <a:pPr algn="l" marL="0" indent="-228600">
-              <a:buNone/>
-            </a:pPr>
-            <a:r>
-              <a:rPr sz="1900" b="0">
-                <a:solidFill>
-                  <a:srgbClr val="333844"/>
-                </a:solidFill>
-                <a:latin typeface="Calibri"/>
-              </a:rPr>
-              <a:t>▸  Filtro de aristas débiles: se descartan pares que solo comparten 1 thread (ruido)</a:t>
-            </a:r>
-          </a:p>
-          <a:p>
-            <a:pPr algn="l" marL="0" indent="-228600">
-              <a:buNone/>
-            </a:pPr>
-            <a:r>
-              <a:rPr sz="1900" b="0">
-                <a:solidFill>
-                  <a:srgbClr val="333844"/>
-                </a:solidFill>
-                <a:latin typeface="Calibri"/>
-              </a:rPr>
-              <a:t>▸  Componente gigante resultante: 11,113 nodos tras el filtrado</a:t>
-            </a:r>
-          </a:p>
-          <a:p>
-            <a:pPr algn="l" marL="0" indent="-228600">
-              <a:buNone/>
-            </a:pPr>
-            <a:r>
-              <a:rPr sz="1900" b="0">
-                <a:solidFill>
-                  <a:srgbClr val="333844"/>
-                </a:solidFill>
-                <a:latin typeface="Calibri"/>
-              </a:rPr>
-              <a:t>▸  Degree centrality (conexiones directas) y betweenness centrality (rol de puente) sobre esa componente</a:t>
-            </a:r>
-          </a:p>
-          <a:p>
-            <a:pPr algn="l" marL="0" indent="-228600">
-              <a:buNone/>
-            </a:pPr>
-            <a:r>
-              <a:rPr sz="1900" b="0">
-                <a:solidFill>
-                  <a:srgbClr val="333844"/>
-                </a:solidFill>
-                <a:latin typeface="Calibri"/>
-              </a:rPr>
-              <a:t>▸  betweenness se calcula por muestreo (k=500) — exacto es inviable en grafos de este tamaño</a:t>
+            <a:r>
+              <a:t>Nodo = usuario. Arista = co-participación en el mismo thread, peso = threads compartidos</a:t>
+            </a:r>
+          </a:p>
+          <a:p>
+            <a:r>
+              <a:t>Filtro de aristas débiles: se descartan pares que solo comparten 1 thread (ruido)</a:t>
+            </a:r>
+          </a:p>
+          <a:p>
+            <a:r>
+              <a:t>Componente gigante resultante: 11,113 nodos tras el filtrado</a:t>
+            </a:r>
+          </a:p>
+          <a:p>
+            <a:r>
+              <a:t>Degree centrality (conexiones directas) y betweenness centrality (rol de puente) sobre esa componente</a:t>
+            </a:r>
+          </a:p>
+          <a:p>
+            <a:r>
+              <a:t>betweenness se calcula por muestreo (k=500) — exacto es inviable en grafos de este tamaño</a:t>
             </a:r>
           </a:p>
         </p:txBody>
@@ -6366,12 +6306,6 @@
           <a:lstStyle/>
           <a:p>
             <a:r>
-              <a:rPr sz="2400" b="1">
-                <a:solidFill>
-                  <a:srgbClr val="1A1A2E"/>
-                </a:solidFill>
-                <a:latin typeface="Calibri"/>
-              </a:rPr>
               <a:t>Comunidades — Louvain sobre la red</a:t>
             </a:r>
           </a:p>
@@ -6387,78 +6321,38 @@
             <p:ph type="body" idx="16" sz="quarter"/>
           </p:nvPr>
         </p:nvSpPr>
-        <p:spPr/>
+        <p:spPr>
+          <a:xfrm>
+            <a:off x="1073427" y="2077576"/>
+            <a:ext cx="10084904" cy="3507298"/>
+          </a:xfrm>
+        </p:spPr>
         <p:txBody>
           <a:bodyPr wrap="square"/>
           <a:lstStyle/>
           <a:p>
-            <a:pPr algn="l" marL="0" indent="-228600">
-              <a:buNone/>
-            </a:pPr>
-            <a:r>
-              <a:rPr sz="1900" b="0">
-                <a:solidFill>
-                  <a:srgbClr val="333844"/>
-                </a:solidFill>
-                <a:latin typeface="Calibri"/>
-              </a:rPr>
-              <a:t>▸  21 comunidades detectadas en la componente gigante</a:t>
-            </a:r>
-          </a:p>
-          <a:p>
-            <a:pPr algn="l" marL="0" indent="-228600">
-              <a:buNone/>
-            </a:pPr>
-            <a:r>
-              <a:rPr sz="1900" b="0">
-                <a:solidFill>
-                  <a:srgbClr val="333844"/>
-                </a:solidFill>
-                <a:latin typeface="Calibri"/>
-              </a:rPr>
-              <a:t>▸  Una comunidad homogénea (un solo foro) sugiere un círculo cerrado propio de ese mercado</a:t>
-            </a:r>
-          </a:p>
-          <a:p>
-            <a:pPr algn="l" marL="0" indent="-228600">
-              <a:buNone/>
-            </a:pPr>
-            <a:r>
-              <a:rPr sz="1900" b="0">
-                <a:solidFill>
-                  <a:srgbClr val="333844"/>
-                </a:solidFill>
-                <a:latin typeface="Calibri"/>
-              </a:rPr>
-              <a:t>▸  Una comunidad mixta (varios foros) es candidata a red cross-foro — mismos actores, distintas plataformas</a:t>
-            </a:r>
-          </a:p>
-          <a:p>
-            <a:pPr algn="l" marL="0" indent="-228600">
-              <a:buNone/>
-            </a:pPr>
-            <a:r>
-              <a:rPr sz="1900" b="0">
-                <a:solidFill>
-                  <a:srgbClr val="333844"/>
-                </a:solidFill>
-                <a:latin typeface="Calibri"/>
-              </a:rPr>
-              <a:t>▸  TF-IDF por subforo identifica qué términos dominan cada sección temática (dumps, cashout, tutoriales...)</a:t>
-            </a:r>
-          </a:p>
-          <a:p>
-            <a:pPr algn="l" marL="0" indent="-228600">
-              <a:buNone/>
-            </a:pPr>
-            <a:r>
-              <a:rPr sz="1900" b="0">
-                <a:solidFill>
-                  <a:srgbClr val="333844"/>
-                </a:solidFill>
-                <a:latin typeface="Calibri"/>
-              </a:rPr>
-              <a:t>▸  Todo esto es reproducible sin GPU ni LLM — estadística de grafos y frecuencias de términos</a:t>
+            <a:r>
+              <a:t>21 comunidades detectadas en la componente gigante</a:t>
+            </a:r>
+          </a:p>
+          <a:p>
+            <a:r>
+              <a:t>Una comunidad homogénea (un solo foro) sugiere un círculo cerrado propio de ese mercado</a:t>
+            </a:r>
+          </a:p>
+          <a:p>
+            <a:r>
+              <a:t>Una comunidad mixta (varios foros) es candidata a red cross-foro — mismos actores, distintas plataformas</a:t>
+            </a:r>
+          </a:p>
+          <a:p>
+            <a:r>
+              <a:t>TF-IDF por subforo identifica qué términos dominan cada sección temática (dumps, cashout, tutoriales...)</a:t>
+            </a:r>
+          </a:p>
+          <a:p>
+            <a:r>
+              <a:t>Todo esto es reproducible sin GPU ni LLM — estadística de grafos y frecuencias de términos</a:t>
             </a:r>
           </a:p>
         </p:txBody>
@@ -6496,34 +6390,31 @@
           <a:bodyPr wrap="square"/>
           <a:lstStyle/>
           <a:p>
+            <a:pPr algn="ctr"/>
             <a:r>
               <a:rPr sz="1300" b="1">
                 <a:solidFill>
-                  <a:srgbClr val="E32B3D"/>
-                </a:solidFill>
-                <a:latin typeface="Calibri"/>
+                  <a:srgbClr val="CD2D37"/>
+                </a:solidFill>
+                <a:latin typeface="Arial"/>
               </a:rPr>
               <a:t>DEMO EN VIVO</a:t>
             </a:r>
           </a:p>
           <a:p>
-            <a:r>
-              <a:rPr sz="2600" b="1">
-                <a:solidFill>
-                  <a:srgbClr val="FFFFFF"/>
-                </a:solidFill>
-                <a:latin typeface="Calibri"/>
-              </a:rPr>
+            <a:pPr algn="ctr"/>
+            <a:r>
               <a:t>Demo — red y comunidades</a:t>
             </a:r>
           </a:p>
           <a:p>
+            <a:pPr algn="ctr"/>
             <a:r>
               <a:rPr sz="1400">
                 <a:solidFill>
                   <a:srgbClr val="9AA3B5"/>
                 </a:solidFill>
-                <a:latin typeface="Calibri"/>
+                <a:latin typeface="Arial"/>
               </a:rPr>
               <a:t>CardingForums/02_analisis_estructural.ipynb</a:t>
             </a:r>
@@ -6557,7 +6448,7 @@
                 <a:solidFill>
                   <a:srgbClr val="D6DAE2"/>
                 </a:solidFill>
-                <a:latin typeface="Calibri"/>
+                <a:latin typeface="Arial"/>
               </a:rPr>
               <a:t>1.  Abrir notebook 02_analisis_estructural</a:t>
             </a:r>
@@ -6568,7 +6459,7 @@
                 <a:solidFill>
                   <a:srgbClr val="D6DAE2"/>
                 </a:solidFill>
-                <a:latin typeface="Calibri"/>
+                <a:latin typeface="Arial"/>
               </a:rPr>
               <a:t>2.  Sección 3: scatter de degree vs. betweenness centrality</a:t>
             </a:r>
@@ -6579,7 +6470,7 @@
                 <a:solidFill>
                   <a:srgbClr val="D6DAE2"/>
                 </a:solidFill>
-                <a:latin typeface="Calibri"/>
+                <a:latin typeface="Arial"/>
               </a:rPr>
               <a:t>3.  Sección 4: composición de comunidades por foro</a:t>
             </a:r>
@@ -6590,7 +6481,7 @@
                 <a:solidFill>
                   <a:srgbClr val="D6DAE2"/>
                 </a:solidFill>
-                <a:latin typeface="Calibri"/>
+                <a:latin typeface="Arial"/>
               </a:rPr>
               <a:t>4.  Sección 5: visualización interactiva de los top-150 nodos</a:t>
             </a:r>
@@ -6630,34 +6521,31 @@
           <a:bodyPr wrap="square"/>
           <a:lstStyle/>
           <a:p>
+            <a:pPr algn="ctr"/>
             <a:r>
               <a:rPr sz="1300" b="1">
                 <a:solidFill>
-                  <a:srgbClr val="E32B3D"/>
-                </a:solidFill>
-                <a:latin typeface="Calibri"/>
+                  <a:srgbClr val="CD2D37"/>
+                </a:solidFill>
+                <a:latin typeface="Arial"/>
               </a:rPr>
               <a:t>SECCIÓN 4</a:t>
             </a:r>
           </a:p>
           <a:p>
-            <a:r>
-              <a:rPr sz="3000" b="1">
-                <a:solidFill>
-                  <a:srgbClr val="FFFFFF"/>
-                </a:solidFill>
-                <a:latin typeface="Calibri"/>
-              </a:rPr>
+            <a:pPr algn="ctr"/>
+            <a:r>
               <a:t>Semántica y perfilado de actores</a:t>
             </a:r>
           </a:p>
           <a:p>
+            <a:pPr algn="ctr"/>
             <a:r>
               <a:rPr sz="1600">
                 <a:solidFill>
                   <a:srgbClr val="D6DAE2"/>
                 </a:solidFill>
-                <a:latin typeface="Calibri"/>
+                <a:latin typeface="Arial"/>
               </a:rPr>
               <a:t>Notebook 03 — embeddings, NER y LLM local</a:t>
             </a:r>
@@ -6698,12 +6586,6 @@
           <a:lstStyle/>
           <a:p>
             <a:r>
-              <a:rPr sz="2400" b="1">
-                <a:solidFill>
-                  <a:srgbClr val="1A1A2E"/>
-                </a:solidFill>
-                <a:latin typeface="Calibri"/>
-              </a:rPr>
               <a:t>Embeddings — un vector por usuario</a:t>
             </a:r>
           </a:p>
@@ -6719,78 +6601,38 @@
             <p:ph type="body" idx="16" sz="quarter"/>
           </p:nvPr>
         </p:nvSpPr>
-        <p:spPr/>
+        <p:spPr>
+          <a:xfrm>
+            <a:off x="1073427" y="2077576"/>
+            <a:ext cx="10084904" cy="3507298"/>
+          </a:xfrm>
+        </p:spPr>
         <p:txBody>
           <a:bodyPr wrap="square"/>
           <a:lstStyle/>
           <a:p>
-            <a:pPr algn="l" marL="0" indent="-228600">
-              <a:buNone/>
-            </a:pPr>
-            <a:r>
-              <a:rPr sz="1900" b="0">
-                <a:solidFill>
-                  <a:srgbClr val="333844"/>
-                </a:solidFill>
-                <a:latin typeface="Calibri"/>
-              </a:rPr>
-              <a:t>▸  qwen3-embedding (4096D) vía Ollama, completamente local</a:t>
-            </a:r>
-          </a:p>
-          <a:p>
-            <a:pPr algn="l" marL="0" indent="-228600">
-              <a:buNone/>
-            </a:pPr>
-            <a:r>
-              <a:rPr sz="1900" b="0">
-                <a:solidFill>
-                  <a:srgbClr val="333844"/>
-                </a:solidFill>
-                <a:latin typeface="Calibri"/>
-              </a:rPr>
-              <a:t>▸  9,550 usuarios con ≥10 posts obtienen embedding — el resto no tiene suficiente texto para ser confiable</a:t>
-            </a:r>
-          </a:p>
-          <a:p>
-            <a:pPr algn="l" marL="0" indent="-228600">
-              <a:buNone/>
-            </a:pPr>
-            <a:r>
-              <a:rPr sz="1900" b="0">
-                <a:solidFill>
-                  <a:srgbClr val="333844"/>
-                </a:solidFill>
-                <a:latin typeface="Calibri"/>
-              </a:rPr>
-              <a:t>▸  Concatenación de posts por usuario, capada a 50K caracteres para no colgar Ollama con usuarios extremos</a:t>
-            </a:r>
-          </a:p>
-          <a:p>
-            <a:pPr algn="l" marL="0" indent="-228600">
-              <a:buNone/>
-            </a:pPr>
-            <a:r>
-              <a:rPr sz="1900" b="0">
-                <a:solidFill>
-                  <a:srgbClr val="333844"/>
-                </a:solidFill>
-                <a:latin typeface="Calibri"/>
-              </a:rPr>
-              <a:t>▸  UMAP + HDBSCAN sobre esos vectores para clustering de comportamiento de escritura</a:t>
-            </a:r>
-          </a:p>
-          <a:p>
-            <a:pPr algn="l" marL="0" indent="-228600">
-              <a:buNone/>
-            </a:pPr>
-            <a:r>
-              <a:rPr sz="1900" b="0">
-                <a:solidFill>
-                  <a:srgbClr val="333844"/>
-                </a:solidFill>
-                <a:latin typeface="Calibri"/>
-              </a:rPr>
-              <a:t>▸  BERTopic sobre el mismo corpus para topic modeling — qué temas dominan cada cluster</a:t>
+            <a:r>
+              <a:t>qwen3-embedding (4096D) vía Ollama, completamente local</a:t>
+            </a:r>
+          </a:p>
+          <a:p>
+            <a:r>
+              <a:t>9,550 usuarios con ≥10 posts obtienen embedding — el resto no tiene suficiente texto para ser confiable</a:t>
+            </a:r>
+          </a:p>
+          <a:p>
+            <a:r>
+              <a:t>Concatenación de posts por usuario, capada a 50K caracteres para no colgar Ollama con usuarios extremos</a:t>
+            </a:r>
+          </a:p>
+          <a:p>
+            <a:r>
+              <a:t>UMAP + HDBSCAN sobre esos vectores para clustering de comportamiento de escritura</a:t>
+            </a:r>
+          </a:p>
+          <a:p>
+            <a:r>
+              <a:t>BERTopic sobre el mismo corpus para topic modeling — qué temas dominan cada cluster</a:t>
             </a:r>
           </a:p>
         </p:txBody>
@@ -6829,12 +6671,6 @@
           <a:lstStyle/>
           <a:p>
             <a:r>
-              <a:rPr sz="2400" b="1">
-                <a:solidFill>
-                  <a:srgbClr val="1A1A2E"/>
-                </a:solidFill>
-                <a:latin typeface="Calibri"/>
-              </a:rPr>
               <a:t>NER + perfilado — LLM local infiriendo roles</a:t>
             </a:r>
           </a:p>
@@ -6850,78 +6686,38 @@
             <p:ph type="body" idx="16" sz="quarter"/>
           </p:nvPr>
         </p:nvSpPr>
-        <p:spPr/>
+        <p:spPr>
+          <a:xfrm>
+            <a:off x="1073427" y="2077576"/>
+            <a:ext cx="10084904" cy="3507298"/>
+          </a:xfrm>
+        </p:spPr>
         <p:txBody>
           <a:bodyPr wrap="square"/>
           <a:lstStyle/>
           <a:p>
-            <a:pPr algn="l" marL="0" indent="-228600">
-              <a:buNone/>
-            </a:pPr>
-            <a:r>
-              <a:rPr sz="1900" b="0">
-                <a:solidFill>
-                  <a:srgbClr val="333844"/>
-                </a:solidFill>
-                <a:latin typeface="Calibri"/>
-              </a:rPr>
-              <a:t>▸  qwen2.5:14b extrae entidades de dominio: TOOL, PRODUCT, PAYMENT, MARKET, CARD_TYPE, COUNTRY</a:t>
-            </a:r>
-          </a:p>
-          <a:p>
-            <a:pPr algn="l" marL="0" indent="-228600">
-              <a:buNone/>
-            </a:pPr>
-            <a:r>
-              <a:rPr sz="1900" b="0">
-                <a:solidFill>
-                  <a:srgbClr val="333844"/>
-                </a:solidFill>
-                <a:latin typeface="Calibri"/>
-              </a:rPr>
-              <a:t>▸  Perfilado limitado a los 100 usuarios más activos (según el contador de posts del propio foro)</a:t>
-            </a:r>
-          </a:p>
-          <a:p>
-            <a:pPr algn="l" marL="0" indent="-228600">
-              <a:buNone/>
-            </a:pPr>
-            <a:r>
-              <a:rPr sz="1900" b="0">
-                <a:solidFill>
-                  <a:srgbClr val="333844"/>
-                </a:solidFill>
-                <a:latin typeface="Calibri"/>
-              </a:rPr>
-              <a:t>▸  El LLM recibe centralidad, cluster semántico, entidades extraídas y muestra de posts — infiere un rol</a:t>
-            </a:r>
-          </a:p>
-          <a:p>
-            <a:pPr algn="l" marL="0" indent="-228600">
-              <a:buNone/>
-            </a:pPr>
-            <a:r>
-              <a:rPr sz="1900" b="0">
-                <a:solidFill>
-                  <a:srgbClr val="333844"/>
-                </a:solidFill>
-                <a:latin typeface="Calibri"/>
-              </a:rPr>
-              <a:t>▸  Categorías de rol: vendedor_dumps, vendedor_cvv, comprador, checker, intermediario_escrow, lurker...</a:t>
-            </a:r>
-          </a:p>
-          <a:p>
-            <a:pPr algn="l" marL="0" indent="-228600">
-              <a:buNone/>
-            </a:pPr>
-            <a:r>
-              <a:rPr sz="1900" b="0">
-                <a:solidFill>
-                  <a:srgbClr val="333844"/>
-                </a:solidFill>
-                <a:latin typeface="Calibri"/>
-              </a:rPr>
-              <a:t>▸  30 perfiles generados con confianza asociada — no es verdad de campo, es inferencia razonada</a:t>
+            <a:r>
+              <a:t>qwen2.5:14b extrae entidades de dominio: TOOL, PRODUCT, PAYMENT, MARKET, CARD_TYPE, COUNTRY</a:t>
+            </a:r>
+          </a:p>
+          <a:p>
+            <a:r>
+              <a:t>Perfilado limitado a los 100 usuarios más activos (según el contador de posts del propio foro)</a:t>
+            </a:r>
+          </a:p>
+          <a:p>
+            <a:r>
+              <a:t>El LLM recibe centralidad, cluster semántico, entidades extraídas y muestra de posts — infiere un rol</a:t>
+            </a:r>
+          </a:p>
+          <a:p>
+            <a:r>
+              <a:t>Categorías de rol: vendedor_dumps, vendedor_cvv, comprador, checker, intermediario_escrow, lurker...</a:t>
+            </a:r>
+          </a:p>
+          <a:p>
+            <a:r>
+              <a:t>30 perfiles generados con confianza asociada — no es verdad de campo, es inferencia razonada</a:t>
             </a:r>
           </a:p>
         </p:txBody>
@@ -6960,12 +6756,6 @@
           <a:lstStyle/>
           <a:p>
             <a:r>
-              <a:rPr sz="2400" b="1">
-                <a:solidFill>
-                  <a:srgbClr val="1A1A2E"/>
-                </a:solidFill>
-                <a:latin typeface="Calibri"/>
-              </a:rPr>
               <a:t>Distribución de roles inferidos (30 perfiles)</a:t>
             </a:r>
           </a:p>
@@ -6996,14 +6786,14 @@
         </p:nvSpPr>
         <p:spPr>
           <a:xfrm>
-            <a:off x="1051560" y="1645920"/>
+            <a:off x="1051560" y="2148840"/>
             <a:ext cx="10058400" cy="365760"/>
           </a:xfrm>
           <a:prstGeom prst="rect">
             <a:avLst/>
           </a:prstGeom>
           <a:solidFill>
-            <a:srgbClr val="E32B3D"/>
+            <a:srgbClr val="CD2D37"/>
           </a:solidFill>
           <a:ln>
             <a:noFill/>
@@ -7039,7 +6829,7 @@
         </p:nvSpPr>
         <p:spPr>
           <a:xfrm>
-            <a:off x="1097280" y="1700920"/>
+            <a:off x="1097280" y="2203840"/>
             <a:ext cx="3261360" cy="365760"/>
           </a:xfrm>
           <a:prstGeom prst="rect">
@@ -7059,7 +6849,7 @@
                 <a:solidFill>
                   <a:srgbClr val="FFFFFF"/>
                 </a:solidFill>
-                <a:latin typeface="Calibri"/>
+                <a:latin typeface="Arial"/>
               </a:rPr>
               <a:t>Rol</a:t>
             </a:r>
@@ -7074,7 +6864,7 @@
         </p:nvSpPr>
         <p:spPr>
           <a:xfrm>
-            <a:off x="4450080" y="1700920"/>
+            <a:off x="4450080" y="2203840"/>
             <a:ext cx="3261360" cy="365760"/>
           </a:xfrm>
           <a:prstGeom prst="rect">
@@ -7094,7 +6884,7 @@
                 <a:solidFill>
                   <a:srgbClr val="FFFFFF"/>
                 </a:solidFill>
-                <a:latin typeface="Calibri"/>
+                <a:latin typeface="Arial"/>
               </a:rPr>
               <a:t>Usuarios</a:t>
             </a:r>
@@ -7109,7 +6899,7 @@
         </p:nvSpPr>
         <p:spPr>
           <a:xfrm>
-            <a:off x="7802880" y="1700920"/>
+            <a:off x="7802880" y="2203840"/>
             <a:ext cx="3261360" cy="365760"/>
           </a:xfrm>
           <a:prstGeom prst="rect">
@@ -7129,7 +6919,7 @@
                 <a:solidFill>
                   <a:srgbClr val="FFFFFF"/>
                 </a:solidFill>
-                <a:latin typeface="Calibri"/>
+                <a:latin typeface="Arial"/>
               </a:rPr>
               <a:t>Confianza típica</a:t>
             </a:r>
@@ -7144,7 +6934,7 @@
         </p:nvSpPr>
         <p:spPr>
           <a:xfrm>
-            <a:off x="1051560" y="2011680"/>
+            <a:off x="1051560" y="2514600"/>
             <a:ext cx="10058400" cy="310896"/>
           </a:xfrm>
           <a:prstGeom prst="rect">
@@ -7187,7 +6977,7 @@
         </p:nvSpPr>
         <p:spPr>
           <a:xfrm>
-            <a:off x="1097280" y="2051680"/>
+            <a:off x="1097280" y="2554600"/>
             <a:ext cx="3261360" cy="310896"/>
           </a:xfrm>
           <a:prstGeom prst="rect">
@@ -7205,9 +6995,9 @@
             <a:r>
               <a:rPr sz="1100" b="0">
                 <a:solidFill>
-                  <a:srgbClr val="333844"/>
-                </a:solidFill>
-                <a:latin typeface="Calibri"/>
+                  <a:srgbClr val="465461"/>
+                </a:solidFill>
+                <a:latin typeface="Arial"/>
               </a:rPr>
               <a:t>lurker</a:t>
             </a:r>
@@ -7222,7 +7012,7 @@
         </p:nvSpPr>
         <p:spPr>
           <a:xfrm>
-            <a:off x="4450080" y="2051680"/>
+            <a:off x="4450080" y="2554600"/>
             <a:ext cx="3261360" cy="310896"/>
           </a:xfrm>
           <a:prstGeom prst="rect">
@@ -7240,9 +7030,9 @@
             <a:r>
               <a:rPr sz="1100" b="0">
                 <a:solidFill>
-                  <a:srgbClr val="333844"/>
-                </a:solidFill>
-                <a:latin typeface="Calibri"/>
+                  <a:srgbClr val="465461"/>
+                </a:solidFill>
+                <a:latin typeface="Arial"/>
               </a:rPr>
               <a:t>20</a:t>
             </a:r>
@@ -7257,7 +7047,7 @@
         </p:nvSpPr>
         <p:spPr>
           <a:xfrm>
-            <a:off x="7802880" y="2051680"/>
+            <a:off x="7802880" y="2554600"/>
             <a:ext cx="3261360" cy="310896"/>
           </a:xfrm>
           <a:prstGeom prst="rect">
@@ -7275,9 +7065,9 @@
             <a:r>
               <a:rPr sz="1100" b="0">
                 <a:solidFill>
-                  <a:srgbClr val="333844"/>
-                </a:solidFill>
-                <a:latin typeface="Calibri"/>
+                  <a:srgbClr val="465461"/>
+                </a:solidFill>
+                <a:latin typeface="Arial"/>
               </a:rPr>
               <a:t>0.85–0.95</a:t>
             </a:r>
@@ -7292,7 +7082,7 @@
         </p:nvSpPr>
         <p:spPr>
           <a:xfrm>
-            <a:off x="1051560" y="2322576"/>
+            <a:off x="1051560" y="2825496"/>
             <a:ext cx="10058400" cy="310896"/>
           </a:xfrm>
           <a:prstGeom prst="rect">
@@ -7335,7 +7125,7 @@
         </p:nvSpPr>
         <p:spPr>
           <a:xfrm>
-            <a:off x="1097280" y="2362576"/>
+            <a:off x="1097280" y="2865496"/>
             <a:ext cx="3261360" cy="310896"/>
           </a:xfrm>
           <a:prstGeom prst="rect">
@@ -7353,9 +7143,9 @@
             <a:r>
               <a:rPr sz="1100" b="0">
                 <a:solidFill>
-                  <a:srgbClr val="333844"/>
-                </a:solidFill>
-                <a:latin typeface="Calibri"/>
+                  <a:srgbClr val="465461"/>
+                </a:solidFill>
+                <a:latin typeface="Arial"/>
               </a:rPr>
               <a:t>comprador</a:t>
             </a:r>
@@ -7370,7 +7160,7 @@
         </p:nvSpPr>
         <p:spPr>
           <a:xfrm>
-            <a:off x="4450080" y="2362576"/>
+            <a:off x="4450080" y="2865496"/>
             <a:ext cx="3261360" cy="310896"/>
           </a:xfrm>
           <a:prstGeom prst="rect">
@@ -7388,9 +7178,9 @@
             <a:r>
               <a:rPr sz="1100" b="0">
                 <a:solidFill>
-                  <a:srgbClr val="333844"/>
-                </a:solidFill>
-                <a:latin typeface="Calibri"/>
+                  <a:srgbClr val="465461"/>
+                </a:solidFill>
+                <a:latin typeface="Arial"/>
               </a:rPr>
               <a:t>3</a:t>
             </a:r>
@@ -7405,7 +7195,7 @@
         </p:nvSpPr>
         <p:spPr>
           <a:xfrm>
-            <a:off x="7802880" y="2362576"/>
+            <a:off x="7802880" y="2865496"/>
             <a:ext cx="3261360" cy="310896"/>
           </a:xfrm>
           <a:prstGeom prst="rect">
@@ -7423,9 +7213,9 @@
             <a:r>
               <a:rPr sz="1100" b="0">
                 <a:solidFill>
-                  <a:srgbClr val="333844"/>
-                </a:solidFill>
-                <a:latin typeface="Calibri"/>
+                  <a:srgbClr val="465461"/>
+                </a:solidFill>
+                <a:latin typeface="Arial"/>
               </a:rPr>
               <a:t>0.70–0.85</a:t>
             </a:r>
@@ -7440,7 +7230,7 @@
         </p:nvSpPr>
         <p:spPr>
           <a:xfrm>
-            <a:off x="1051560" y="2633472"/>
+            <a:off x="1051560" y="3136391"/>
             <a:ext cx="10058400" cy="310896"/>
           </a:xfrm>
           <a:prstGeom prst="rect">
@@ -7483,7 +7273,7 @@
         </p:nvSpPr>
         <p:spPr>
           <a:xfrm>
-            <a:off x="1097280" y="2673472"/>
+            <a:off x="1097280" y="3176391"/>
             <a:ext cx="3261360" cy="310896"/>
           </a:xfrm>
           <a:prstGeom prst="rect">
@@ -7501,9 +7291,9 @@
             <a:r>
               <a:rPr sz="1100" b="0">
                 <a:solidFill>
-                  <a:srgbClr val="333844"/>
-                </a:solidFill>
-                <a:latin typeface="Calibri"/>
+                  <a:srgbClr val="465461"/>
+                </a:solidFill>
+                <a:latin typeface="Arial"/>
               </a:rPr>
               <a:t>intermediario_escrow</a:t>
             </a:r>
@@ -7518,7 +7308,7 @@
         </p:nvSpPr>
         <p:spPr>
           <a:xfrm>
-            <a:off x="4450080" y="2673472"/>
+            <a:off x="4450080" y="3176391"/>
             <a:ext cx="3261360" cy="310896"/>
           </a:xfrm>
           <a:prstGeom prst="rect">
@@ -7536,9 +7326,9 @@
             <a:r>
               <a:rPr sz="1100" b="0">
                 <a:solidFill>
-                  <a:srgbClr val="333844"/>
-                </a:solidFill>
-                <a:latin typeface="Calibri"/>
+                  <a:srgbClr val="465461"/>
+                </a:solidFill>
+                <a:latin typeface="Arial"/>
               </a:rPr>
               <a:t>3</a:t>
             </a:r>
@@ -7553,7 +7343,7 @@
         </p:nvSpPr>
         <p:spPr>
           <a:xfrm>
-            <a:off x="7802880" y="2673472"/>
+            <a:off x="7802880" y="3176391"/>
             <a:ext cx="3261360" cy="310896"/>
           </a:xfrm>
           <a:prstGeom prst="rect">
@@ -7571,9 +7361,9 @@
             <a:r>
               <a:rPr sz="1100" b="0">
                 <a:solidFill>
-                  <a:srgbClr val="333844"/>
-                </a:solidFill>
-                <a:latin typeface="Calibri"/>
+                  <a:srgbClr val="465461"/>
+                </a:solidFill>
+                <a:latin typeface="Arial"/>
               </a:rPr>
               <a:t>0.70–0.85</a:t>
             </a:r>
@@ -7588,7 +7378,7 @@
         </p:nvSpPr>
         <p:spPr>
           <a:xfrm>
-            <a:off x="1051560" y="2944368"/>
+            <a:off x="1051560" y="3447287"/>
             <a:ext cx="10058400" cy="310896"/>
           </a:xfrm>
           <a:prstGeom prst="rect">
@@ -7631,7 +7421,7 @@
         </p:nvSpPr>
         <p:spPr>
           <a:xfrm>
-            <a:off x="1097280" y="2984368"/>
+            <a:off x="1097280" y="3487287"/>
             <a:ext cx="3261360" cy="310896"/>
           </a:xfrm>
           <a:prstGeom prst="rect">
@@ -7649,9 +7439,9 @@
             <a:r>
               <a:rPr sz="1100" b="0">
                 <a:solidFill>
-                  <a:srgbClr val="333844"/>
-                </a:solidFill>
-                <a:latin typeface="Calibri"/>
+                  <a:srgbClr val="465461"/>
+                </a:solidFill>
+                <a:latin typeface="Arial"/>
               </a:rPr>
               <a:t>indeterminado</a:t>
             </a:r>
@@ -7666,7 +7456,7 @@
         </p:nvSpPr>
         <p:spPr>
           <a:xfrm>
-            <a:off x="4450080" y="2984368"/>
+            <a:off x="4450080" y="3487287"/>
             <a:ext cx="3261360" cy="310896"/>
           </a:xfrm>
           <a:prstGeom prst="rect">
@@ -7684,9 +7474,9 @@
             <a:r>
               <a:rPr sz="1100" b="0">
                 <a:solidFill>
-                  <a:srgbClr val="333844"/>
-                </a:solidFill>
-                <a:latin typeface="Calibri"/>
+                  <a:srgbClr val="465461"/>
+                </a:solidFill>
+                <a:latin typeface="Arial"/>
               </a:rPr>
               <a:t>2</a:t>
             </a:r>
@@ -7701,7 +7491,7 @@
         </p:nvSpPr>
         <p:spPr>
           <a:xfrm>
-            <a:off x="7802880" y="2984368"/>
+            <a:off x="7802880" y="3487287"/>
             <a:ext cx="3261360" cy="310896"/>
           </a:xfrm>
           <a:prstGeom prst="rect">
@@ -7719,9 +7509,9 @@
             <a:r>
               <a:rPr sz="1100" b="0">
                 <a:solidFill>
-                  <a:srgbClr val="333844"/>
-                </a:solidFill>
-                <a:latin typeface="Calibri"/>
+                  <a:srgbClr val="465461"/>
+                </a:solidFill>
+                <a:latin typeface="Arial"/>
               </a:rPr>
               <a:t>0.50–0.65</a:t>
             </a:r>
@@ -7736,7 +7526,7 @@
         </p:nvSpPr>
         <p:spPr>
           <a:xfrm>
-            <a:off x="1051560" y="3255263"/>
+            <a:off x="1051560" y="3758183"/>
             <a:ext cx="10058400" cy="310896"/>
           </a:xfrm>
           <a:prstGeom prst="rect">
@@ -7779,7 +7569,7 @@
         </p:nvSpPr>
         <p:spPr>
           <a:xfrm>
-            <a:off x="1097280" y="3295263"/>
+            <a:off x="1097280" y="3798183"/>
             <a:ext cx="3261360" cy="310896"/>
           </a:xfrm>
           <a:prstGeom prst="rect">
@@ -7797,9 +7587,9 @@
             <a:r>
               <a:rPr sz="1100" b="0">
                 <a:solidFill>
-                  <a:srgbClr val="333844"/>
-                </a:solidFill>
-                <a:latin typeface="Calibri"/>
+                  <a:srgbClr val="465461"/>
+                </a:solidFill>
+                <a:latin typeface="Arial"/>
               </a:rPr>
               <a:t>vendedor_dumps</a:t>
             </a:r>
@@ -7814,7 +7604,7 @@
         </p:nvSpPr>
         <p:spPr>
           <a:xfrm>
-            <a:off x="4450080" y="3295263"/>
+            <a:off x="4450080" y="3798183"/>
             <a:ext cx="3261360" cy="310896"/>
           </a:xfrm>
           <a:prstGeom prst="rect">
@@ -7832,9 +7622,9 @@
             <a:r>
               <a:rPr sz="1100" b="0">
                 <a:solidFill>
-                  <a:srgbClr val="333844"/>
-                </a:solidFill>
-                <a:latin typeface="Calibri"/>
+                  <a:srgbClr val="465461"/>
+                </a:solidFill>
+                <a:latin typeface="Arial"/>
               </a:rPr>
               <a:t>1</a:t>
             </a:r>
@@ -7849,7 +7639,7 @@
         </p:nvSpPr>
         <p:spPr>
           <a:xfrm>
-            <a:off x="7802880" y="3295263"/>
+            <a:off x="7802880" y="3798183"/>
             <a:ext cx="3261360" cy="310896"/>
           </a:xfrm>
           <a:prstGeom prst="rect">
@@ -7867,9 +7657,9 @@
             <a:r>
               <a:rPr sz="1100" b="0">
                 <a:solidFill>
-                  <a:srgbClr val="333844"/>
-                </a:solidFill>
-                <a:latin typeface="Calibri"/>
+                  <a:srgbClr val="465461"/>
+                </a:solidFill>
+                <a:latin typeface="Arial"/>
               </a:rPr>
               <a:t>0.80</a:t>
             </a:r>
@@ -7884,7 +7674,7 @@
         </p:nvSpPr>
         <p:spPr>
           <a:xfrm>
-            <a:off x="1051560" y="3566159"/>
+            <a:off x="1051560" y="4069079"/>
             <a:ext cx="10058400" cy="310896"/>
           </a:xfrm>
           <a:prstGeom prst="rect">
@@ -7927,7 +7717,7 @@
         </p:nvSpPr>
         <p:spPr>
           <a:xfrm>
-            <a:off x="1097280" y="3606159"/>
+            <a:off x="1097280" y="4109079"/>
             <a:ext cx="3261360" cy="310896"/>
           </a:xfrm>
           <a:prstGeom prst="rect">
@@ -7945,9 +7735,9 @@
             <a:r>
               <a:rPr sz="1100" b="0">
                 <a:solidFill>
-                  <a:srgbClr val="333844"/>
-                </a:solidFill>
-                <a:latin typeface="Calibri"/>
+                  <a:srgbClr val="465461"/>
+                </a:solidFill>
+                <a:latin typeface="Arial"/>
               </a:rPr>
               <a:t>checker</a:t>
             </a:r>
@@ -7962,7 +7752,7 @@
         </p:nvSpPr>
         <p:spPr>
           <a:xfrm>
-            <a:off x="4450080" y="3606159"/>
+            <a:off x="4450080" y="4109079"/>
             <a:ext cx="3261360" cy="310896"/>
           </a:xfrm>
           <a:prstGeom prst="rect">
@@ -7980,9 +7770,9 @@
             <a:r>
               <a:rPr sz="1100" b="0">
                 <a:solidFill>
-                  <a:srgbClr val="333844"/>
-                </a:solidFill>
-                <a:latin typeface="Calibri"/>
+                  <a:srgbClr val="465461"/>
+                </a:solidFill>
+                <a:latin typeface="Arial"/>
               </a:rPr>
               <a:t>1</a:t>
             </a:r>
@@ -7997,7 +7787,7 @@
         </p:nvSpPr>
         <p:spPr>
           <a:xfrm>
-            <a:off x="7802880" y="3606159"/>
+            <a:off x="7802880" y="4109079"/>
             <a:ext cx="3261360" cy="310896"/>
           </a:xfrm>
           <a:prstGeom prst="rect">
@@ -8015,9 +7805,9 @@
             <a:r>
               <a:rPr sz="1100" b="0">
                 <a:solidFill>
-                  <a:srgbClr val="333844"/>
-                </a:solidFill>
-                <a:latin typeface="Calibri"/>
+                  <a:srgbClr val="465461"/>
+                </a:solidFill>
+                <a:latin typeface="Arial"/>
               </a:rPr>
               <a:t>0.75</a:t>
             </a:r>
@@ -8052,7 +7842,7 @@
                 <a:solidFill>
                   <a:srgbClr val="707888"/>
                 </a:solidFill>
-                <a:latin typeface="Calibri"/>
+                <a:latin typeface="Arial"/>
               </a:rPr>
               <a:t>ℹ  La mayoría de los top-100 por contador de posts terminan clasificados como lurker — ver limitación en la siguiente slide.</a:t>
             </a:r>
@@ -8093,12 +7883,6 @@
           <a:lstStyle/>
           <a:p>
             <a:r>
-              <a:rPr sz="2400" b="1">
-                <a:solidFill>
-                  <a:srgbClr val="1A1A2E"/>
-                </a:solidFill>
-                <a:latin typeface="Calibri"/>
-              </a:rPr>
               <a:t>Una limitación honesta — el contador de posts miente</a:t>
             </a:r>
           </a:p>
@@ -8114,78 +7898,38 @@
             <p:ph type="body" idx="16" sz="quarter"/>
           </p:nvPr>
         </p:nvSpPr>
-        <p:spPr/>
+        <p:spPr>
+          <a:xfrm>
+            <a:off x="1073427" y="2580496"/>
+            <a:ext cx="10084904" cy="3004378"/>
+          </a:xfrm>
+        </p:spPr>
         <p:txBody>
           <a:bodyPr wrap="square"/>
           <a:lstStyle/>
           <a:p>
-            <a:pPr algn="l" marL="0" indent="-228600">
-              <a:buNone/>
-            </a:pPr>
-            <a:r>
-              <a:rPr sz="1900" b="0">
-                <a:solidFill>
-                  <a:srgbClr val="333844"/>
-                </a:solidFill>
-                <a:latin typeface="Calibri"/>
-              </a:rPr>
-              <a:t>▸  El perfilado selecciona a los usuarios por el campo posts de la tabla user del propio vBulletin</a:t>
-            </a:r>
-          </a:p>
-          <a:p>
-            <a:pPr algn="l" marL="0" indent="-228600">
-              <a:buNone/>
-            </a:pPr>
-            <a:r>
-              <a:rPr sz="1900" b="0">
-                <a:solidFill>
-                  <a:srgbClr val="333844"/>
-                </a:solidFill>
-                <a:latin typeface="Calibri"/>
-              </a:rPr>
-              <a:t>▸  Ese contador es un valor almacenado por el foro, no un recuento verificado contra la tabla post real</a:t>
-            </a:r>
-          </a:p>
-          <a:p>
-            <a:pPr algn="l" marL="0" indent="-228600">
-              <a:buNone/>
-            </a:pPr>
-            <a:r>
-              <a:rPr sz="1900" b="0">
-                <a:solidFill>
-                  <a:srgbClr val="333844"/>
-                </a:solidFill>
-                <a:latin typeface="Calibri"/>
-              </a:rPr>
-              <a:t>▸  Resultado: varios de los 'top 100 más activos' aparecen en el corpus con 0 posts extraídos</a:t>
-            </a:r>
-          </a:p>
-          <a:p>
-            <a:pPr algn="l" marL="0" indent="-228600">
-              <a:buNone/>
-            </a:pPr>
-            <a:r>
-              <a:rPr sz="1900" b="0">
-                <a:solidFill>
-                  <a:srgbClr val="333844"/>
-                </a:solidFill>
-                <a:latin typeface="Calibri"/>
-              </a:rPr>
-              <a:t>▸  El LLM los clasifica como lurker con alta confianza — pero es lurker por falta de datos, no por comportamiento real</a:t>
-            </a:r>
-          </a:p>
-          <a:p>
-            <a:pPr algn="l" marL="0" indent="-228600">
-              <a:buNone/>
-            </a:pPr>
-            <a:r>
-              <a:rPr sz="1900" b="0">
-                <a:solidFill>
-                  <a:srgbClr val="333844"/>
-                </a:solidFill>
-                <a:latin typeface="Calibri"/>
-              </a:rPr>
-              <a:t>▸  Lección: un contador de actividad propio del sistema origen puede estar desactualizado o ser directamente falso</a:t>
+            <a:r>
+              <a:t>El perfilado selecciona a los usuarios por el campo posts de la tabla user del propio vBulletin</a:t>
+            </a:r>
+          </a:p>
+          <a:p>
+            <a:r>
+              <a:t>Ese contador es un valor almacenado por el foro, no un recuento verificado contra la tabla post real</a:t>
+            </a:r>
+          </a:p>
+          <a:p>
+            <a:r>
+              <a:t>Resultado: varios de los 'top 100 más activos' aparecen en el corpus con 0 posts extraídos</a:t>
+            </a:r>
+          </a:p>
+          <a:p>
+            <a:r>
+              <a:t>El LLM los clasifica como lurker con alta confianza — pero es lurker por falta de datos, no por comportamiento real</a:t>
+            </a:r>
+          </a:p>
+          <a:p>
+            <a:r>
+              <a:t>Lección: un contador de actividad propio del sistema origen puede estar desactualizado o ser directamente falso</a:t>
             </a:r>
           </a:p>
         </p:txBody>
@@ -8223,34 +7967,31 @@
           <a:bodyPr wrap="square"/>
           <a:lstStyle/>
           <a:p>
+            <a:pPr algn="ctr"/>
             <a:r>
               <a:rPr sz="1300" b="1">
                 <a:solidFill>
-                  <a:srgbClr val="E32B3D"/>
-                </a:solidFill>
-                <a:latin typeface="Calibri"/>
+                  <a:srgbClr val="CD2D37"/>
+                </a:solidFill>
+                <a:latin typeface="Arial"/>
               </a:rPr>
               <a:t>SECCIÓN 5</a:t>
             </a:r>
           </a:p>
           <a:p>
-            <a:r>
-              <a:rPr sz="3000" b="1">
-                <a:solidFill>
-                  <a:srgbClr val="FFFFFF"/>
-                </a:solidFill>
-                <a:latin typeface="Calibri"/>
-              </a:rPr>
+            <a:pPr algn="ctr"/>
+            <a:r>
               <a:t>Conclusiones y aprendizajes</a:t>
             </a:r>
           </a:p>
           <a:p>
+            <a:pPr algn="ctr"/>
             <a:r>
               <a:rPr sz="1600">
                 <a:solidFill>
                   <a:srgbClr val="D6DAE2"/>
                 </a:solidFill>
-                <a:latin typeface="Calibri"/>
+                <a:latin typeface="Arial"/>
               </a:rPr>
               <a:t>Qué nos enseña el caso Carding Forums</a:t>
             </a:r>
@@ -8290,34 +8031,31 @@
           <a:bodyPr wrap="square"/>
           <a:lstStyle/>
           <a:p>
+            <a:pPr algn="ctr"/>
             <a:r>
               <a:rPr sz="1300" b="1">
                 <a:solidFill>
-                  <a:srgbClr val="E32B3D"/>
-                </a:solidFill>
-                <a:latin typeface="Calibri"/>
+                  <a:srgbClr val="CD2D37"/>
+                </a:solidFill>
+                <a:latin typeface="Arial"/>
               </a:rPr>
               <a:t>SECCIÓN 1</a:t>
             </a:r>
           </a:p>
           <a:p>
-            <a:r>
-              <a:rPr sz="3000" b="1">
-                <a:solidFill>
-                  <a:srgbClr val="FFFFFF"/>
-                </a:solidFill>
-                <a:latin typeface="Calibri"/>
-              </a:rPr>
+            <a:pPr algn="ctr"/>
+            <a:r>
               <a:t>Datasets y formatos</a:t>
             </a:r>
           </a:p>
           <a:p>
+            <a:pPr algn="ctr"/>
             <a:r>
               <a:rPr sz="1600">
                 <a:solidFill>
                   <a:srgbClr val="D6DAE2"/>
                 </a:solidFill>
-                <a:latin typeface="Calibri"/>
+                <a:latin typeface="Arial"/>
               </a:rPr>
               <a:t>Diez archivos, tres formatos, un duplicado escondido</a:t>
             </a:r>
@@ -8358,12 +8096,6 @@
           <a:lstStyle/>
           <a:p>
             <a:r>
-              <a:rPr sz="2400" b="1">
-                <a:solidFill>
-                  <a:srgbClr val="1A1A2E"/>
-                </a:solidFill>
-                <a:latin typeface="Calibri"/>
-              </a:rPr>
               <a:t>Resumen ejecutivo</a:t>
             </a:r>
           </a:p>
@@ -8412,9 +8144,9 @@
             <a:r>
               <a:rPr sz="1600" b="1">
                 <a:solidFill>
-                  <a:srgbClr val="E32B3D"/>
-                </a:solidFill>
-                <a:latin typeface="Calibri"/>
+                  <a:srgbClr val="CD2D37"/>
+                </a:solidFill>
+                <a:latin typeface="Arial"/>
               </a:rPr>
               <a:t>Hallazgos técnicos</a:t>
             </a:r>
@@ -8446,9 +8178,9 @@
             <a:r>
               <a:rPr sz="1600">
                 <a:solidFill>
-                  <a:srgbClr val="333844"/>
-                </a:solidFill>
-                <a:latin typeface="Calibri"/>
+                  <a:srgbClr val="465461"/>
+                </a:solidFill>
+                <a:latin typeface="Arial"/>
               </a:rPr>
               <a:t>▸  Un dump duplicado bajo dos nombres distintos — verificar contenido, no solo el nombre del archivo</a:t>
             </a:r>
@@ -8457,9 +8189,9 @@
             <a:r>
               <a:rPr sz="1600">
                 <a:solidFill>
-                  <a:srgbClr val="333844"/>
-                </a:solidFill>
-                <a:latin typeface="Calibri"/>
+                  <a:srgbClr val="465461"/>
+                </a:solidFill>
+                <a:latin typeface="Arial"/>
               </a:rPr>
               <a:t>▸  Un formato flat file escondido entre dumps SQL — el auto-detect de parser es imprescindible</a:t>
             </a:r>
@@ -8468,9 +8200,9 @@
             <a:r>
               <a:rPr sz="1600">
                 <a:solidFill>
-                  <a:srgbClr val="333844"/>
-                </a:solidFill>
-                <a:latin typeface="Calibri"/>
+                  <a:srgbClr val="465461"/>
+                </a:solidFill>
+                <a:latin typeface="Arial"/>
               </a:rPr>
               <a:t>▸  178K registros con timestamp inválido — el patrón epoch-0 aparece en todos los casos del curso</a:t>
             </a:r>
@@ -8479,9 +8211,9 @@
             <a:r>
               <a:rPr sz="1600">
                 <a:solidFill>
-                  <a:srgbClr val="333844"/>
-                </a:solidFill>
-                <a:latin typeface="Calibri"/>
+                  <a:srgbClr val="465461"/>
+                </a:solidFill>
+                <a:latin typeface="Arial"/>
               </a:rPr>
               <a:t>▸  11,113 usuarios en la componente gigante de la red, 21 comunidades vía Louvain</a:t>
             </a:r>
@@ -8490,9 +8222,9 @@
             <a:r>
               <a:rPr sz="1600">
                 <a:solidFill>
-                  <a:srgbClr val="333844"/>
-                </a:solidFill>
-                <a:latin typeface="Calibri"/>
+                  <a:srgbClr val="465461"/>
+                </a:solidFill>
+                <a:latin typeface="Arial"/>
               </a:rPr>
               <a:t>▸  9,550 usuarios embebidos con qwen3-embedding para clustering semántico</a:t>
             </a:r>
@@ -8525,9 +8257,9 @@
             <a:r>
               <a:rPr sz="1600" b="1">
                 <a:solidFill>
-                  <a:srgbClr val="E32B3D"/>
-                </a:solidFill>
-                <a:latin typeface="Calibri"/>
+                  <a:srgbClr val="CD2D37"/>
+                </a:solidFill>
+                <a:latin typeface="Arial"/>
               </a:rPr>
               <a:t>Aprendizajes metodológicos</a:t>
             </a:r>
@@ -8559,9 +8291,9 @@
             <a:r>
               <a:rPr sz="1600">
                 <a:solidFill>
-                  <a:srgbClr val="333844"/>
-                </a:solidFill>
-                <a:latin typeface="Calibri"/>
+                  <a:srgbClr val="465461"/>
+                </a:solidFill>
+                <a:latin typeface="Arial"/>
               </a:rPr>
               <a:t>▸  load_forum() con auto-detección de formato es la única forma segura de procesar un lote heterogéneo</a:t>
             </a:r>
@@ -8570,9 +8302,9 @@
             <a:r>
               <a:rPr sz="1600">
                 <a:solidFill>
-                  <a:srgbClr val="333844"/>
-                </a:solidFill>
-                <a:latin typeface="Calibri"/>
+                  <a:srgbClr val="465461"/>
+                </a:solidFill>
+                <a:latin typeface="Arial"/>
               </a:rPr>
               <a:t>▸  Validar rango de fechas y deduplicar antes de cualquier análisis temporal o de red</a:t>
             </a:r>
@@ -8581,9 +8313,9 @@
             <a:r>
               <a:rPr sz="1600">
                 <a:solidFill>
-                  <a:srgbClr val="333844"/>
-                </a:solidFill>
-                <a:latin typeface="Calibri"/>
+                  <a:srgbClr val="465461"/>
+                </a:solidFill>
+                <a:latin typeface="Arial"/>
               </a:rPr>
               <a:t>▸  Un contador de actividad del sistema origen no sustituye contar directamente sobre los datos limpios</a:t>
             </a:r>
@@ -8592,9 +8324,9 @@
             <a:r>
               <a:rPr sz="1600">
                 <a:solidFill>
-                  <a:srgbClr val="333844"/>
-                </a:solidFill>
-                <a:latin typeface="Calibri"/>
+                  <a:srgbClr val="465461"/>
+                </a:solidFill>
+                <a:latin typeface="Arial"/>
               </a:rPr>
               <a:t>▸  El LLM local puede perfilar roles, pero la confianza reportada depende de la calidad del input</a:t>
             </a:r>
@@ -8603,9 +8335,9 @@
             <a:r>
               <a:rPr sz="1600">
                 <a:solidFill>
-                  <a:srgbClr val="333844"/>
-                </a:solidFill>
-                <a:latin typeface="Calibri"/>
+                  <a:srgbClr val="465461"/>
+                </a:solidFill>
+                <a:latin typeface="Arial"/>
               </a:rPr>
               <a:t>▸  Todo el pipeline corre sin mandar un solo post a una API externa</a:t>
             </a:r>
@@ -8646,12 +8378,6 @@
           <a:lstStyle/>
           <a:p>
             <a:r>
-              <a:rPr sz="2400" b="1">
-                <a:solidFill>
-                  <a:srgbClr val="1A1A2E"/>
-                </a:solidFill>
-                <a:latin typeface="Calibri"/>
-              </a:rPr>
               <a:t>¿Por qué este caso importa?</a:t>
             </a:r>
           </a:p>
@@ -8667,64 +8393,33 @@
             <p:ph type="body" idx="16" sz="quarter"/>
           </p:nvPr>
         </p:nvSpPr>
-        <p:spPr/>
+        <p:spPr>
+          <a:xfrm>
+            <a:off x="1073427" y="2077576"/>
+            <a:ext cx="10084904" cy="3507298"/>
+          </a:xfrm>
+        </p:spPr>
         <p:txBody>
           <a:bodyPr wrap="square"/>
           <a:lstStyle/>
           <a:p>
-            <a:pPr algn="l" marL="0" indent="-228600">
-              <a:buNone/>
-            </a:pPr>
-            <a:r>
-              <a:rPr sz="1900" b="0">
-                <a:solidFill>
-                  <a:srgbClr val="333844"/>
-                </a:solidFill>
-                <a:latin typeface="Calibri"/>
-              </a:rPr>
-              <a:t>▸  Es el caso más grande en volumen de usuarios del curso — pone a prueba el pipeline a escala</a:t>
-            </a:r>
-          </a:p>
-          <a:p>
-            <a:pPr algn="l" marL="0" indent="-228600">
-              <a:buNone/>
-            </a:pPr>
-            <a:r>
-              <a:rPr sz="1900" b="0">
-                <a:solidFill>
-                  <a:srgbClr val="333844"/>
-                </a:solidFill>
-                <a:latin typeface="Calibri"/>
-              </a:rPr>
-              <a:t>▸  Combina los tres formatos vistos en el curso: vBulletin estándar, vBulletin con encoding no-UTF8, flat file</a:t>
-            </a:r>
-          </a:p>
-          <a:p>
-            <a:pPr algn="l" marL="0" indent="-228600">
-              <a:buNone/>
-            </a:pPr>
-            <a:r>
-              <a:rPr sz="1900" b="0">
-                <a:solidFill>
-                  <a:srgbClr val="333844"/>
-                </a:solidFill>
-                <a:latin typeface="Calibri"/>
-              </a:rPr>
-              <a:t>▸  Demuestra que la ingeniería de datos (deduplicar, validar, auto-detectar formato) determina la calidad de todo lo que viene después</a:t>
-            </a:r>
-          </a:p>
-          <a:p>
-            <a:pPr algn="l" marL="0" indent="-228600">
-              <a:buNone/>
-            </a:pPr>
-            <a:r>
-              <a:rPr sz="1900" b="0">
-                <a:solidFill>
-                  <a:srgbClr val="333844"/>
-                </a:solidFill>
-                <a:latin typeface="Calibri"/>
-              </a:rPr>
-              <a:t>▸  El perfilado de roles con LLM local muestra tanto el potencial como los límites de inferir comportamiento desde metadatos incompletos</a:t>
+            <a:r>
+              <a:t>Es el caso más grande en volumen de usuarios del curso — pone a prueba el pipeline a escala</a:t>
+            </a:r>
+          </a:p>
+          <a:p>
+            <a:r>
+              <a:t>Combina los tres formatos vistos en el curso: vBulletin estándar, vBulletin con encoding no-UTF8, flat file</a:t>
+            </a:r>
+          </a:p>
+          <a:p>
+            <a:r>
+              <a:t>Demuestra que la ingeniería de datos (deduplicar, validar, auto-detectar formato) determina la calidad de todo lo que viene después</a:t>
+            </a:r>
+          </a:p>
+          <a:p>
+            <a:r>
+              <a:t>El perfilado de roles con LLM local muestra tanto el potencial como los límites de inferir comportamiento desde metadatos incompletos</a:t>
             </a:r>
           </a:p>
         </p:txBody>
@@ -8763,12 +8458,6 @@
           <a:lstStyle/>
           <a:p>
             <a:r>
-              <a:rPr sz="2400" b="1">
-                <a:solidFill>
-                  <a:srgbClr val="1A1A2E"/>
-                </a:solidFill>
-                <a:latin typeface="Calibri"/>
-              </a:rPr>
               <a:t>Los foros evaluados</a:t>
             </a:r>
           </a:p>
@@ -8806,7 +8495,7 @@
             <a:avLst/>
           </a:prstGeom>
           <a:solidFill>
-            <a:srgbClr val="E32B3D"/>
+            <a:srgbClr val="CD2D37"/>
           </a:solidFill>
           <a:ln>
             <a:noFill/>
@@ -8862,7 +8551,7 @@
                 <a:solidFill>
                   <a:srgbClr val="FFFFFF"/>
                 </a:solidFill>
-                <a:latin typeface="Calibri"/>
+                <a:latin typeface="Arial"/>
               </a:rPr>
               <a:t>Foro</a:t>
             </a:r>
@@ -8897,7 +8586,7 @@
                 <a:solidFill>
                   <a:srgbClr val="FFFFFF"/>
                 </a:solidFill>
-                <a:latin typeface="Calibri"/>
+                <a:latin typeface="Arial"/>
               </a:rPr>
               <a:t>Fecha del dump</a:t>
             </a:r>
@@ -8932,7 +8621,7 @@
                 <a:solidFill>
                   <a:srgbClr val="FFFFFF"/>
                 </a:solidFill>
-                <a:latin typeface="Calibri"/>
+                <a:latin typeface="Arial"/>
               </a:rPr>
               <a:t>Formato</a:t>
             </a:r>
@@ -8967,7 +8656,7 @@
                 <a:solidFill>
                   <a:srgbClr val="FFFFFF"/>
                 </a:solidFill>
-                <a:latin typeface="Calibri"/>
+                <a:latin typeface="Arial"/>
               </a:rPr>
               <a:t>Notas</a:t>
             </a:r>
@@ -9043,9 +8732,9 @@
             <a:r>
               <a:rPr sz="1100" b="0">
                 <a:solidFill>
-                  <a:srgbClr val="333844"/>
-                </a:solidFill>
-                <a:latin typeface="Calibri"/>
+                  <a:srgbClr val="465461"/>
+                </a:solidFill>
+                <a:latin typeface="Arial"/>
               </a:rPr>
               <a:t>Carder.su</a:t>
             </a:r>
@@ -9078,9 +8767,9 @@
             <a:r>
               <a:rPr sz="1100" b="0">
                 <a:solidFill>
-                  <a:srgbClr val="333844"/>
-                </a:solidFill>
-                <a:latin typeface="Calibri"/>
+                  <a:srgbClr val="465461"/>
+                </a:solidFill>
+                <a:latin typeface="Arial"/>
               </a:rPr>
               <a:t>2009-02</a:t>
             </a:r>
@@ -9113,9 +8802,9 @@
             <a:r>
               <a:rPr sz="1100" b="0">
                 <a:solidFill>
-                  <a:srgbClr val="333844"/>
-                </a:solidFill>
-                <a:latin typeface="Calibri"/>
+                  <a:srgbClr val="465461"/>
+                </a:solidFill>
+                <a:latin typeface="Arial"/>
               </a:rPr>
               <a:t>vBulletin SQL</a:t>
             </a:r>
@@ -9148,9 +8837,9 @@
             <a:r>
               <a:rPr sz="1100" b="0">
                 <a:solidFill>
-                  <a:srgbClr val="333844"/>
-                </a:solidFill>
-                <a:latin typeface="Calibri"/>
+                  <a:srgbClr val="465461"/>
+                </a:solidFill>
+                <a:latin typeface="Arial"/>
               </a:rPr>
               <a:t>Uno de los primeros foros importantes</a:t>
             </a:r>
@@ -9226,9 +8915,9 @@
             <a:r>
               <a:rPr sz="1100" b="0">
                 <a:solidFill>
-                  <a:srgbClr val="333844"/>
-                </a:solidFill>
-                <a:latin typeface="Calibri"/>
+                  <a:srgbClr val="465461"/>
+                </a:solidFill>
+                <a:latin typeface="Arial"/>
               </a:rPr>
               <a:t>Carding.biz</a:t>
             </a:r>
@@ -9261,9 +8950,9 @@
             <a:r>
               <a:rPr sz="1100" b="0">
                 <a:solidFill>
-                  <a:srgbClr val="333844"/>
-                </a:solidFill>
-                <a:latin typeface="Calibri"/>
+                  <a:srgbClr val="465461"/>
+                </a:solidFill>
+                <a:latin typeface="Arial"/>
               </a:rPr>
               <a:t>2009-11</a:t>
             </a:r>
@@ -9296,9 +8985,9 @@
             <a:r>
               <a:rPr sz="1100" b="0">
                 <a:solidFill>
-                  <a:srgbClr val="333844"/>
-                </a:solidFill>
-                <a:latin typeface="Calibri"/>
+                  <a:srgbClr val="465461"/>
+                </a:solidFill>
+                <a:latin typeface="Arial"/>
               </a:rPr>
               <a:t>vBulletin SQL</a:t>
             </a:r>
@@ -9331,9 +9020,9 @@
             <a:r>
               <a:rPr sz="1100" b="0">
                 <a:solidFill>
-                  <a:srgbClr val="333844"/>
-                </a:solidFill>
-                <a:latin typeface="Calibri"/>
+                  <a:srgbClr val="465461"/>
+                </a:solidFill>
+                <a:latin typeface="Arial"/>
               </a:rPr>
               <a:t/>
             </a:r>
@@ -9409,9 +9098,9 @@
             <a:r>
               <a:rPr sz="1100" b="0">
                 <a:solidFill>
-                  <a:srgbClr val="333844"/>
-                </a:solidFill>
-                <a:latin typeface="Calibri"/>
+                  <a:srgbClr val="465461"/>
+                </a:solidFill>
+                <a:latin typeface="Arial"/>
               </a:rPr>
               <a:t>Cardersplanet.biz</a:t>
             </a:r>
@@ -9444,9 +9133,9 @@
             <a:r>
               <a:rPr sz="1100" b="0">
                 <a:solidFill>
-                  <a:srgbClr val="333844"/>
-                </a:solidFill>
-                <a:latin typeface="Calibri"/>
+                  <a:srgbClr val="465461"/>
+                </a:solidFill>
+                <a:latin typeface="Arial"/>
               </a:rPr>
               <a:t>2010-05</a:t>
             </a:r>
@@ -9479,9 +9168,9 @@
             <a:r>
               <a:rPr sz="1100" b="0">
                 <a:solidFill>
-                  <a:srgbClr val="333844"/>
-                </a:solidFill>
-                <a:latin typeface="Calibri"/>
+                  <a:srgbClr val="465461"/>
+                </a:solidFill>
+                <a:latin typeface="Arial"/>
               </a:rPr>
               <a:t>vBulletin SQL</a:t>
             </a:r>
@@ -9514,9 +9203,9 @@
             <a:r>
               <a:rPr sz="1100" b="0">
                 <a:solidFill>
-                  <a:srgbClr val="333844"/>
-                </a:solidFill>
-                <a:latin typeface="Calibri"/>
+                  <a:srgbClr val="465461"/>
+                </a:solidFill>
+                <a:latin typeface="Arial"/>
               </a:rPr>
               <a:t/>
             </a:r>
@@ -9592,9 +9281,9 @@
             <a:r>
               <a:rPr sz="1100" b="0">
                 <a:solidFill>
-                  <a:srgbClr val="333844"/>
-                </a:solidFill>
-                <a:latin typeface="Calibri"/>
+                  <a:srgbClr val="465461"/>
+                </a:solidFill>
+                <a:latin typeface="Arial"/>
               </a:rPr>
               <a:t>Carders.cc</a:t>
             </a:r>
@@ -9627,9 +9316,9 @@
             <a:r>
               <a:rPr sz="1100" b="0">
                 <a:solidFill>
-                  <a:srgbClr val="333844"/>
-                </a:solidFill>
-                <a:latin typeface="Calibri"/>
+                  <a:srgbClr val="465461"/>
+                </a:solidFill>
+                <a:latin typeface="Arial"/>
               </a:rPr>
               <a:t>2010-12</a:t>
             </a:r>
@@ -9662,9 +9351,9 @@
             <a:r>
               <a:rPr sz="1100" b="0">
                 <a:solidFill>
-                  <a:srgbClr val="333844"/>
-                </a:solidFill>
-                <a:latin typeface="Calibri"/>
+                  <a:srgbClr val="465461"/>
+                </a:solidFill>
+                <a:latin typeface="Arial"/>
               </a:rPr>
               <a:t>vBulletin SQL</a:t>
             </a:r>
@@ -9697,9 +9386,9 @@
             <a:r>
               <a:rPr sz="1100" b="0">
                 <a:solidFill>
-                  <a:srgbClr val="333844"/>
-                </a:solidFill>
-                <a:latin typeface="Calibri"/>
+                  <a:srgbClr val="465461"/>
+                </a:solidFill>
+                <a:latin typeface="Arial"/>
               </a:rPr>
               <a:t/>
             </a:r>
@@ -9775,9 +9464,9 @@
             <a:r>
               <a:rPr sz="1100" b="0">
                 <a:solidFill>
-                  <a:srgbClr val="333844"/>
-                </a:solidFill>
-                <a:latin typeface="Calibri"/>
+                  <a:srgbClr val="465461"/>
+                </a:solidFill>
+                <a:latin typeface="Arial"/>
               </a:rPr>
               <a:t>Carder.pro</a:t>
             </a:r>
@@ -9810,9 +9499,9 @@
             <a:r>
               <a:rPr sz="1100" b="0">
                 <a:solidFill>
-                  <a:srgbClr val="333844"/>
-                </a:solidFill>
-                <a:latin typeface="Calibri"/>
+                  <a:srgbClr val="465461"/>
+                </a:solidFill>
+                <a:latin typeface="Arial"/>
               </a:rPr>
               <a:t>2013-04</a:t>
             </a:r>
@@ -9845,9 +9534,9 @@
             <a:r>
               <a:rPr sz="1100" b="0">
                 <a:solidFill>
-                  <a:srgbClr val="333844"/>
-                </a:solidFill>
-                <a:latin typeface="Calibri"/>
+                  <a:srgbClr val="465461"/>
+                </a:solidFill>
+                <a:latin typeface="Arial"/>
               </a:rPr>
               <a:t>vBulletin SQL</a:t>
             </a:r>
@@ -9880,9 +9569,9 @@
             <a:r>
               <a:rPr sz="1100" b="0">
                 <a:solidFill>
-                  <a:srgbClr val="333844"/>
-                </a:solidFill>
-                <a:latin typeface="Calibri"/>
+                  <a:srgbClr val="465461"/>
+                </a:solidFill>
+                <a:latin typeface="Arial"/>
               </a:rPr>
               <a:t>Encoding cp1251 (cirílico)</a:t>
             </a:r>
@@ -9958,9 +9647,9 @@
             <a:r>
               <a:rPr sz="1100" b="0">
                 <a:solidFill>
-                  <a:srgbClr val="333844"/>
-                </a:solidFill>
-                <a:latin typeface="Calibri"/>
+                  <a:srgbClr val="465461"/>
+                </a:solidFill>
+                <a:latin typeface="Arial"/>
               </a:rPr>
               <a:t>Cardingmafia.ws</a:t>
             </a:r>
@@ -9993,9 +9682,9 @@
             <a:r>
               <a:rPr sz="1100" b="0">
                 <a:solidFill>
-                  <a:srgbClr val="333844"/>
-                </a:solidFill>
-                <a:latin typeface="Calibri"/>
+                  <a:srgbClr val="465461"/>
+                </a:solidFill>
+                <a:latin typeface="Arial"/>
               </a:rPr>
               <a:t>2016-02</a:t>
             </a:r>
@@ -10028,9 +9717,9 @@
             <a:r>
               <a:rPr sz="1100" b="0">
                 <a:solidFill>
-                  <a:srgbClr val="333844"/>
-                </a:solidFill>
-                <a:latin typeface="Calibri"/>
+                  <a:srgbClr val="465461"/>
+                </a:solidFill>
+                <a:latin typeface="Arial"/>
               </a:rPr>
               <a:t>Flat file</a:t>
             </a:r>
@@ -10063,9 +9752,9 @@
             <a:r>
               <a:rPr sz="1100" b="0">
                 <a:solidFill>
-                  <a:srgbClr val="333844"/>
-                </a:solidFill>
-                <a:latin typeface="Calibri"/>
+                  <a:srgbClr val="465461"/>
+                </a:solidFill>
+                <a:latin typeface="Arial"/>
               </a:rPr>
               <a:t>Colon-delimited, solo tabla user</a:t>
             </a:r>
@@ -10141,9 +9830,9 @@
             <a:r>
               <a:rPr sz="1100" b="0">
                 <a:solidFill>
-                  <a:srgbClr val="333844"/>
-                </a:solidFill>
-                <a:latin typeface="Calibri"/>
+                  <a:srgbClr val="465461"/>
+                </a:solidFill>
+                <a:latin typeface="Arial"/>
               </a:rPr>
               <a:t>Crdshop.su</a:t>
             </a:r>
@@ -10176,9 +9865,9 @@
             <a:r>
               <a:rPr sz="1100" b="0">
                 <a:solidFill>
-                  <a:srgbClr val="333844"/>
-                </a:solidFill>
-                <a:latin typeface="Calibri"/>
+                  <a:srgbClr val="465461"/>
+                </a:solidFill>
+                <a:latin typeface="Arial"/>
               </a:rPr>
               <a:t>2016-11</a:t>
             </a:r>
@@ -10211,9 +9900,9 @@
             <a:r>
               <a:rPr sz="1100" b="0">
                 <a:solidFill>
-                  <a:srgbClr val="333844"/>
-                </a:solidFill>
-                <a:latin typeface="Calibri"/>
+                  <a:srgbClr val="465461"/>
+                </a:solidFill>
+                <a:latin typeface="Arial"/>
               </a:rPr>
               <a:t>vBulletin SQL</a:t>
             </a:r>
@@ -10246,9 +9935,9 @@
             <a:r>
               <a:rPr sz="1100" b="0">
                 <a:solidFill>
-                  <a:srgbClr val="333844"/>
-                </a:solidFill>
-                <a:latin typeface="Calibri"/>
+                  <a:srgbClr val="465461"/>
+                </a:solidFill>
+                <a:latin typeface="Arial"/>
               </a:rPr>
               <a:t/>
             </a:r>
@@ -10324,9 +10013,9 @@
             <a:r>
               <a:rPr sz="1100" b="0">
                 <a:solidFill>
-                  <a:srgbClr val="333844"/>
-                </a:solidFill>
-                <a:latin typeface="Calibri"/>
+                  <a:srgbClr val="465461"/>
+                </a:solidFill>
+                <a:latin typeface="Arial"/>
               </a:rPr>
               <a:t>Elitecarders.name</a:t>
             </a:r>
@@ -10359,9 +10048,9 @@
             <a:r>
               <a:rPr sz="1100" b="0">
                 <a:solidFill>
-                  <a:srgbClr val="333844"/>
-                </a:solidFill>
-                <a:latin typeface="Calibri"/>
+                  <a:srgbClr val="465461"/>
+                </a:solidFill>
+                <a:latin typeface="Arial"/>
               </a:rPr>
               <a:t>2016-08</a:t>
             </a:r>
@@ -10394,9 +10083,9 @@
             <a:r>
               <a:rPr sz="1100" b="0">
                 <a:solidFill>
-                  <a:srgbClr val="333844"/>
-                </a:solidFill>
-                <a:latin typeface="Calibri"/>
+                  <a:srgbClr val="465461"/>
+                </a:solidFill>
+                <a:latin typeface="Arial"/>
               </a:rPr>
               <a:t>vBulletin SQL</a:t>
             </a:r>
@@ -10429,9 +10118,9 @@
             <a:r>
               <a:rPr sz="1100" b="0">
                 <a:solidFill>
-                  <a:srgbClr val="333844"/>
-                </a:solidFill>
-                <a:latin typeface="Calibri"/>
+                  <a:srgbClr val="465461"/>
+                </a:solidFill>
+                <a:latin typeface="Arial"/>
               </a:rPr>
               <a:t/>
             </a:r>
@@ -10507,9 +10196,9 @@
             <a:r>
               <a:rPr sz="1100" b="0">
                 <a:solidFill>
-                  <a:srgbClr val="333844"/>
-                </a:solidFill>
-                <a:latin typeface="Calibri"/>
+                  <a:srgbClr val="465461"/>
+                </a:solidFill>
+                <a:latin typeface="Arial"/>
               </a:rPr>
               <a:t>CardingMafia</a:t>
             </a:r>
@@ -10542,9 +10231,9 @@
             <a:r>
               <a:rPr sz="1100" b="0">
                 <a:solidFill>
-                  <a:srgbClr val="333844"/>
-                </a:solidFill>
-                <a:latin typeface="Calibri"/>
+                  <a:srgbClr val="465461"/>
+                </a:solidFill>
+                <a:latin typeface="Arial"/>
               </a:rPr>
               <a:t>2021-03</a:t>
             </a:r>
@@ -10577,9 +10266,9 @@
             <a:r>
               <a:rPr sz="1100" b="0">
                 <a:solidFill>
-                  <a:srgbClr val="333844"/>
-                </a:solidFill>
-                <a:latin typeface="Calibri"/>
+                  <a:srgbClr val="465461"/>
+                </a:solidFill>
+                <a:latin typeface="Arial"/>
               </a:rPr>
               <a:t>vBulletin SQL</a:t>
             </a:r>
@@ -10612,9 +10301,9 @@
             <a:r>
               <a:rPr sz="1100" b="0">
                 <a:solidFill>
-                  <a:srgbClr val="333844"/>
-                </a:solidFill>
-                <a:latin typeface="Calibri"/>
+                  <a:srgbClr val="465461"/>
+                </a:solidFill>
+                <a:latin typeface="Arial"/>
               </a:rPr>
               <a:t>Ver siguiente slide</a:t>
             </a:r>
@@ -10690,9 +10379,9 @@
             <a:r>
               <a:rPr sz="1100" b="0">
                 <a:solidFill>
-                  <a:srgbClr val="333844"/>
-                </a:solidFill>
-                <a:latin typeface="Calibri"/>
+                  <a:srgbClr val="465461"/>
+                </a:solidFill>
+                <a:latin typeface="Arial"/>
               </a:rPr>
               <a:t>Cardmafia.cc</a:t>
             </a:r>
@@ -10725,9 +10414,9 @@
             <a:r>
               <a:rPr sz="1100" b="0">
                 <a:solidFill>
-                  <a:srgbClr val="333844"/>
-                </a:solidFill>
-                <a:latin typeface="Calibri"/>
+                  <a:srgbClr val="465461"/>
+                </a:solidFill>
+                <a:latin typeface="Arial"/>
               </a:rPr>
               <a:t>2021-03</a:t>
             </a:r>
@@ -10760,9 +10449,9 @@
             <a:r>
               <a:rPr sz="1100" b="0">
                 <a:solidFill>
-                  <a:srgbClr val="333844"/>
-                </a:solidFill>
-                <a:latin typeface="Calibri"/>
+                  <a:srgbClr val="465461"/>
+                </a:solidFill>
+                <a:latin typeface="Arial"/>
               </a:rPr>
               <a:t>vBulletin SQL</a:t>
             </a:r>
@@ -10795,9 +10484,9 @@
             <a:r>
               <a:rPr sz="1100" b="0">
                 <a:solidFill>
-                  <a:srgbClr val="333844"/>
-                </a:solidFill>
-                <a:latin typeface="Calibri"/>
+                  <a:srgbClr val="465461"/>
+                </a:solidFill>
+                <a:latin typeface="Arial"/>
               </a:rPr>
               <a:t>Ver siguiente slide</a:t>
             </a:r>
@@ -10832,7 +10521,7 @@
                 <a:solidFill>
                   <a:srgbClr val="707888"/>
                 </a:solidFill>
-                <a:latin typeface="Calibri"/>
+                <a:latin typeface="Arial"/>
               </a:rPr>
               <a:t>ℹ  9 foros distintos esperados según el reconocimiento inicial — la tabla real tiene 10 archivos.</a:t>
             </a:r>
@@ -10873,12 +10562,6 @@
           <a:lstStyle/>
           <a:p>
             <a:r>
-              <a:rPr sz="2400" b="1">
-                <a:solidFill>
-                  <a:srgbClr val="1A1A2E"/>
-                </a:solidFill>
-                <a:latin typeface="Calibri"/>
-              </a:rPr>
               <a:t>El bug que no esperabas — un dump subido dos veces</a:t>
             </a:r>
           </a:p>
@@ -10894,90 +10577,50 @@
             <p:ph type="body" idx="16" sz="quarter"/>
           </p:nvPr>
         </p:nvSpPr>
-        <p:spPr/>
+        <p:spPr>
+          <a:xfrm>
+            <a:off x="1073427" y="2077576"/>
+            <a:ext cx="10084904" cy="3507298"/>
+          </a:xfrm>
+        </p:spPr>
         <p:txBody>
           <a:bodyPr wrap="square"/>
           <a:lstStyle/>
           <a:p>
-            <a:pPr algn="l" marL="0" indent="-228600">
+            <a:r>
+              <a:t>list_forums() devuelve 10 archivos .zip, pero el reconocimiento inicial documentaba 9 foros</a:t>
+            </a:r>
+          </a:p>
+          <a:p>
+            <a:r>
+              <a:t>Diagnóstico: CardingMafia_2021.03.zip y Cardmafia.cc_2021.03.zip pesan exactamente 175,674,160 bytes</a:t>
+            </a:r>
+          </a:p>
+          <a:p>
+            <a:r>
+              <a:t>Verificación byte a byte: mismo INSERT INTO user, mismas 296,909 filas, mismo contenido</a:t>
+            </a:r>
+          </a:p>
+          <a:p>
+            <a:r>
+              <a:t>Es el mismo leak subido dos veces bajo nombres distintos — no dos foros diferentes</a:t>
+            </a:r>
+          </a:p>
+          <a:p>
+            <a:r>
+              <a:t>Ninguno de los dos incluye tabla post: el leak solo contiene el registro de usuarios</a:t>
+            </a:r>
+          </a:p>
+          <a:p>
+            <a:pPr lvl="1" marL="274320" indent="-228600">
               <a:buNone/>
             </a:pPr>
             <a:r>
-              <a:rPr sz="1900" b="0">
-                <a:solidFill>
-                  <a:srgbClr val="333844"/>
-                </a:solidFill>
-                <a:latin typeface="Calibri"/>
-              </a:rPr>
-              <a:t>▸  list_forums() devuelve 10 archivos .zip, pero el reconocimiento inicial documentaba 9 foros</a:t>
-            </a:r>
-          </a:p>
-          <a:p>
-            <a:pPr algn="l" marL="0" indent="-228600">
-              <a:buNone/>
-            </a:pPr>
-            <a:r>
-              <a:rPr sz="1900" b="0">
-                <a:solidFill>
-                  <a:srgbClr val="333844"/>
-                </a:solidFill>
-                <a:latin typeface="Calibri"/>
-              </a:rPr>
-              <a:t>▸  Diagnóstico: CardingMafia_2021.03.zip y Cardmafia.cc_2021.03.zip pesan exactamente 175,674,160 bytes</a:t>
-            </a:r>
-          </a:p>
-          <a:p>
-            <a:pPr algn="l" marL="0" indent="-228600">
-              <a:buNone/>
-            </a:pPr>
-            <a:r>
-              <a:rPr sz="1900" b="0">
-                <a:solidFill>
-                  <a:srgbClr val="333844"/>
-                </a:solidFill>
-                <a:latin typeface="Calibri"/>
-              </a:rPr>
-              <a:t>▸  Verificación byte a byte: mismo INSERT INTO user, mismas 296,909 filas, mismo contenido</a:t>
-            </a:r>
-          </a:p>
-          <a:p>
-            <a:pPr algn="l" marL="0" indent="-228600">
-              <a:buNone/>
-            </a:pPr>
-            <a:r>
-              <a:rPr sz="1900" b="0">
-                <a:solidFill>
-                  <a:srgbClr val="333844"/>
-                </a:solidFill>
-                <a:latin typeface="Calibri"/>
-              </a:rPr>
-              <a:t>▸  Es el mismo leak subido dos veces bajo nombres distintos — no dos foros diferentes</a:t>
-            </a:r>
-          </a:p>
-          <a:p>
-            <a:pPr algn="l" marL="0" indent="-228600">
-              <a:buNone/>
-            </a:pPr>
-            <a:r>
-              <a:rPr sz="1900" b="0">
-                <a:solidFill>
-                  <a:srgbClr val="333844"/>
-                </a:solidFill>
-                <a:latin typeface="Calibri"/>
-              </a:rPr>
-              <a:t>▸  Ninguno de los dos incluye tabla post: el leak solo contiene el registro de usuarios</a:t>
-            </a:r>
-          </a:p>
-          <a:p>
-            <a:pPr lvl="1" algn="l" marL="274320" indent="-228600">
-              <a:buNone/>
-            </a:pPr>
-            <a:r>
-              <a:rPr sz="1600" b="0">
+              <a:rPr sz="1500" b="0">
                 <a:solidFill>
                   <a:srgbClr val="707888"/>
                 </a:solidFill>
-                <a:latin typeface="Calibri"/>
+                <a:latin typeface="Arial"/>
               </a:rPr>
               <a:t>·  Lección: nunca asumas que archivo distinto = fuente distinta — verificá tamaño y contenido</a:t>
             </a:r>
@@ -11018,12 +10661,6 @@
           <a:lstStyle/>
           <a:p>
             <a:r>
-              <a:rPr sz="2400" b="1">
-                <a:solidFill>
-                  <a:srgbClr val="1A1A2E"/>
-                </a:solidFill>
-                <a:latin typeface="Calibri"/>
-              </a:rPr>
               <a:t>Un formato que no es SQL — Cardingmafia.ws</a:t>
             </a:r>
           </a:p>
@@ -11039,90 +10676,50 @@
             <p:ph type="body" idx="16" sz="quarter"/>
           </p:nvPr>
         </p:nvSpPr>
-        <p:spPr/>
+        <p:spPr>
+          <a:xfrm>
+            <a:off x="1073427" y="2077576"/>
+            <a:ext cx="10084904" cy="3507298"/>
+          </a:xfrm>
+        </p:spPr>
         <p:txBody>
           <a:bodyPr wrap="square"/>
           <a:lstStyle/>
           <a:p>
-            <a:pPr algn="l" marL="0" indent="-228600">
+            <a:r>
+              <a:t>load_forum() devolvía 0 filas para Cardingmafia.ws con el parser vBulletin</a:t>
+            </a:r>
+          </a:p>
+          <a:p>
+            <a:r>
+              <a:t>El zip contiene un único archivo Dump_cardingmafia.txt — no un dump SQL</a:t>
+            </a:r>
+          </a:p>
+          <a:p>
+            <a:r>
+              <a:t>Formato real: texto plano delimitado por ':' — userid:username:email:ipaddress:...</a:t>
+            </a:r>
+          </a:p>
+          <a:p>
+            <a:r>
+              <a:t>El proyecto ya tenía un parser para este formato exacto (src/parsers/flat.py)</a:t>
+            </a:r>
+          </a:p>
+          <a:p>
+            <a:r>
+              <a:t>Fix: load_forum() en src/utils.py auto-detecta flat/MyBB/IPS/vBulletin antes de elegir parser</a:t>
+            </a:r>
+          </a:p>
+          <a:p>
+            <a:pPr lvl="1" marL="274320" indent="-228600">
               <a:buNone/>
             </a:pPr>
             <a:r>
-              <a:rPr sz="1900" b="0">
-                <a:solidFill>
-                  <a:srgbClr val="333844"/>
-                </a:solidFill>
-                <a:latin typeface="Calibri"/>
-              </a:rPr>
-              <a:t>▸  load_forum() devolvía 0 filas para Cardingmafia.ws con el parser vBulletin</a:t>
-            </a:r>
-          </a:p>
-          <a:p>
-            <a:pPr algn="l" marL="0" indent="-228600">
-              <a:buNone/>
-            </a:pPr>
-            <a:r>
-              <a:rPr sz="1900" b="0">
-                <a:solidFill>
-                  <a:srgbClr val="333844"/>
-                </a:solidFill>
-                <a:latin typeface="Calibri"/>
-              </a:rPr>
-              <a:t>▸  El zip contiene un único archivo Dump_cardingmafia.txt — no un dump SQL</a:t>
-            </a:r>
-          </a:p>
-          <a:p>
-            <a:pPr algn="l" marL="0" indent="-228600">
-              <a:buNone/>
-            </a:pPr>
-            <a:r>
-              <a:rPr sz="1900" b="0">
-                <a:solidFill>
-                  <a:srgbClr val="333844"/>
-                </a:solidFill>
-                <a:latin typeface="Calibri"/>
-              </a:rPr>
-              <a:t>▸  Formato real: texto plano delimitado por ':' — userid:username:email:ipaddress:...</a:t>
-            </a:r>
-          </a:p>
-          <a:p>
-            <a:pPr algn="l" marL="0" indent="-228600">
-              <a:buNone/>
-            </a:pPr>
-            <a:r>
-              <a:rPr sz="1900" b="0">
-                <a:solidFill>
-                  <a:srgbClr val="333844"/>
-                </a:solidFill>
-                <a:latin typeface="Calibri"/>
-              </a:rPr>
-              <a:t>▸  El proyecto ya tenía un parser para este formato exacto (src/parsers/flat.py)</a:t>
-            </a:r>
-          </a:p>
-          <a:p>
-            <a:pPr algn="l" marL="0" indent="-228600">
-              <a:buNone/>
-            </a:pPr>
-            <a:r>
-              <a:rPr sz="1900" b="0">
-                <a:solidFill>
-                  <a:srgbClr val="333844"/>
-                </a:solidFill>
-                <a:latin typeface="Calibri"/>
-              </a:rPr>
-              <a:t>▸  Fix: load_forum() en src/utils.py auto-detecta flat/MyBB/IPS/vBulletin antes de elegir parser</a:t>
-            </a:r>
-          </a:p>
-          <a:p>
-            <a:pPr lvl="1" algn="l" marL="274320" indent="-228600">
-              <a:buNone/>
-            </a:pPr>
-            <a:r>
-              <a:rPr sz="1600" b="0">
+              <a:rPr sz="1500" b="0">
                 <a:solidFill>
                   <a:srgbClr val="707888"/>
                 </a:solidFill>
-                <a:latin typeface="Calibri"/>
+                <a:latin typeface="Arial"/>
               </a:rPr>
               <a:t>·  177,938 usuarios recuperados de un archivo que el parser vBulletin ignoraba por completo</a:t>
             </a:r>
@@ -11162,34 +10759,31 @@
           <a:bodyPr wrap="square"/>
           <a:lstStyle/>
           <a:p>
+            <a:pPr algn="ctr"/>
             <a:r>
               <a:rPr sz="1300" b="1">
                 <a:solidFill>
-                  <a:srgbClr val="E32B3D"/>
-                </a:solidFill>
-                <a:latin typeface="Calibri"/>
+                  <a:srgbClr val="CD2D37"/>
+                </a:solidFill>
+                <a:latin typeface="Arial"/>
               </a:rPr>
               <a:t>SECCIÓN 2</a:t>
             </a:r>
           </a:p>
           <a:p>
-            <a:r>
-              <a:rPr sz="3000" b="1">
-                <a:solidFill>
-                  <a:srgbClr val="FFFFFF"/>
-                </a:solidFill>
-                <a:latin typeface="Calibri"/>
-              </a:rPr>
+            <a:pPr algn="ctr"/>
+            <a:r>
               <a:t>Reconocimiento y limpieza</a:t>
             </a:r>
           </a:p>
           <a:p>
+            <a:pPr algn="ctr"/>
             <a:r>
               <a:rPr sz="1600">
                 <a:solidFill>
                   <a:srgbClr val="D6DAE2"/>
                 </a:solidFill>
-                <a:latin typeface="Calibri"/>
+                <a:latin typeface="Arial"/>
               </a:rPr>
               <a:t>Notebooks 00 y 01 — de dump crudo a datos confiables</a:t>
             </a:r>
@@ -11230,12 +10824,6 @@
           <a:lstStyle/>
           <a:p>
             <a:r>
-              <a:rPr sz="2400" b="1">
-                <a:solidFill>
-                  <a:srgbClr val="1A1A2E"/>
-                </a:solidFill>
-                <a:latin typeface="Calibri"/>
-              </a:rPr>
               <a:t>El dataset en cifras</a:t>
             </a:r>
           </a:p>
@@ -11256,73 +10844,28 @@
           <a:bodyPr wrap="square"/>
           <a:lstStyle/>
           <a:p>
-            <a:pPr algn="l" marL="0" indent="-228600">
-              <a:buNone/>
-            </a:pPr>
-            <a:r>
-              <a:rPr sz="1900" b="0">
-                <a:solidFill>
-                  <a:srgbClr val="333844"/>
-                </a:solidFill>
-                <a:latin typeface="Calibri"/>
-              </a:rPr>
-              <a:t>▸  949,816 usuarios y 1,470,866 posts across 10 dumps</a:t>
-            </a:r>
-          </a:p>
-          <a:p>
-            <a:pPr algn="l" marL="0" indent="-228600">
-              <a:buNone/>
-            </a:pPr>
-            <a:r>
-              <a:rPr sz="1900" b="0">
-                <a:solidFill>
-                  <a:srgbClr val="333844"/>
-                </a:solidFill>
-                <a:latin typeface="Calibri"/>
-              </a:rPr>
-              <a:t>▸  209,406 threads y 876,935 mensajes privados</a:t>
-            </a:r>
-          </a:p>
-          <a:p>
-            <a:pPr algn="l" marL="0" indent="-228600">
-              <a:buNone/>
-            </a:pPr>
-            <a:r>
-              <a:rPr sz="1900" b="0">
-                <a:solidFill>
-                  <a:srgbClr val="333844"/>
-                </a:solidFill>
-                <a:latin typeface="Calibri"/>
-              </a:rPr>
-              <a:t>▸  Rango temporal: 2009 a 2016 (con timestamps corruptos que hay que filtrar antes de confiar en esto)</a:t>
-            </a:r>
-          </a:p>
-          <a:p>
-            <a:pPr algn="l" marL="0" indent="-228600">
-              <a:buNone/>
-            </a:pPr>
-            <a:r>
-              <a:rPr sz="1900" b="0">
-                <a:solidFill>
-                  <a:srgbClr val="333844"/>
-                </a:solidFill>
-                <a:latin typeface="Calibri"/>
-              </a:rPr>
-              <a:t>▸  vBulletin es el formato dominante — mismo problema de encoding que otros casos del curso</a:t>
-            </a:r>
-          </a:p>
-          <a:p>
-            <a:pPr algn="l" marL="0" indent="-228600">
-              <a:buNone/>
-            </a:pPr>
-            <a:r>
-              <a:rPr sz="1900" b="0">
-                <a:solidFill>
-                  <a:srgbClr val="333844"/>
-                </a:solidFill>
-                <a:latin typeface="Calibri"/>
-              </a:rPr>
-              <a:t>▸  Carder.pro usa cp1251 (cirílico): el parser lo maneja, pero hay que detectarlo, no asumirlo</a:t>
+            <a:r>
+              <a:t>949,816 usuarios y 1,470,866 posts across 10 dumps</a:t>
+            </a:r>
+          </a:p>
+          <a:p>
+            <a:r>
+              <a:t>209,406 threads y 876,935 mensajes privados</a:t>
+            </a:r>
+          </a:p>
+          <a:p>
+            <a:r>
+              <a:t>Rango temporal: 2009 a 2016 (con timestamps corruptos que hay que filtrar antes de confiar en esto)</a:t>
+            </a:r>
+          </a:p>
+          <a:p>
+            <a:r>
+              <a:t>vBulletin es el formato dominante — mismo problema de encoding que otros casos del curso</a:t>
+            </a:r>
+          </a:p>
+          <a:p>
+            <a:r>
+              <a:t>Carder.pro usa cp1251 (cirílico): el parser lo maneja, pero hay que detectarlo, no asumirlo</a:t>
             </a:r>
           </a:p>
         </p:txBody>
@@ -11361,12 +10904,6 @@
           <a:lstStyle/>
           <a:p>
             <a:r>
-              <a:rPr sz="2400" b="1">
-                <a:solidFill>
-                  <a:srgbClr val="1A1A2E"/>
-                </a:solidFill>
-                <a:latin typeface="Calibri"/>
-              </a:rPr>
               <a:t>Limpieza — los mismos problemas de siempre, otra escala</a:t>
             </a:r>
           </a:p>
@@ -11382,78 +10919,38 @@
             <p:ph type="body" idx="16" sz="quarter"/>
           </p:nvPr>
         </p:nvSpPr>
-        <p:spPr/>
+        <p:spPr>
+          <a:xfrm>
+            <a:off x="1073427" y="2580496"/>
+            <a:ext cx="10084904" cy="3004378"/>
+          </a:xfrm>
+        </p:spPr>
         <p:txBody>
           <a:bodyPr wrap="square"/>
           <a:lstStyle/>
           <a:p>
-            <a:pPr algn="l" marL="0" indent="-228600">
-              <a:buNone/>
-            </a:pPr>
-            <a:r>
-              <a:rPr sz="1900" b="0">
-                <a:solidFill>
-                  <a:srgbClr val="333844"/>
-                </a:solidFill>
-                <a:latin typeface="Calibri"/>
-              </a:rPr>
-              <a:t>▸  178,420 usuarios con joindate inválido (epoch-0 o nulo) — 18.8% del total</a:t>
-            </a:r>
-          </a:p>
-          <a:p>
-            <a:pPr algn="l" marL="0" indent="-228600">
-              <a:buNone/>
-            </a:pPr>
-            <a:r>
-              <a:rPr sz="1900" b="0">
-                <a:solidFill>
-                  <a:srgbClr val="333844"/>
-                </a:solidFill>
-                <a:latin typeface="Calibri"/>
-              </a:rPr>
-              <a:t>▸  16,206 posts con timestamp fuera de rango (antes de 2000 o después de 2025)</a:t>
-            </a:r>
-          </a:p>
-          <a:p>
-            <a:pPr algn="l" marL="0" indent="-228600">
-              <a:buNone/>
-            </a:pPr>
-            <a:r>
-              <a:rPr sz="1900" b="0">
-                <a:solidFill>
-                  <a:srgbClr val="333844"/>
-                </a:solidFill>
-                <a:latin typeface="Calibri"/>
-              </a:rPr>
-              <a:t>▸  58,939 posts con texto vacío o menor a 5 caracteres — posts borrados por moderación</a:t>
-            </a:r>
-          </a:p>
-          <a:p>
-            <a:pPr algn="l" marL="0" indent="-228600">
-              <a:buNone/>
-            </a:pPr>
-            <a:r>
-              <a:rPr sz="1900" b="0">
-                <a:solidFill>
-                  <a:srgbClr val="333844"/>
-                </a:solidFill>
-                <a:latin typeface="Calibri"/>
-              </a:rPr>
-              <a:t>▸  Deduplicación por (userid, forum): filas repetidas por errores de exportación del dump</a:t>
-            </a:r>
-          </a:p>
-          <a:p>
-            <a:pPr algn="l" marL="0" indent="-228600">
-              <a:buNone/>
-            </a:pPr>
-            <a:r>
-              <a:rPr sz="1900" b="0">
-                <a:solidFill>
-                  <a:srgbClr val="333844"/>
-                </a:solidFill>
-                <a:latin typeface="Calibri"/>
-              </a:rPr>
-              <a:t>▸  1,470,866 → 1,412,107 posts limpios — un 4% se descarta antes de cualquier análisis semántico</a:t>
+            <a:r>
+              <a:t>178,420 usuarios con joindate inválido (epoch-0 o nulo) — 18.8% del total</a:t>
+            </a:r>
+          </a:p>
+          <a:p>
+            <a:r>
+              <a:t>16,206 posts con timestamp fuera de rango (antes de 2000 o después de 2025)</a:t>
+            </a:r>
+          </a:p>
+          <a:p>
+            <a:r>
+              <a:t>58,939 posts con texto vacío o menor a 5 caracteres — posts borrados por moderación</a:t>
+            </a:r>
+          </a:p>
+          <a:p>
+            <a:r>
+              <a:t>Deduplicación por (userid, forum): filas repetidas por errores de exportación del dump</a:t>
+            </a:r>
+          </a:p>
+          <a:p>
+            <a:r>
+              <a:t>1,470,866 → 1,412,107 posts limpios — un 4% se descarta antes de cualquier análisis semántico</a:t>
             </a:r>
           </a:p>
         </p:txBody>
@@ -11486,7 +10983,7 @@
                 <a:solidFill>
                   <a:srgbClr val="707888"/>
                 </a:solidFill>
-                <a:latin typeface="Calibri"/>
+                <a:latin typeface="Arial"/>
               </a:rPr>
               <a:t>ℹ  Mismo patrón epoch-0 que en HackingForums: nunca confíes en un timestamp sin validar su rango primero.</a:t>
             </a:r>
@@ -11526,34 +11023,31 @@
           <a:bodyPr wrap="square"/>
           <a:lstStyle/>
           <a:p>
+            <a:pPr algn="ctr"/>
             <a:r>
               <a:rPr sz="1300" b="1">
                 <a:solidFill>
-                  <a:srgbClr val="E32B3D"/>
-                </a:solidFill>
-                <a:latin typeface="Calibri"/>
+                  <a:srgbClr val="CD2D37"/>
+                </a:solidFill>
+                <a:latin typeface="Arial"/>
               </a:rPr>
               <a:t>DEMO EN VIVO</a:t>
             </a:r>
           </a:p>
           <a:p>
-            <a:r>
-              <a:rPr sz="2600" b="1">
-                <a:solidFill>
-                  <a:srgbClr val="FFFFFF"/>
-                </a:solidFill>
-                <a:latin typeface="Calibri"/>
-              </a:rPr>
+            <a:pPr algn="ctr"/>
+            <a:r>
               <a:t>Demo — reconocimiento y limpieza</a:t>
             </a:r>
           </a:p>
           <a:p>
+            <a:pPr algn="ctr"/>
             <a:r>
               <a:rPr sz="1400">
                 <a:solidFill>
                   <a:srgbClr val="9AA3B5"/>
                 </a:solidFill>
-                <a:latin typeface="Calibri"/>
+                <a:latin typeface="Arial"/>
               </a:rPr>
               <a:t>CardingForums/00_reconocimiento.ipynb</a:t>
             </a:r>
@@ -11587,7 +11081,7 @@
                 <a:solidFill>
                   <a:srgbClr val="D6DAE2"/>
                 </a:solidFill>
-                <a:latin typeface="Calibri"/>
+                <a:latin typeface="Arial"/>
               </a:rPr>
               <a:t>1.  Abrir notebook 00_reconocimiento</a:t>
             </a:r>
@@ -11598,7 +11092,7 @@
                 <a:solidFill>
                   <a:srgbClr val="D6DAE2"/>
                 </a:solidFill>
-                <a:latin typeface="Calibri"/>
+                <a:latin typeface="Arial"/>
               </a:rPr>
               <a:t>2.  Sección 6: tabla de usuarios y posts por foro, timeline de registros</a:t>
             </a:r>
@@ -11609,7 +11103,7 @@
                 <a:solidFill>
                   <a:srgbClr val="D6DAE2"/>
                 </a:solidFill>
-                <a:latin typeface="Calibri"/>
+                <a:latin typeface="Arial"/>
               </a:rPr>
               <a:t>3.  Sección 7: validación de calidad — completitud de campos de contacto</a:t>
             </a:r>
@@ -11620,7 +11114,7 @@
                 <a:solidFill>
                   <a:srgbClr val="D6DAE2"/>
                 </a:solidFill>
-                <a:latin typeface="Calibri"/>
+                <a:latin typeface="Arial"/>
               </a:rPr>
               <a:t>4.  Notebook 01, sección 5: resumen de limpieza con conteos antes/después</a:t>
             </a:r>

</xml_diff>

<commit_message>
feat: use native PowerPoint tables instead of hand-drawn rectangles
Switch table_slide to graphic-frame tables (add_table) so column widths
and row heights can be adjusted directly in PowerPoint/LibreOffice, and
let the app handle text wrapping instead of a manual row-height estimate.
</commit_message>
<xml_diff>
--- a/CardingForums/csbc26_caso_cardingforums.pptx
+++ b/CardingForums/csbc26_caso_cardingforums.pptx
@@ -6778,1045 +6778,512 @@
           <a:p/>
         </p:txBody>
       </p:sp>
-      <p:sp>
-        <p:nvSpPr>
-          <p:cNvPr id="4" name="Rectangle 3"/>
-          <p:cNvSpPr/>
+      <p:graphicFrame>
+        <p:nvGraphicFramePr>
+          <p:cNvPr id="4" name="Table 3"/>
+          <p:cNvGraphicFramePr>
+            <a:graphicFrameLocks noGrp="1"/>
+          </p:cNvGraphicFramePr>
           <p:nvPr/>
-        </p:nvSpPr>
-        <p:spPr>
-          <a:xfrm>
-            <a:off x="1051560" y="2148840"/>
-            <a:ext cx="10058400" cy="365760"/>
-          </a:xfrm>
-          <a:prstGeom prst="rect">
-            <a:avLst/>
-          </a:prstGeom>
-          <a:solidFill>
-            <a:srgbClr val="CD2D37"/>
-          </a:solidFill>
-          <a:ln>
-            <a:noFill/>
-          </a:ln>
-        </p:spPr>
-        <p:style>
-          <a:lnRef idx="1">
-            <a:schemeClr val="accent1"/>
-          </a:lnRef>
-          <a:fillRef idx="3">
-            <a:schemeClr val="accent1"/>
-          </a:fillRef>
-          <a:effectRef idx="2">
-            <a:schemeClr val="accent1"/>
-          </a:effectRef>
-          <a:fontRef idx="minor">
-            <a:schemeClr val="lt1"/>
-          </a:fontRef>
-        </p:style>
-        <p:txBody>
-          <a:bodyPr rtlCol="0" anchor="ctr"/>
-          <a:lstStyle/>
-          <a:p>
-            <a:pPr algn="ctr"/>
-          </a:p>
-        </p:txBody>
-      </p:sp>
+        </p:nvGraphicFramePr>
+        <p:xfrm>
+          <a:off x="1051560" y="2148840"/>
+          <a:ext cx="10058400" cy="2560320"/>
+        </p:xfrm>
+        <a:graphic>
+          <a:graphicData uri="http://schemas.openxmlformats.org/drawingml/2006/table">
+            <a:tbl>
+              <a:tblPr>
+                <a:tableStyleId>{5C22544A-7EE6-4342-B048-85BDC9FD1C3A}</a:tableStyleId>
+              </a:tblPr>
+              <a:tblGrid>
+                <a:gridCol w="3352800"/>
+                <a:gridCol w="3352800"/>
+                <a:gridCol w="3352800"/>
+              </a:tblGrid>
+              <a:tr h="365760">
+                <a:tc>
+                  <a:txBody>
+                    <a:bodyPr/>
+                    <a:lstStyle/>
+                    <a:p>
+                      <a:r>
+                        <a:rPr sz="1200" b="1">
+                          <a:solidFill>
+                            <a:srgbClr val="FFFFFF"/>
+                          </a:solidFill>
+                          <a:latin typeface="Arial"/>
+                        </a:rPr>
+                        <a:t>Rol</a:t>
+                      </a:r>
+                    </a:p>
+                  </a:txBody>
+                  <a:tcPr marL="45000" marR="45000" marT="25000" marB="25000" anchor="ctr">
+                    <a:solidFill>
+                      <a:srgbClr val="CD2D37"/>
+                    </a:solidFill>
+                  </a:tcPr>
+                </a:tc>
+                <a:tc>
+                  <a:txBody>
+                    <a:bodyPr/>
+                    <a:lstStyle/>
+                    <a:p>
+                      <a:r>
+                        <a:rPr sz="1200" b="1">
+                          <a:solidFill>
+                            <a:srgbClr val="FFFFFF"/>
+                          </a:solidFill>
+                          <a:latin typeface="Arial"/>
+                        </a:rPr>
+                        <a:t>Usuarios</a:t>
+                      </a:r>
+                    </a:p>
+                  </a:txBody>
+                  <a:tcPr marL="45000" marR="45000" marT="25000" marB="25000" anchor="ctr">
+                    <a:solidFill>
+                      <a:srgbClr val="CD2D37"/>
+                    </a:solidFill>
+                  </a:tcPr>
+                </a:tc>
+                <a:tc>
+                  <a:txBody>
+                    <a:bodyPr/>
+                    <a:lstStyle/>
+                    <a:p>
+                      <a:r>
+                        <a:rPr sz="1200" b="1">
+                          <a:solidFill>
+                            <a:srgbClr val="FFFFFF"/>
+                          </a:solidFill>
+                          <a:latin typeface="Arial"/>
+                        </a:rPr>
+                        <a:t>Confianza típica</a:t>
+                      </a:r>
+                    </a:p>
+                  </a:txBody>
+                  <a:tcPr marL="45000" marR="45000" marT="25000" marB="25000" anchor="ctr">
+                    <a:solidFill>
+                      <a:srgbClr val="CD2D37"/>
+                    </a:solidFill>
+                  </a:tcPr>
+                </a:tc>
+              </a:tr>
+              <a:tr h="365760">
+                <a:tc>
+                  <a:txBody>
+                    <a:bodyPr/>
+                    <a:lstStyle/>
+                    <a:p>
+                      <a:r>
+                        <a:rPr sz="1100" b="0">
+                          <a:solidFill>
+                            <a:srgbClr val="465461"/>
+                          </a:solidFill>
+                          <a:latin typeface="Arial"/>
+                        </a:rPr>
+                        <a:t>lurker</a:t>
+                      </a:r>
+                    </a:p>
+                  </a:txBody>
+                  <a:tcPr marL="45000" marR="45000" marT="25000" marB="25000" anchor="ctr">
+                    <a:solidFill>
+                      <a:srgbClr val="F1F2F6"/>
+                    </a:solidFill>
+                  </a:tcPr>
+                </a:tc>
+                <a:tc>
+                  <a:txBody>
+                    <a:bodyPr/>
+                    <a:lstStyle/>
+                    <a:p>
+                      <a:r>
+                        <a:rPr sz="1100" b="0">
+                          <a:solidFill>
+                            <a:srgbClr val="465461"/>
+                          </a:solidFill>
+                          <a:latin typeface="Arial"/>
+                        </a:rPr>
+                        <a:t>20</a:t>
+                      </a:r>
+                    </a:p>
+                  </a:txBody>
+                  <a:tcPr marL="45000" marR="45000" marT="25000" marB="25000" anchor="ctr">
+                    <a:solidFill>
+                      <a:srgbClr val="F1F2F6"/>
+                    </a:solidFill>
+                  </a:tcPr>
+                </a:tc>
+                <a:tc>
+                  <a:txBody>
+                    <a:bodyPr/>
+                    <a:lstStyle/>
+                    <a:p>
+                      <a:r>
+                        <a:rPr sz="1100" b="0">
+                          <a:solidFill>
+                            <a:srgbClr val="465461"/>
+                          </a:solidFill>
+                          <a:latin typeface="Arial"/>
+                        </a:rPr>
+                        <a:t>0.85–0.95</a:t>
+                      </a:r>
+                    </a:p>
+                  </a:txBody>
+                  <a:tcPr marL="45000" marR="45000" marT="25000" marB="25000" anchor="ctr">
+                    <a:solidFill>
+                      <a:srgbClr val="F1F2F6"/>
+                    </a:solidFill>
+                  </a:tcPr>
+                </a:tc>
+              </a:tr>
+              <a:tr h="365760">
+                <a:tc>
+                  <a:txBody>
+                    <a:bodyPr/>
+                    <a:lstStyle/>
+                    <a:p>
+                      <a:r>
+                        <a:rPr sz="1100" b="0">
+                          <a:solidFill>
+                            <a:srgbClr val="465461"/>
+                          </a:solidFill>
+                          <a:latin typeface="Arial"/>
+                        </a:rPr>
+                        <a:t>comprador</a:t>
+                      </a:r>
+                    </a:p>
+                  </a:txBody>
+                  <a:tcPr marL="45000" marR="45000" marT="25000" marB="25000" anchor="ctr">
+                    <a:solidFill>
+                      <a:srgbClr val="FFFFFF"/>
+                    </a:solidFill>
+                  </a:tcPr>
+                </a:tc>
+                <a:tc>
+                  <a:txBody>
+                    <a:bodyPr/>
+                    <a:lstStyle/>
+                    <a:p>
+                      <a:r>
+                        <a:rPr sz="1100" b="0">
+                          <a:solidFill>
+                            <a:srgbClr val="465461"/>
+                          </a:solidFill>
+                          <a:latin typeface="Arial"/>
+                        </a:rPr>
+                        <a:t>3</a:t>
+                      </a:r>
+                    </a:p>
+                  </a:txBody>
+                  <a:tcPr marL="45000" marR="45000" marT="25000" marB="25000" anchor="ctr">
+                    <a:solidFill>
+                      <a:srgbClr val="FFFFFF"/>
+                    </a:solidFill>
+                  </a:tcPr>
+                </a:tc>
+                <a:tc>
+                  <a:txBody>
+                    <a:bodyPr/>
+                    <a:lstStyle/>
+                    <a:p>
+                      <a:r>
+                        <a:rPr sz="1100" b="0">
+                          <a:solidFill>
+                            <a:srgbClr val="465461"/>
+                          </a:solidFill>
+                          <a:latin typeface="Arial"/>
+                        </a:rPr>
+                        <a:t>0.70–0.85</a:t>
+                      </a:r>
+                    </a:p>
+                  </a:txBody>
+                  <a:tcPr marL="45000" marR="45000" marT="25000" marB="25000" anchor="ctr">
+                    <a:solidFill>
+                      <a:srgbClr val="FFFFFF"/>
+                    </a:solidFill>
+                  </a:tcPr>
+                </a:tc>
+              </a:tr>
+              <a:tr h="365760">
+                <a:tc>
+                  <a:txBody>
+                    <a:bodyPr/>
+                    <a:lstStyle/>
+                    <a:p>
+                      <a:r>
+                        <a:rPr sz="1100" b="0">
+                          <a:solidFill>
+                            <a:srgbClr val="465461"/>
+                          </a:solidFill>
+                          <a:latin typeface="Arial"/>
+                        </a:rPr>
+                        <a:t>intermediario_escrow</a:t>
+                      </a:r>
+                    </a:p>
+                  </a:txBody>
+                  <a:tcPr marL="45000" marR="45000" marT="25000" marB="25000" anchor="ctr">
+                    <a:solidFill>
+                      <a:srgbClr val="F1F2F6"/>
+                    </a:solidFill>
+                  </a:tcPr>
+                </a:tc>
+                <a:tc>
+                  <a:txBody>
+                    <a:bodyPr/>
+                    <a:lstStyle/>
+                    <a:p>
+                      <a:r>
+                        <a:rPr sz="1100" b="0">
+                          <a:solidFill>
+                            <a:srgbClr val="465461"/>
+                          </a:solidFill>
+                          <a:latin typeface="Arial"/>
+                        </a:rPr>
+                        <a:t>3</a:t>
+                      </a:r>
+                    </a:p>
+                  </a:txBody>
+                  <a:tcPr marL="45000" marR="45000" marT="25000" marB="25000" anchor="ctr">
+                    <a:solidFill>
+                      <a:srgbClr val="F1F2F6"/>
+                    </a:solidFill>
+                  </a:tcPr>
+                </a:tc>
+                <a:tc>
+                  <a:txBody>
+                    <a:bodyPr/>
+                    <a:lstStyle/>
+                    <a:p>
+                      <a:r>
+                        <a:rPr sz="1100" b="0">
+                          <a:solidFill>
+                            <a:srgbClr val="465461"/>
+                          </a:solidFill>
+                          <a:latin typeface="Arial"/>
+                        </a:rPr>
+                        <a:t>0.70–0.85</a:t>
+                      </a:r>
+                    </a:p>
+                  </a:txBody>
+                  <a:tcPr marL="45000" marR="45000" marT="25000" marB="25000" anchor="ctr">
+                    <a:solidFill>
+                      <a:srgbClr val="F1F2F6"/>
+                    </a:solidFill>
+                  </a:tcPr>
+                </a:tc>
+              </a:tr>
+              <a:tr h="365760">
+                <a:tc>
+                  <a:txBody>
+                    <a:bodyPr/>
+                    <a:lstStyle/>
+                    <a:p>
+                      <a:r>
+                        <a:rPr sz="1100" b="0">
+                          <a:solidFill>
+                            <a:srgbClr val="465461"/>
+                          </a:solidFill>
+                          <a:latin typeface="Arial"/>
+                        </a:rPr>
+                        <a:t>indeterminado</a:t>
+                      </a:r>
+                    </a:p>
+                  </a:txBody>
+                  <a:tcPr marL="45000" marR="45000" marT="25000" marB="25000" anchor="ctr">
+                    <a:solidFill>
+                      <a:srgbClr val="FFFFFF"/>
+                    </a:solidFill>
+                  </a:tcPr>
+                </a:tc>
+                <a:tc>
+                  <a:txBody>
+                    <a:bodyPr/>
+                    <a:lstStyle/>
+                    <a:p>
+                      <a:r>
+                        <a:rPr sz="1100" b="0">
+                          <a:solidFill>
+                            <a:srgbClr val="465461"/>
+                          </a:solidFill>
+                          <a:latin typeface="Arial"/>
+                        </a:rPr>
+                        <a:t>2</a:t>
+                      </a:r>
+                    </a:p>
+                  </a:txBody>
+                  <a:tcPr marL="45000" marR="45000" marT="25000" marB="25000" anchor="ctr">
+                    <a:solidFill>
+                      <a:srgbClr val="FFFFFF"/>
+                    </a:solidFill>
+                  </a:tcPr>
+                </a:tc>
+                <a:tc>
+                  <a:txBody>
+                    <a:bodyPr/>
+                    <a:lstStyle/>
+                    <a:p>
+                      <a:r>
+                        <a:rPr sz="1100" b="0">
+                          <a:solidFill>
+                            <a:srgbClr val="465461"/>
+                          </a:solidFill>
+                          <a:latin typeface="Arial"/>
+                        </a:rPr>
+                        <a:t>0.50–0.65</a:t>
+                      </a:r>
+                    </a:p>
+                  </a:txBody>
+                  <a:tcPr marL="45000" marR="45000" marT="25000" marB="25000" anchor="ctr">
+                    <a:solidFill>
+                      <a:srgbClr val="FFFFFF"/>
+                    </a:solidFill>
+                  </a:tcPr>
+                </a:tc>
+              </a:tr>
+              <a:tr h="365760">
+                <a:tc>
+                  <a:txBody>
+                    <a:bodyPr/>
+                    <a:lstStyle/>
+                    <a:p>
+                      <a:r>
+                        <a:rPr sz="1100" b="0">
+                          <a:solidFill>
+                            <a:srgbClr val="465461"/>
+                          </a:solidFill>
+                          <a:latin typeface="Arial"/>
+                        </a:rPr>
+                        <a:t>vendedor_dumps</a:t>
+                      </a:r>
+                    </a:p>
+                  </a:txBody>
+                  <a:tcPr marL="45000" marR="45000" marT="25000" marB="25000" anchor="ctr">
+                    <a:solidFill>
+                      <a:srgbClr val="F1F2F6"/>
+                    </a:solidFill>
+                  </a:tcPr>
+                </a:tc>
+                <a:tc>
+                  <a:txBody>
+                    <a:bodyPr/>
+                    <a:lstStyle/>
+                    <a:p>
+                      <a:r>
+                        <a:rPr sz="1100" b="0">
+                          <a:solidFill>
+                            <a:srgbClr val="465461"/>
+                          </a:solidFill>
+                          <a:latin typeface="Arial"/>
+                        </a:rPr>
+                        <a:t>1</a:t>
+                      </a:r>
+                    </a:p>
+                  </a:txBody>
+                  <a:tcPr marL="45000" marR="45000" marT="25000" marB="25000" anchor="ctr">
+                    <a:solidFill>
+                      <a:srgbClr val="F1F2F6"/>
+                    </a:solidFill>
+                  </a:tcPr>
+                </a:tc>
+                <a:tc>
+                  <a:txBody>
+                    <a:bodyPr/>
+                    <a:lstStyle/>
+                    <a:p>
+                      <a:r>
+                        <a:rPr sz="1100" b="0">
+                          <a:solidFill>
+                            <a:srgbClr val="465461"/>
+                          </a:solidFill>
+                          <a:latin typeface="Arial"/>
+                        </a:rPr>
+                        <a:t>0.80</a:t>
+                      </a:r>
+                    </a:p>
+                  </a:txBody>
+                  <a:tcPr marL="45000" marR="45000" marT="25000" marB="25000" anchor="ctr">
+                    <a:solidFill>
+                      <a:srgbClr val="F1F2F6"/>
+                    </a:solidFill>
+                  </a:tcPr>
+                </a:tc>
+              </a:tr>
+              <a:tr h="365760">
+                <a:tc>
+                  <a:txBody>
+                    <a:bodyPr/>
+                    <a:lstStyle/>
+                    <a:p>
+                      <a:r>
+                        <a:rPr sz="1100" b="0">
+                          <a:solidFill>
+                            <a:srgbClr val="465461"/>
+                          </a:solidFill>
+                          <a:latin typeface="Arial"/>
+                        </a:rPr>
+                        <a:t>checker</a:t>
+                      </a:r>
+                    </a:p>
+                  </a:txBody>
+                  <a:tcPr marL="45000" marR="45000" marT="25000" marB="25000" anchor="ctr">
+                    <a:solidFill>
+                      <a:srgbClr val="FFFFFF"/>
+                    </a:solidFill>
+                  </a:tcPr>
+                </a:tc>
+                <a:tc>
+                  <a:txBody>
+                    <a:bodyPr/>
+                    <a:lstStyle/>
+                    <a:p>
+                      <a:r>
+                        <a:rPr sz="1100" b="0">
+                          <a:solidFill>
+                            <a:srgbClr val="465461"/>
+                          </a:solidFill>
+                          <a:latin typeface="Arial"/>
+                        </a:rPr>
+                        <a:t>1</a:t>
+                      </a:r>
+                    </a:p>
+                  </a:txBody>
+                  <a:tcPr marL="45000" marR="45000" marT="25000" marB="25000" anchor="ctr">
+                    <a:solidFill>
+                      <a:srgbClr val="FFFFFF"/>
+                    </a:solidFill>
+                  </a:tcPr>
+                </a:tc>
+                <a:tc>
+                  <a:txBody>
+                    <a:bodyPr/>
+                    <a:lstStyle/>
+                    <a:p>
+                      <a:r>
+                        <a:rPr sz="1100" b="0">
+                          <a:solidFill>
+                            <a:srgbClr val="465461"/>
+                          </a:solidFill>
+                          <a:latin typeface="Arial"/>
+                        </a:rPr>
+                        <a:t>0.75</a:t>
+                      </a:r>
+                    </a:p>
+                  </a:txBody>
+                  <a:tcPr marL="45000" marR="45000" marT="25000" marB="25000" anchor="ctr">
+                    <a:solidFill>
+                      <a:srgbClr val="FFFFFF"/>
+                    </a:solidFill>
+                  </a:tcPr>
+                </a:tc>
+              </a:tr>
+            </a:tbl>
+          </a:graphicData>
+        </a:graphic>
+      </p:graphicFrame>
       <p:sp>
         <p:nvSpPr>
           <p:cNvPr id="5" name="TextBox 4"/>
-          <p:cNvSpPr txBox="1"/>
-          <p:nvPr/>
-        </p:nvSpPr>
-        <p:spPr>
-          <a:xfrm>
-            <a:off x="1097280" y="2203840"/>
-            <a:ext cx="3261360" cy="365760"/>
-          </a:xfrm>
-          <a:prstGeom prst="rect">
-            <a:avLst/>
-          </a:prstGeom>
-          <a:noFill/>
-        </p:spPr>
-        <p:txBody>
-          <a:bodyPr wrap="square">
-            <a:spAutoFit/>
-          </a:bodyPr>
-          <a:lstStyle/>
-          <a:p>
-            <a:pPr algn="l"/>
-            <a:r>
-              <a:rPr sz="1200" b="1">
-                <a:solidFill>
-                  <a:srgbClr val="FFFFFF"/>
-                </a:solidFill>
-                <a:latin typeface="Arial"/>
-              </a:rPr>
-              <a:t>Rol</a:t>
-            </a:r>
-          </a:p>
-        </p:txBody>
-      </p:sp>
-      <p:sp>
-        <p:nvSpPr>
-          <p:cNvPr id="6" name="TextBox 5"/>
-          <p:cNvSpPr txBox="1"/>
-          <p:nvPr/>
-        </p:nvSpPr>
-        <p:spPr>
-          <a:xfrm>
-            <a:off x="4450080" y="2203840"/>
-            <a:ext cx="3261360" cy="365760"/>
-          </a:xfrm>
-          <a:prstGeom prst="rect">
-            <a:avLst/>
-          </a:prstGeom>
-          <a:noFill/>
-        </p:spPr>
-        <p:txBody>
-          <a:bodyPr wrap="square">
-            <a:spAutoFit/>
-          </a:bodyPr>
-          <a:lstStyle/>
-          <a:p>
-            <a:pPr algn="l"/>
-            <a:r>
-              <a:rPr sz="1200" b="1">
-                <a:solidFill>
-                  <a:srgbClr val="FFFFFF"/>
-                </a:solidFill>
-                <a:latin typeface="Arial"/>
-              </a:rPr>
-              <a:t>Usuarios</a:t>
-            </a:r>
-          </a:p>
-        </p:txBody>
-      </p:sp>
-      <p:sp>
-        <p:nvSpPr>
-          <p:cNvPr id="7" name="TextBox 6"/>
-          <p:cNvSpPr txBox="1"/>
-          <p:nvPr/>
-        </p:nvSpPr>
-        <p:spPr>
-          <a:xfrm>
-            <a:off x="7802880" y="2203840"/>
-            <a:ext cx="3261360" cy="365760"/>
-          </a:xfrm>
-          <a:prstGeom prst="rect">
-            <a:avLst/>
-          </a:prstGeom>
-          <a:noFill/>
-        </p:spPr>
-        <p:txBody>
-          <a:bodyPr wrap="square">
-            <a:spAutoFit/>
-          </a:bodyPr>
-          <a:lstStyle/>
-          <a:p>
-            <a:pPr algn="l"/>
-            <a:r>
-              <a:rPr sz="1200" b="1">
-                <a:solidFill>
-                  <a:srgbClr val="FFFFFF"/>
-                </a:solidFill>
-                <a:latin typeface="Arial"/>
-              </a:rPr>
-              <a:t>Confianza típica</a:t>
-            </a:r>
-          </a:p>
-        </p:txBody>
-      </p:sp>
-      <p:sp>
-        <p:nvSpPr>
-          <p:cNvPr id="8" name="Rectangle 7"/>
-          <p:cNvSpPr/>
-          <p:nvPr/>
-        </p:nvSpPr>
-        <p:spPr>
-          <a:xfrm>
-            <a:off x="1051560" y="2514600"/>
-            <a:ext cx="10058400" cy="310896"/>
-          </a:xfrm>
-          <a:prstGeom prst="rect">
-            <a:avLst/>
-          </a:prstGeom>
-          <a:solidFill>
-            <a:srgbClr val="F1F2F6"/>
-          </a:solidFill>
-          <a:ln>
-            <a:noFill/>
-          </a:ln>
-        </p:spPr>
-        <p:style>
-          <a:lnRef idx="1">
-            <a:schemeClr val="accent1"/>
-          </a:lnRef>
-          <a:fillRef idx="3">
-            <a:schemeClr val="accent1"/>
-          </a:fillRef>
-          <a:effectRef idx="2">
-            <a:schemeClr val="accent1"/>
-          </a:effectRef>
-          <a:fontRef idx="minor">
-            <a:schemeClr val="lt1"/>
-          </a:fontRef>
-        </p:style>
-        <p:txBody>
-          <a:bodyPr rtlCol="0" anchor="ctr"/>
-          <a:lstStyle/>
-          <a:p>
-            <a:pPr algn="ctr"/>
-          </a:p>
-        </p:txBody>
-      </p:sp>
-      <p:sp>
-        <p:nvSpPr>
-          <p:cNvPr id="9" name="TextBox 8"/>
-          <p:cNvSpPr txBox="1"/>
-          <p:nvPr/>
-        </p:nvSpPr>
-        <p:spPr>
-          <a:xfrm>
-            <a:off x="1097280" y="2554600"/>
-            <a:ext cx="3261360" cy="310896"/>
-          </a:xfrm>
-          <a:prstGeom prst="rect">
-            <a:avLst/>
-          </a:prstGeom>
-          <a:noFill/>
-        </p:spPr>
-        <p:txBody>
-          <a:bodyPr wrap="square">
-            <a:spAutoFit/>
-          </a:bodyPr>
-          <a:lstStyle/>
-          <a:p>
-            <a:pPr algn="l"/>
-            <a:r>
-              <a:rPr sz="1100" b="0">
-                <a:solidFill>
-                  <a:srgbClr val="465461"/>
-                </a:solidFill>
-                <a:latin typeface="Arial"/>
-              </a:rPr>
-              <a:t>lurker</a:t>
-            </a:r>
-          </a:p>
-        </p:txBody>
-      </p:sp>
-      <p:sp>
-        <p:nvSpPr>
-          <p:cNvPr id="10" name="TextBox 9"/>
-          <p:cNvSpPr txBox="1"/>
-          <p:nvPr/>
-        </p:nvSpPr>
-        <p:spPr>
-          <a:xfrm>
-            <a:off x="4450080" y="2554600"/>
-            <a:ext cx="3261360" cy="310896"/>
-          </a:xfrm>
-          <a:prstGeom prst="rect">
-            <a:avLst/>
-          </a:prstGeom>
-          <a:noFill/>
-        </p:spPr>
-        <p:txBody>
-          <a:bodyPr wrap="square">
-            <a:spAutoFit/>
-          </a:bodyPr>
-          <a:lstStyle/>
-          <a:p>
-            <a:pPr algn="l"/>
-            <a:r>
-              <a:rPr sz="1100" b="0">
-                <a:solidFill>
-                  <a:srgbClr val="465461"/>
-                </a:solidFill>
-                <a:latin typeface="Arial"/>
-              </a:rPr>
-              <a:t>20</a:t>
-            </a:r>
-          </a:p>
-        </p:txBody>
-      </p:sp>
-      <p:sp>
-        <p:nvSpPr>
-          <p:cNvPr id="11" name="TextBox 10"/>
-          <p:cNvSpPr txBox="1"/>
-          <p:nvPr/>
-        </p:nvSpPr>
-        <p:spPr>
-          <a:xfrm>
-            <a:off x="7802880" y="2554600"/>
-            <a:ext cx="3261360" cy="310896"/>
-          </a:xfrm>
-          <a:prstGeom prst="rect">
-            <a:avLst/>
-          </a:prstGeom>
-          <a:noFill/>
-        </p:spPr>
-        <p:txBody>
-          <a:bodyPr wrap="square">
-            <a:spAutoFit/>
-          </a:bodyPr>
-          <a:lstStyle/>
-          <a:p>
-            <a:pPr algn="l"/>
-            <a:r>
-              <a:rPr sz="1100" b="0">
-                <a:solidFill>
-                  <a:srgbClr val="465461"/>
-                </a:solidFill>
-                <a:latin typeface="Arial"/>
-              </a:rPr>
-              <a:t>0.85–0.95</a:t>
-            </a:r>
-          </a:p>
-        </p:txBody>
-      </p:sp>
-      <p:sp>
-        <p:nvSpPr>
-          <p:cNvPr id="12" name="Rectangle 11"/>
-          <p:cNvSpPr/>
-          <p:nvPr/>
-        </p:nvSpPr>
-        <p:spPr>
-          <a:xfrm>
-            <a:off x="1051560" y="2825496"/>
-            <a:ext cx="10058400" cy="310896"/>
-          </a:xfrm>
-          <a:prstGeom prst="rect">
-            <a:avLst/>
-          </a:prstGeom>
-          <a:solidFill>
-            <a:srgbClr val="FFFFFF"/>
-          </a:solidFill>
-          <a:ln>
-            <a:noFill/>
-          </a:ln>
-        </p:spPr>
-        <p:style>
-          <a:lnRef idx="1">
-            <a:schemeClr val="accent1"/>
-          </a:lnRef>
-          <a:fillRef idx="3">
-            <a:schemeClr val="accent1"/>
-          </a:fillRef>
-          <a:effectRef idx="2">
-            <a:schemeClr val="accent1"/>
-          </a:effectRef>
-          <a:fontRef idx="minor">
-            <a:schemeClr val="lt1"/>
-          </a:fontRef>
-        </p:style>
-        <p:txBody>
-          <a:bodyPr rtlCol="0" anchor="ctr"/>
-          <a:lstStyle/>
-          <a:p>
-            <a:pPr algn="ctr"/>
-          </a:p>
-        </p:txBody>
-      </p:sp>
-      <p:sp>
-        <p:nvSpPr>
-          <p:cNvPr id="13" name="TextBox 12"/>
-          <p:cNvSpPr txBox="1"/>
-          <p:nvPr/>
-        </p:nvSpPr>
-        <p:spPr>
-          <a:xfrm>
-            <a:off x="1097280" y="2865496"/>
-            <a:ext cx="3261360" cy="310896"/>
-          </a:xfrm>
-          <a:prstGeom prst="rect">
-            <a:avLst/>
-          </a:prstGeom>
-          <a:noFill/>
-        </p:spPr>
-        <p:txBody>
-          <a:bodyPr wrap="square">
-            <a:spAutoFit/>
-          </a:bodyPr>
-          <a:lstStyle/>
-          <a:p>
-            <a:pPr algn="l"/>
-            <a:r>
-              <a:rPr sz="1100" b="0">
-                <a:solidFill>
-                  <a:srgbClr val="465461"/>
-                </a:solidFill>
-                <a:latin typeface="Arial"/>
-              </a:rPr>
-              <a:t>comprador</a:t>
-            </a:r>
-          </a:p>
-        </p:txBody>
-      </p:sp>
-      <p:sp>
-        <p:nvSpPr>
-          <p:cNvPr id="14" name="TextBox 13"/>
-          <p:cNvSpPr txBox="1"/>
-          <p:nvPr/>
-        </p:nvSpPr>
-        <p:spPr>
-          <a:xfrm>
-            <a:off x="4450080" y="2865496"/>
-            <a:ext cx="3261360" cy="310896"/>
-          </a:xfrm>
-          <a:prstGeom prst="rect">
-            <a:avLst/>
-          </a:prstGeom>
-          <a:noFill/>
-        </p:spPr>
-        <p:txBody>
-          <a:bodyPr wrap="square">
-            <a:spAutoFit/>
-          </a:bodyPr>
-          <a:lstStyle/>
-          <a:p>
-            <a:pPr algn="l"/>
-            <a:r>
-              <a:rPr sz="1100" b="0">
-                <a:solidFill>
-                  <a:srgbClr val="465461"/>
-                </a:solidFill>
-                <a:latin typeface="Arial"/>
-              </a:rPr>
-              <a:t>3</a:t>
-            </a:r>
-          </a:p>
-        </p:txBody>
-      </p:sp>
-      <p:sp>
-        <p:nvSpPr>
-          <p:cNvPr id="15" name="TextBox 14"/>
-          <p:cNvSpPr txBox="1"/>
-          <p:nvPr/>
-        </p:nvSpPr>
-        <p:spPr>
-          <a:xfrm>
-            <a:off x="7802880" y="2865496"/>
-            <a:ext cx="3261360" cy="310896"/>
-          </a:xfrm>
-          <a:prstGeom prst="rect">
-            <a:avLst/>
-          </a:prstGeom>
-          <a:noFill/>
-        </p:spPr>
-        <p:txBody>
-          <a:bodyPr wrap="square">
-            <a:spAutoFit/>
-          </a:bodyPr>
-          <a:lstStyle/>
-          <a:p>
-            <a:pPr algn="l"/>
-            <a:r>
-              <a:rPr sz="1100" b="0">
-                <a:solidFill>
-                  <a:srgbClr val="465461"/>
-                </a:solidFill>
-                <a:latin typeface="Arial"/>
-              </a:rPr>
-              <a:t>0.70–0.85</a:t>
-            </a:r>
-          </a:p>
-        </p:txBody>
-      </p:sp>
-      <p:sp>
-        <p:nvSpPr>
-          <p:cNvPr id="16" name="Rectangle 15"/>
-          <p:cNvSpPr/>
-          <p:nvPr/>
-        </p:nvSpPr>
-        <p:spPr>
-          <a:xfrm>
-            <a:off x="1051560" y="3136391"/>
-            <a:ext cx="10058400" cy="310896"/>
-          </a:xfrm>
-          <a:prstGeom prst="rect">
-            <a:avLst/>
-          </a:prstGeom>
-          <a:solidFill>
-            <a:srgbClr val="F1F2F6"/>
-          </a:solidFill>
-          <a:ln>
-            <a:noFill/>
-          </a:ln>
-        </p:spPr>
-        <p:style>
-          <a:lnRef idx="1">
-            <a:schemeClr val="accent1"/>
-          </a:lnRef>
-          <a:fillRef idx="3">
-            <a:schemeClr val="accent1"/>
-          </a:fillRef>
-          <a:effectRef idx="2">
-            <a:schemeClr val="accent1"/>
-          </a:effectRef>
-          <a:fontRef idx="minor">
-            <a:schemeClr val="lt1"/>
-          </a:fontRef>
-        </p:style>
-        <p:txBody>
-          <a:bodyPr rtlCol="0" anchor="ctr"/>
-          <a:lstStyle/>
-          <a:p>
-            <a:pPr algn="ctr"/>
-          </a:p>
-        </p:txBody>
-      </p:sp>
-      <p:sp>
-        <p:nvSpPr>
-          <p:cNvPr id="17" name="TextBox 16"/>
-          <p:cNvSpPr txBox="1"/>
-          <p:nvPr/>
-        </p:nvSpPr>
-        <p:spPr>
-          <a:xfrm>
-            <a:off x="1097280" y="3176391"/>
-            <a:ext cx="3261360" cy="310896"/>
-          </a:xfrm>
-          <a:prstGeom prst="rect">
-            <a:avLst/>
-          </a:prstGeom>
-          <a:noFill/>
-        </p:spPr>
-        <p:txBody>
-          <a:bodyPr wrap="square">
-            <a:spAutoFit/>
-          </a:bodyPr>
-          <a:lstStyle/>
-          <a:p>
-            <a:pPr algn="l"/>
-            <a:r>
-              <a:rPr sz="1100" b="0">
-                <a:solidFill>
-                  <a:srgbClr val="465461"/>
-                </a:solidFill>
-                <a:latin typeface="Arial"/>
-              </a:rPr>
-              <a:t>intermediario_escrow</a:t>
-            </a:r>
-          </a:p>
-        </p:txBody>
-      </p:sp>
-      <p:sp>
-        <p:nvSpPr>
-          <p:cNvPr id="18" name="TextBox 17"/>
-          <p:cNvSpPr txBox="1"/>
-          <p:nvPr/>
-        </p:nvSpPr>
-        <p:spPr>
-          <a:xfrm>
-            <a:off x="4450080" y="3176391"/>
-            <a:ext cx="3261360" cy="310896"/>
-          </a:xfrm>
-          <a:prstGeom prst="rect">
-            <a:avLst/>
-          </a:prstGeom>
-          <a:noFill/>
-        </p:spPr>
-        <p:txBody>
-          <a:bodyPr wrap="square">
-            <a:spAutoFit/>
-          </a:bodyPr>
-          <a:lstStyle/>
-          <a:p>
-            <a:pPr algn="l"/>
-            <a:r>
-              <a:rPr sz="1100" b="0">
-                <a:solidFill>
-                  <a:srgbClr val="465461"/>
-                </a:solidFill>
-                <a:latin typeface="Arial"/>
-              </a:rPr>
-              <a:t>3</a:t>
-            </a:r>
-          </a:p>
-        </p:txBody>
-      </p:sp>
-      <p:sp>
-        <p:nvSpPr>
-          <p:cNvPr id="19" name="TextBox 18"/>
-          <p:cNvSpPr txBox="1"/>
-          <p:nvPr/>
-        </p:nvSpPr>
-        <p:spPr>
-          <a:xfrm>
-            <a:off x="7802880" y="3176391"/>
-            <a:ext cx="3261360" cy="310896"/>
-          </a:xfrm>
-          <a:prstGeom prst="rect">
-            <a:avLst/>
-          </a:prstGeom>
-          <a:noFill/>
-        </p:spPr>
-        <p:txBody>
-          <a:bodyPr wrap="square">
-            <a:spAutoFit/>
-          </a:bodyPr>
-          <a:lstStyle/>
-          <a:p>
-            <a:pPr algn="l"/>
-            <a:r>
-              <a:rPr sz="1100" b="0">
-                <a:solidFill>
-                  <a:srgbClr val="465461"/>
-                </a:solidFill>
-                <a:latin typeface="Arial"/>
-              </a:rPr>
-              <a:t>0.70–0.85</a:t>
-            </a:r>
-          </a:p>
-        </p:txBody>
-      </p:sp>
-      <p:sp>
-        <p:nvSpPr>
-          <p:cNvPr id="20" name="Rectangle 19"/>
-          <p:cNvSpPr/>
-          <p:nvPr/>
-        </p:nvSpPr>
-        <p:spPr>
-          <a:xfrm>
-            <a:off x="1051560" y="3447287"/>
-            <a:ext cx="10058400" cy="310896"/>
-          </a:xfrm>
-          <a:prstGeom prst="rect">
-            <a:avLst/>
-          </a:prstGeom>
-          <a:solidFill>
-            <a:srgbClr val="FFFFFF"/>
-          </a:solidFill>
-          <a:ln>
-            <a:noFill/>
-          </a:ln>
-        </p:spPr>
-        <p:style>
-          <a:lnRef idx="1">
-            <a:schemeClr val="accent1"/>
-          </a:lnRef>
-          <a:fillRef idx="3">
-            <a:schemeClr val="accent1"/>
-          </a:fillRef>
-          <a:effectRef idx="2">
-            <a:schemeClr val="accent1"/>
-          </a:effectRef>
-          <a:fontRef idx="minor">
-            <a:schemeClr val="lt1"/>
-          </a:fontRef>
-        </p:style>
-        <p:txBody>
-          <a:bodyPr rtlCol="0" anchor="ctr"/>
-          <a:lstStyle/>
-          <a:p>
-            <a:pPr algn="ctr"/>
-          </a:p>
-        </p:txBody>
-      </p:sp>
-      <p:sp>
-        <p:nvSpPr>
-          <p:cNvPr id="21" name="TextBox 20"/>
-          <p:cNvSpPr txBox="1"/>
-          <p:nvPr/>
-        </p:nvSpPr>
-        <p:spPr>
-          <a:xfrm>
-            <a:off x="1097280" y="3487287"/>
-            <a:ext cx="3261360" cy="310896"/>
-          </a:xfrm>
-          <a:prstGeom prst="rect">
-            <a:avLst/>
-          </a:prstGeom>
-          <a:noFill/>
-        </p:spPr>
-        <p:txBody>
-          <a:bodyPr wrap="square">
-            <a:spAutoFit/>
-          </a:bodyPr>
-          <a:lstStyle/>
-          <a:p>
-            <a:pPr algn="l"/>
-            <a:r>
-              <a:rPr sz="1100" b="0">
-                <a:solidFill>
-                  <a:srgbClr val="465461"/>
-                </a:solidFill>
-                <a:latin typeface="Arial"/>
-              </a:rPr>
-              <a:t>indeterminado</a:t>
-            </a:r>
-          </a:p>
-        </p:txBody>
-      </p:sp>
-      <p:sp>
-        <p:nvSpPr>
-          <p:cNvPr id="22" name="TextBox 21"/>
-          <p:cNvSpPr txBox="1"/>
-          <p:nvPr/>
-        </p:nvSpPr>
-        <p:spPr>
-          <a:xfrm>
-            <a:off x="4450080" y="3487287"/>
-            <a:ext cx="3261360" cy="310896"/>
-          </a:xfrm>
-          <a:prstGeom prst="rect">
-            <a:avLst/>
-          </a:prstGeom>
-          <a:noFill/>
-        </p:spPr>
-        <p:txBody>
-          <a:bodyPr wrap="square">
-            <a:spAutoFit/>
-          </a:bodyPr>
-          <a:lstStyle/>
-          <a:p>
-            <a:pPr algn="l"/>
-            <a:r>
-              <a:rPr sz="1100" b="0">
-                <a:solidFill>
-                  <a:srgbClr val="465461"/>
-                </a:solidFill>
-                <a:latin typeface="Arial"/>
-              </a:rPr>
-              <a:t>2</a:t>
-            </a:r>
-          </a:p>
-        </p:txBody>
-      </p:sp>
-      <p:sp>
-        <p:nvSpPr>
-          <p:cNvPr id="23" name="TextBox 22"/>
-          <p:cNvSpPr txBox="1"/>
-          <p:nvPr/>
-        </p:nvSpPr>
-        <p:spPr>
-          <a:xfrm>
-            <a:off x="7802880" y="3487287"/>
-            <a:ext cx="3261360" cy="310896"/>
-          </a:xfrm>
-          <a:prstGeom prst="rect">
-            <a:avLst/>
-          </a:prstGeom>
-          <a:noFill/>
-        </p:spPr>
-        <p:txBody>
-          <a:bodyPr wrap="square">
-            <a:spAutoFit/>
-          </a:bodyPr>
-          <a:lstStyle/>
-          <a:p>
-            <a:pPr algn="l"/>
-            <a:r>
-              <a:rPr sz="1100" b="0">
-                <a:solidFill>
-                  <a:srgbClr val="465461"/>
-                </a:solidFill>
-                <a:latin typeface="Arial"/>
-              </a:rPr>
-              <a:t>0.50–0.65</a:t>
-            </a:r>
-          </a:p>
-        </p:txBody>
-      </p:sp>
-      <p:sp>
-        <p:nvSpPr>
-          <p:cNvPr id="24" name="Rectangle 23"/>
-          <p:cNvSpPr/>
-          <p:nvPr/>
-        </p:nvSpPr>
-        <p:spPr>
-          <a:xfrm>
-            <a:off x="1051560" y="3758183"/>
-            <a:ext cx="10058400" cy="310896"/>
-          </a:xfrm>
-          <a:prstGeom prst="rect">
-            <a:avLst/>
-          </a:prstGeom>
-          <a:solidFill>
-            <a:srgbClr val="F1F2F6"/>
-          </a:solidFill>
-          <a:ln>
-            <a:noFill/>
-          </a:ln>
-        </p:spPr>
-        <p:style>
-          <a:lnRef idx="1">
-            <a:schemeClr val="accent1"/>
-          </a:lnRef>
-          <a:fillRef idx="3">
-            <a:schemeClr val="accent1"/>
-          </a:fillRef>
-          <a:effectRef idx="2">
-            <a:schemeClr val="accent1"/>
-          </a:effectRef>
-          <a:fontRef idx="minor">
-            <a:schemeClr val="lt1"/>
-          </a:fontRef>
-        </p:style>
-        <p:txBody>
-          <a:bodyPr rtlCol="0" anchor="ctr"/>
-          <a:lstStyle/>
-          <a:p>
-            <a:pPr algn="ctr"/>
-          </a:p>
-        </p:txBody>
-      </p:sp>
-      <p:sp>
-        <p:nvSpPr>
-          <p:cNvPr id="25" name="TextBox 24"/>
-          <p:cNvSpPr txBox="1"/>
-          <p:nvPr/>
-        </p:nvSpPr>
-        <p:spPr>
-          <a:xfrm>
-            <a:off x="1097280" y="3798183"/>
-            <a:ext cx="3261360" cy="310896"/>
-          </a:xfrm>
-          <a:prstGeom prst="rect">
-            <a:avLst/>
-          </a:prstGeom>
-          <a:noFill/>
-        </p:spPr>
-        <p:txBody>
-          <a:bodyPr wrap="square">
-            <a:spAutoFit/>
-          </a:bodyPr>
-          <a:lstStyle/>
-          <a:p>
-            <a:pPr algn="l"/>
-            <a:r>
-              <a:rPr sz="1100" b="0">
-                <a:solidFill>
-                  <a:srgbClr val="465461"/>
-                </a:solidFill>
-                <a:latin typeface="Arial"/>
-              </a:rPr>
-              <a:t>vendedor_dumps</a:t>
-            </a:r>
-          </a:p>
-        </p:txBody>
-      </p:sp>
-      <p:sp>
-        <p:nvSpPr>
-          <p:cNvPr id="26" name="TextBox 25"/>
-          <p:cNvSpPr txBox="1"/>
-          <p:nvPr/>
-        </p:nvSpPr>
-        <p:spPr>
-          <a:xfrm>
-            <a:off x="4450080" y="3798183"/>
-            <a:ext cx="3261360" cy="310896"/>
-          </a:xfrm>
-          <a:prstGeom prst="rect">
-            <a:avLst/>
-          </a:prstGeom>
-          <a:noFill/>
-        </p:spPr>
-        <p:txBody>
-          <a:bodyPr wrap="square">
-            <a:spAutoFit/>
-          </a:bodyPr>
-          <a:lstStyle/>
-          <a:p>
-            <a:pPr algn="l"/>
-            <a:r>
-              <a:rPr sz="1100" b="0">
-                <a:solidFill>
-                  <a:srgbClr val="465461"/>
-                </a:solidFill>
-                <a:latin typeface="Arial"/>
-              </a:rPr>
-              <a:t>1</a:t>
-            </a:r>
-          </a:p>
-        </p:txBody>
-      </p:sp>
-      <p:sp>
-        <p:nvSpPr>
-          <p:cNvPr id="27" name="TextBox 26"/>
-          <p:cNvSpPr txBox="1"/>
-          <p:nvPr/>
-        </p:nvSpPr>
-        <p:spPr>
-          <a:xfrm>
-            <a:off x="7802880" y="3798183"/>
-            <a:ext cx="3261360" cy="310896"/>
-          </a:xfrm>
-          <a:prstGeom prst="rect">
-            <a:avLst/>
-          </a:prstGeom>
-          <a:noFill/>
-        </p:spPr>
-        <p:txBody>
-          <a:bodyPr wrap="square">
-            <a:spAutoFit/>
-          </a:bodyPr>
-          <a:lstStyle/>
-          <a:p>
-            <a:pPr algn="l"/>
-            <a:r>
-              <a:rPr sz="1100" b="0">
-                <a:solidFill>
-                  <a:srgbClr val="465461"/>
-                </a:solidFill>
-                <a:latin typeface="Arial"/>
-              </a:rPr>
-              <a:t>0.80</a:t>
-            </a:r>
-          </a:p>
-        </p:txBody>
-      </p:sp>
-      <p:sp>
-        <p:nvSpPr>
-          <p:cNvPr id="28" name="Rectangle 27"/>
-          <p:cNvSpPr/>
-          <p:nvPr/>
-        </p:nvSpPr>
-        <p:spPr>
-          <a:xfrm>
-            <a:off x="1051560" y="4069079"/>
-            <a:ext cx="10058400" cy="310896"/>
-          </a:xfrm>
-          <a:prstGeom prst="rect">
-            <a:avLst/>
-          </a:prstGeom>
-          <a:solidFill>
-            <a:srgbClr val="FFFFFF"/>
-          </a:solidFill>
-          <a:ln>
-            <a:noFill/>
-          </a:ln>
-        </p:spPr>
-        <p:style>
-          <a:lnRef idx="1">
-            <a:schemeClr val="accent1"/>
-          </a:lnRef>
-          <a:fillRef idx="3">
-            <a:schemeClr val="accent1"/>
-          </a:fillRef>
-          <a:effectRef idx="2">
-            <a:schemeClr val="accent1"/>
-          </a:effectRef>
-          <a:fontRef idx="minor">
-            <a:schemeClr val="lt1"/>
-          </a:fontRef>
-        </p:style>
-        <p:txBody>
-          <a:bodyPr rtlCol="0" anchor="ctr"/>
-          <a:lstStyle/>
-          <a:p>
-            <a:pPr algn="ctr"/>
-          </a:p>
-        </p:txBody>
-      </p:sp>
-      <p:sp>
-        <p:nvSpPr>
-          <p:cNvPr id="29" name="TextBox 28"/>
-          <p:cNvSpPr txBox="1"/>
-          <p:nvPr/>
-        </p:nvSpPr>
-        <p:spPr>
-          <a:xfrm>
-            <a:off x="1097280" y="4109079"/>
-            <a:ext cx="3261360" cy="310896"/>
-          </a:xfrm>
-          <a:prstGeom prst="rect">
-            <a:avLst/>
-          </a:prstGeom>
-          <a:noFill/>
-        </p:spPr>
-        <p:txBody>
-          <a:bodyPr wrap="square">
-            <a:spAutoFit/>
-          </a:bodyPr>
-          <a:lstStyle/>
-          <a:p>
-            <a:pPr algn="l"/>
-            <a:r>
-              <a:rPr sz="1100" b="0">
-                <a:solidFill>
-                  <a:srgbClr val="465461"/>
-                </a:solidFill>
-                <a:latin typeface="Arial"/>
-              </a:rPr>
-              <a:t>checker</a:t>
-            </a:r>
-          </a:p>
-        </p:txBody>
-      </p:sp>
-      <p:sp>
-        <p:nvSpPr>
-          <p:cNvPr id="30" name="TextBox 29"/>
-          <p:cNvSpPr txBox="1"/>
-          <p:nvPr/>
-        </p:nvSpPr>
-        <p:spPr>
-          <a:xfrm>
-            <a:off x="4450080" y="4109079"/>
-            <a:ext cx="3261360" cy="310896"/>
-          </a:xfrm>
-          <a:prstGeom prst="rect">
-            <a:avLst/>
-          </a:prstGeom>
-          <a:noFill/>
-        </p:spPr>
-        <p:txBody>
-          <a:bodyPr wrap="square">
-            <a:spAutoFit/>
-          </a:bodyPr>
-          <a:lstStyle/>
-          <a:p>
-            <a:pPr algn="l"/>
-            <a:r>
-              <a:rPr sz="1100" b="0">
-                <a:solidFill>
-                  <a:srgbClr val="465461"/>
-                </a:solidFill>
-                <a:latin typeface="Arial"/>
-              </a:rPr>
-              <a:t>1</a:t>
-            </a:r>
-          </a:p>
-        </p:txBody>
-      </p:sp>
-      <p:sp>
-        <p:nvSpPr>
-          <p:cNvPr id="31" name="TextBox 30"/>
-          <p:cNvSpPr txBox="1"/>
-          <p:nvPr/>
-        </p:nvSpPr>
-        <p:spPr>
-          <a:xfrm>
-            <a:off x="7802880" y="4109079"/>
-            <a:ext cx="3261360" cy="310896"/>
-          </a:xfrm>
-          <a:prstGeom prst="rect">
-            <a:avLst/>
-          </a:prstGeom>
-          <a:noFill/>
-        </p:spPr>
-        <p:txBody>
-          <a:bodyPr wrap="square">
-            <a:spAutoFit/>
-          </a:bodyPr>
-          <a:lstStyle/>
-          <a:p>
-            <a:pPr algn="l"/>
-            <a:r>
-              <a:rPr sz="1100" b="0">
-                <a:solidFill>
-                  <a:srgbClr val="465461"/>
-                </a:solidFill>
-                <a:latin typeface="Arial"/>
-              </a:rPr>
-              <a:t>0.75</a:t>
-            </a:r>
-          </a:p>
-        </p:txBody>
-      </p:sp>
-      <p:sp>
-        <p:nvSpPr>
-          <p:cNvPr id="32" name="TextBox 31"/>
           <p:cNvSpPr txBox="1"/>
           <p:nvPr/>
         </p:nvSpPr>
@@ -8480,49 +7947,1024 @@
           <a:p/>
         </p:txBody>
       </p:sp>
-      <p:sp>
-        <p:nvSpPr>
-          <p:cNvPr id="4" name="Rectangle 3"/>
-          <p:cNvSpPr/>
+      <p:graphicFrame>
+        <p:nvGraphicFramePr>
+          <p:cNvPr id="4" name="Table 3"/>
+          <p:cNvGraphicFramePr>
+            <a:graphicFrameLocks noGrp="1"/>
+          </p:cNvGraphicFramePr>
           <p:nvPr/>
-        </p:nvSpPr>
-        <p:spPr>
-          <a:xfrm>
-            <a:off x="1051560" y="1645920"/>
-            <a:ext cx="10058400" cy="365760"/>
-          </a:xfrm>
-          <a:prstGeom prst="rect">
-            <a:avLst/>
-          </a:prstGeom>
-          <a:solidFill>
-            <a:srgbClr val="CD2D37"/>
-          </a:solidFill>
-          <a:ln>
-            <a:noFill/>
-          </a:ln>
-        </p:spPr>
-        <p:style>
-          <a:lnRef idx="1">
-            <a:schemeClr val="accent1"/>
-          </a:lnRef>
-          <a:fillRef idx="3">
-            <a:schemeClr val="accent1"/>
-          </a:fillRef>
-          <a:effectRef idx="2">
-            <a:schemeClr val="accent1"/>
-          </a:effectRef>
-          <a:fontRef idx="minor">
-            <a:schemeClr val="lt1"/>
-          </a:fontRef>
-        </p:style>
-        <p:txBody>
-          <a:bodyPr rtlCol="0" anchor="ctr"/>
-          <a:lstStyle/>
-          <a:p>
-            <a:pPr algn="ctr"/>
-          </a:p>
-        </p:txBody>
-      </p:sp>
+        </p:nvGraphicFramePr>
+        <p:xfrm>
+          <a:off x="1051560" y="1645920"/>
+          <a:ext cx="10058400" cy="4023360"/>
+        </p:xfrm>
+        <a:graphic>
+          <a:graphicData uri="http://schemas.openxmlformats.org/drawingml/2006/table">
+            <a:tbl>
+              <a:tblPr>
+                <a:tableStyleId>{5C22544A-7EE6-4342-B048-85BDC9FD1C3A}</a:tableStyleId>
+              </a:tblPr>
+              <a:tblGrid>
+                <a:gridCol w="2514600"/>
+                <a:gridCol w="2514600"/>
+                <a:gridCol w="2514600"/>
+                <a:gridCol w="2514600"/>
+              </a:tblGrid>
+              <a:tr h="365760">
+                <a:tc>
+                  <a:txBody>
+                    <a:bodyPr/>
+                    <a:lstStyle/>
+                    <a:p>
+                      <a:r>
+                        <a:rPr sz="1200" b="1">
+                          <a:solidFill>
+                            <a:srgbClr val="FFFFFF"/>
+                          </a:solidFill>
+                          <a:latin typeface="Arial"/>
+                        </a:rPr>
+                        <a:t>Foro</a:t>
+                      </a:r>
+                    </a:p>
+                  </a:txBody>
+                  <a:tcPr marL="45000" marR="45000" marT="25000" marB="25000" anchor="ctr">
+                    <a:solidFill>
+                      <a:srgbClr val="CD2D37"/>
+                    </a:solidFill>
+                  </a:tcPr>
+                </a:tc>
+                <a:tc>
+                  <a:txBody>
+                    <a:bodyPr/>
+                    <a:lstStyle/>
+                    <a:p>
+                      <a:r>
+                        <a:rPr sz="1200" b="1">
+                          <a:solidFill>
+                            <a:srgbClr val="FFFFFF"/>
+                          </a:solidFill>
+                          <a:latin typeface="Arial"/>
+                        </a:rPr>
+                        <a:t>Fecha del dump</a:t>
+                      </a:r>
+                    </a:p>
+                  </a:txBody>
+                  <a:tcPr marL="45000" marR="45000" marT="25000" marB="25000" anchor="ctr">
+                    <a:solidFill>
+                      <a:srgbClr val="CD2D37"/>
+                    </a:solidFill>
+                  </a:tcPr>
+                </a:tc>
+                <a:tc>
+                  <a:txBody>
+                    <a:bodyPr/>
+                    <a:lstStyle/>
+                    <a:p>
+                      <a:r>
+                        <a:rPr sz="1200" b="1">
+                          <a:solidFill>
+                            <a:srgbClr val="FFFFFF"/>
+                          </a:solidFill>
+                          <a:latin typeface="Arial"/>
+                        </a:rPr>
+                        <a:t>Formato</a:t>
+                      </a:r>
+                    </a:p>
+                  </a:txBody>
+                  <a:tcPr marL="45000" marR="45000" marT="25000" marB="25000" anchor="ctr">
+                    <a:solidFill>
+                      <a:srgbClr val="CD2D37"/>
+                    </a:solidFill>
+                  </a:tcPr>
+                </a:tc>
+                <a:tc>
+                  <a:txBody>
+                    <a:bodyPr/>
+                    <a:lstStyle/>
+                    <a:p>
+                      <a:r>
+                        <a:rPr sz="1200" b="1">
+                          <a:solidFill>
+                            <a:srgbClr val="FFFFFF"/>
+                          </a:solidFill>
+                          <a:latin typeface="Arial"/>
+                        </a:rPr>
+                        <a:t>Notas</a:t>
+                      </a:r>
+                    </a:p>
+                  </a:txBody>
+                  <a:tcPr marL="45000" marR="45000" marT="25000" marB="25000" anchor="ctr">
+                    <a:solidFill>
+                      <a:srgbClr val="CD2D37"/>
+                    </a:solidFill>
+                  </a:tcPr>
+                </a:tc>
+              </a:tr>
+              <a:tr h="365760">
+                <a:tc>
+                  <a:txBody>
+                    <a:bodyPr/>
+                    <a:lstStyle/>
+                    <a:p>
+                      <a:r>
+                        <a:rPr sz="1100" b="0">
+                          <a:solidFill>
+                            <a:srgbClr val="465461"/>
+                          </a:solidFill>
+                          <a:latin typeface="Arial"/>
+                        </a:rPr>
+                        <a:t>Carder.su</a:t>
+                      </a:r>
+                    </a:p>
+                  </a:txBody>
+                  <a:tcPr marL="45000" marR="45000" marT="25000" marB="25000" anchor="ctr">
+                    <a:solidFill>
+                      <a:srgbClr val="F1F2F6"/>
+                    </a:solidFill>
+                  </a:tcPr>
+                </a:tc>
+                <a:tc>
+                  <a:txBody>
+                    <a:bodyPr/>
+                    <a:lstStyle/>
+                    <a:p>
+                      <a:r>
+                        <a:rPr sz="1100" b="0">
+                          <a:solidFill>
+                            <a:srgbClr val="465461"/>
+                          </a:solidFill>
+                          <a:latin typeface="Arial"/>
+                        </a:rPr>
+                        <a:t>2009-02</a:t>
+                      </a:r>
+                    </a:p>
+                  </a:txBody>
+                  <a:tcPr marL="45000" marR="45000" marT="25000" marB="25000" anchor="ctr">
+                    <a:solidFill>
+                      <a:srgbClr val="F1F2F6"/>
+                    </a:solidFill>
+                  </a:tcPr>
+                </a:tc>
+                <a:tc>
+                  <a:txBody>
+                    <a:bodyPr/>
+                    <a:lstStyle/>
+                    <a:p>
+                      <a:r>
+                        <a:rPr sz="1100" b="0">
+                          <a:solidFill>
+                            <a:srgbClr val="465461"/>
+                          </a:solidFill>
+                          <a:latin typeface="Arial"/>
+                        </a:rPr>
+                        <a:t>vBulletin SQL</a:t>
+                      </a:r>
+                    </a:p>
+                  </a:txBody>
+                  <a:tcPr marL="45000" marR="45000" marT="25000" marB="25000" anchor="ctr">
+                    <a:solidFill>
+                      <a:srgbClr val="F1F2F6"/>
+                    </a:solidFill>
+                  </a:tcPr>
+                </a:tc>
+                <a:tc>
+                  <a:txBody>
+                    <a:bodyPr/>
+                    <a:lstStyle/>
+                    <a:p>
+                      <a:r>
+                        <a:rPr sz="1100" b="0">
+                          <a:solidFill>
+                            <a:srgbClr val="465461"/>
+                          </a:solidFill>
+                          <a:latin typeface="Arial"/>
+                        </a:rPr>
+                        <a:t>Uno de los primeros foros importantes</a:t>
+                      </a:r>
+                    </a:p>
+                  </a:txBody>
+                  <a:tcPr marL="45000" marR="45000" marT="25000" marB="25000" anchor="ctr">
+                    <a:solidFill>
+                      <a:srgbClr val="F1F2F6"/>
+                    </a:solidFill>
+                  </a:tcPr>
+                </a:tc>
+              </a:tr>
+              <a:tr h="365760">
+                <a:tc>
+                  <a:txBody>
+                    <a:bodyPr/>
+                    <a:lstStyle/>
+                    <a:p>
+                      <a:r>
+                        <a:rPr sz="1100" b="0">
+                          <a:solidFill>
+                            <a:srgbClr val="465461"/>
+                          </a:solidFill>
+                          <a:latin typeface="Arial"/>
+                        </a:rPr>
+                        <a:t>Carding.biz</a:t>
+                      </a:r>
+                    </a:p>
+                  </a:txBody>
+                  <a:tcPr marL="45000" marR="45000" marT="25000" marB="25000" anchor="ctr">
+                    <a:solidFill>
+                      <a:srgbClr val="FFFFFF"/>
+                    </a:solidFill>
+                  </a:tcPr>
+                </a:tc>
+                <a:tc>
+                  <a:txBody>
+                    <a:bodyPr/>
+                    <a:lstStyle/>
+                    <a:p>
+                      <a:r>
+                        <a:rPr sz="1100" b="0">
+                          <a:solidFill>
+                            <a:srgbClr val="465461"/>
+                          </a:solidFill>
+                          <a:latin typeface="Arial"/>
+                        </a:rPr>
+                        <a:t>2009-11</a:t>
+                      </a:r>
+                    </a:p>
+                  </a:txBody>
+                  <a:tcPr marL="45000" marR="45000" marT="25000" marB="25000" anchor="ctr">
+                    <a:solidFill>
+                      <a:srgbClr val="FFFFFF"/>
+                    </a:solidFill>
+                  </a:tcPr>
+                </a:tc>
+                <a:tc>
+                  <a:txBody>
+                    <a:bodyPr/>
+                    <a:lstStyle/>
+                    <a:p>
+                      <a:r>
+                        <a:rPr sz="1100" b="0">
+                          <a:solidFill>
+                            <a:srgbClr val="465461"/>
+                          </a:solidFill>
+                          <a:latin typeface="Arial"/>
+                        </a:rPr>
+                        <a:t>vBulletin SQL</a:t>
+                      </a:r>
+                    </a:p>
+                  </a:txBody>
+                  <a:tcPr marL="45000" marR="45000" marT="25000" marB="25000" anchor="ctr">
+                    <a:solidFill>
+                      <a:srgbClr val="FFFFFF"/>
+                    </a:solidFill>
+                  </a:tcPr>
+                </a:tc>
+                <a:tc>
+                  <a:txBody>
+                    <a:bodyPr/>
+                    <a:lstStyle/>
+                    <a:p>
+                      <a:r>
+                        <a:rPr sz="1100" b="0">
+                          <a:solidFill>
+                            <a:srgbClr val="465461"/>
+                          </a:solidFill>
+                          <a:latin typeface="Arial"/>
+                        </a:rPr>
+                        <a:t/>
+                      </a:r>
+                    </a:p>
+                  </a:txBody>
+                  <a:tcPr marL="45000" marR="45000" marT="25000" marB="25000" anchor="ctr">
+                    <a:solidFill>
+                      <a:srgbClr val="FFFFFF"/>
+                    </a:solidFill>
+                  </a:tcPr>
+                </a:tc>
+              </a:tr>
+              <a:tr h="365760">
+                <a:tc>
+                  <a:txBody>
+                    <a:bodyPr/>
+                    <a:lstStyle/>
+                    <a:p>
+                      <a:r>
+                        <a:rPr sz="1100" b="0">
+                          <a:solidFill>
+                            <a:srgbClr val="465461"/>
+                          </a:solidFill>
+                          <a:latin typeface="Arial"/>
+                        </a:rPr>
+                        <a:t>Cardersplanet.biz</a:t>
+                      </a:r>
+                    </a:p>
+                  </a:txBody>
+                  <a:tcPr marL="45000" marR="45000" marT="25000" marB="25000" anchor="ctr">
+                    <a:solidFill>
+                      <a:srgbClr val="F1F2F6"/>
+                    </a:solidFill>
+                  </a:tcPr>
+                </a:tc>
+                <a:tc>
+                  <a:txBody>
+                    <a:bodyPr/>
+                    <a:lstStyle/>
+                    <a:p>
+                      <a:r>
+                        <a:rPr sz="1100" b="0">
+                          <a:solidFill>
+                            <a:srgbClr val="465461"/>
+                          </a:solidFill>
+                          <a:latin typeface="Arial"/>
+                        </a:rPr>
+                        <a:t>2010-05</a:t>
+                      </a:r>
+                    </a:p>
+                  </a:txBody>
+                  <a:tcPr marL="45000" marR="45000" marT="25000" marB="25000" anchor="ctr">
+                    <a:solidFill>
+                      <a:srgbClr val="F1F2F6"/>
+                    </a:solidFill>
+                  </a:tcPr>
+                </a:tc>
+                <a:tc>
+                  <a:txBody>
+                    <a:bodyPr/>
+                    <a:lstStyle/>
+                    <a:p>
+                      <a:r>
+                        <a:rPr sz="1100" b="0">
+                          <a:solidFill>
+                            <a:srgbClr val="465461"/>
+                          </a:solidFill>
+                          <a:latin typeface="Arial"/>
+                        </a:rPr>
+                        <a:t>vBulletin SQL</a:t>
+                      </a:r>
+                    </a:p>
+                  </a:txBody>
+                  <a:tcPr marL="45000" marR="45000" marT="25000" marB="25000" anchor="ctr">
+                    <a:solidFill>
+                      <a:srgbClr val="F1F2F6"/>
+                    </a:solidFill>
+                  </a:tcPr>
+                </a:tc>
+                <a:tc>
+                  <a:txBody>
+                    <a:bodyPr/>
+                    <a:lstStyle/>
+                    <a:p>
+                      <a:r>
+                        <a:rPr sz="1100" b="0">
+                          <a:solidFill>
+                            <a:srgbClr val="465461"/>
+                          </a:solidFill>
+                          <a:latin typeface="Arial"/>
+                        </a:rPr>
+                        <a:t/>
+                      </a:r>
+                    </a:p>
+                  </a:txBody>
+                  <a:tcPr marL="45000" marR="45000" marT="25000" marB="25000" anchor="ctr">
+                    <a:solidFill>
+                      <a:srgbClr val="F1F2F6"/>
+                    </a:solidFill>
+                  </a:tcPr>
+                </a:tc>
+              </a:tr>
+              <a:tr h="365760">
+                <a:tc>
+                  <a:txBody>
+                    <a:bodyPr/>
+                    <a:lstStyle/>
+                    <a:p>
+                      <a:r>
+                        <a:rPr sz="1100" b="0">
+                          <a:solidFill>
+                            <a:srgbClr val="465461"/>
+                          </a:solidFill>
+                          <a:latin typeface="Arial"/>
+                        </a:rPr>
+                        <a:t>Carders.cc</a:t>
+                      </a:r>
+                    </a:p>
+                  </a:txBody>
+                  <a:tcPr marL="45000" marR="45000" marT="25000" marB="25000" anchor="ctr">
+                    <a:solidFill>
+                      <a:srgbClr val="FFFFFF"/>
+                    </a:solidFill>
+                  </a:tcPr>
+                </a:tc>
+                <a:tc>
+                  <a:txBody>
+                    <a:bodyPr/>
+                    <a:lstStyle/>
+                    <a:p>
+                      <a:r>
+                        <a:rPr sz="1100" b="0">
+                          <a:solidFill>
+                            <a:srgbClr val="465461"/>
+                          </a:solidFill>
+                          <a:latin typeface="Arial"/>
+                        </a:rPr>
+                        <a:t>2010-12</a:t>
+                      </a:r>
+                    </a:p>
+                  </a:txBody>
+                  <a:tcPr marL="45000" marR="45000" marT="25000" marB="25000" anchor="ctr">
+                    <a:solidFill>
+                      <a:srgbClr val="FFFFFF"/>
+                    </a:solidFill>
+                  </a:tcPr>
+                </a:tc>
+                <a:tc>
+                  <a:txBody>
+                    <a:bodyPr/>
+                    <a:lstStyle/>
+                    <a:p>
+                      <a:r>
+                        <a:rPr sz="1100" b="0">
+                          <a:solidFill>
+                            <a:srgbClr val="465461"/>
+                          </a:solidFill>
+                          <a:latin typeface="Arial"/>
+                        </a:rPr>
+                        <a:t>vBulletin SQL</a:t>
+                      </a:r>
+                    </a:p>
+                  </a:txBody>
+                  <a:tcPr marL="45000" marR="45000" marT="25000" marB="25000" anchor="ctr">
+                    <a:solidFill>
+                      <a:srgbClr val="FFFFFF"/>
+                    </a:solidFill>
+                  </a:tcPr>
+                </a:tc>
+                <a:tc>
+                  <a:txBody>
+                    <a:bodyPr/>
+                    <a:lstStyle/>
+                    <a:p>
+                      <a:r>
+                        <a:rPr sz="1100" b="0">
+                          <a:solidFill>
+                            <a:srgbClr val="465461"/>
+                          </a:solidFill>
+                          <a:latin typeface="Arial"/>
+                        </a:rPr>
+                        <a:t/>
+                      </a:r>
+                    </a:p>
+                  </a:txBody>
+                  <a:tcPr marL="45000" marR="45000" marT="25000" marB="25000" anchor="ctr">
+                    <a:solidFill>
+                      <a:srgbClr val="FFFFFF"/>
+                    </a:solidFill>
+                  </a:tcPr>
+                </a:tc>
+              </a:tr>
+              <a:tr h="365760">
+                <a:tc>
+                  <a:txBody>
+                    <a:bodyPr/>
+                    <a:lstStyle/>
+                    <a:p>
+                      <a:r>
+                        <a:rPr sz="1100" b="0">
+                          <a:solidFill>
+                            <a:srgbClr val="465461"/>
+                          </a:solidFill>
+                          <a:latin typeface="Arial"/>
+                        </a:rPr>
+                        <a:t>Carder.pro</a:t>
+                      </a:r>
+                    </a:p>
+                  </a:txBody>
+                  <a:tcPr marL="45000" marR="45000" marT="25000" marB="25000" anchor="ctr">
+                    <a:solidFill>
+                      <a:srgbClr val="F1F2F6"/>
+                    </a:solidFill>
+                  </a:tcPr>
+                </a:tc>
+                <a:tc>
+                  <a:txBody>
+                    <a:bodyPr/>
+                    <a:lstStyle/>
+                    <a:p>
+                      <a:r>
+                        <a:rPr sz="1100" b="0">
+                          <a:solidFill>
+                            <a:srgbClr val="465461"/>
+                          </a:solidFill>
+                          <a:latin typeface="Arial"/>
+                        </a:rPr>
+                        <a:t>2013-04</a:t>
+                      </a:r>
+                    </a:p>
+                  </a:txBody>
+                  <a:tcPr marL="45000" marR="45000" marT="25000" marB="25000" anchor="ctr">
+                    <a:solidFill>
+                      <a:srgbClr val="F1F2F6"/>
+                    </a:solidFill>
+                  </a:tcPr>
+                </a:tc>
+                <a:tc>
+                  <a:txBody>
+                    <a:bodyPr/>
+                    <a:lstStyle/>
+                    <a:p>
+                      <a:r>
+                        <a:rPr sz="1100" b="0">
+                          <a:solidFill>
+                            <a:srgbClr val="465461"/>
+                          </a:solidFill>
+                          <a:latin typeface="Arial"/>
+                        </a:rPr>
+                        <a:t>vBulletin SQL</a:t>
+                      </a:r>
+                    </a:p>
+                  </a:txBody>
+                  <a:tcPr marL="45000" marR="45000" marT="25000" marB="25000" anchor="ctr">
+                    <a:solidFill>
+                      <a:srgbClr val="F1F2F6"/>
+                    </a:solidFill>
+                  </a:tcPr>
+                </a:tc>
+                <a:tc>
+                  <a:txBody>
+                    <a:bodyPr/>
+                    <a:lstStyle/>
+                    <a:p>
+                      <a:r>
+                        <a:rPr sz="1100" b="0">
+                          <a:solidFill>
+                            <a:srgbClr val="465461"/>
+                          </a:solidFill>
+                          <a:latin typeface="Arial"/>
+                        </a:rPr>
+                        <a:t>Encoding cp1251 (cirílico)</a:t>
+                      </a:r>
+                    </a:p>
+                  </a:txBody>
+                  <a:tcPr marL="45000" marR="45000" marT="25000" marB="25000" anchor="ctr">
+                    <a:solidFill>
+                      <a:srgbClr val="F1F2F6"/>
+                    </a:solidFill>
+                  </a:tcPr>
+                </a:tc>
+              </a:tr>
+              <a:tr h="365760">
+                <a:tc>
+                  <a:txBody>
+                    <a:bodyPr/>
+                    <a:lstStyle/>
+                    <a:p>
+                      <a:r>
+                        <a:rPr sz="1100" b="0">
+                          <a:solidFill>
+                            <a:srgbClr val="465461"/>
+                          </a:solidFill>
+                          <a:latin typeface="Arial"/>
+                        </a:rPr>
+                        <a:t>Cardingmafia.ws</a:t>
+                      </a:r>
+                    </a:p>
+                  </a:txBody>
+                  <a:tcPr marL="45000" marR="45000" marT="25000" marB="25000" anchor="ctr">
+                    <a:solidFill>
+                      <a:srgbClr val="FFFFFF"/>
+                    </a:solidFill>
+                  </a:tcPr>
+                </a:tc>
+                <a:tc>
+                  <a:txBody>
+                    <a:bodyPr/>
+                    <a:lstStyle/>
+                    <a:p>
+                      <a:r>
+                        <a:rPr sz="1100" b="0">
+                          <a:solidFill>
+                            <a:srgbClr val="465461"/>
+                          </a:solidFill>
+                          <a:latin typeface="Arial"/>
+                        </a:rPr>
+                        <a:t>2016-02</a:t>
+                      </a:r>
+                    </a:p>
+                  </a:txBody>
+                  <a:tcPr marL="45000" marR="45000" marT="25000" marB="25000" anchor="ctr">
+                    <a:solidFill>
+                      <a:srgbClr val="FFFFFF"/>
+                    </a:solidFill>
+                  </a:tcPr>
+                </a:tc>
+                <a:tc>
+                  <a:txBody>
+                    <a:bodyPr/>
+                    <a:lstStyle/>
+                    <a:p>
+                      <a:r>
+                        <a:rPr sz="1100" b="0">
+                          <a:solidFill>
+                            <a:srgbClr val="465461"/>
+                          </a:solidFill>
+                          <a:latin typeface="Arial"/>
+                        </a:rPr>
+                        <a:t>Flat file</a:t>
+                      </a:r>
+                    </a:p>
+                  </a:txBody>
+                  <a:tcPr marL="45000" marR="45000" marT="25000" marB="25000" anchor="ctr">
+                    <a:solidFill>
+                      <a:srgbClr val="FFFFFF"/>
+                    </a:solidFill>
+                  </a:tcPr>
+                </a:tc>
+                <a:tc>
+                  <a:txBody>
+                    <a:bodyPr/>
+                    <a:lstStyle/>
+                    <a:p>
+                      <a:r>
+                        <a:rPr sz="1100" b="0">
+                          <a:solidFill>
+                            <a:srgbClr val="465461"/>
+                          </a:solidFill>
+                          <a:latin typeface="Arial"/>
+                        </a:rPr>
+                        <a:t>Colon-delimited, solo tabla user</a:t>
+                      </a:r>
+                    </a:p>
+                  </a:txBody>
+                  <a:tcPr marL="45000" marR="45000" marT="25000" marB="25000" anchor="ctr">
+                    <a:solidFill>
+                      <a:srgbClr val="FFFFFF"/>
+                    </a:solidFill>
+                  </a:tcPr>
+                </a:tc>
+              </a:tr>
+              <a:tr h="365760">
+                <a:tc>
+                  <a:txBody>
+                    <a:bodyPr/>
+                    <a:lstStyle/>
+                    <a:p>
+                      <a:r>
+                        <a:rPr sz="1100" b="0">
+                          <a:solidFill>
+                            <a:srgbClr val="465461"/>
+                          </a:solidFill>
+                          <a:latin typeface="Arial"/>
+                        </a:rPr>
+                        <a:t>Crdshop.su</a:t>
+                      </a:r>
+                    </a:p>
+                  </a:txBody>
+                  <a:tcPr marL="45000" marR="45000" marT="25000" marB="25000" anchor="ctr">
+                    <a:solidFill>
+                      <a:srgbClr val="F1F2F6"/>
+                    </a:solidFill>
+                  </a:tcPr>
+                </a:tc>
+                <a:tc>
+                  <a:txBody>
+                    <a:bodyPr/>
+                    <a:lstStyle/>
+                    <a:p>
+                      <a:r>
+                        <a:rPr sz="1100" b="0">
+                          <a:solidFill>
+                            <a:srgbClr val="465461"/>
+                          </a:solidFill>
+                          <a:latin typeface="Arial"/>
+                        </a:rPr>
+                        <a:t>2016-11</a:t>
+                      </a:r>
+                    </a:p>
+                  </a:txBody>
+                  <a:tcPr marL="45000" marR="45000" marT="25000" marB="25000" anchor="ctr">
+                    <a:solidFill>
+                      <a:srgbClr val="F1F2F6"/>
+                    </a:solidFill>
+                  </a:tcPr>
+                </a:tc>
+                <a:tc>
+                  <a:txBody>
+                    <a:bodyPr/>
+                    <a:lstStyle/>
+                    <a:p>
+                      <a:r>
+                        <a:rPr sz="1100" b="0">
+                          <a:solidFill>
+                            <a:srgbClr val="465461"/>
+                          </a:solidFill>
+                          <a:latin typeface="Arial"/>
+                        </a:rPr>
+                        <a:t>vBulletin SQL</a:t>
+                      </a:r>
+                    </a:p>
+                  </a:txBody>
+                  <a:tcPr marL="45000" marR="45000" marT="25000" marB="25000" anchor="ctr">
+                    <a:solidFill>
+                      <a:srgbClr val="F1F2F6"/>
+                    </a:solidFill>
+                  </a:tcPr>
+                </a:tc>
+                <a:tc>
+                  <a:txBody>
+                    <a:bodyPr/>
+                    <a:lstStyle/>
+                    <a:p>
+                      <a:r>
+                        <a:rPr sz="1100" b="0">
+                          <a:solidFill>
+                            <a:srgbClr val="465461"/>
+                          </a:solidFill>
+                          <a:latin typeface="Arial"/>
+                        </a:rPr>
+                        <a:t/>
+                      </a:r>
+                    </a:p>
+                  </a:txBody>
+                  <a:tcPr marL="45000" marR="45000" marT="25000" marB="25000" anchor="ctr">
+                    <a:solidFill>
+                      <a:srgbClr val="F1F2F6"/>
+                    </a:solidFill>
+                  </a:tcPr>
+                </a:tc>
+              </a:tr>
+              <a:tr h="365760">
+                <a:tc>
+                  <a:txBody>
+                    <a:bodyPr/>
+                    <a:lstStyle/>
+                    <a:p>
+                      <a:r>
+                        <a:rPr sz="1100" b="0">
+                          <a:solidFill>
+                            <a:srgbClr val="465461"/>
+                          </a:solidFill>
+                          <a:latin typeface="Arial"/>
+                        </a:rPr>
+                        <a:t>Elitecarders.name</a:t>
+                      </a:r>
+                    </a:p>
+                  </a:txBody>
+                  <a:tcPr marL="45000" marR="45000" marT="25000" marB="25000" anchor="ctr">
+                    <a:solidFill>
+                      <a:srgbClr val="FFFFFF"/>
+                    </a:solidFill>
+                  </a:tcPr>
+                </a:tc>
+                <a:tc>
+                  <a:txBody>
+                    <a:bodyPr/>
+                    <a:lstStyle/>
+                    <a:p>
+                      <a:r>
+                        <a:rPr sz="1100" b="0">
+                          <a:solidFill>
+                            <a:srgbClr val="465461"/>
+                          </a:solidFill>
+                          <a:latin typeface="Arial"/>
+                        </a:rPr>
+                        <a:t>2016-08</a:t>
+                      </a:r>
+                    </a:p>
+                  </a:txBody>
+                  <a:tcPr marL="45000" marR="45000" marT="25000" marB="25000" anchor="ctr">
+                    <a:solidFill>
+                      <a:srgbClr val="FFFFFF"/>
+                    </a:solidFill>
+                  </a:tcPr>
+                </a:tc>
+                <a:tc>
+                  <a:txBody>
+                    <a:bodyPr/>
+                    <a:lstStyle/>
+                    <a:p>
+                      <a:r>
+                        <a:rPr sz="1100" b="0">
+                          <a:solidFill>
+                            <a:srgbClr val="465461"/>
+                          </a:solidFill>
+                          <a:latin typeface="Arial"/>
+                        </a:rPr>
+                        <a:t>vBulletin SQL</a:t>
+                      </a:r>
+                    </a:p>
+                  </a:txBody>
+                  <a:tcPr marL="45000" marR="45000" marT="25000" marB="25000" anchor="ctr">
+                    <a:solidFill>
+                      <a:srgbClr val="FFFFFF"/>
+                    </a:solidFill>
+                  </a:tcPr>
+                </a:tc>
+                <a:tc>
+                  <a:txBody>
+                    <a:bodyPr/>
+                    <a:lstStyle/>
+                    <a:p>
+                      <a:r>
+                        <a:rPr sz="1100" b="0">
+                          <a:solidFill>
+                            <a:srgbClr val="465461"/>
+                          </a:solidFill>
+                          <a:latin typeface="Arial"/>
+                        </a:rPr>
+                        <a:t/>
+                      </a:r>
+                    </a:p>
+                  </a:txBody>
+                  <a:tcPr marL="45000" marR="45000" marT="25000" marB="25000" anchor="ctr">
+                    <a:solidFill>
+                      <a:srgbClr val="FFFFFF"/>
+                    </a:solidFill>
+                  </a:tcPr>
+                </a:tc>
+              </a:tr>
+              <a:tr h="365760">
+                <a:tc>
+                  <a:txBody>
+                    <a:bodyPr/>
+                    <a:lstStyle/>
+                    <a:p>
+                      <a:r>
+                        <a:rPr sz="1100" b="0">
+                          <a:solidFill>
+                            <a:srgbClr val="465461"/>
+                          </a:solidFill>
+                          <a:latin typeface="Arial"/>
+                        </a:rPr>
+                        <a:t>CardingMafia</a:t>
+                      </a:r>
+                    </a:p>
+                  </a:txBody>
+                  <a:tcPr marL="45000" marR="45000" marT="25000" marB="25000" anchor="ctr">
+                    <a:solidFill>
+                      <a:srgbClr val="F1F2F6"/>
+                    </a:solidFill>
+                  </a:tcPr>
+                </a:tc>
+                <a:tc>
+                  <a:txBody>
+                    <a:bodyPr/>
+                    <a:lstStyle/>
+                    <a:p>
+                      <a:r>
+                        <a:rPr sz="1100" b="0">
+                          <a:solidFill>
+                            <a:srgbClr val="465461"/>
+                          </a:solidFill>
+                          <a:latin typeface="Arial"/>
+                        </a:rPr>
+                        <a:t>2021-03</a:t>
+                      </a:r>
+                    </a:p>
+                  </a:txBody>
+                  <a:tcPr marL="45000" marR="45000" marT="25000" marB="25000" anchor="ctr">
+                    <a:solidFill>
+                      <a:srgbClr val="F1F2F6"/>
+                    </a:solidFill>
+                  </a:tcPr>
+                </a:tc>
+                <a:tc>
+                  <a:txBody>
+                    <a:bodyPr/>
+                    <a:lstStyle/>
+                    <a:p>
+                      <a:r>
+                        <a:rPr sz="1100" b="0">
+                          <a:solidFill>
+                            <a:srgbClr val="465461"/>
+                          </a:solidFill>
+                          <a:latin typeface="Arial"/>
+                        </a:rPr>
+                        <a:t>vBulletin SQL</a:t>
+                      </a:r>
+                    </a:p>
+                  </a:txBody>
+                  <a:tcPr marL="45000" marR="45000" marT="25000" marB="25000" anchor="ctr">
+                    <a:solidFill>
+                      <a:srgbClr val="F1F2F6"/>
+                    </a:solidFill>
+                  </a:tcPr>
+                </a:tc>
+                <a:tc>
+                  <a:txBody>
+                    <a:bodyPr/>
+                    <a:lstStyle/>
+                    <a:p>
+                      <a:r>
+                        <a:rPr sz="1100" b="0">
+                          <a:solidFill>
+                            <a:srgbClr val="465461"/>
+                          </a:solidFill>
+                          <a:latin typeface="Arial"/>
+                        </a:rPr>
+                        <a:t>Ver siguiente slide</a:t>
+                      </a:r>
+                    </a:p>
+                  </a:txBody>
+                  <a:tcPr marL="45000" marR="45000" marT="25000" marB="25000" anchor="ctr">
+                    <a:solidFill>
+                      <a:srgbClr val="F1F2F6"/>
+                    </a:solidFill>
+                  </a:tcPr>
+                </a:tc>
+              </a:tr>
+              <a:tr h="365760">
+                <a:tc>
+                  <a:txBody>
+                    <a:bodyPr/>
+                    <a:lstStyle/>
+                    <a:p>
+                      <a:r>
+                        <a:rPr sz="1100" b="0">
+                          <a:solidFill>
+                            <a:srgbClr val="465461"/>
+                          </a:solidFill>
+                          <a:latin typeface="Arial"/>
+                        </a:rPr>
+                        <a:t>Cardmafia.cc</a:t>
+                      </a:r>
+                    </a:p>
+                  </a:txBody>
+                  <a:tcPr marL="45000" marR="45000" marT="25000" marB="25000" anchor="ctr">
+                    <a:solidFill>
+                      <a:srgbClr val="FFFFFF"/>
+                    </a:solidFill>
+                  </a:tcPr>
+                </a:tc>
+                <a:tc>
+                  <a:txBody>
+                    <a:bodyPr/>
+                    <a:lstStyle/>
+                    <a:p>
+                      <a:r>
+                        <a:rPr sz="1100" b="0">
+                          <a:solidFill>
+                            <a:srgbClr val="465461"/>
+                          </a:solidFill>
+                          <a:latin typeface="Arial"/>
+                        </a:rPr>
+                        <a:t>2021-03</a:t>
+                      </a:r>
+                    </a:p>
+                  </a:txBody>
+                  <a:tcPr marL="45000" marR="45000" marT="25000" marB="25000" anchor="ctr">
+                    <a:solidFill>
+                      <a:srgbClr val="FFFFFF"/>
+                    </a:solidFill>
+                  </a:tcPr>
+                </a:tc>
+                <a:tc>
+                  <a:txBody>
+                    <a:bodyPr/>
+                    <a:lstStyle/>
+                    <a:p>
+                      <a:r>
+                        <a:rPr sz="1100" b="0">
+                          <a:solidFill>
+                            <a:srgbClr val="465461"/>
+                          </a:solidFill>
+                          <a:latin typeface="Arial"/>
+                        </a:rPr>
+                        <a:t>vBulletin SQL</a:t>
+                      </a:r>
+                    </a:p>
+                  </a:txBody>
+                  <a:tcPr marL="45000" marR="45000" marT="25000" marB="25000" anchor="ctr">
+                    <a:solidFill>
+                      <a:srgbClr val="FFFFFF"/>
+                    </a:solidFill>
+                  </a:tcPr>
+                </a:tc>
+                <a:tc>
+                  <a:txBody>
+                    <a:bodyPr/>
+                    <a:lstStyle/>
+                    <a:p>
+                      <a:r>
+                        <a:rPr sz="1100" b="0">
+                          <a:solidFill>
+                            <a:srgbClr val="465461"/>
+                          </a:solidFill>
+                          <a:latin typeface="Arial"/>
+                        </a:rPr>
+                        <a:t>Ver siguiente slide</a:t>
+                      </a:r>
+                    </a:p>
+                  </a:txBody>
+                  <a:tcPr marL="45000" marR="45000" marT="25000" marB="25000" anchor="ctr">
+                    <a:solidFill>
+                      <a:srgbClr val="FFFFFF"/>
+                    </a:solidFill>
+                  </a:tcPr>
+                </a:tc>
+              </a:tr>
+            </a:tbl>
+          </a:graphicData>
+        </a:graphic>
+      </p:graphicFrame>
       <p:sp>
         <p:nvSpPr>
           <p:cNvPr id="5" name="TextBox 4"/>
@@ -8531,1977 +8973,7 @@
         </p:nvSpPr>
         <p:spPr>
           <a:xfrm>
-            <a:off x="1097280" y="1700920"/>
-            <a:ext cx="2423160" cy="365760"/>
-          </a:xfrm>
-          <a:prstGeom prst="rect">
-            <a:avLst/>
-          </a:prstGeom>
-          <a:noFill/>
-        </p:spPr>
-        <p:txBody>
-          <a:bodyPr wrap="square">
-            <a:spAutoFit/>
-          </a:bodyPr>
-          <a:lstStyle/>
-          <a:p>
-            <a:pPr algn="l"/>
-            <a:r>
-              <a:rPr sz="1200" b="1">
-                <a:solidFill>
-                  <a:srgbClr val="FFFFFF"/>
-                </a:solidFill>
-                <a:latin typeface="Arial"/>
-              </a:rPr>
-              <a:t>Foro</a:t>
-            </a:r>
-          </a:p>
-        </p:txBody>
-      </p:sp>
-      <p:sp>
-        <p:nvSpPr>
-          <p:cNvPr id="6" name="TextBox 5"/>
-          <p:cNvSpPr txBox="1"/>
-          <p:nvPr/>
-        </p:nvSpPr>
-        <p:spPr>
-          <a:xfrm>
-            <a:off x="3611880" y="1700920"/>
-            <a:ext cx="2423160" cy="365760"/>
-          </a:xfrm>
-          <a:prstGeom prst="rect">
-            <a:avLst/>
-          </a:prstGeom>
-          <a:noFill/>
-        </p:spPr>
-        <p:txBody>
-          <a:bodyPr wrap="square">
-            <a:spAutoFit/>
-          </a:bodyPr>
-          <a:lstStyle/>
-          <a:p>
-            <a:pPr algn="l"/>
-            <a:r>
-              <a:rPr sz="1200" b="1">
-                <a:solidFill>
-                  <a:srgbClr val="FFFFFF"/>
-                </a:solidFill>
-                <a:latin typeface="Arial"/>
-              </a:rPr>
-              <a:t>Fecha del dump</a:t>
-            </a:r>
-          </a:p>
-        </p:txBody>
-      </p:sp>
-      <p:sp>
-        <p:nvSpPr>
-          <p:cNvPr id="7" name="TextBox 6"/>
-          <p:cNvSpPr txBox="1"/>
-          <p:nvPr/>
-        </p:nvSpPr>
-        <p:spPr>
-          <a:xfrm>
-            <a:off x="6126480" y="1700920"/>
-            <a:ext cx="2423160" cy="365760"/>
-          </a:xfrm>
-          <a:prstGeom prst="rect">
-            <a:avLst/>
-          </a:prstGeom>
-          <a:noFill/>
-        </p:spPr>
-        <p:txBody>
-          <a:bodyPr wrap="square">
-            <a:spAutoFit/>
-          </a:bodyPr>
-          <a:lstStyle/>
-          <a:p>
-            <a:pPr algn="l"/>
-            <a:r>
-              <a:rPr sz="1200" b="1">
-                <a:solidFill>
-                  <a:srgbClr val="FFFFFF"/>
-                </a:solidFill>
-                <a:latin typeface="Arial"/>
-              </a:rPr>
-              <a:t>Formato</a:t>
-            </a:r>
-          </a:p>
-        </p:txBody>
-      </p:sp>
-      <p:sp>
-        <p:nvSpPr>
-          <p:cNvPr id="8" name="TextBox 7"/>
-          <p:cNvSpPr txBox="1"/>
-          <p:nvPr/>
-        </p:nvSpPr>
-        <p:spPr>
-          <a:xfrm>
-            <a:off x="8641080" y="1700920"/>
-            <a:ext cx="2423160" cy="365760"/>
-          </a:xfrm>
-          <a:prstGeom prst="rect">
-            <a:avLst/>
-          </a:prstGeom>
-          <a:noFill/>
-        </p:spPr>
-        <p:txBody>
-          <a:bodyPr wrap="square">
-            <a:spAutoFit/>
-          </a:bodyPr>
-          <a:lstStyle/>
-          <a:p>
-            <a:pPr algn="l"/>
-            <a:r>
-              <a:rPr sz="1200" b="1">
-                <a:solidFill>
-                  <a:srgbClr val="FFFFFF"/>
-                </a:solidFill>
-                <a:latin typeface="Arial"/>
-              </a:rPr>
-              <a:t>Notas</a:t>
-            </a:r>
-          </a:p>
-        </p:txBody>
-      </p:sp>
-      <p:sp>
-        <p:nvSpPr>
-          <p:cNvPr id="9" name="Rectangle 8"/>
-          <p:cNvSpPr/>
-          <p:nvPr/>
-        </p:nvSpPr>
-        <p:spPr>
-          <a:xfrm>
-            <a:off x="1051560" y="2011680"/>
-            <a:ext cx="10058400" cy="440689"/>
-          </a:xfrm>
-          <a:prstGeom prst="rect">
-            <a:avLst/>
-          </a:prstGeom>
-          <a:solidFill>
-            <a:srgbClr val="F1F2F6"/>
-          </a:solidFill>
-          <a:ln>
-            <a:noFill/>
-          </a:ln>
-        </p:spPr>
-        <p:style>
-          <a:lnRef idx="1">
-            <a:schemeClr val="accent1"/>
-          </a:lnRef>
-          <a:fillRef idx="3">
-            <a:schemeClr val="accent1"/>
-          </a:fillRef>
-          <a:effectRef idx="2">
-            <a:schemeClr val="accent1"/>
-          </a:effectRef>
-          <a:fontRef idx="minor">
-            <a:schemeClr val="lt1"/>
-          </a:fontRef>
-        </p:style>
-        <p:txBody>
-          <a:bodyPr rtlCol="0" anchor="ctr"/>
-          <a:lstStyle/>
-          <a:p>
-            <a:pPr algn="ctr"/>
-          </a:p>
-        </p:txBody>
-      </p:sp>
-      <p:sp>
-        <p:nvSpPr>
-          <p:cNvPr id="10" name="TextBox 9"/>
-          <p:cNvSpPr txBox="1"/>
-          <p:nvPr/>
-        </p:nvSpPr>
-        <p:spPr>
-          <a:xfrm>
-            <a:off x="1097280" y="2051680"/>
-            <a:ext cx="2423160" cy="440689"/>
-          </a:xfrm>
-          <a:prstGeom prst="rect">
-            <a:avLst/>
-          </a:prstGeom>
-          <a:noFill/>
-        </p:spPr>
-        <p:txBody>
-          <a:bodyPr wrap="square">
-            <a:spAutoFit/>
-          </a:bodyPr>
-          <a:lstStyle/>
-          <a:p>
-            <a:pPr algn="l"/>
-            <a:r>
-              <a:rPr sz="1100" b="0">
-                <a:solidFill>
-                  <a:srgbClr val="465461"/>
-                </a:solidFill>
-                <a:latin typeface="Arial"/>
-              </a:rPr>
-              <a:t>Carder.su</a:t>
-            </a:r>
-          </a:p>
-        </p:txBody>
-      </p:sp>
-      <p:sp>
-        <p:nvSpPr>
-          <p:cNvPr id="11" name="TextBox 10"/>
-          <p:cNvSpPr txBox="1"/>
-          <p:nvPr/>
-        </p:nvSpPr>
-        <p:spPr>
-          <a:xfrm>
-            <a:off x="3611880" y="2051680"/>
-            <a:ext cx="2423160" cy="440689"/>
-          </a:xfrm>
-          <a:prstGeom prst="rect">
-            <a:avLst/>
-          </a:prstGeom>
-          <a:noFill/>
-        </p:spPr>
-        <p:txBody>
-          <a:bodyPr wrap="square">
-            <a:spAutoFit/>
-          </a:bodyPr>
-          <a:lstStyle/>
-          <a:p>
-            <a:pPr algn="l"/>
-            <a:r>
-              <a:rPr sz="1100" b="0">
-                <a:solidFill>
-                  <a:srgbClr val="465461"/>
-                </a:solidFill>
-                <a:latin typeface="Arial"/>
-              </a:rPr>
-              <a:t>2009-02</a:t>
-            </a:r>
-          </a:p>
-        </p:txBody>
-      </p:sp>
-      <p:sp>
-        <p:nvSpPr>
-          <p:cNvPr id="12" name="TextBox 11"/>
-          <p:cNvSpPr txBox="1"/>
-          <p:nvPr/>
-        </p:nvSpPr>
-        <p:spPr>
-          <a:xfrm>
-            <a:off x="6126480" y="2051680"/>
-            <a:ext cx="2423160" cy="440689"/>
-          </a:xfrm>
-          <a:prstGeom prst="rect">
-            <a:avLst/>
-          </a:prstGeom>
-          <a:noFill/>
-        </p:spPr>
-        <p:txBody>
-          <a:bodyPr wrap="square">
-            <a:spAutoFit/>
-          </a:bodyPr>
-          <a:lstStyle/>
-          <a:p>
-            <a:pPr algn="l"/>
-            <a:r>
-              <a:rPr sz="1100" b="0">
-                <a:solidFill>
-                  <a:srgbClr val="465461"/>
-                </a:solidFill>
-                <a:latin typeface="Arial"/>
-              </a:rPr>
-              <a:t>vBulletin SQL</a:t>
-            </a:r>
-          </a:p>
-        </p:txBody>
-      </p:sp>
-      <p:sp>
-        <p:nvSpPr>
-          <p:cNvPr id="13" name="TextBox 12"/>
-          <p:cNvSpPr txBox="1"/>
-          <p:nvPr/>
-        </p:nvSpPr>
-        <p:spPr>
-          <a:xfrm>
-            <a:off x="8641080" y="2051680"/>
-            <a:ext cx="2423160" cy="440689"/>
-          </a:xfrm>
-          <a:prstGeom prst="rect">
-            <a:avLst/>
-          </a:prstGeom>
-          <a:noFill/>
-        </p:spPr>
-        <p:txBody>
-          <a:bodyPr wrap="square">
-            <a:spAutoFit/>
-          </a:bodyPr>
-          <a:lstStyle/>
-          <a:p>
-            <a:pPr algn="l"/>
-            <a:r>
-              <a:rPr sz="1100" b="0">
-                <a:solidFill>
-                  <a:srgbClr val="465461"/>
-                </a:solidFill>
-                <a:latin typeface="Arial"/>
-              </a:rPr>
-              <a:t>Uno de los primeros foros importantes</a:t>
-            </a:r>
-          </a:p>
-        </p:txBody>
-      </p:sp>
-      <p:sp>
-        <p:nvSpPr>
-          <p:cNvPr id="14" name="Rectangle 13"/>
-          <p:cNvSpPr/>
-          <p:nvPr/>
-        </p:nvSpPr>
-        <p:spPr>
-          <a:xfrm>
-            <a:off x="1051560" y="2452370"/>
-            <a:ext cx="10058400" cy="310896"/>
-          </a:xfrm>
-          <a:prstGeom prst="rect">
-            <a:avLst/>
-          </a:prstGeom>
-          <a:solidFill>
-            <a:srgbClr val="FFFFFF"/>
-          </a:solidFill>
-          <a:ln>
-            <a:noFill/>
-          </a:ln>
-        </p:spPr>
-        <p:style>
-          <a:lnRef idx="1">
-            <a:schemeClr val="accent1"/>
-          </a:lnRef>
-          <a:fillRef idx="3">
-            <a:schemeClr val="accent1"/>
-          </a:fillRef>
-          <a:effectRef idx="2">
-            <a:schemeClr val="accent1"/>
-          </a:effectRef>
-          <a:fontRef idx="minor">
-            <a:schemeClr val="lt1"/>
-          </a:fontRef>
-        </p:style>
-        <p:txBody>
-          <a:bodyPr rtlCol="0" anchor="ctr"/>
-          <a:lstStyle/>
-          <a:p>
-            <a:pPr algn="ctr"/>
-          </a:p>
-        </p:txBody>
-      </p:sp>
-      <p:sp>
-        <p:nvSpPr>
-          <p:cNvPr id="15" name="TextBox 14"/>
-          <p:cNvSpPr txBox="1"/>
-          <p:nvPr/>
-        </p:nvSpPr>
-        <p:spPr>
-          <a:xfrm>
-            <a:off x="1097280" y="2492370"/>
-            <a:ext cx="2423160" cy="310896"/>
-          </a:xfrm>
-          <a:prstGeom prst="rect">
-            <a:avLst/>
-          </a:prstGeom>
-          <a:noFill/>
-        </p:spPr>
-        <p:txBody>
-          <a:bodyPr wrap="square">
-            <a:spAutoFit/>
-          </a:bodyPr>
-          <a:lstStyle/>
-          <a:p>
-            <a:pPr algn="l"/>
-            <a:r>
-              <a:rPr sz="1100" b="0">
-                <a:solidFill>
-                  <a:srgbClr val="465461"/>
-                </a:solidFill>
-                <a:latin typeface="Arial"/>
-              </a:rPr>
-              <a:t>Carding.biz</a:t>
-            </a:r>
-          </a:p>
-        </p:txBody>
-      </p:sp>
-      <p:sp>
-        <p:nvSpPr>
-          <p:cNvPr id="16" name="TextBox 15"/>
-          <p:cNvSpPr txBox="1"/>
-          <p:nvPr/>
-        </p:nvSpPr>
-        <p:spPr>
-          <a:xfrm>
-            <a:off x="3611880" y="2492370"/>
-            <a:ext cx="2423160" cy="310896"/>
-          </a:xfrm>
-          <a:prstGeom prst="rect">
-            <a:avLst/>
-          </a:prstGeom>
-          <a:noFill/>
-        </p:spPr>
-        <p:txBody>
-          <a:bodyPr wrap="square">
-            <a:spAutoFit/>
-          </a:bodyPr>
-          <a:lstStyle/>
-          <a:p>
-            <a:pPr algn="l"/>
-            <a:r>
-              <a:rPr sz="1100" b="0">
-                <a:solidFill>
-                  <a:srgbClr val="465461"/>
-                </a:solidFill>
-                <a:latin typeface="Arial"/>
-              </a:rPr>
-              <a:t>2009-11</a:t>
-            </a:r>
-          </a:p>
-        </p:txBody>
-      </p:sp>
-      <p:sp>
-        <p:nvSpPr>
-          <p:cNvPr id="17" name="TextBox 16"/>
-          <p:cNvSpPr txBox="1"/>
-          <p:nvPr/>
-        </p:nvSpPr>
-        <p:spPr>
-          <a:xfrm>
-            <a:off x="6126480" y="2492370"/>
-            <a:ext cx="2423160" cy="310896"/>
-          </a:xfrm>
-          <a:prstGeom prst="rect">
-            <a:avLst/>
-          </a:prstGeom>
-          <a:noFill/>
-        </p:spPr>
-        <p:txBody>
-          <a:bodyPr wrap="square">
-            <a:spAutoFit/>
-          </a:bodyPr>
-          <a:lstStyle/>
-          <a:p>
-            <a:pPr algn="l"/>
-            <a:r>
-              <a:rPr sz="1100" b="0">
-                <a:solidFill>
-                  <a:srgbClr val="465461"/>
-                </a:solidFill>
-                <a:latin typeface="Arial"/>
-              </a:rPr>
-              <a:t>vBulletin SQL</a:t>
-            </a:r>
-          </a:p>
-        </p:txBody>
-      </p:sp>
-      <p:sp>
-        <p:nvSpPr>
-          <p:cNvPr id="18" name="TextBox 17"/>
-          <p:cNvSpPr txBox="1"/>
-          <p:nvPr/>
-        </p:nvSpPr>
-        <p:spPr>
-          <a:xfrm>
-            <a:off x="8641080" y="2492370"/>
-            <a:ext cx="2423160" cy="310896"/>
-          </a:xfrm>
-          <a:prstGeom prst="rect">
-            <a:avLst/>
-          </a:prstGeom>
-          <a:noFill/>
-        </p:spPr>
-        <p:txBody>
-          <a:bodyPr wrap="square">
-            <a:spAutoFit/>
-          </a:bodyPr>
-          <a:lstStyle/>
-          <a:p>
-            <a:pPr algn="l"/>
-            <a:r>
-              <a:rPr sz="1100" b="0">
-                <a:solidFill>
-                  <a:srgbClr val="465461"/>
-                </a:solidFill>
-                <a:latin typeface="Arial"/>
-              </a:rPr>
-              <a:t/>
-            </a:r>
-          </a:p>
-        </p:txBody>
-      </p:sp>
-      <p:sp>
-        <p:nvSpPr>
-          <p:cNvPr id="19" name="Rectangle 18"/>
-          <p:cNvSpPr/>
-          <p:nvPr/>
-        </p:nvSpPr>
-        <p:spPr>
-          <a:xfrm>
-            <a:off x="1051560" y="2763266"/>
-            <a:ext cx="10058400" cy="310896"/>
-          </a:xfrm>
-          <a:prstGeom prst="rect">
-            <a:avLst/>
-          </a:prstGeom>
-          <a:solidFill>
-            <a:srgbClr val="F1F2F6"/>
-          </a:solidFill>
-          <a:ln>
-            <a:noFill/>
-          </a:ln>
-        </p:spPr>
-        <p:style>
-          <a:lnRef idx="1">
-            <a:schemeClr val="accent1"/>
-          </a:lnRef>
-          <a:fillRef idx="3">
-            <a:schemeClr val="accent1"/>
-          </a:fillRef>
-          <a:effectRef idx="2">
-            <a:schemeClr val="accent1"/>
-          </a:effectRef>
-          <a:fontRef idx="minor">
-            <a:schemeClr val="lt1"/>
-          </a:fontRef>
-        </p:style>
-        <p:txBody>
-          <a:bodyPr rtlCol="0" anchor="ctr"/>
-          <a:lstStyle/>
-          <a:p>
-            <a:pPr algn="ctr"/>
-          </a:p>
-        </p:txBody>
-      </p:sp>
-      <p:sp>
-        <p:nvSpPr>
-          <p:cNvPr id="20" name="TextBox 19"/>
-          <p:cNvSpPr txBox="1"/>
-          <p:nvPr/>
-        </p:nvSpPr>
-        <p:spPr>
-          <a:xfrm>
-            <a:off x="1097280" y="2803266"/>
-            <a:ext cx="2423160" cy="310896"/>
-          </a:xfrm>
-          <a:prstGeom prst="rect">
-            <a:avLst/>
-          </a:prstGeom>
-          <a:noFill/>
-        </p:spPr>
-        <p:txBody>
-          <a:bodyPr wrap="square">
-            <a:spAutoFit/>
-          </a:bodyPr>
-          <a:lstStyle/>
-          <a:p>
-            <a:pPr algn="l"/>
-            <a:r>
-              <a:rPr sz="1100" b="0">
-                <a:solidFill>
-                  <a:srgbClr val="465461"/>
-                </a:solidFill>
-                <a:latin typeface="Arial"/>
-              </a:rPr>
-              <a:t>Cardersplanet.biz</a:t>
-            </a:r>
-          </a:p>
-        </p:txBody>
-      </p:sp>
-      <p:sp>
-        <p:nvSpPr>
-          <p:cNvPr id="21" name="TextBox 20"/>
-          <p:cNvSpPr txBox="1"/>
-          <p:nvPr/>
-        </p:nvSpPr>
-        <p:spPr>
-          <a:xfrm>
-            <a:off x="3611880" y="2803266"/>
-            <a:ext cx="2423160" cy="310896"/>
-          </a:xfrm>
-          <a:prstGeom prst="rect">
-            <a:avLst/>
-          </a:prstGeom>
-          <a:noFill/>
-        </p:spPr>
-        <p:txBody>
-          <a:bodyPr wrap="square">
-            <a:spAutoFit/>
-          </a:bodyPr>
-          <a:lstStyle/>
-          <a:p>
-            <a:pPr algn="l"/>
-            <a:r>
-              <a:rPr sz="1100" b="0">
-                <a:solidFill>
-                  <a:srgbClr val="465461"/>
-                </a:solidFill>
-                <a:latin typeface="Arial"/>
-              </a:rPr>
-              <a:t>2010-05</a:t>
-            </a:r>
-          </a:p>
-        </p:txBody>
-      </p:sp>
-      <p:sp>
-        <p:nvSpPr>
-          <p:cNvPr id="22" name="TextBox 21"/>
-          <p:cNvSpPr txBox="1"/>
-          <p:nvPr/>
-        </p:nvSpPr>
-        <p:spPr>
-          <a:xfrm>
-            <a:off x="6126480" y="2803266"/>
-            <a:ext cx="2423160" cy="310896"/>
-          </a:xfrm>
-          <a:prstGeom prst="rect">
-            <a:avLst/>
-          </a:prstGeom>
-          <a:noFill/>
-        </p:spPr>
-        <p:txBody>
-          <a:bodyPr wrap="square">
-            <a:spAutoFit/>
-          </a:bodyPr>
-          <a:lstStyle/>
-          <a:p>
-            <a:pPr algn="l"/>
-            <a:r>
-              <a:rPr sz="1100" b="0">
-                <a:solidFill>
-                  <a:srgbClr val="465461"/>
-                </a:solidFill>
-                <a:latin typeface="Arial"/>
-              </a:rPr>
-              <a:t>vBulletin SQL</a:t>
-            </a:r>
-          </a:p>
-        </p:txBody>
-      </p:sp>
-      <p:sp>
-        <p:nvSpPr>
-          <p:cNvPr id="23" name="TextBox 22"/>
-          <p:cNvSpPr txBox="1"/>
-          <p:nvPr/>
-        </p:nvSpPr>
-        <p:spPr>
-          <a:xfrm>
-            <a:off x="8641080" y="2803266"/>
-            <a:ext cx="2423160" cy="310896"/>
-          </a:xfrm>
-          <a:prstGeom prst="rect">
-            <a:avLst/>
-          </a:prstGeom>
-          <a:noFill/>
-        </p:spPr>
-        <p:txBody>
-          <a:bodyPr wrap="square">
-            <a:spAutoFit/>
-          </a:bodyPr>
-          <a:lstStyle/>
-          <a:p>
-            <a:pPr algn="l"/>
-            <a:r>
-              <a:rPr sz="1100" b="0">
-                <a:solidFill>
-                  <a:srgbClr val="465461"/>
-                </a:solidFill>
-                <a:latin typeface="Arial"/>
-              </a:rPr>
-              <a:t/>
-            </a:r>
-          </a:p>
-        </p:txBody>
-      </p:sp>
-      <p:sp>
-        <p:nvSpPr>
-          <p:cNvPr id="24" name="Rectangle 23"/>
-          <p:cNvSpPr/>
-          <p:nvPr/>
-        </p:nvSpPr>
-        <p:spPr>
-          <a:xfrm>
-            <a:off x="1051560" y="3074161"/>
-            <a:ext cx="10058400" cy="310896"/>
-          </a:xfrm>
-          <a:prstGeom prst="rect">
-            <a:avLst/>
-          </a:prstGeom>
-          <a:solidFill>
-            <a:srgbClr val="FFFFFF"/>
-          </a:solidFill>
-          <a:ln>
-            <a:noFill/>
-          </a:ln>
-        </p:spPr>
-        <p:style>
-          <a:lnRef idx="1">
-            <a:schemeClr val="accent1"/>
-          </a:lnRef>
-          <a:fillRef idx="3">
-            <a:schemeClr val="accent1"/>
-          </a:fillRef>
-          <a:effectRef idx="2">
-            <a:schemeClr val="accent1"/>
-          </a:effectRef>
-          <a:fontRef idx="minor">
-            <a:schemeClr val="lt1"/>
-          </a:fontRef>
-        </p:style>
-        <p:txBody>
-          <a:bodyPr rtlCol="0" anchor="ctr"/>
-          <a:lstStyle/>
-          <a:p>
-            <a:pPr algn="ctr"/>
-          </a:p>
-        </p:txBody>
-      </p:sp>
-      <p:sp>
-        <p:nvSpPr>
-          <p:cNvPr id="25" name="TextBox 24"/>
-          <p:cNvSpPr txBox="1"/>
-          <p:nvPr/>
-        </p:nvSpPr>
-        <p:spPr>
-          <a:xfrm>
-            <a:off x="1097280" y="3114161"/>
-            <a:ext cx="2423160" cy="310896"/>
-          </a:xfrm>
-          <a:prstGeom prst="rect">
-            <a:avLst/>
-          </a:prstGeom>
-          <a:noFill/>
-        </p:spPr>
-        <p:txBody>
-          <a:bodyPr wrap="square">
-            <a:spAutoFit/>
-          </a:bodyPr>
-          <a:lstStyle/>
-          <a:p>
-            <a:pPr algn="l"/>
-            <a:r>
-              <a:rPr sz="1100" b="0">
-                <a:solidFill>
-                  <a:srgbClr val="465461"/>
-                </a:solidFill>
-                <a:latin typeface="Arial"/>
-              </a:rPr>
-              <a:t>Carders.cc</a:t>
-            </a:r>
-          </a:p>
-        </p:txBody>
-      </p:sp>
-      <p:sp>
-        <p:nvSpPr>
-          <p:cNvPr id="26" name="TextBox 25"/>
-          <p:cNvSpPr txBox="1"/>
-          <p:nvPr/>
-        </p:nvSpPr>
-        <p:spPr>
-          <a:xfrm>
-            <a:off x="3611880" y="3114161"/>
-            <a:ext cx="2423160" cy="310896"/>
-          </a:xfrm>
-          <a:prstGeom prst="rect">
-            <a:avLst/>
-          </a:prstGeom>
-          <a:noFill/>
-        </p:spPr>
-        <p:txBody>
-          <a:bodyPr wrap="square">
-            <a:spAutoFit/>
-          </a:bodyPr>
-          <a:lstStyle/>
-          <a:p>
-            <a:pPr algn="l"/>
-            <a:r>
-              <a:rPr sz="1100" b="0">
-                <a:solidFill>
-                  <a:srgbClr val="465461"/>
-                </a:solidFill>
-                <a:latin typeface="Arial"/>
-              </a:rPr>
-              <a:t>2010-12</a:t>
-            </a:r>
-          </a:p>
-        </p:txBody>
-      </p:sp>
-      <p:sp>
-        <p:nvSpPr>
-          <p:cNvPr id="27" name="TextBox 26"/>
-          <p:cNvSpPr txBox="1"/>
-          <p:nvPr/>
-        </p:nvSpPr>
-        <p:spPr>
-          <a:xfrm>
-            <a:off x="6126480" y="3114161"/>
-            <a:ext cx="2423160" cy="310896"/>
-          </a:xfrm>
-          <a:prstGeom prst="rect">
-            <a:avLst/>
-          </a:prstGeom>
-          <a:noFill/>
-        </p:spPr>
-        <p:txBody>
-          <a:bodyPr wrap="square">
-            <a:spAutoFit/>
-          </a:bodyPr>
-          <a:lstStyle/>
-          <a:p>
-            <a:pPr algn="l"/>
-            <a:r>
-              <a:rPr sz="1100" b="0">
-                <a:solidFill>
-                  <a:srgbClr val="465461"/>
-                </a:solidFill>
-                <a:latin typeface="Arial"/>
-              </a:rPr>
-              <a:t>vBulletin SQL</a:t>
-            </a:r>
-          </a:p>
-        </p:txBody>
-      </p:sp>
-      <p:sp>
-        <p:nvSpPr>
-          <p:cNvPr id="28" name="TextBox 27"/>
-          <p:cNvSpPr txBox="1"/>
-          <p:nvPr/>
-        </p:nvSpPr>
-        <p:spPr>
-          <a:xfrm>
-            <a:off x="8641080" y="3114161"/>
-            <a:ext cx="2423160" cy="310896"/>
-          </a:xfrm>
-          <a:prstGeom prst="rect">
-            <a:avLst/>
-          </a:prstGeom>
-          <a:noFill/>
-        </p:spPr>
-        <p:txBody>
-          <a:bodyPr wrap="square">
-            <a:spAutoFit/>
-          </a:bodyPr>
-          <a:lstStyle/>
-          <a:p>
-            <a:pPr algn="l"/>
-            <a:r>
-              <a:rPr sz="1100" b="0">
-                <a:solidFill>
-                  <a:srgbClr val="465461"/>
-                </a:solidFill>
-                <a:latin typeface="Arial"/>
-              </a:rPr>
-              <a:t/>
-            </a:r>
-          </a:p>
-        </p:txBody>
-      </p:sp>
-      <p:sp>
-        <p:nvSpPr>
-          <p:cNvPr id="29" name="Rectangle 28"/>
-          <p:cNvSpPr/>
-          <p:nvPr/>
-        </p:nvSpPr>
-        <p:spPr>
-          <a:xfrm>
-            <a:off x="1051560" y="3385057"/>
-            <a:ext cx="10058400" cy="440689"/>
-          </a:xfrm>
-          <a:prstGeom prst="rect">
-            <a:avLst/>
-          </a:prstGeom>
-          <a:solidFill>
-            <a:srgbClr val="F1F2F6"/>
-          </a:solidFill>
-          <a:ln>
-            <a:noFill/>
-          </a:ln>
-        </p:spPr>
-        <p:style>
-          <a:lnRef idx="1">
-            <a:schemeClr val="accent1"/>
-          </a:lnRef>
-          <a:fillRef idx="3">
-            <a:schemeClr val="accent1"/>
-          </a:fillRef>
-          <a:effectRef idx="2">
-            <a:schemeClr val="accent1"/>
-          </a:effectRef>
-          <a:fontRef idx="minor">
-            <a:schemeClr val="lt1"/>
-          </a:fontRef>
-        </p:style>
-        <p:txBody>
-          <a:bodyPr rtlCol="0" anchor="ctr"/>
-          <a:lstStyle/>
-          <a:p>
-            <a:pPr algn="ctr"/>
-          </a:p>
-        </p:txBody>
-      </p:sp>
-      <p:sp>
-        <p:nvSpPr>
-          <p:cNvPr id="30" name="TextBox 29"/>
-          <p:cNvSpPr txBox="1"/>
-          <p:nvPr/>
-        </p:nvSpPr>
-        <p:spPr>
-          <a:xfrm>
-            <a:off x="1097280" y="3425057"/>
-            <a:ext cx="2423160" cy="440689"/>
-          </a:xfrm>
-          <a:prstGeom prst="rect">
-            <a:avLst/>
-          </a:prstGeom>
-          <a:noFill/>
-        </p:spPr>
-        <p:txBody>
-          <a:bodyPr wrap="square">
-            <a:spAutoFit/>
-          </a:bodyPr>
-          <a:lstStyle/>
-          <a:p>
-            <a:pPr algn="l"/>
-            <a:r>
-              <a:rPr sz="1100" b="0">
-                <a:solidFill>
-                  <a:srgbClr val="465461"/>
-                </a:solidFill>
-                <a:latin typeface="Arial"/>
-              </a:rPr>
-              <a:t>Carder.pro</a:t>
-            </a:r>
-          </a:p>
-        </p:txBody>
-      </p:sp>
-      <p:sp>
-        <p:nvSpPr>
-          <p:cNvPr id="31" name="TextBox 30"/>
-          <p:cNvSpPr txBox="1"/>
-          <p:nvPr/>
-        </p:nvSpPr>
-        <p:spPr>
-          <a:xfrm>
-            <a:off x="3611880" y="3425057"/>
-            <a:ext cx="2423160" cy="440689"/>
-          </a:xfrm>
-          <a:prstGeom prst="rect">
-            <a:avLst/>
-          </a:prstGeom>
-          <a:noFill/>
-        </p:spPr>
-        <p:txBody>
-          <a:bodyPr wrap="square">
-            <a:spAutoFit/>
-          </a:bodyPr>
-          <a:lstStyle/>
-          <a:p>
-            <a:pPr algn="l"/>
-            <a:r>
-              <a:rPr sz="1100" b="0">
-                <a:solidFill>
-                  <a:srgbClr val="465461"/>
-                </a:solidFill>
-                <a:latin typeface="Arial"/>
-              </a:rPr>
-              <a:t>2013-04</a:t>
-            </a:r>
-          </a:p>
-        </p:txBody>
-      </p:sp>
-      <p:sp>
-        <p:nvSpPr>
-          <p:cNvPr id="32" name="TextBox 31"/>
-          <p:cNvSpPr txBox="1"/>
-          <p:nvPr/>
-        </p:nvSpPr>
-        <p:spPr>
-          <a:xfrm>
-            <a:off x="6126480" y="3425057"/>
-            <a:ext cx="2423160" cy="440689"/>
-          </a:xfrm>
-          <a:prstGeom prst="rect">
-            <a:avLst/>
-          </a:prstGeom>
-          <a:noFill/>
-        </p:spPr>
-        <p:txBody>
-          <a:bodyPr wrap="square">
-            <a:spAutoFit/>
-          </a:bodyPr>
-          <a:lstStyle/>
-          <a:p>
-            <a:pPr algn="l"/>
-            <a:r>
-              <a:rPr sz="1100" b="0">
-                <a:solidFill>
-                  <a:srgbClr val="465461"/>
-                </a:solidFill>
-                <a:latin typeface="Arial"/>
-              </a:rPr>
-              <a:t>vBulletin SQL</a:t>
-            </a:r>
-          </a:p>
-        </p:txBody>
-      </p:sp>
-      <p:sp>
-        <p:nvSpPr>
-          <p:cNvPr id="33" name="TextBox 32"/>
-          <p:cNvSpPr txBox="1"/>
-          <p:nvPr/>
-        </p:nvSpPr>
-        <p:spPr>
-          <a:xfrm>
-            <a:off x="8641080" y="3425057"/>
-            <a:ext cx="2423160" cy="440689"/>
-          </a:xfrm>
-          <a:prstGeom prst="rect">
-            <a:avLst/>
-          </a:prstGeom>
-          <a:noFill/>
-        </p:spPr>
-        <p:txBody>
-          <a:bodyPr wrap="square">
-            <a:spAutoFit/>
-          </a:bodyPr>
-          <a:lstStyle/>
-          <a:p>
-            <a:pPr algn="l"/>
-            <a:r>
-              <a:rPr sz="1100" b="0">
-                <a:solidFill>
-                  <a:srgbClr val="465461"/>
-                </a:solidFill>
-                <a:latin typeface="Arial"/>
-              </a:rPr>
-              <a:t>Encoding cp1251 (cirílico)</a:t>
-            </a:r>
-          </a:p>
-        </p:txBody>
-      </p:sp>
-      <p:sp>
-        <p:nvSpPr>
-          <p:cNvPr id="34" name="Rectangle 33"/>
-          <p:cNvSpPr/>
-          <p:nvPr/>
-        </p:nvSpPr>
-        <p:spPr>
-          <a:xfrm>
-            <a:off x="1051560" y="3825747"/>
-            <a:ext cx="10058400" cy="440689"/>
-          </a:xfrm>
-          <a:prstGeom prst="rect">
-            <a:avLst/>
-          </a:prstGeom>
-          <a:solidFill>
-            <a:srgbClr val="FFFFFF"/>
-          </a:solidFill>
-          <a:ln>
-            <a:noFill/>
-          </a:ln>
-        </p:spPr>
-        <p:style>
-          <a:lnRef idx="1">
-            <a:schemeClr val="accent1"/>
-          </a:lnRef>
-          <a:fillRef idx="3">
-            <a:schemeClr val="accent1"/>
-          </a:fillRef>
-          <a:effectRef idx="2">
-            <a:schemeClr val="accent1"/>
-          </a:effectRef>
-          <a:fontRef idx="minor">
-            <a:schemeClr val="lt1"/>
-          </a:fontRef>
-        </p:style>
-        <p:txBody>
-          <a:bodyPr rtlCol="0" anchor="ctr"/>
-          <a:lstStyle/>
-          <a:p>
-            <a:pPr algn="ctr"/>
-          </a:p>
-        </p:txBody>
-      </p:sp>
-      <p:sp>
-        <p:nvSpPr>
-          <p:cNvPr id="35" name="TextBox 34"/>
-          <p:cNvSpPr txBox="1"/>
-          <p:nvPr/>
-        </p:nvSpPr>
-        <p:spPr>
-          <a:xfrm>
-            <a:off x="1097280" y="3865747"/>
-            <a:ext cx="2423160" cy="440689"/>
-          </a:xfrm>
-          <a:prstGeom prst="rect">
-            <a:avLst/>
-          </a:prstGeom>
-          <a:noFill/>
-        </p:spPr>
-        <p:txBody>
-          <a:bodyPr wrap="square">
-            <a:spAutoFit/>
-          </a:bodyPr>
-          <a:lstStyle/>
-          <a:p>
-            <a:pPr algn="l"/>
-            <a:r>
-              <a:rPr sz="1100" b="0">
-                <a:solidFill>
-                  <a:srgbClr val="465461"/>
-                </a:solidFill>
-                <a:latin typeface="Arial"/>
-              </a:rPr>
-              <a:t>Cardingmafia.ws</a:t>
-            </a:r>
-          </a:p>
-        </p:txBody>
-      </p:sp>
-      <p:sp>
-        <p:nvSpPr>
-          <p:cNvPr id="36" name="TextBox 35"/>
-          <p:cNvSpPr txBox="1"/>
-          <p:nvPr/>
-        </p:nvSpPr>
-        <p:spPr>
-          <a:xfrm>
-            <a:off x="3611880" y="3865747"/>
-            <a:ext cx="2423160" cy="440689"/>
-          </a:xfrm>
-          <a:prstGeom prst="rect">
-            <a:avLst/>
-          </a:prstGeom>
-          <a:noFill/>
-        </p:spPr>
-        <p:txBody>
-          <a:bodyPr wrap="square">
-            <a:spAutoFit/>
-          </a:bodyPr>
-          <a:lstStyle/>
-          <a:p>
-            <a:pPr algn="l"/>
-            <a:r>
-              <a:rPr sz="1100" b="0">
-                <a:solidFill>
-                  <a:srgbClr val="465461"/>
-                </a:solidFill>
-                <a:latin typeface="Arial"/>
-              </a:rPr>
-              <a:t>2016-02</a:t>
-            </a:r>
-          </a:p>
-        </p:txBody>
-      </p:sp>
-      <p:sp>
-        <p:nvSpPr>
-          <p:cNvPr id="37" name="TextBox 36"/>
-          <p:cNvSpPr txBox="1"/>
-          <p:nvPr/>
-        </p:nvSpPr>
-        <p:spPr>
-          <a:xfrm>
-            <a:off x="6126480" y="3865747"/>
-            <a:ext cx="2423160" cy="440689"/>
-          </a:xfrm>
-          <a:prstGeom prst="rect">
-            <a:avLst/>
-          </a:prstGeom>
-          <a:noFill/>
-        </p:spPr>
-        <p:txBody>
-          <a:bodyPr wrap="square">
-            <a:spAutoFit/>
-          </a:bodyPr>
-          <a:lstStyle/>
-          <a:p>
-            <a:pPr algn="l"/>
-            <a:r>
-              <a:rPr sz="1100" b="0">
-                <a:solidFill>
-                  <a:srgbClr val="465461"/>
-                </a:solidFill>
-                <a:latin typeface="Arial"/>
-              </a:rPr>
-              <a:t>Flat file</a:t>
-            </a:r>
-          </a:p>
-        </p:txBody>
-      </p:sp>
-      <p:sp>
-        <p:nvSpPr>
-          <p:cNvPr id="38" name="TextBox 37"/>
-          <p:cNvSpPr txBox="1"/>
-          <p:nvPr/>
-        </p:nvSpPr>
-        <p:spPr>
-          <a:xfrm>
-            <a:off x="8641080" y="3865747"/>
-            <a:ext cx="2423160" cy="440689"/>
-          </a:xfrm>
-          <a:prstGeom prst="rect">
-            <a:avLst/>
-          </a:prstGeom>
-          <a:noFill/>
-        </p:spPr>
-        <p:txBody>
-          <a:bodyPr wrap="square">
-            <a:spAutoFit/>
-          </a:bodyPr>
-          <a:lstStyle/>
-          <a:p>
-            <a:pPr algn="l"/>
-            <a:r>
-              <a:rPr sz="1100" b="0">
-                <a:solidFill>
-                  <a:srgbClr val="465461"/>
-                </a:solidFill>
-                <a:latin typeface="Arial"/>
-              </a:rPr>
-              <a:t>Colon-delimited, solo tabla user</a:t>
-            </a:r>
-          </a:p>
-        </p:txBody>
-      </p:sp>
-      <p:sp>
-        <p:nvSpPr>
-          <p:cNvPr id="39" name="Rectangle 38"/>
-          <p:cNvSpPr/>
-          <p:nvPr/>
-        </p:nvSpPr>
-        <p:spPr>
-          <a:xfrm>
-            <a:off x="1051560" y="4266437"/>
-            <a:ext cx="10058400" cy="310896"/>
-          </a:xfrm>
-          <a:prstGeom prst="rect">
-            <a:avLst/>
-          </a:prstGeom>
-          <a:solidFill>
-            <a:srgbClr val="F1F2F6"/>
-          </a:solidFill>
-          <a:ln>
-            <a:noFill/>
-          </a:ln>
-        </p:spPr>
-        <p:style>
-          <a:lnRef idx="1">
-            <a:schemeClr val="accent1"/>
-          </a:lnRef>
-          <a:fillRef idx="3">
-            <a:schemeClr val="accent1"/>
-          </a:fillRef>
-          <a:effectRef idx="2">
-            <a:schemeClr val="accent1"/>
-          </a:effectRef>
-          <a:fontRef idx="minor">
-            <a:schemeClr val="lt1"/>
-          </a:fontRef>
-        </p:style>
-        <p:txBody>
-          <a:bodyPr rtlCol="0" anchor="ctr"/>
-          <a:lstStyle/>
-          <a:p>
-            <a:pPr algn="ctr"/>
-          </a:p>
-        </p:txBody>
-      </p:sp>
-      <p:sp>
-        <p:nvSpPr>
-          <p:cNvPr id="40" name="TextBox 39"/>
-          <p:cNvSpPr txBox="1"/>
-          <p:nvPr/>
-        </p:nvSpPr>
-        <p:spPr>
-          <a:xfrm>
-            <a:off x="1097280" y="4306437"/>
-            <a:ext cx="2423160" cy="310896"/>
-          </a:xfrm>
-          <a:prstGeom prst="rect">
-            <a:avLst/>
-          </a:prstGeom>
-          <a:noFill/>
-        </p:spPr>
-        <p:txBody>
-          <a:bodyPr wrap="square">
-            <a:spAutoFit/>
-          </a:bodyPr>
-          <a:lstStyle/>
-          <a:p>
-            <a:pPr algn="l"/>
-            <a:r>
-              <a:rPr sz="1100" b="0">
-                <a:solidFill>
-                  <a:srgbClr val="465461"/>
-                </a:solidFill>
-                <a:latin typeface="Arial"/>
-              </a:rPr>
-              <a:t>Crdshop.su</a:t>
-            </a:r>
-          </a:p>
-        </p:txBody>
-      </p:sp>
-      <p:sp>
-        <p:nvSpPr>
-          <p:cNvPr id="41" name="TextBox 40"/>
-          <p:cNvSpPr txBox="1"/>
-          <p:nvPr/>
-        </p:nvSpPr>
-        <p:spPr>
-          <a:xfrm>
-            <a:off x="3611880" y="4306437"/>
-            <a:ext cx="2423160" cy="310896"/>
-          </a:xfrm>
-          <a:prstGeom prst="rect">
-            <a:avLst/>
-          </a:prstGeom>
-          <a:noFill/>
-        </p:spPr>
-        <p:txBody>
-          <a:bodyPr wrap="square">
-            <a:spAutoFit/>
-          </a:bodyPr>
-          <a:lstStyle/>
-          <a:p>
-            <a:pPr algn="l"/>
-            <a:r>
-              <a:rPr sz="1100" b="0">
-                <a:solidFill>
-                  <a:srgbClr val="465461"/>
-                </a:solidFill>
-                <a:latin typeface="Arial"/>
-              </a:rPr>
-              <a:t>2016-11</a:t>
-            </a:r>
-          </a:p>
-        </p:txBody>
-      </p:sp>
-      <p:sp>
-        <p:nvSpPr>
-          <p:cNvPr id="42" name="TextBox 41"/>
-          <p:cNvSpPr txBox="1"/>
-          <p:nvPr/>
-        </p:nvSpPr>
-        <p:spPr>
-          <a:xfrm>
-            <a:off x="6126480" y="4306437"/>
-            <a:ext cx="2423160" cy="310896"/>
-          </a:xfrm>
-          <a:prstGeom prst="rect">
-            <a:avLst/>
-          </a:prstGeom>
-          <a:noFill/>
-        </p:spPr>
-        <p:txBody>
-          <a:bodyPr wrap="square">
-            <a:spAutoFit/>
-          </a:bodyPr>
-          <a:lstStyle/>
-          <a:p>
-            <a:pPr algn="l"/>
-            <a:r>
-              <a:rPr sz="1100" b="0">
-                <a:solidFill>
-                  <a:srgbClr val="465461"/>
-                </a:solidFill>
-                <a:latin typeface="Arial"/>
-              </a:rPr>
-              <a:t>vBulletin SQL</a:t>
-            </a:r>
-          </a:p>
-        </p:txBody>
-      </p:sp>
-      <p:sp>
-        <p:nvSpPr>
-          <p:cNvPr id="43" name="TextBox 42"/>
-          <p:cNvSpPr txBox="1"/>
-          <p:nvPr/>
-        </p:nvSpPr>
-        <p:spPr>
-          <a:xfrm>
-            <a:off x="8641080" y="4306437"/>
-            <a:ext cx="2423160" cy="310896"/>
-          </a:xfrm>
-          <a:prstGeom prst="rect">
-            <a:avLst/>
-          </a:prstGeom>
-          <a:noFill/>
-        </p:spPr>
-        <p:txBody>
-          <a:bodyPr wrap="square">
-            <a:spAutoFit/>
-          </a:bodyPr>
-          <a:lstStyle/>
-          <a:p>
-            <a:pPr algn="l"/>
-            <a:r>
-              <a:rPr sz="1100" b="0">
-                <a:solidFill>
-                  <a:srgbClr val="465461"/>
-                </a:solidFill>
-                <a:latin typeface="Arial"/>
-              </a:rPr>
-              <a:t/>
-            </a:r>
-          </a:p>
-        </p:txBody>
-      </p:sp>
-      <p:sp>
-        <p:nvSpPr>
-          <p:cNvPr id="44" name="Rectangle 43"/>
-          <p:cNvSpPr/>
-          <p:nvPr/>
-        </p:nvSpPr>
-        <p:spPr>
-          <a:xfrm>
-            <a:off x="1051560" y="4577333"/>
-            <a:ext cx="10058400" cy="310896"/>
-          </a:xfrm>
-          <a:prstGeom prst="rect">
-            <a:avLst/>
-          </a:prstGeom>
-          <a:solidFill>
-            <a:srgbClr val="FFFFFF"/>
-          </a:solidFill>
-          <a:ln>
-            <a:noFill/>
-          </a:ln>
-        </p:spPr>
-        <p:style>
-          <a:lnRef idx="1">
-            <a:schemeClr val="accent1"/>
-          </a:lnRef>
-          <a:fillRef idx="3">
-            <a:schemeClr val="accent1"/>
-          </a:fillRef>
-          <a:effectRef idx="2">
-            <a:schemeClr val="accent1"/>
-          </a:effectRef>
-          <a:fontRef idx="minor">
-            <a:schemeClr val="lt1"/>
-          </a:fontRef>
-        </p:style>
-        <p:txBody>
-          <a:bodyPr rtlCol="0" anchor="ctr"/>
-          <a:lstStyle/>
-          <a:p>
-            <a:pPr algn="ctr"/>
-          </a:p>
-        </p:txBody>
-      </p:sp>
-      <p:sp>
-        <p:nvSpPr>
-          <p:cNvPr id="45" name="TextBox 44"/>
-          <p:cNvSpPr txBox="1"/>
-          <p:nvPr/>
-        </p:nvSpPr>
-        <p:spPr>
-          <a:xfrm>
-            <a:off x="1097280" y="4617333"/>
-            <a:ext cx="2423160" cy="310896"/>
-          </a:xfrm>
-          <a:prstGeom prst="rect">
-            <a:avLst/>
-          </a:prstGeom>
-          <a:noFill/>
-        </p:spPr>
-        <p:txBody>
-          <a:bodyPr wrap="square">
-            <a:spAutoFit/>
-          </a:bodyPr>
-          <a:lstStyle/>
-          <a:p>
-            <a:pPr algn="l"/>
-            <a:r>
-              <a:rPr sz="1100" b="0">
-                <a:solidFill>
-                  <a:srgbClr val="465461"/>
-                </a:solidFill>
-                <a:latin typeface="Arial"/>
-              </a:rPr>
-              <a:t>Elitecarders.name</a:t>
-            </a:r>
-          </a:p>
-        </p:txBody>
-      </p:sp>
-      <p:sp>
-        <p:nvSpPr>
-          <p:cNvPr id="46" name="TextBox 45"/>
-          <p:cNvSpPr txBox="1"/>
-          <p:nvPr/>
-        </p:nvSpPr>
-        <p:spPr>
-          <a:xfrm>
-            <a:off x="3611880" y="4617333"/>
-            <a:ext cx="2423160" cy="310896"/>
-          </a:xfrm>
-          <a:prstGeom prst="rect">
-            <a:avLst/>
-          </a:prstGeom>
-          <a:noFill/>
-        </p:spPr>
-        <p:txBody>
-          <a:bodyPr wrap="square">
-            <a:spAutoFit/>
-          </a:bodyPr>
-          <a:lstStyle/>
-          <a:p>
-            <a:pPr algn="l"/>
-            <a:r>
-              <a:rPr sz="1100" b="0">
-                <a:solidFill>
-                  <a:srgbClr val="465461"/>
-                </a:solidFill>
-                <a:latin typeface="Arial"/>
-              </a:rPr>
-              <a:t>2016-08</a:t>
-            </a:r>
-          </a:p>
-        </p:txBody>
-      </p:sp>
-      <p:sp>
-        <p:nvSpPr>
-          <p:cNvPr id="47" name="TextBox 46"/>
-          <p:cNvSpPr txBox="1"/>
-          <p:nvPr/>
-        </p:nvSpPr>
-        <p:spPr>
-          <a:xfrm>
-            <a:off x="6126480" y="4617333"/>
-            <a:ext cx="2423160" cy="310896"/>
-          </a:xfrm>
-          <a:prstGeom prst="rect">
-            <a:avLst/>
-          </a:prstGeom>
-          <a:noFill/>
-        </p:spPr>
-        <p:txBody>
-          <a:bodyPr wrap="square">
-            <a:spAutoFit/>
-          </a:bodyPr>
-          <a:lstStyle/>
-          <a:p>
-            <a:pPr algn="l"/>
-            <a:r>
-              <a:rPr sz="1100" b="0">
-                <a:solidFill>
-                  <a:srgbClr val="465461"/>
-                </a:solidFill>
-                <a:latin typeface="Arial"/>
-              </a:rPr>
-              <a:t>vBulletin SQL</a:t>
-            </a:r>
-          </a:p>
-        </p:txBody>
-      </p:sp>
-      <p:sp>
-        <p:nvSpPr>
-          <p:cNvPr id="48" name="TextBox 47"/>
-          <p:cNvSpPr txBox="1"/>
-          <p:nvPr/>
-        </p:nvSpPr>
-        <p:spPr>
-          <a:xfrm>
-            <a:off x="8641080" y="4617333"/>
-            <a:ext cx="2423160" cy="310896"/>
-          </a:xfrm>
-          <a:prstGeom prst="rect">
-            <a:avLst/>
-          </a:prstGeom>
-          <a:noFill/>
-        </p:spPr>
-        <p:txBody>
-          <a:bodyPr wrap="square">
-            <a:spAutoFit/>
-          </a:bodyPr>
-          <a:lstStyle/>
-          <a:p>
-            <a:pPr algn="l"/>
-            <a:r>
-              <a:rPr sz="1100" b="0">
-                <a:solidFill>
-                  <a:srgbClr val="465461"/>
-                </a:solidFill>
-                <a:latin typeface="Arial"/>
-              </a:rPr>
-              <a:t/>
-            </a:r>
-          </a:p>
-        </p:txBody>
-      </p:sp>
-      <p:sp>
-        <p:nvSpPr>
-          <p:cNvPr id="49" name="Rectangle 48"/>
-          <p:cNvSpPr/>
-          <p:nvPr/>
-        </p:nvSpPr>
-        <p:spPr>
-          <a:xfrm>
-            <a:off x="1051560" y="4888229"/>
-            <a:ext cx="10058400" cy="310896"/>
-          </a:xfrm>
-          <a:prstGeom prst="rect">
-            <a:avLst/>
-          </a:prstGeom>
-          <a:solidFill>
-            <a:srgbClr val="F1F2F6"/>
-          </a:solidFill>
-          <a:ln>
-            <a:noFill/>
-          </a:ln>
-        </p:spPr>
-        <p:style>
-          <a:lnRef idx="1">
-            <a:schemeClr val="accent1"/>
-          </a:lnRef>
-          <a:fillRef idx="3">
-            <a:schemeClr val="accent1"/>
-          </a:fillRef>
-          <a:effectRef idx="2">
-            <a:schemeClr val="accent1"/>
-          </a:effectRef>
-          <a:fontRef idx="minor">
-            <a:schemeClr val="lt1"/>
-          </a:fontRef>
-        </p:style>
-        <p:txBody>
-          <a:bodyPr rtlCol="0" anchor="ctr"/>
-          <a:lstStyle/>
-          <a:p>
-            <a:pPr algn="ctr"/>
-          </a:p>
-        </p:txBody>
-      </p:sp>
-      <p:sp>
-        <p:nvSpPr>
-          <p:cNvPr id="50" name="TextBox 49"/>
-          <p:cNvSpPr txBox="1"/>
-          <p:nvPr/>
-        </p:nvSpPr>
-        <p:spPr>
-          <a:xfrm>
-            <a:off x="1097280" y="4928229"/>
-            <a:ext cx="2423160" cy="310896"/>
-          </a:xfrm>
-          <a:prstGeom prst="rect">
-            <a:avLst/>
-          </a:prstGeom>
-          <a:noFill/>
-        </p:spPr>
-        <p:txBody>
-          <a:bodyPr wrap="square">
-            <a:spAutoFit/>
-          </a:bodyPr>
-          <a:lstStyle/>
-          <a:p>
-            <a:pPr algn="l"/>
-            <a:r>
-              <a:rPr sz="1100" b="0">
-                <a:solidFill>
-                  <a:srgbClr val="465461"/>
-                </a:solidFill>
-                <a:latin typeface="Arial"/>
-              </a:rPr>
-              <a:t>CardingMafia</a:t>
-            </a:r>
-          </a:p>
-        </p:txBody>
-      </p:sp>
-      <p:sp>
-        <p:nvSpPr>
-          <p:cNvPr id="51" name="TextBox 50"/>
-          <p:cNvSpPr txBox="1"/>
-          <p:nvPr/>
-        </p:nvSpPr>
-        <p:spPr>
-          <a:xfrm>
-            <a:off x="3611880" y="4928229"/>
-            <a:ext cx="2423160" cy="310896"/>
-          </a:xfrm>
-          <a:prstGeom prst="rect">
-            <a:avLst/>
-          </a:prstGeom>
-          <a:noFill/>
-        </p:spPr>
-        <p:txBody>
-          <a:bodyPr wrap="square">
-            <a:spAutoFit/>
-          </a:bodyPr>
-          <a:lstStyle/>
-          <a:p>
-            <a:pPr algn="l"/>
-            <a:r>
-              <a:rPr sz="1100" b="0">
-                <a:solidFill>
-                  <a:srgbClr val="465461"/>
-                </a:solidFill>
-                <a:latin typeface="Arial"/>
-              </a:rPr>
-              <a:t>2021-03</a:t>
-            </a:r>
-          </a:p>
-        </p:txBody>
-      </p:sp>
-      <p:sp>
-        <p:nvSpPr>
-          <p:cNvPr id="52" name="TextBox 51"/>
-          <p:cNvSpPr txBox="1"/>
-          <p:nvPr/>
-        </p:nvSpPr>
-        <p:spPr>
-          <a:xfrm>
-            <a:off x="6126480" y="4928229"/>
-            <a:ext cx="2423160" cy="310896"/>
-          </a:xfrm>
-          <a:prstGeom prst="rect">
-            <a:avLst/>
-          </a:prstGeom>
-          <a:noFill/>
-        </p:spPr>
-        <p:txBody>
-          <a:bodyPr wrap="square">
-            <a:spAutoFit/>
-          </a:bodyPr>
-          <a:lstStyle/>
-          <a:p>
-            <a:pPr algn="l"/>
-            <a:r>
-              <a:rPr sz="1100" b="0">
-                <a:solidFill>
-                  <a:srgbClr val="465461"/>
-                </a:solidFill>
-                <a:latin typeface="Arial"/>
-              </a:rPr>
-              <a:t>vBulletin SQL</a:t>
-            </a:r>
-          </a:p>
-        </p:txBody>
-      </p:sp>
-      <p:sp>
-        <p:nvSpPr>
-          <p:cNvPr id="53" name="TextBox 52"/>
-          <p:cNvSpPr txBox="1"/>
-          <p:nvPr/>
-        </p:nvSpPr>
-        <p:spPr>
-          <a:xfrm>
-            <a:off x="8641080" y="4928229"/>
-            <a:ext cx="2423160" cy="310896"/>
-          </a:xfrm>
-          <a:prstGeom prst="rect">
-            <a:avLst/>
-          </a:prstGeom>
-          <a:noFill/>
-        </p:spPr>
-        <p:txBody>
-          <a:bodyPr wrap="square">
-            <a:spAutoFit/>
-          </a:bodyPr>
-          <a:lstStyle/>
-          <a:p>
-            <a:pPr algn="l"/>
-            <a:r>
-              <a:rPr sz="1100" b="0">
-                <a:solidFill>
-                  <a:srgbClr val="465461"/>
-                </a:solidFill>
-                <a:latin typeface="Arial"/>
-              </a:rPr>
-              <a:t>Ver siguiente slide</a:t>
-            </a:r>
-          </a:p>
-        </p:txBody>
-      </p:sp>
-      <p:sp>
-        <p:nvSpPr>
-          <p:cNvPr id="54" name="Rectangle 53"/>
-          <p:cNvSpPr/>
-          <p:nvPr/>
-        </p:nvSpPr>
-        <p:spPr>
-          <a:xfrm>
-            <a:off x="1051560" y="5199125"/>
-            <a:ext cx="10058400" cy="310896"/>
-          </a:xfrm>
-          <a:prstGeom prst="rect">
-            <a:avLst/>
-          </a:prstGeom>
-          <a:solidFill>
-            <a:srgbClr val="FFFFFF"/>
-          </a:solidFill>
-          <a:ln>
-            <a:noFill/>
-          </a:ln>
-        </p:spPr>
-        <p:style>
-          <a:lnRef idx="1">
-            <a:schemeClr val="accent1"/>
-          </a:lnRef>
-          <a:fillRef idx="3">
-            <a:schemeClr val="accent1"/>
-          </a:fillRef>
-          <a:effectRef idx="2">
-            <a:schemeClr val="accent1"/>
-          </a:effectRef>
-          <a:fontRef idx="minor">
-            <a:schemeClr val="lt1"/>
-          </a:fontRef>
-        </p:style>
-        <p:txBody>
-          <a:bodyPr rtlCol="0" anchor="ctr"/>
-          <a:lstStyle/>
-          <a:p>
-            <a:pPr algn="ctr"/>
-          </a:p>
-        </p:txBody>
-      </p:sp>
-      <p:sp>
-        <p:nvSpPr>
-          <p:cNvPr id="55" name="TextBox 54"/>
-          <p:cNvSpPr txBox="1"/>
-          <p:nvPr/>
-        </p:nvSpPr>
-        <p:spPr>
-          <a:xfrm>
-            <a:off x="1097280" y="5239125"/>
-            <a:ext cx="2423160" cy="310896"/>
-          </a:xfrm>
-          <a:prstGeom prst="rect">
-            <a:avLst/>
-          </a:prstGeom>
-          <a:noFill/>
-        </p:spPr>
-        <p:txBody>
-          <a:bodyPr wrap="square">
-            <a:spAutoFit/>
-          </a:bodyPr>
-          <a:lstStyle/>
-          <a:p>
-            <a:pPr algn="l"/>
-            <a:r>
-              <a:rPr sz="1100" b="0">
-                <a:solidFill>
-                  <a:srgbClr val="465461"/>
-                </a:solidFill>
-                <a:latin typeface="Arial"/>
-              </a:rPr>
-              <a:t>Cardmafia.cc</a:t>
-            </a:r>
-          </a:p>
-        </p:txBody>
-      </p:sp>
-      <p:sp>
-        <p:nvSpPr>
-          <p:cNvPr id="56" name="TextBox 55"/>
-          <p:cNvSpPr txBox="1"/>
-          <p:nvPr/>
-        </p:nvSpPr>
-        <p:spPr>
-          <a:xfrm>
-            <a:off x="3611880" y="5239125"/>
-            <a:ext cx="2423160" cy="310896"/>
-          </a:xfrm>
-          <a:prstGeom prst="rect">
-            <a:avLst/>
-          </a:prstGeom>
-          <a:noFill/>
-        </p:spPr>
-        <p:txBody>
-          <a:bodyPr wrap="square">
-            <a:spAutoFit/>
-          </a:bodyPr>
-          <a:lstStyle/>
-          <a:p>
-            <a:pPr algn="l"/>
-            <a:r>
-              <a:rPr sz="1100" b="0">
-                <a:solidFill>
-                  <a:srgbClr val="465461"/>
-                </a:solidFill>
-                <a:latin typeface="Arial"/>
-              </a:rPr>
-              <a:t>2021-03</a:t>
-            </a:r>
-          </a:p>
-        </p:txBody>
-      </p:sp>
-      <p:sp>
-        <p:nvSpPr>
-          <p:cNvPr id="57" name="TextBox 56"/>
-          <p:cNvSpPr txBox="1"/>
-          <p:nvPr/>
-        </p:nvSpPr>
-        <p:spPr>
-          <a:xfrm>
-            <a:off x="6126480" y="5239125"/>
-            <a:ext cx="2423160" cy="310896"/>
-          </a:xfrm>
-          <a:prstGeom prst="rect">
-            <a:avLst/>
-          </a:prstGeom>
-          <a:noFill/>
-        </p:spPr>
-        <p:txBody>
-          <a:bodyPr wrap="square">
-            <a:spAutoFit/>
-          </a:bodyPr>
-          <a:lstStyle/>
-          <a:p>
-            <a:pPr algn="l"/>
-            <a:r>
-              <a:rPr sz="1100" b="0">
-                <a:solidFill>
-                  <a:srgbClr val="465461"/>
-                </a:solidFill>
-                <a:latin typeface="Arial"/>
-              </a:rPr>
-              <a:t>vBulletin SQL</a:t>
-            </a:r>
-          </a:p>
-        </p:txBody>
-      </p:sp>
-      <p:sp>
-        <p:nvSpPr>
-          <p:cNvPr id="58" name="TextBox 57"/>
-          <p:cNvSpPr txBox="1"/>
-          <p:nvPr/>
-        </p:nvSpPr>
-        <p:spPr>
-          <a:xfrm>
-            <a:off x="8641080" y="5239125"/>
-            <a:ext cx="2423160" cy="310896"/>
-          </a:xfrm>
-          <a:prstGeom prst="rect">
-            <a:avLst/>
-          </a:prstGeom>
-          <a:noFill/>
-        </p:spPr>
-        <p:txBody>
-          <a:bodyPr wrap="square">
-            <a:spAutoFit/>
-          </a:bodyPr>
-          <a:lstStyle/>
-          <a:p>
-            <a:pPr algn="l"/>
-            <a:r>
-              <a:rPr sz="1100" b="0">
-                <a:solidFill>
-                  <a:srgbClr val="465461"/>
-                </a:solidFill>
-                <a:latin typeface="Arial"/>
-              </a:rPr>
-              <a:t>Ver siguiente slide</a:t>
-            </a:r>
-          </a:p>
-        </p:txBody>
-      </p:sp>
-      <p:sp>
-        <p:nvSpPr>
-          <p:cNvPr id="59" name="TextBox 58"/>
-          <p:cNvSpPr txBox="1"/>
-          <p:nvPr/>
-        </p:nvSpPr>
-        <p:spPr>
-          <a:xfrm>
-            <a:off x="1051560" y="5760720"/>
+            <a:off x="1051560" y="5806440"/>
             <a:ext cx="10058400" cy="320040"/>
           </a:xfrm>
           <a:prstGeom prst="rect">

</xml_diff>

<commit_message>
feat: reenfocar los 3 casos prácticos en una técnica protagonista
Cada caso propio (CardingForums, HackingForums, IronMarch) reduce ahora
lo genérico/redundante con Ransomware o entre sí y profundiza su hilo
conductor: IronMarch en centralidad + ground truth judicial, HackingForums
en atribución cross-foro multi-señal (incluida persistencia real
verificada entre los 4 snapshots de OGUsers), CardingForums en Louvain +
especialización de mercado. Notebooks y .pptx regenerados en los tres.

También: correcciones de bloque0_ecosistema (guion y contenido según
revisión) y ajustes globales en _shared/theme.py (tamaño de etiqueta de
sección, aire título-cuerpo, color de viñeta en two_col_slide).
</commit_message>
<xml_diff>
--- a/CardingForums/csbc26_caso_cardingforums.pptx
+++ b/CardingForums/csbc26_caso_cardingforums.pptx
@@ -28,7 +28,6 @@
     <p:sldId id="273" r:id="rId28"/>
     <p:sldId id="274" r:id="rId29"/>
     <p:sldId id="275" r:id="rId30"/>
-    <p:sldId id="276" r:id="rId31"/>
   </p:sldIdLst>
   <p:sldSz cx="12192000" cy="6858000"/>
   <p:notesSz cx="6858000" cy="9144000"/>
@@ -727,12 +726,12 @@
           </a:p>
           <a:p>
             <a:r>
-              <a:t>Pregunta: reconstruir quién es quién, sin API externa</a:t>
-            </a:r>
-          </a:p>
-          <a:p>
-            <a:r>
-              <a:t>Prueba de escala: 1.5M posts sostenidos por el pipeline</a:t>
+              <a:t>Pregunta: cómo se reparte el trabajo en un mercado sin jerarquía única</a:t>
+            </a:r>
+          </a:p>
+          <a:p>
+            <a:r>
+              <a:t>Hilo conductor: comunidades + especialización, no perfilado individual</a:t>
             </a:r>
           </a:p>
           <a:p>
@@ -807,22 +806,22 @@
           <a:lstStyle/>
           <a:p>
             <a:r>
-              <a:t>Datos limpios → pregunta: quién habla con quién</a:t>
-            </a:r>
-          </a:p>
-          <a:p>
-            <a:r>
-              <a:t>¿Esas interacciones forman grupos identificables?</a:t>
-            </a:r>
-          </a:p>
-          <a:p>
-            <a:r>
-              <a:t>Estadística de grafos pura, sin IA generativa aún</a:t>
-            </a:r>
-          </a:p>
-          <a:p>
-            <a:r>
-              <a:t>→ base sólida antes del LLM</a:t>
+              <a:t>Nodo=usuario, arista=co-participación en thread</a:t>
+            </a:r>
+          </a:p>
+          <a:p>
+            <a:r>
+              <a:t>Componente gigante: 11,113 nodos tras filtrado</a:t>
+            </a:r>
+          </a:p>
+          <a:p>
+            <a:r>
+              <a:t>Degree y betweenness centrality sobre esa componente</a:t>
+            </a:r>
+          </a:p>
+          <a:p>
+            <a:r>
+              <a:t>Betweenness por muestreo k=500 — exacto es inviable</a:t>
             </a:r>
           </a:p>
         </p:txBody>
@@ -892,27 +891,22 @@
           <a:lstStyle/>
           <a:p>
             <a:r>
-              <a:t>Nodo=usuario, arista=co-participación en thread</a:t>
-            </a:r>
-          </a:p>
-          <a:p>
-            <a:r>
-              <a:t>Filtro aristas de 1 thread compartido, elimina ruido</a:t>
-            </a:r>
-          </a:p>
-          <a:p>
-            <a:r>
-              <a:t>Componente gigante: 11,113 nodos tras filtrado</a:t>
-            </a:r>
-          </a:p>
-          <a:p>
-            <a:r>
-              <a:t>Degree y betweenness centrality sobre esa componente</a:t>
-            </a:r>
-          </a:p>
-          <a:p>
-            <a:r>
-              <a:t>Betweenness por muestreo k=500 — exacto es inviable</a:t>
+              <a:t>Sin filtro: hilo masivo mezcla comunidades sin relación real</a:t>
+            </a:r>
+          </a:p>
+          <a:p>
+            <a:r>
+              <a:t>Regla: &gt;=2 threads compartidos, no 1</a:t>
+            </a:r>
+          </a:p>
+          <a:p>
+            <a:r>
+              <a:t>Aplicar ANTES de Louvain, no como corrección posterior</a:t>
+            </a:r>
+          </a:p>
+          <a:p>
+            <a:r>
+              <a:t>→ sigue: qué encuentra Louvain con este grafo limpio</a:t>
             </a:r>
           </a:p>
         </p:txBody>
@@ -982,27 +976,22 @@
           <a:lstStyle/>
           <a:p>
             <a:r>
-              <a:t>21 comunidades, manejable para inspección manual</a:t>
-            </a:r>
-          </a:p>
-          <a:p>
-            <a:r>
-              <a:t>Comunidad homogénea = círculo cerrado de un foro</a:t>
-            </a:r>
-          </a:p>
-          <a:p>
-            <a:r>
-              <a:t>Comunidad mixta = mismos actores, varias plataformas</a:t>
-            </a:r>
-          </a:p>
-          <a:p>
-            <a:r>
-              <a:t>TF-IDF por subforo nombra cada sección temática</a:t>
-            </a:r>
-          </a:p>
-          <a:p>
-            <a:r>
-              <a:t>Todo sin GPU ni LLM, 100% reproducible</a:t>
+              <a:t>Louvain no fija K, k-means sí — aquí no hay coordenadas naturales</a:t>
+            </a:r>
+          </a:p>
+          <a:p>
+            <a:r>
+              <a:t>Modularidad como criterio, escala a decenas de miles de nodos</a:t>
+            </a:r>
+          </a:p>
+          <a:p>
+            <a:r>
+              <a:t>21 comunidades: homogéneas = círculo cerrado de un foro</a:t>
+            </a:r>
+          </a:p>
+          <a:p>
+            <a:r>
+              <a:t>Comunidad mixta = nota de pasada, no repetir atribución de HackingForums</a:t>
             </a:r>
           </a:p>
         </p:txBody>
@@ -1072,22 +1061,22 @@
           <a:lstStyle/>
           <a:p>
             <a:r>
-              <a:t>Notebook 02: scatter degree vs. betweenness</a:t>
-            </a:r>
-          </a:p>
-          <a:p>
-            <a:r>
-              <a:t>Nodos conectados ≠ nodos puente, distinguirlos</a:t>
-            </a:r>
-          </a:p>
-          <a:p>
-            <a:r>
-              <a:t>Sección 4: composición de comunidades por foro</a:t>
-            </a:r>
-          </a:p>
-          <a:p>
-            <a:r>
-              <a:t>Sección 5: visualización interactiva top-150 nodos</a:t>
+              <a:t>Louvain solo mide conexiones, BERTopic solo mide contenido — señales independientes</a:t>
+            </a:r>
+          </a:p>
+          <a:p>
+            <a:r>
+              <a:t>Si coinciden: especialización real, no ruido del grafo</a:t>
+            </a:r>
+          </a:p>
+          <a:p>
+            <a:r>
+              <a:t>TF-IDF por subforo ya apuntaba a esto</a:t>
+            </a:r>
+          </a:p>
+          <a:p>
+            <a:r>
+              <a:t>→ confirma vendedores de dumps, cashers, tutoriales como grupos reales</a:t>
             </a:r>
           </a:p>
         </p:txBody>
@@ -1157,17 +1146,22 @@
           <a:lstStyle/>
           <a:p>
             <a:r>
-              <a:t>Entra el LLM local: texto → vectores, entidades, roles</a:t>
-            </a:r>
-          </a:p>
-          <a:p>
-            <a:r>
-              <a:t>Sección más ambiciosa del caso</a:t>
-            </a:r>
-          </a:p>
-          <a:p>
-            <a:r>
-              <a:t>Más matices y limitaciones a comunicar con honestidad</a:t>
+              <a:t>Notebook 02: scatter degree vs. betweenness</a:t>
+            </a:r>
+          </a:p>
+          <a:p>
+            <a:r>
+              <a:t>Nodos conectados ≠ nodos puente, distinguirlos</a:t>
+            </a:r>
+          </a:p>
+          <a:p>
+            <a:r>
+              <a:t>Sección 4: composición de comunidades por foro</a:t>
+            </a:r>
+          </a:p>
+          <a:p>
+            <a:r>
+              <a:t>Notebook 03: cruce comunidad × topic</a:t>
             </a:r>
           </a:p>
         </p:txBody>
@@ -1237,27 +1231,17 @@
           <a:lstStyle/>
           <a:p>
             <a:r>
-              <a:t>Umbral mínimo 10 posts para embedding confiable</a:t>
-            </a:r>
-          </a:p>
-          <a:p>
-            <a:r>
-              <a:t>Solo 9,550 de ~1M usuarios pasan el filtro</a:t>
-            </a:r>
-          </a:p>
-          <a:p>
-            <a:r>
-              <a:t>Cap de 50K caracteres, evita colgar Ollama</a:t>
-            </a:r>
-          </a:p>
-          <a:p>
-            <a:r>
-              <a:t>Todo local: qwen3-embedding, 4096D, sin API externa</a:t>
-            </a:r>
-          </a:p>
-          <a:p>
-            <a:r>
-              <a:t>UMAP+HDBSCAN y BERTopic, dos vistas complementarias</a:t>
+              <a:t>Entra el LLM local solo para embeddings y topics</a:t>
+            </a:r>
+          </a:p>
+          <a:p>
+            <a:r>
+              <a:t>Objetivo: confirmar la especialización que sugiere la red</a:t>
+            </a:r>
+          </a:p>
+          <a:p>
+            <a:r>
+              <a:t>El perfilado individual de roles no es el foco aquí</a:t>
             </a:r>
           </a:p>
         </p:txBody>
@@ -1327,27 +1311,22 @@
           <a:lstStyle/>
           <a:p>
             <a:r>
-              <a:t>qwen2.5:14b infiere rol, no solo extrae entidades</a:t>
-            </a:r>
-          </a:p>
-          <a:p>
-            <a:r>
-              <a:t>Input: centralidad, cluster, entidades, muestra de posts</a:t>
-            </a:r>
-          </a:p>
-          <a:p>
-            <a:r>
-              <a:t>Limitado a los 100 usuarios más activos (elección de alcance)</a:t>
-            </a:r>
-          </a:p>
-          <a:p>
-            <a:r>
-              <a:t>Categorías: vendedor, comprador, escrow, lurker...</a:t>
-            </a:r>
-          </a:p>
-          <a:p>
-            <a:r>
-              <a:t>30 perfiles con confianza: inferencia, no verdad de campo</a:t>
+              <a:t>Umbral mínimo 10 posts para embedding confiable</a:t>
+            </a:r>
+          </a:p>
+          <a:p>
+            <a:r>
+              <a:t>Solo 9,550 de ~1M usuarios pasan el filtro</a:t>
+            </a:r>
+          </a:p>
+          <a:p>
+            <a:r>
+              <a:t>Cap de 50K caracteres, evita colgar Ollama</a:t>
+            </a:r>
+          </a:p>
+          <a:p>
+            <a:r>
+              <a:t>UMAP+HDBSCAN y BERTopic, insumo para el cruce con comunidades</a:t>
             </a:r>
           </a:p>
         </p:txBody>
@@ -1417,22 +1396,22 @@
           <a:lstStyle/>
           <a:p>
             <a:r>
-              <a:t>20 de 30 = lurker, confianza alta 0.85–0.95</a:t>
-            </a:r>
-          </a:p>
-          <a:p>
-            <a:r>
-              <a:t>Contraintuitivo: eran los 100 usuarios más activos</a:t>
-            </a:r>
-          </a:p>
-          <a:p>
-            <a:r>
-              <a:t>¿Cómo un 'top' termina siendo lurker?</a:t>
-            </a:r>
-          </a:p>
-          <a:p>
-            <a:r>
-              <a:t>→ sigue: no es error del LLM, es problema de los datos</a:t>
+              <a:t>NER+perfilado existe en el notebook, pero como contraste</a:t>
+            </a:r>
+          </a:p>
+          <a:p>
+            <a:r>
+              <a:t>Ransomware profundiza esta técnica, aquí no se repite</a:t>
+            </a:r>
+          </a:p>
+          <a:p>
+            <a:r>
+              <a:t>Matiz que se conserva: contador de posts del foro puede mentir</a:t>
+            </a:r>
+          </a:p>
+          <a:p>
+            <a:r>
+              <a:t>→ sigue: conclusiones</a:t>
             </a:r>
           </a:p>
         </p:txBody>
@@ -1502,22 +1481,17 @@
           <a:lstStyle/>
           <a:p>
             <a:r>
-              <a:t>Campo posts = contador propio del foro, no verificado</a:t>
-            </a:r>
-          </a:p>
-          <a:p>
-            <a:r>
-              <a:t>Varios 'top 100' aparecen con 0 posts en el corpus limpio</a:t>
-            </a:r>
-          </a:p>
-          <a:p>
-            <a:r>
-              <a:t>LLM clasifica lurker por falta de datos, no de actividad</a:t>
-            </a:r>
-          </a:p>
-          <a:p>
-            <a:r>
-              <a:t>Lección: contador del sistema origen, sospechoso hasta verificar</a:t>
+              <a:t>Cierre: del dump crudo a la anatomía de un mercado</a:t>
+            </a:r>
+          </a:p>
+          <a:p>
+            <a:r>
+              <a:t>Conclusiones aplicables a otros casos y trabajo futuro</a:t>
+            </a:r>
+          </a:p>
+          <a:p>
+            <a:r>
+              <a:t>Qué es técnica reutilizable, qué es específico del dataset</a:t>
             </a:r>
           </a:p>
         </p:txBody>
@@ -1587,17 +1561,22 @@
           <a:lstStyle/>
           <a:p>
             <a:r>
-              <a:t>Cierre: del dump crudo al perfilado de actores</a:t>
-            </a:r>
-          </a:p>
-          <a:p>
-            <a:r>
-              <a:t>Conclusiones aplicables a otros casos y trabajo futuro</a:t>
-            </a:r>
-          </a:p>
-          <a:p>
-            <a:r>
-              <a:t>Qué es técnica reutilizable, qué es específico del dataset</a:t>
+              <a:t>Dump duplicado y flat file: verificar entrada no es opcional</a:t>
+            </a:r>
+          </a:p>
+          <a:p>
+            <a:r>
+              <a:t>Louvain sobre k-means: la estructura es un grafo, no coordenadas</a:t>
+            </a:r>
+          </a:p>
+          <a:p>
+            <a:r>
+              <a:t>Filtrar aristas triviales antes de Louvain, no después</a:t>
+            </a:r>
+          </a:p>
+          <a:p>
+            <a:r>
+              <a:t>Cruzar red + contenido confirma, no asume</a:t>
             </a:r>
           </a:p>
         </p:txBody>
@@ -1672,17 +1651,7 @@
           </a:p>
           <a:p>
             <a:r>
-              <a:t>10 archivos, no 10 foros distintos</a:t>
-            </a:r>
-          </a:p>
-          <a:p>
-            <a:r>
-              <a:t>Un dump duplicado bajo dos nombres</a:t>
-            </a:r>
-          </a:p>
-          <a:p>
-            <a:r>
-              <a:t>Un archivo no-SQL pese al zip</a:t>
+              <a:t>Gancho breve — el detalle está en el notebook 00</a:t>
             </a:r>
           </a:p>
           <a:p>
@@ -1757,91 +1726,6 @@
           <a:lstStyle/>
           <a:p>
             <a:r>
-              <a:t>Dump duplicado y flat file: verificar entrada no es opcional</a:t>
-            </a:r>
-          </a:p>
-          <a:p>
-            <a:r>
-              <a:t>Ninguna automatización reemplaza la validación</a:t>
-            </a:r>
-          </a:p>
-          <a:p>
-            <a:r>
-              <a:t>Auto-detectar formato, validar fechas, deduplicar primero</a:t>
-            </a:r>
-          </a:p>
-          <a:p>
-            <a:r>
-              <a:t>Decisión deliberada: pipeline 100% local, sin API externa</a:t>
-            </a:r>
-          </a:p>
-        </p:txBody>
-      </p:sp>
-      <p:sp>
-        <p:nvSpPr>
-          <p:cNvPr id="4" name="Slide Number Placeholder 3"/>
-          <p:cNvSpPr>
-            <a:spLocks noGrp="1"/>
-          </p:cNvSpPr>
-          <p:nvPr>
-            <p:ph type="sldNum" idx="5" sz="quarter"/>
-          </p:nvPr>
-        </p:nvSpPr>
-        <p:spPr/>
-      </p:sp>
-    </p:spTree>
-  </p:cSld>
-  <p:clrMapOvr>
-    <a:masterClrMapping/>
-  </p:clrMapOvr>
-</p:notes>
-</file>
-
-<file path=ppt/notesSlides/notesSlide21.xml><?xml version="1.0" encoding="utf-8"?>
-<p:notes xmlns:a="http://schemas.openxmlformats.org/drawingml/2006/main" xmlns:p="http://schemas.openxmlformats.org/presentationml/2006/main" xmlns:r="http://schemas.openxmlformats.org/officeDocument/2006/relationships">
-  <p:cSld>
-    <p:spTree>
-      <p:nvGrpSpPr>
-        <p:cNvPr id="1" name=""/>
-        <p:cNvGrpSpPr/>
-        <p:nvPr/>
-      </p:nvGrpSpPr>
-      <p:grpSpPr>
-        <a:xfrm>
-          <a:off x="0" y="0"/>
-          <a:ext cx="0" cy="0"/>
-          <a:chOff x="0" y="0"/>
-          <a:chExt cx="0" cy="0"/>
-        </a:xfrm>
-      </p:grpSpPr>
-      <p:sp>
-        <p:nvSpPr>
-          <p:cNvPr id="2" name="Slide Image Placeholder 1"/>
-          <p:cNvSpPr>
-            <a:spLocks noGrp="1"/>
-          </p:cNvSpPr>
-          <p:nvPr>
-            <p:ph type="sldImg" idx="2"/>
-          </p:nvPr>
-        </p:nvSpPr>
-        <p:spPr/>
-      </p:sp>
-      <p:sp>
-        <p:nvSpPr>
-          <p:cNvPr id="3" name="Notes Placeholder 2"/>
-          <p:cNvSpPr>
-            <a:spLocks noGrp="1"/>
-          </p:cNvSpPr>
-          <p:nvPr>
-            <p:ph type="body" idx="3" sz="quarter"/>
-          </p:nvPr>
-        </p:nvSpPr>
-        <p:spPr/>
-        <p:txBody>
-          <a:bodyPr/>
-          <a:lstStyle/>
-          <a:p>
-            <a:r>
               <a:t>Pregunta a la audiencia: ¿mejor caso para probar escala?</a:t>
             </a:r>
           </a:p>
@@ -1857,7 +1741,7 @@
           </a:p>
           <a:p>
             <a:r>
-              <a:t>LLM local: funciona, pero tan bueno como el input</a:t>
+              <a:t>Anatomía de mercado sin perfilar a cada actor</a:t>
             </a:r>
           </a:p>
           <a:p>
@@ -1937,22 +1821,17 @@
           </a:p>
           <a:p>
             <a:r>
-              <a:t>Carder.pro: encoding cp1251 cirílico, se detecta o rompe</a:t>
-            </a:r>
-          </a:p>
-          <a:p>
-            <a:r>
-              <a:t>Ojo: CardingMafia y Cardmafia.cc, ambas 2021-03</a:t>
-            </a:r>
-          </a:p>
-          <a:p>
-            <a:r>
-              <a:t>→ sigue: demuestra que son el mismo leak</a:t>
-            </a:r>
-          </a:p>
-          <a:p>
-            <a:r>
-              <a:t>Pregunta: ¿confiamos en el nombre sin verificar contenido?</a:t>
+              <a:t>Carder.pro: cirílico, se detecta o rompe</a:t>
+            </a:r>
+          </a:p>
+          <a:p>
+            <a:r>
+              <a:t>CardingMafia/Cardmafia.cc: mismo leak, dos nombres</a:t>
+            </a:r>
+          </a:p>
+          <a:p>
+            <a:r>
+              <a:t>→ sigue: gancho de apertura con los dos bugs</a:t>
             </a:r>
           </a:p>
         </p:txBody>
@@ -2022,27 +1901,22 @@
           <a:lstStyle/>
           <a:p>
             <a:r>
-              <a:t>2 zips, nombre distinto, mismo tamaño exacto en bytes</a:t>
-            </a:r>
-          </a:p>
-          <a:p>
-            <a:r>
-              <a:t>Verificación byte a byte confirma: mismo leak</a:t>
-            </a:r>
-          </a:p>
-          <a:p>
-            <a:r>
-              <a:t>Probable inflar catálogo del vendedor</a:t>
-            </a:r>
-          </a:p>
-          <a:p>
-            <a:r>
-              <a:t>Ninguno trae tabla post, solo usuarios</a:t>
-            </a:r>
-          </a:p>
-          <a:p>
-            <a:r>
-              <a:t>Lección: el nombre no es fuente de verdad, el contenido sí</a:t>
+              <a:t>Gancho, no sección profunda — detalle en notebook 00</a:t>
+            </a:r>
+          </a:p>
+          <a:p>
+            <a:r>
+              <a:t>Dump duplicado: mismo tamaño en bytes, mismo contenido</a:t>
+            </a:r>
+          </a:p>
+          <a:p>
+            <a:r>
+              <a:t>Flat file: 0 filas sin error, parser equivocado</a:t>
+            </a:r>
+          </a:p>
+          <a:p>
+            <a:r>
+              <a:t>→ sigue: reconocimiento y limpieza</a:t>
             </a:r>
           </a:p>
         </p:txBody>
@@ -2112,27 +1986,22 @@
           <a:lstStyle/>
           <a:p>
             <a:r>
-              <a:t>Error silencioso: load_forum() no tira excepción, da 0 filas</a:t>
-            </a:r>
-          </a:p>
-          <a:p>
-            <a:r>
-              <a:t>Zip real: txt delimitado por ':', no SQL</a:t>
-            </a:r>
-          </a:p>
-          <a:p>
-            <a:r>
-              <a:t>Parser ya existía, faltaba auto-detección</a:t>
-            </a:r>
-          </a:p>
-          <a:p>
-            <a:r>
-              <a:t>Resultado: 177,938 usuarios recuperados</a:t>
-            </a:r>
-          </a:p>
-          <a:p>
-            <a:r>
-              <a:t>Moraleja: 0 filas ≠ dataset vacío, a veces es parser equivocado</a:t>
+              <a:t>Ya conocemos archivos y formatos, toca cuantificar y limpiar</a:t>
+            </a:r>
+          </a:p>
+          <a:p>
+            <a:r>
+              <a:t>Escala real: casi 1M usuarios</a:t>
+            </a:r>
+          </a:p>
+          <a:p>
+            <a:r>
+              <a:t>Mismos problemas de siempre: timestamps, texto vacío, duplicados</a:t>
+            </a:r>
+          </a:p>
+          <a:p>
+            <a:r>
+              <a:t>A mayor escala, más cuidado, no menos</a:t>
             </a:r>
           </a:p>
         </p:txBody>
@@ -2202,22 +2071,22 @@
           <a:lstStyle/>
           <a:p>
             <a:r>
-              <a:t>Ya conocemos archivos y formatos, toca cuantificar y limpiar</a:t>
-            </a:r>
-          </a:p>
-          <a:p>
-            <a:r>
-              <a:t>Escala real: casi 1M usuarios</a:t>
-            </a:r>
-          </a:p>
-          <a:p>
-            <a:r>
-              <a:t>Mismos problemas de siempre: timestamps, texto vacío, duplicados</a:t>
-            </a:r>
-          </a:p>
-          <a:p>
-            <a:r>
-              <a:t>A mayor escala, más cuidado, no menos</a:t>
+              <a:t>Escala obliga a reglas sistemáticas, no revisión fila a fila</a:t>
+            </a:r>
+          </a:p>
+          <a:p>
+            <a:r>
+              <a:t>Rango 2009-2016, pero hay timestamps corruptos</a:t>
+            </a:r>
+          </a:p>
+          <a:p>
+            <a:r>
+              <a:t>vBulletin domina: se reutiliza parseo de casos previos</a:t>
+            </a:r>
+          </a:p>
+          <a:p>
+            <a:r>
+              <a:t>→ sigue: cuantificamos ese ruido</a:t>
             </a:r>
           </a:p>
         </p:txBody>
@@ -2287,27 +2156,22 @@
           <a:lstStyle/>
           <a:p>
             <a:r>
-              <a:t>Escala obliga a reglas sistemáticas, no revisión fila a fila</a:t>
-            </a:r>
-          </a:p>
-          <a:p>
-            <a:r>
-              <a:t>Rango 2009-2016, pero hay timestamps corruptos</a:t>
-            </a:r>
-          </a:p>
-          <a:p>
-            <a:r>
-              <a:t>→ sigue: cuantificamos ese ruido</a:t>
-            </a:r>
-          </a:p>
-          <a:p>
-            <a:r>
-              <a:t>vBulletin domina: se reutiliza parseo de casos previos</a:t>
-            </a:r>
-          </a:p>
-          <a:p>
-            <a:r>
-              <a:t>cp1251 se detecta, nunca se asume</a:t>
+              <a:t>18.8% con joindate inválido, epoch-0 o nulo</a:t>
+            </a:r>
+          </a:p>
+          <a:p>
+            <a:r>
+              <a:t>Mismo patrón que en HackingForums, no es casualidad</a:t>
+            </a:r>
+          </a:p>
+          <a:p>
+            <a:r>
+              <a:t>58,939 posts vacíos: contenido borrado por moderación</a:t>
+            </a:r>
+          </a:p>
+          <a:p>
+            <a:r>
+              <a:t>4% descartado antes de red o topics</a:t>
             </a:r>
           </a:p>
         </p:txBody>
@@ -2377,27 +2241,22 @@
           <a:lstStyle/>
           <a:p>
             <a:r>
-              <a:t>18.8% con joindate inválido, epoch-0 o nulo</a:t>
-            </a:r>
-          </a:p>
-          <a:p>
-            <a:r>
-              <a:t>Mismo patrón que en HackingForums, no es casualidad</a:t>
-            </a:r>
-          </a:p>
-          <a:p>
-            <a:r>
-              <a:t>58,939 posts vacíos: contenido borrado por moderación</a:t>
-            </a:r>
-          </a:p>
-          <a:p>
-            <a:r>
-              <a:t>Deduplicación por (userid, forum)</a:t>
-            </a:r>
-          </a:p>
-          <a:p>
-            <a:r>
-              <a:t>4% descartado antes de embeddings o NER</a:t>
+              <a:t>Notebook 00: tabla usuarios/posts por foro, escala en números</a:t>
+            </a:r>
+          </a:p>
+          <a:p>
+            <a:r>
+              <a:t>Timeline de registros: saltos raros = timestamps corruptos</a:t>
+            </a:r>
+          </a:p>
+          <a:p>
+            <a:r>
+              <a:t>Sección 7: completitud de campos de contacto</a:t>
+            </a:r>
+          </a:p>
+          <a:p>
+            <a:r>
+              <a:t>Notebook 01, sección 5: conteos antes/después de limpieza</a:t>
             </a:r>
           </a:p>
         </p:txBody>
@@ -2467,22 +2326,22 @@
           <a:lstStyle/>
           <a:p>
             <a:r>
-              <a:t>Notebook 00: tabla usuarios/posts por foro, escala en números</a:t>
-            </a:r>
-          </a:p>
-          <a:p>
-            <a:r>
-              <a:t>Timeline de registros: saltos raros = timestamps corruptos</a:t>
-            </a:r>
-          </a:p>
-          <a:p>
-            <a:r>
-              <a:t>Sección 7: completitud de campos de contacto</a:t>
-            </a:r>
-          </a:p>
-          <a:p>
-            <a:r>
-              <a:t>Notebook 01, sección 5: conteos antes/después de limpieza</a:t>
+              <a:t>Datos limpios → pregunta central del caso</a:t>
+            </a:r>
+          </a:p>
+          <a:p>
+            <a:r>
+              <a:t>¿Cómo se organiza un mercado sin jerarquía única?</a:t>
+            </a:r>
+          </a:p>
+          <a:p>
+            <a:r>
+              <a:t>Estadística de grafos pura, sin IA generativa</a:t>
+            </a:r>
+          </a:p>
+          <a:p>
+            <a:r>
+              <a:t>→ el hilo conductor de todo el caso</a:t>
             </a:r>
           </a:p>
         </p:txBody>
@@ -6112,7 +5971,7 @@
                 </a:solidFill>
                 <a:latin typeface="Arial"/>
               </a:rPr>
-              <a:t>Del dump SQL al perfilado de actores en un mercado de fraude financiero (2009–2021)</a:t>
+              <a:t>Anatomía de un mercado: comunidades, especialización y quién conecta con quién (2009–2021)</a:t>
             </a:r>
           </a:p>
           <a:p>
@@ -6153,7 +6012,7 @@
             <a:spLocks noGrp="1"/>
           </p:cNvSpPr>
           <p:nvPr>
-            <p:ph type="body" idx="10" sz="quarter"/>
+            <p:ph type="body" idx="13" sz="quarter"/>
           </p:nvPr>
         </p:nvSpPr>
         <p:spPr/>
@@ -6161,33 +6020,49 @@
           <a:bodyPr wrap="square"/>
           <a:lstStyle/>
           <a:p>
-            <a:pPr algn="ctr"/>
-            <a:r>
-              <a:rPr sz="1300" b="1">
-                <a:solidFill>
-                  <a:srgbClr val="CD2D37"/>
-                </a:solidFill>
-                <a:latin typeface="Arial"/>
-              </a:rPr>
-              <a:t>SECCIÓN 3</a:t>
-            </a:r>
-          </a:p>
-          <a:p>
-            <a:pPr algn="ctr"/>
-            <a:r>
-              <a:t>Red de co-participación y comunidades</a:t>
-            </a:r>
-          </a:p>
-          <a:p>
-            <a:pPr algn="ctr"/>
-            <a:r>
-              <a:rPr sz="1600">
-                <a:solidFill>
-                  <a:srgbClr val="D6DAE2"/>
-                </a:solidFill>
-                <a:latin typeface="Arial"/>
-              </a:rPr>
-              <a:t>Notebook 02 — quién habla con quién, sin IA generativa</a:t>
+            <a:r>
+              <a:t>Construcción del grafo</a:t>
+            </a:r>
+          </a:p>
+        </p:txBody>
+      </p:sp>
+      <p:sp>
+        <p:nvSpPr>
+          <p:cNvPr id="3" name="Text Placeholder 2"/>
+          <p:cNvSpPr>
+            <a:spLocks noGrp="1"/>
+          </p:cNvSpPr>
+          <p:nvPr>
+            <p:ph type="body" idx="16" sz="quarter"/>
+          </p:nvPr>
+        </p:nvSpPr>
+        <p:spPr>
+          <a:xfrm>
+            <a:off x="1073427" y="1711816"/>
+            <a:ext cx="10084904" cy="3873058"/>
+          </a:xfrm>
+        </p:spPr>
+        <p:txBody>
+          <a:bodyPr wrap="square"/>
+          <a:lstStyle/>
+          <a:p>
+            <a:r>
+              <a:t>Nodo = usuario. Arista = co-participación en el mismo thread, peso = threads compartidos</a:t>
+            </a:r>
+          </a:p>
+          <a:p>
+            <a:r>
+              <a:t>Componente gigante resultante: 11,113 nodos tras el filtrado</a:t>
+            </a:r>
+          </a:p>
+          <a:p>
+            <a:r>
+              <a:t>Degree centrality (conexiones directas) y betweenness centrality (rol de puente) sobre esa componente</a:t>
+            </a:r>
+          </a:p>
+          <a:p>
+            <a:r>
+              <a:t>betweenness se calcula por muestreo (k=500) — exacto es inviable en grafos de este tamaño</a:t>
             </a:r>
           </a:p>
         </p:txBody>
@@ -6226,7 +6101,7 @@
           <a:lstStyle/>
           <a:p>
             <a:r>
-              <a:t>Construcción del grafo</a:t>
+              <a:t>Por qué filtrar aristas de un solo thread compartido</a:t>
             </a:r>
           </a:p>
         </p:txBody>
@@ -6243,31 +6118,159 @@
         </p:nvSpPr>
         <p:spPr/>
         <p:txBody>
-          <a:bodyPr wrap="square"/>
+          <a:bodyPr/>
           <a:lstStyle/>
-          <a:p>
-            <a:r>
-              <a:t>Nodo = usuario. Arista = co-participación en el mismo thread, peso = threads compartidos</a:t>
-            </a:r>
-          </a:p>
-          <a:p>
-            <a:r>
-              <a:t>Filtro de aristas débiles: se descartan pares que solo comparten 1 thread (ruido)</a:t>
-            </a:r>
-          </a:p>
-          <a:p>
-            <a:r>
-              <a:t>Componente gigante resultante: 11,113 nodos tras el filtrado</a:t>
-            </a:r>
-          </a:p>
-          <a:p>
-            <a:r>
-              <a:t>Degree centrality (conexiones directas) y betweenness centrality (rol de puente) sobre esa componente</a:t>
-            </a:r>
-          </a:p>
-          <a:p>
-            <a:r>
-              <a:t>betweenness se calcula por muestreo (k=500) — exacto es inviable en grafos de este tamaño</a:t>
+          <a:p/>
+        </p:txBody>
+      </p:sp>
+      <p:sp>
+        <p:nvSpPr>
+          <p:cNvPr id="4" name="TextBox 3"/>
+          <p:cNvSpPr txBox="1"/>
+          <p:nvPr/>
+        </p:nvSpPr>
+        <p:spPr>
+          <a:xfrm>
+            <a:off x="1051560" y="2331720"/>
+            <a:ext cx="10058400" cy="502920"/>
+          </a:xfrm>
+          <a:prstGeom prst="rect">
+            <a:avLst/>
+          </a:prstGeom>
+          <a:noFill/>
+        </p:spPr>
+        <p:txBody>
+          <a:bodyPr wrap="square">
+            <a:spAutoFit/>
+          </a:bodyPr>
+          <a:lstStyle/>
+          <a:p>
+            <a:pPr algn="l"/>
+            <a:r>
+              <a:rPr sz="1600" b="0">
+                <a:solidFill>
+                  <a:srgbClr val="465461"/>
+                </a:solidFill>
+                <a:latin typeface="Arial"/>
+              </a:rPr>
+              <a:t>Sin este filtro, Louvain fusiona comunidades ajenas por coincidir una vez en un hilo masivo.</a:t>
+            </a:r>
+          </a:p>
+        </p:txBody>
+      </p:sp>
+      <p:sp>
+        <p:nvSpPr>
+          <p:cNvPr id="5" name="Rectangle 4"/>
+          <p:cNvSpPr/>
+          <p:nvPr/>
+        </p:nvSpPr>
+        <p:spPr>
+          <a:xfrm>
+            <a:off x="1005840" y="2880360"/>
+            <a:ext cx="10149840" cy="2926080"/>
+          </a:xfrm>
+          <a:prstGeom prst="rect">
+            <a:avLst/>
+          </a:prstGeom>
+          <a:solidFill>
+            <a:srgbClr val="0D1B2A"/>
+          </a:solidFill>
+          <a:ln>
+            <a:noFill/>
+          </a:ln>
+        </p:spPr>
+        <p:style>
+          <a:lnRef idx="1">
+            <a:schemeClr val="accent1"/>
+          </a:lnRef>
+          <a:fillRef idx="3">
+            <a:schemeClr val="accent1"/>
+          </a:fillRef>
+          <a:effectRef idx="2">
+            <a:schemeClr val="accent1"/>
+          </a:effectRef>
+          <a:fontRef idx="minor">
+            <a:schemeClr val="lt1"/>
+          </a:fontRef>
+        </p:style>
+        <p:txBody>
+          <a:bodyPr rtlCol="0" anchor="ctr"/>
+          <a:lstStyle/>
+          <a:p>
+            <a:pPr algn="ctr"/>
+          </a:p>
+        </p:txBody>
+      </p:sp>
+      <p:sp>
+        <p:nvSpPr>
+          <p:cNvPr id="6" name="TextBox 5"/>
+          <p:cNvSpPr txBox="1"/>
+          <p:nvPr/>
+        </p:nvSpPr>
+        <p:spPr>
+          <a:xfrm>
+            <a:off x="1188720" y="3017520"/>
+            <a:ext cx="9784080" cy="2651760"/>
+          </a:xfrm>
+          <a:prstGeom prst="rect">
+            <a:avLst/>
+          </a:prstGeom>
+          <a:noFill/>
+        </p:spPr>
+        <p:txBody>
+          <a:bodyPr wrap="none">
+            <a:spAutoFit/>
+          </a:bodyPr>
+          <a:lstStyle/>
+          <a:p>
+            <a:r>
+              <a:rPr sz="1400">
+                <a:solidFill>
+                  <a:srgbClr val="A8FF78"/>
+                </a:solidFill>
+                <a:latin typeface="Consolas"/>
+              </a:rPr>
+              <a:t>MIN_SHARED_THREADS = 2
+# Solo mantenemos una arista si coincidieron en &gt;= 2 threads
+strong_edges = edges_df[edges_df['shared_threads'] &gt;= MIN_SHARED_THREADS]
+# Aristas de '1 thread compartido' = ruido: dos usuarios que
+# postearon una vez en un hilo de cientos de participantes
+# no tienen ninguna relación real entre sí.</a:t>
+            </a:r>
+          </a:p>
+        </p:txBody>
+      </p:sp>
+      <p:sp>
+        <p:nvSpPr>
+          <p:cNvPr id="7" name="TextBox 6"/>
+          <p:cNvSpPr txBox="1"/>
+          <p:nvPr/>
+        </p:nvSpPr>
+        <p:spPr>
+          <a:xfrm>
+            <a:off x="1051560" y="5760720"/>
+            <a:ext cx="10058400" cy="365760"/>
+          </a:xfrm>
+          <a:prstGeom prst="rect">
+            <a:avLst/>
+          </a:prstGeom>
+          <a:noFill/>
+        </p:spPr>
+        <p:txBody>
+          <a:bodyPr wrap="square">
+            <a:spAutoFit/>
+          </a:bodyPr>
+          <a:lstStyle/>
+          <a:p>
+            <a:pPr algn="l"/>
+            <a:r>
+              <a:rPr sz="1100" b="0">
+                <a:solidFill>
+                  <a:srgbClr val="707888"/>
+                </a:solidFill>
+                <a:latin typeface="Arial"/>
+              </a:rPr>
+              <a:t>ℹ  El filtro se aplica ANTES de correr Louvain, no después — si no, ya está contaminada la partición.</a:t>
             </a:r>
           </a:p>
         </p:txBody>
@@ -6306,7 +6309,7 @@
           <a:lstStyle/>
           <a:p>
             <a:r>
-              <a:t>Comunidades — Louvain sobre la red</a:t>
+              <a:t>Comunidades — Louvain, no k-means</a:t>
             </a:r>
           </a:p>
         </p:txBody>
@@ -6323,8 +6326,8 @@
         </p:nvSpPr>
         <p:spPr>
           <a:xfrm>
-            <a:off x="1073427" y="2077576"/>
-            <a:ext cx="10084904" cy="3507298"/>
+            <a:off x="1073427" y="2214736"/>
+            <a:ext cx="10084904" cy="3370138"/>
           </a:xfrm>
         </p:spPr>
         <p:txBody>
@@ -6332,7 +6335,17 @@
           <a:lstStyle/>
           <a:p>
             <a:r>
-              <a:t>21 comunidades detectadas en la componente gigante</a:t>
+              <a:t>21 comunidades detectadas en la componente gigante — Louvain no necesita fijar K de antemano</a:t>
+            </a:r>
+          </a:p>
+          <a:p>
+            <a:r>
+              <a:t>k-means exigiría inventar coordenadas euclidianas para un grafo de conexiones — perdería la estructura real de quién-conecta-con-quién</a:t>
+            </a:r>
+          </a:p>
+          <a:p>
+            <a:r>
+              <a:t>Louvain optimiza modularidad directamente sobre el grafo y escala a decenas de miles de nodos</a:t>
             </a:r>
           </a:p>
           <a:p>
@@ -6341,18 +6354,17 @@
             </a:r>
           </a:p>
           <a:p>
-            <a:r>
-              <a:t>Una comunidad mixta (varios foros) es candidata a red cross-foro — mismos actores, distintas plataformas</a:t>
-            </a:r>
-          </a:p>
-          <a:p>
-            <a:r>
-              <a:t>TF-IDF por subforo identifica qué términos dominan cada sección temática (dumps, cashout, tutoriales...)</a:t>
-            </a:r>
-          </a:p>
-          <a:p>
-            <a:r>
-              <a:t>Todo esto es reproducible sin GPU ni LLM — estadística de grafos y frecuencias de términos</a:t>
+            <a:pPr lvl="1" marL="274320" indent="-228600">
+              <a:buNone/>
+            </a:pPr>
+            <a:r>
+              <a:rPr sz="1500" b="0">
+                <a:solidFill>
+                  <a:srgbClr val="707888"/>
+                </a:solidFill>
+                <a:latin typeface="Arial"/>
+              </a:rPr>
+              <a:t>·  Una comunidad mixta (varios foros) es candidata a red cross-foro — se menciona de pasada, la atribución cross-foro en profundidad es el hilo conductor de HackingForums</a:t>
             </a:r>
           </a:p>
         </p:txBody>
@@ -6382,7 +6394,7 @@
             <a:spLocks noGrp="1"/>
           </p:cNvSpPr>
           <p:nvPr>
-            <p:ph type="body" idx="10" sz="quarter"/>
+            <p:ph type="body" idx="13" sz="quarter"/>
           </p:nvPr>
         </p:nvSpPr>
         <p:spPr/>
@@ -6390,100 +6402,49 @@
           <a:bodyPr wrap="square"/>
           <a:lstStyle/>
           <a:p>
-            <a:pPr algn="ctr"/>
-            <a:r>
-              <a:rPr sz="1300" b="1">
-                <a:solidFill>
-                  <a:srgbClr val="CD2D37"/>
-                </a:solidFill>
-                <a:latin typeface="Arial"/>
-              </a:rPr>
-              <a:t>DEMO EN VIVO</a:t>
-            </a:r>
-          </a:p>
-          <a:p>
-            <a:pPr algn="ctr"/>
-            <a:r>
-              <a:t>Demo — red y comunidades</a:t>
-            </a:r>
-          </a:p>
-          <a:p>
-            <a:pPr algn="ctr"/>
-            <a:r>
-              <a:rPr sz="1400">
-                <a:solidFill>
-                  <a:srgbClr val="9AA3B5"/>
-                </a:solidFill>
-                <a:latin typeface="Arial"/>
-              </a:rPr>
-              <a:t>CardingForums/02_analisis_estructural.ipynb</a:t>
-            </a:r>
-          </a:p>
-        </p:txBody>
-      </p:sp>
-      <p:sp>
-        <p:nvSpPr>
-          <p:cNvPr id="3" name="TextBox 2"/>
-          <p:cNvSpPr txBox="1"/>
-          <p:nvPr/>
+            <a:r>
+              <a:t>Comunidad × topic — ¿especialización real o casualidad del grafo?</a:t>
+            </a:r>
+          </a:p>
+        </p:txBody>
+      </p:sp>
+      <p:sp>
+        <p:nvSpPr>
+          <p:cNvPr id="3" name="Text Placeholder 2"/>
+          <p:cNvSpPr>
+            <a:spLocks noGrp="1"/>
+          </p:cNvSpPr>
+          <p:nvPr>
+            <p:ph type="body" idx="16" sz="quarter"/>
+          </p:nvPr>
         </p:nvSpPr>
         <p:spPr>
           <a:xfrm>
-            <a:off x="2505456" y="3657600"/>
-            <a:ext cx="7168896" cy="2560320"/>
+            <a:off x="1073427" y="2717656"/>
+            <a:ext cx="10084904" cy="2867218"/>
           </a:xfrm>
-          <a:prstGeom prst="rect">
-            <a:avLst/>
-          </a:prstGeom>
-          <a:noFill/>
         </p:spPr>
         <p:txBody>
-          <a:bodyPr wrap="square">
-            <a:spAutoFit/>
-          </a:bodyPr>
+          <a:bodyPr wrap="square"/>
           <a:lstStyle/>
           <a:p>
             <a:r>
-              <a:rPr sz="1600">
-                <a:solidFill>
-                  <a:srgbClr val="D6DAE2"/>
-                </a:solidFill>
-                <a:latin typeface="Arial"/>
-              </a:rPr>
-              <a:t>1.  Abrir notebook 02_analisis_estructural</a:t>
-            </a:r>
-          </a:p>
-          <a:p>
-            <a:r>
-              <a:rPr sz="1600">
-                <a:solidFill>
-                  <a:srgbClr val="D6DAE2"/>
-                </a:solidFill>
-                <a:latin typeface="Arial"/>
-              </a:rPr>
-              <a:t>2.  Sección 3: scatter de degree vs. betweenness centrality</a:t>
-            </a:r>
-          </a:p>
-          <a:p>
-            <a:r>
-              <a:rPr sz="1600">
-                <a:solidFill>
-                  <a:srgbClr val="D6DAE2"/>
-                </a:solidFill>
-                <a:latin typeface="Arial"/>
-              </a:rPr>
-              <a:t>3.  Sección 4: composición de comunidades por foro</a:t>
-            </a:r>
-          </a:p>
-          <a:p>
-            <a:r>
-              <a:rPr sz="1600">
-                <a:solidFill>
-                  <a:srgbClr val="D6DAE2"/>
-                </a:solidFill>
-                <a:latin typeface="Arial"/>
-              </a:rPr>
-              <a:t>4.  Sección 5: visualización interactiva de los top-150 nodos</a:t>
+              <a:t>Cruzar la comunidad de red (Louvain) con el topic de contenido (BERTopic) de cada usuario</a:t>
+            </a:r>
+          </a:p>
+          <a:p>
+            <a:r>
+              <a:t>Si ambas señales coinciden — misma comunidad, mismo topic dominante — no es artefacto del grafo, es especialización real del mercado</a:t>
+            </a:r>
+          </a:p>
+          <a:p>
+            <a:r>
+              <a:t>TF-IDF por subforo ya apuntaba a esto: dumps, cashout, tutoriales como términos discriminantes por sección</a:t>
+            </a:r>
+          </a:p>
+          <a:p>
+            <a:r>
+              <a:t>El cruce confirma qué comunidades son vendedores de dumps, cuáles son cashers, cuáles son buscadores de tutoriales</a:t>
             </a:r>
           </a:p>
         </p:txBody>
@@ -6523,23 +6484,57 @@
           <a:p>
             <a:pPr algn="ctr"/>
             <a:r>
-              <a:rPr sz="1300" b="1">
+              <a:rPr sz="1700" b="1">
                 <a:solidFill>
                   <a:srgbClr val="CD2D37"/>
                 </a:solidFill>
                 <a:latin typeface="Arial"/>
               </a:rPr>
-              <a:t>SECCIÓN 4</a:t>
+              <a:t>DEMO EN VIVO</a:t>
             </a:r>
           </a:p>
           <a:p>
             <a:pPr algn="ctr"/>
             <a:r>
-              <a:t>Semántica y perfilado de actores</a:t>
+              <a:t>Demo — red y comunidades</a:t>
             </a:r>
           </a:p>
           <a:p>
             <a:pPr algn="ctr"/>
+            <a:r>
+              <a:rPr sz="1400">
+                <a:solidFill>
+                  <a:srgbClr val="9AA3B5"/>
+                </a:solidFill>
+                <a:latin typeface="Arial"/>
+              </a:rPr>
+              <a:t>CardingForums/02_analisis_estructural.ipynb</a:t>
+            </a:r>
+          </a:p>
+        </p:txBody>
+      </p:sp>
+      <p:sp>
+        <p:nvSpPr>
+          <p:cNvPr id="3" name="TextBox 2"/>
+          <p:cNvSpPr txBox="1"/>
+          <p:nvPr/>
+        </p:nvSpPr>
+        <p:spPr>
+          <a:xfrm>
+            <a:off x="2505456" y="3657600"/>
+            <a:ext cx="7168896" cy="2560320"/>
+          </a:xfrm>
+          <a:prstGeom prst="rect">
+            <a:avLst/>
+          </a:prstGeom>
+          <a:noFill/>
+        </p:spPr>
+        <p:txBody>
+          <a:bodyPr wrap="square">
+            <a:spAutoFit/>
+          </a:bodyPr>
+          <a:lstStyle/>
+          <a:p>
             <a:r>
               <a:rPr sz="1600">
                 <a:solidFill>
@@ -6547,7 +6542,40 @@
                 </a:solidFill>
                 <a:latin typeface="Arial"/>
               </a:rPr>
-              <a:t>Notebook 03 — embeddings, NER y LLM local</a:t>
+              <a:t>1.  Abrir notebook 02_analisis_estructural</a:t>
+            </a:r>
+          </a:p>
+          <a:p>
+            <a:r>
+              <a:rPr sz="1600">
+                <a:solidFill>
+                  <a:srgbClr val="D6DAE2"/>
+                </a:solidFill>
+                <a:latin typeface="Arial"/>
+              </a:rPr>
+              <a:t>2.  Sección 3: scatter de degree vs. betweenness centrality</a:t>
+            </a:r>
+          </a:p>
+          <a:p>
+            <a:r>
+              <a:rPr sz="1600">
+                <a:solidFill>
+                  <a:srgbClr val="D6DAE2"/>
+                </a:solidFill>
+                <a:latin typeface="Arial"/>
+              </a:rPr>
+              <a:t>3.  Sección 4: composición de comunidades por foro</a:t>
+            </a:r>
+          </a:p>
+          <a:p>
+            <a:r>
+              <a:rPr sz="1600">
+                <a:solidFill>
+                  <a:srgbClr val="D6DAE2"/>
+                </a:solidFill>
+                <a:latin typeface="Arial"/>
+              </a:rPr>
+              <a:t>4.  Notebook 03, sección 5: cruce comunidad × topic</a:t>
             </a:r>
           </a:p>
         </p:txBody>
@@ -6577,7 +6605,7 @@
             <a:spLocks noGrp="1"/>
           </p:cNvSpPr>
           <p:nvPr>
-            <p:ph type="body" idx="13" sz="quarter"/>
+            <p:ph type="body" idx="10" sz="quarter"/>
           </p:nvPr>
         </p:nvSpPr>
         <p:spPr/>
@@ -6585,54 +6613,33 @@
           <a:bodyPr wrap="square"/>
           <a:lstStyle/>
           <a:p>
-            <a:r>
-              <a:t>Embeddings — un vector por usuario</a:t>
-            </a:r>
-          </a:p>
-        </p:txBody>
-      </p:sp>
-      <p:sp>
-        <p:nvSpPr>
-          <p:cNvPr id="3" name="Text Placeholder 2"/>
-          <p:cNvSpPr>
-            <a:spLocks noGrp="1"/>
-          </p:cNvSpPr>
-          <p:nvPr>
-            <p:ph type="body" idx="16" sz="quarter"/>
-          </p:nvPr>
-        </p:nvSpPr>
-        <p:spPr>
-          <a:xfrm>
-            <a:off x="1073427" y="2077576"/>
-            <a:ext cx="10084904" cy="3507298"/>
-          </a:xfrm>
-        </p:spPr>
-        <p:txBody>
-          <a:bodyPr wrap="square"/>
-          <a:lstStyle/>
-          <a:p>
-            <a:r>
-              <a:t>qwen3-embedding (4096D) vía Ollama, completamente local</a:t>
-            </a:r>
-          </a:p>
-          <a:p>
-            <a:r>
-              <a:t>9,550 usuarios con ≥10 posts obtienen embedding — el resto no tiene suficiente texto para ser confiable</a:t>
-            </a:r>
-          </a:p>
-          <a:p>
-            <a:r>
-              <a:t>Concatenación de posts por usuario, capada a 50K caracteres para no colgar Ollama con usuarios extremos</a:t>
-            </a:r>
-          </a:p>
-          <a:p>
-            <a:r>
-              <a:t>UMAP + HDBSCAN sobre esos vectores para clustering de comportamiento de escritura</a:t>
-            </a:r>
-          </a:p>
-          <a:p>
-            <a:r>
-              <a:t>BERTopic sobre el mismo corpus para topic modeling — qué temas dominan cada cluster</a:t>
+            <a:pPr algn="ctr"/>
+            <a:r>
+              <a:rPr sz="1700" b="1">
+                <a:solidFill>
+                  <a:srgbClr val="CD2D37"/>
+                </a:solidFill>
+                <a:latin typeface="Arial"/>
+              </a:rPr>
+              <a:t>SECCIÓN 4</a:t>
+            </a:r>
+          </a:p>
+          <a:p>
+            <a:pPr algn="ctr"/>
+            <a:r>
+              <a:t>Semántica: embeddings y especialización</a:t>
+            </a:r>
+          </a:p>
+          <a:p>
+            <a:pPr algn="ctr"/>
+            <a:r>
+              <a:rPr sz="1600">
+                <a:solidFill>
+                  <a:srgbClr val="D6DAE2"/>
+                </a:solidFill>
+                <a:latin typeface="Arial"/>
+              </a:rPr>
+              <a:t>Notebook 03 — el contenido confirma lo que dice la red</a:t>
             </a:r>
           </a:p>
         </p:txBody>
@@ -6671,7 +6678,7 @@
           <a:lstStyle/>
           <a:p>
             <a:r>
-              <a:t>NER + perfilado — LLM local infiriendo roles</a:t>
+              <a:t>Embeddings — un vector por usuario</a:t>
             </a:r>
           </a:p>
         </p:txBody>
@@ -6688,8 +6695,8 @@
         </p:nvSpPr>
         <p:spPr>
           <a:xfrm>
-            <a:off x="1073427" y="2077576"/>
-            <a:ext cx="10084904" cy="3507298"/>
+            <a:off x="1073427" y="2214736"/>
+            <a:ext cx="10084904" cy="3370138"/>
           </a:xfrm>
         </p:spPr>
         <p:txBody>
@@ -6697,27 +6704,22 @@
           <a:lstStyle/>
           <a:p>
             <a:r>
-              <a:t>qwen2.5:14b extrae entidades de dominio: TOOL, PRODUCT, PAYMENT, MARKET, CARD_TYPE, COUNTRY</a:t>
-            </a:r>
-          </a:p>
-          <a:p>
-            <a:r>
-              <a:t>Perfilado limitado a los 100 usuarios más activos (según el contador de posts del propio foro)</a:t>
-            </a:r>
-          </a:p>
-          <a:p>
-            <a:r>
-              <a:t>El LLM recibe centralidad, cluster semántico, entidades extraídas y muestra de posts — infiere un rol</a:t>
-            </a:r>
-          </a:p>
-          <a:p>
-            <a:r>
-              <a:t>Categorías de rol: vendedor_dumps, vendedor_cvv, comprador, checker, intermediario_escrow, lurker...</a:t>
-            </a:r>
-          </a:p>
-          <a:p>
-            <a:r>
-              <a:t>30 perfiles generados con confianza asociada — no es verdad de campo, es inferencia razonada</a:t>
+              <a:t>qwen3-embedding (4096D) vía Ollama, completamente local</a:t>
+            </a:r>
+          </a:p>
+          <a:p>
+            <a:r>
+              <a:t>9,550 usuarios con ≥10 posts obtienen embedding — el resto no tiene suficiente texto para ser confiable</a:t>
+            </a:r>
+          </a:p>
+          <a:p>
+            <a:r>
+              <a:t>Concatenación de posts por usuario, capada a 50K caracteres para no colgar Ollama con usuarios extremos</a:t>
+            </a:r>
+          </a:p>
+          <a:p>
+            <a:r>
+              <a:t>UMAP + HDBSCAN sobre esos vectores, BERTopic sobre el mismo corpus para nombrar cada cluster</a:t>
             </a:r>
           </a:p>
         </p:txBody>
@@ -6756,7 +6758,7 @@
           <a:lstStyle/>
           <a:p>
             <a:r>
-              <a:t>Distribución de roles inferidos (30 perfiles)</a:t>
+              <a:t>Perfilado de roles con LLM — por qué no lo repetimos aquí</a:t>
             </a:r>
           </a:p>
         </p:txBody>
@@ -6770,548 +6772,38 @@
           <p:nvPr>
             <p:ph type="body" idx="16" sz="quarter"/>
           </p:nvPr>
-        </p:nvSpPr>
-        <p:spPr/>
-        <p:txBody>
-          <a:bodyPr/>
-          <a:lstStyle/>
-          <a:p/>
-        </p:txBody>
-      </p:sp>
-      <p:graphicFrame>
-        <p:nvGraphicFramePr>
-          <p:cNvPr id="4" name="Table 3"/>
-          <p:cNvGraphicFramePr>
-            <a:graphicFrameLocks noGrp="1"/>
-          </p:cNvGraphicFramePr>
-          <p:nvPr/>
-        </p:nvGraphicFramePr>
-        <p:xfrm>
-          <a:off x="1051560" y="2148840"/>
-          <a:ext cx="10058400" cy="2560320"/>
-        </p:xfrm>
-        <a:graphic>
-          <a:graphicData uri="http://schemas.openxmlformats.org/drawingml/2006/table">
-            <a:tbl>
-              <a:tblPr>
-                <a:tableStyleId>{5C22544A-7EE6-4342-B048-85BDC9FD1C3A}</a:tableStyleId>
-              </a:tblPr>
-              <a:tblGrid>
-                <a:gridCol w="3352800"/>
-                <a:gridCol w="3352800"/>
-                <a:gridCol w="3352800"/>
-              </a:tblGrid>
-              <a:tr h="365760">
-                <a:tc>
-                  <a:txBody>
-                    <a:bodyPr/>
-                    <a:lstStyle/>
-                    <a:p>
-                      <a:r>
-                        <a:rPr sz="1200" b="1">
-                          <a:solidFill>
-                            <a:srgbClr val="FFFFFF"/>
-                          </a:solidFill>
-                          <a:latin typeface="Arial"/>
-                        </a:rPr>
-                        <a:t>Rol</a:t>
-                      </a:r>
-                    </a:p>
-                  </a:txBody>
-                  <a:tcPr marL="45000" marR="45000" marT="25000" marB="25000" anchor="ctr">
-                    <a:solidFill>
-                      <a:srgbClr val="CD2D37"/>
-                    </a:solidFill>
-                  </a:tcPr>
-                </a:tc>
-                <a:tc>
-                  <a:txBody>
-                    <a:bodyPr/>
-                    <a:lstStyle/>
-                    <a:p>
-                      <a:r>
-                        <a:rPr sz="1200" b="1">
-                          <a:solidFill>
-                            <a:srgbClr val="FFFFFF"/>
-                          </a:solidFill>
-                          <a:latin typeface="Arial"/>
-                        </a:rPr>
-                        <a:t>Usuarios</a:t>
-                      </a:r>
-                    </a:p>
-                  </a:txBody>
-                  <a:tcPr marL="45000" marR="45000" marT="25000" marB="25000" anchor="ctr">
-                    <a:solidFill>
-                      <a:srgbClr val="CD2D37"/>
-                    </a:solidFill>
-                  </a:tcPr>
-                </a:tc>
-                <a:tc>
-                  <a:txBody>
-                    <a:bodyPr/>
-                    <a:lstStyle/>
-                    <a:p>
-                      <a:r>
-                        <a:rPr sz="1200" b="1">
-                          <a:solidFill>
-                            <a:srgbClr val="FFFFFF"/>
-                          </a:solidFill>
-                          <a:latin typeface="Arial"/>
-                        </a:rPr>
-                        <a:t>Confianza típica</a:t>
-                      </a:r>
-                    </a:p>
-                  </a:txBody>
-                  <a:tcPr marL="45000" marR="45000" marT="25000" marB="25000" anchor="ctr">
-                    <a:solidFill>
-                      <a:srgbClr val="CD2D37"/>
-                    </a:solidFill>
-                  </a:tcPr>
-                </a:tc>
-              </a:tr>
-              <a:tr h="365760">
-                <a:tc>
-                  <a:txBody>
-                    <a:bodyPr/>
-                    <a:lstStyle/>
-                    <a:p>
-                      <a:r>
-                        <a:rPr sz="1100" b="0">
-                          <a:solidFill>
-                            <a:srgbClr val="465461"/>
-                          </a:solidFill>
-                          <a:latin typeface="Arial"/>
-                        </a:rPr>
-                        <a:t>lurker</a:t>
-                      </a:r>
-                    </a:p>
-                  </a:txBody>
-                  <a:tcPr marL="45000" marR="45000" marT="25000" marB="25000" anchor="ctr">
-                    <a:solidFill>
-                      <a:srgbClr val="F1F2F6"/>
-                    </a:solidFill>
-                  </a:tcPr>
-                </a:tc>
-                <a:tc>
-                  <a:txBody>
-                    <a:bodyPr/>
-                    <a:lstStyle/>
-                    <a:p>
-                      <a:r>
-                        <a:rPr sz="1100" b="0">
-                          <a:solidFill>
-                            <a:srgbClr val="465461"/>
-                          </a:solidFill>
-                          <a:latin typeface="Arial"/>
-                        </a:rPr>
-                        <a:t>20</a:t>
-                      </a:r>
-                    </a:p>
-                  </a:txBody>
-                  <a:tcPr marL="45000" marR="45000" marT="25000" marB="25000" anchor="ctr">
-                    <a:solidFill>
-                      <a:srgbClr val="F1F2F6"/>
-                    </a:solidFill>
-                  </a:tcPr>
-                </a:tc>
-                <a:tc>
-                  <a:txBody>
-                    <a:bodyPr/>
-                    <a:lstStyle/>
-                    <a:p>
-                      <a:r>
-                        <a:rPr sz="1100" b="0">
-                          <a:solidFill>
-                            <a:srgbClr val="465461"/>
-                          </a:solidFill>
-                          <a:latin typeface="Arial"/>
-                        </a:rPr>
-                        <a:t>0.85–0.95</a:t>
-                      </a:r>
-                    </a:p>
-                  </a:txBody>
-                  <a:tcPr marL="45000" marR="45000" marT="25000" marB="25000" anchor="ctr">
-                    <a:solidFill>
-                      <a:srgbClr val="F1F2F6"/>
-                    </a:solidFill>
-                  </a:tcPr>
-                </a:tc>
-              </a:tr>
-              <a:tr h="365760">
-                <a:tc>
-                  <a:txBody>
-                    <a:bodyPr/>
-                    <a:lstStyle/>
-                    <a:p>
-                      <a:r>
-                        <a:rPr sz="1100" b="0">
-                          <a:solidFill>
-                            <a:srgbClr val="465461"/>
-                          </a:solidFill>
-                          <a:latin typeface="Arial"/>
-                        </a:rPr>
-                        <a:t>comprador</a:t>
-                      </a:r>
-                    </a:p>
-                  </a:txBody>
-                  <a:tcPr marL="45000" marR="45000" marT="25000" marB="25000" anchor="ctr">
-                    <a:solidFill>
-                      <a:srgbClr val="FFFFFF"/>
-                    </a:solidFill>
-                  </a:tcPr>
-                </a:tc>
-                <a:tc>
-                  <a:txBody>
-                    <a:bodyPr/>
-                    <a:lstStyle/>
-                    <a:p>
-                      <a:r>
-                        <a:rPr sz="1100" b="0">
-                          <a:solidFill>
-                            <a:srgbClr val="465461"/>
-                          </a:solidFill>
-                          <a:latin typeface="Arial"/>
-                        </a:rPr>
-                        <a:t>3</a:t>
-                      </a:r>
-                    </a:p>
-                  </a:txBody>
-                  <a:tcPr marL="45000" marR="45000" marT="25000" marB="25000" anchor="ctr">
-                    <a:solidFill>
-                      <a:srgbClr val="FFFFFF"/>
-                    </a:solidFill>
-                  </a:tcPr>
-                </a:tc>
-                <a:tc>
-                  <a:txBody>
-                    <a:bodyPr/>
-                    <a:lstStyle/>
-                    <a:p>
-                      <a:r>
-                        <a:rPr sz="1100" b="0">
-                          <a:solidFill>
-                            <a:srgbClr val="465461"/>
-                          </a:solidFill>
-                          <a:latin typeface="Arial"/>
-                        </a:rPr>
-                        <a:t>0.70–0.85</a:t>
-                      </a:r>
-                    </a:p>
-                  </a:txBody>
-                  <a:tcPr marL="45000" marR="45000" marT="25000" marB="25000" anchor="ctr">
-                    <a:solidFill>
-                      <a:srgbClr val="FFFFFF"/>
-                    </a:solidFill>
-                  </a:tcPr>
-                </a:tc>
-              </a:tr>
-              <a:tr h="365760">
-                <a:tc>
-                  <a:txBody>
-                    <a:bodyPr/>
-                    <a:lstStyle/>
-                    <a:p>
-                      <a:r>
-                        <a:rPr sz="1100" b="0">
-                          <a:solidFill>
-                            <a:srgbClr val="465461"/>
-                          </a:solidFill>
-                          <a:latin typeface="Arial"/>
-                        </a:rPr>
-                        <a:t>intermediario_escrow</a:t>
-                      </a:r>
-                    </a:p>
-                  </a:txBody>
-                  <a:tcPr marL="45000" marR="45000" marT="25000" marB="25000" anchor="ctr">
-                    <a:solidFill>
-                      <a:srgbClr val="F1F2F6"/>
-                    </a:solidFill>
-                  </a:tcPr>
-                </a:tc>
-                <a:tc>
-                  <a:txBody>
-                    <a:bodyPr/>
-                    <a:lstStyle/>
-                    <a:p>
-                      <a:r>
-                        <a:rPr sz="1100" b="0">
-                          <a:solidFill>
-                            <a:srgbClr val="465461"/>
-                          </a:solidFill>
-                          <a:latin typeface="Arial"/>
-                        </a:rPr>
-                        <a:t>3</a:t>
-                      </a:r>
-                    </a:p>
-                  </a:txBody>
-                  <a:tcPr marL="45000" marR="45000" marT="25000" marB="25000" anchor="ctr">
-                    <a:solidFill>
-                      <a:srgbClr val="F1F2F6"/>
-                    </a:solidFill>
-                  </a:tcPr>
-                </a:tc>
-                <a:tc>
-                  <a:txBody>
-                    <a:bodyPr/>
-                    <a:lstStyle/>
-                    <a:p>
-                      <a:r>
-                        <a:rPr sz="1100" b="0">
-                          <a:solidFill>
-                            <a:srgbClr val="465461"/>
-                          </a:solidFill>
-                          <a:latin typeface="Arial"/>
-                        </a:rPr>
-                        <a:t>0.70–0.85</a:t>
-                      </a:r>
-                    </a:p>
-                  </a:txBody>
-                  <a:tcPr marL="45000" marR="45000" marT="25000" marB="25000" anchor="ctr">
-                    <a:solidFill>
-                      <a:srgbClr val="F1F2F6"/>
-                    </a:solidFill>
-                  </a:tcPr>
-                </a:tc>
-              </a:tr>
-              <a:tr h="365760">
-                <a:tc>
-                  <a:txBody>
-                    <a:bodyPr/>
-                    <a:lstStyle/>
-                    <a:p>
-                      <a:r>
-                        <a:rPr sz="1100" b="0">
-                          <a:solidFill>
-                            <a:srgbClr val="465461"/>
-                          </a:solidFill>
-                          <a:latin typeface="Arial"/>
-                        </a:rPr>
-                        <a:t>indeterminado</a:t>
-                      </a:r>
-                    </a:p>
-                  </a:txBody>
-                  <a:tcPr marL="45000" marR="45000" marT="25000" marB="25000" anchor="ctr">
-                    <a:solidFill>
-                      <a:srgbClr val="FFFFFF"/>
-                    </a:solidFill>
-                  </a:tcPr>
-                </a:tc>
-                <a:tc>
-                  <a:txBody>
-                    <a:bodyPr/>
-                    <a:lstStyle/>
-                    <a:p>
-                      <a:r>
-                        <a:rPr sz="1100" b="0">
-                          <a:solidFill>
-                            <a:srgbClr val="465461"/>
-                          </a:solidFill>
-                          <a:latin typeface="Arial"/>
-                        </a:rPr>
-                        <a:t>2</a:t>
-                      </a:r>
-                    </a:p>
-                  </a:txBody>
-                  <a:tcPr marL="45000" marR="45000" marT="25000" marB="25000" anchor="ctr">
-                    <a:solidFill>
-                      <a:srgbClr val="FFFFFF"/>
-                    </a:solidFill>
-                  </a:tcPr>
-                </a:tc>
-                <a:tc>
-                  <a:txBody>
-                    <a:bodyPr/>
-                    <a:lstStyle/>
-                    <a:p>
-                      <a:r>
-                        <a:rPr sz="1100" b="0">
-                          <a:solidFill>
-                            <a:srgbClr val="465461"/>
-                          </a:solidFill>
-                          <a:latin typeface="Arial"/>
-                        </a:rPr>
-                        <a:t>0.50–0.65</a:t>
-                      </a:r>
-                    </a:p>
-                  </a:txBody>
-                  <a:tcPr marL="45000" marR="45000" marT="25000" marB="25000" anchor="ctr">
-                    <a:solidFill>
-                      <a:srgbClr val="FFFFFF"/>
-                    </a:solidFill>
-                  </a:tcPr>
-                </a:tc>
-              </a:tr>
-              <a:tr h="365760">
-                <a:tc>
-                  <a:txBody>
-                    <a:bodyPr/>
-                    <a:lstStyle/>
-                    <a:p>
-                      <a:r>
-                        <a:rPr sz="1100" b="0">
-                          <a:solidFill>
-                            <a:srgbClr val="465461"/>
-                          </a:solidFill>
-                          <a:latin typeface="Arial"/>
-                        </a:rPr>
-                        <a:t>vendedor_dumps</a:t>
-                      </a:r>
-                    </a:p>
-                  </a:txBody>
-                  <a:tcPr marL="45000" marR="45000" marT="25000" marB="25000" anchor="ctr">
-                    <a:solidFill>
-                      <a:srgbClr val="F1F2F6"/>
-                    </a:solidFill>
-                  </a:tcPr>
-                </a:tc>
-                <a:tc>
-                  <a:txBody>
-                    <a:bodyPr/>
-                    <a:lstStyle/>
-                    <a:p>
-                      <a:r>
-                        <a:rPr sz="1100" b="0">
-                          <a:solidFill>
-                            <a:srgbClr val="465461"/>
-                          </a:solidFill>
-                          <a:latin typeface="Arial"/>
-                        </a:rPr>
-                        <a:t>1</a:t>
-                      </a:r>
-                    </a:p>
-                  </a:txBody>
-                  <a:tcPr marL="45000" marR="45000" marT="25000" marB="25000" anchor="ctr">
-                    <a:solidFill>
-                      <a:srgbClr val="F1F2F6"/>
-                    </a:solidFill>
-                  </a:tcPr>
-                </a:tc>
-                <a:tc>
-                  <a:txBody>
-                    <a:bodyPr/>
-                    <a:lstStyle/>
-                    <a:p>
-                      <a:r>
-                        <a:rPr sz="1100" b="0">
-                          <a:solidFill>
-                            <a:srgbClr val="465461"/>
-                          </a:solidFill>
-                          <a:latin typeface="Arial"/>
-                        </a:rPr>
-                        <a:t>0.80</a:t>
-                      </a:r>
-                    </a:p>
-                  </a:txBody>
-                  <a:tcPr marL="45000" marR="45000" marT="25000" marB="25000" anchor="ctr">
-                    <a:solidFill>
-                      <a:srgbClr val="F1F2F6"/>
-                    </a:solidFill>
-                  </a:tcPr>
-                </a:tc>
-              </a:tr>
-              <a:tr h="365760">
-                <a:tc>
-                  <a:txBody>
-                    <a:bodyPr/>
-                    <a:lstStyle/>
-                    <a:p>
-                      <a:r>
-                        <a:rPr sz="1100" b="0">
-                          <a:solidFill>
-                            <a:srgbClr val="465461"/>
-                          </a:solidFill>
-                          <a:latin typeface="Arial"/>
-                        </a:rPr>
-                        <a:t>checker</a:t>
-                      </a:r>
-                    </a:p>
-                  </a:txBody>
-                  <a:tcPr marL="45000" marR="45000" marT="25000" marB="25000" anchor="ctr">
-                    <a:solidFill>
-                      <a:srgbClr val="FFFFFF"/>
-                    </a:solidFill>
-                  </a:tcPr>
-                </a:tc>
-                <a:tc>
-                  <a:txBody>
-                    <a:bodyPr/>
-                    <a:lstStyle/>
-                    <a:p>
-                      <a:r>
-                        <a:rPr sz="1100" b="0">
-                          <a:solidFill>
-                            <a:srgbClr val="465461"/>
-                          </a:solidFill>
-                          <a:latin typeface="Arial"/>
-                        </a:rPr>
-                        <a:t>1</a:t>
-                      </a:r>
-                    </a:p>
-                  </a:txBody>
-                  <a:tcPr marL="45000" marR="45000" marT="25000" marB="25000" anchor="ctr">
-                    <a:solidFill>
-                      <a:srgbClr val="FFFFFF"/>
-                    </a:solidFill>
-                  </a:tcPr>
-                </a:tc>
-                <a:tc>
-                  <a:txBody>
-                    <a:bodyPr/>
-                    <a:lstStyle/>
-                    <a:p>
-                      <a:r>
-                        <a:rPr sz="1100" b="0">
-                          <a:solidFill>
-                            <a:srgbClr val="465461"/>
-                          </a:solidFill>
-                          <a:latin typeface="Arial"/>
-                        </a:rPr>
-                        <a:t>0.75</a:t>
-                      </a:r>
-                    </a:p>
-                  </a:txBody>
-                  <a:tcPr marL="45000" marR="45000" marT="25000" marB="25000" anchor="ctr">
-                    <a:solidFill>
-                      <a:srgbClr val="FFFFFF"/>
-                    </a:solidFill>
-                  </a:tcPr>
-                </a:tc>
-              </a:tr>
-            </a:tbl>
-          </a:graphicData>
-        </a:graphic>
-      </p:graphicFrame>
-      <p:sp>
-        <p:nvSpPr>
-          <p:cNvPr id="5" name="TextBox 4"/>
-          <p:cNvSpPr txBox="1"/>
-          <p:nvPr/>
         </p:nvSpPr>
         <p:spPr>
           <a:xfrm>
-            <a:off x="1051560" y="5760720"/>
-            <a:ext cx="10058400" cy="320040"/>
+            <a:off x="1073427" y="2717656"/>
+            <a:ext cx="10084904" cy="2867218"/>
           </a:xfrm>
-          <a:prstGeom prst="rect">
-            <a:avLst/>
-          </a:prstGeom>
-          <a:noFill/>
         </p:spPr>
         <p:txBody>
-          <a:bodyPr wrap="square">
-            <a:spAutoFit/>
-          </a:bodyPr>
+          <a:bodyPr wrap="square"/>
           <a:lstStyle/>
           <a:p>
-            <a:pPr algn="l"/>
-            <a:r>
-              <a:rPr sz="1000" b="0">
+            <a:r>
+              <a:t>El notebook sí explora NER + perfilado de rol individual (vendedor_dumps, checker, escrow...) con qwen2.5:14b, en modo de contraste</a:t>
+            </a:r>
+          </a:p>
+          <a:p>
+            <a:r>
+              <a:t>Esa técnica se trabaja en profundidad en el caso Ransomware — aquí solo la dejamos como referencia, no como hilo conductor</a:t>
+            </a:r>
+          </a:p>
+          <a:p>
+            <a:pPr lvl="1" marL="274320" indent="-228600">
+              <a:buNone/>
+            </a:pPr>
+            <a:r>
+              <a:rPr sz="1500" b="0">
                 <a:solidFill>
                   <a:srgbClr val="707888"/>
                 </a:solidFill>
                 <a:latin typeface="Arial"/>
               </a:rPr>
-              <a:t>ℹ  La mayoría de los top-100 por contador de posts terminan clasificados como lurker — ver limitación en la siguiente slide.</a:t>
+              <a:t>·  Matiz que sí conservamos: el campo posts de vBulletin es un contador propio del foro, no verificado — varios 'top activos' aparecen con 0 posts reales en el corpus</a:t>
             </a:r>
           </a:p>
         </p:txBody>
@@ -7341,7 +6833,7 @@
             <a:spLocks noGrp="1"/>
           </p:cNvSpPr>
           <p:nvPr>
-            <p:ph type="body" idx="13" sz="quarter"/>
+            <p:ph type="body" idx="10" sz="quarter"/>
           </p:nvPr>
         </p:nvSpPr>
         <p:spPr/>
@@ -7349,54 +6841,33 @@
           <a:bodyPr wrap="square"/>
           <a:lstStyle/>
           <a:p>
-            <a:r>
-              <a:t>Una limitación honesta — el contador de posts miente</a:t>
-            </a:r>
-          </a:p>
-        </p:txBody>
-      </p:sp>
-      <p:sp>
-        <p:nvSpPr>
-          <p:cNvPr id="3" name="Text Placeholder 2"/>
-          <p:cNvSpPr>
-            <a:spLocks noGrp="1"/>
-          </p:cNvSpPr>
-          <p:nvPr>
-            <p:ph type="body" idx="16" sz="quarter"/>
-          </p:nvPr>
-        </p:nvSpPr>
-        <p:spPr>
-          <a:xfrm>
-            <a:off x="1073427" y="2580496"/>
-            <a:ext cx="10084904" cy="3004378"/>
-          </a:xfrm>
-        </p:spPr>
-        <p:txBody>
-          <a:bodyPr wrap="square"/>
-          <a:lstStyle/>
-          <a:p>
-            <a:r>
-              <a:t>El perfilado selecciona a los usuarios por el campo posts de la tabla user del propio vBulletin</a:t>
-            </a:r>
-          </a:p>
-          <a:p>
-            <a:r>
-              <a:t>Ese contador es un valor almacenado por el foro, no un recuento verificado contra la tabla post real</a:t>
-            </a:r>
-          </a:p>
-          <a:p>
-            <a:r>
-              <a:t>Resultado: varios de los 'top 100 más activos' aparecen en el corpus con 0 posts extraídos</a:t>
-            </a:r>
-          </a:p>
-          <a:p>
-            <a:r>
-              <a:t>El LLM los clasifica como lurker con alta confianza — pero es lurker por falta de datos, no por comportamiento real</a:t>
-            </a:r>
-          </a:p>
-          <a:p>
-            <a:r>
-              <a:t>Lección: un contador de actividad propio del sistema origen puede estar desactualizado o ser directamente falso</a:t>
+            <a:pPr algn="ctr"/>
+            <a:r>
+              <a:rPr sz="1700" b="1">
+                <a:solidFill>
+                  <a:srgbClr val="CD2D37"/>
+                </a:solidFill>
+                <a:latin typeface="Arial"/>
+              </a:rPr>
+              <a:t>SECCIÓN 5</a:t>
+            </a:r>
+          </a:p>
+          <a:p>
+            <a:pPr algn="ctr"/>
+            <a:r>
+              <a:t>Conclusiones y aprendizajes</a:t>
+            </a:r>
+          </a:p>
+          <a:p>
+            <a:pPr algn="ctr"/>
+            <a:r>
+              <a:rPr sz="1600">
+                <a:solidFill>
+                  <a:srgbClr val="D6DAE2"/>
+                </a:solidFill>
+                <a:latin typeface="Arial"/>
+              </a:rPr>
+              <a:t>Qué nos enseña el caso Carding Forums</a:t>
             </a:r>
           </a:p>
         </p:txBody>
@@ -7426,7 +6897,7 @@
             <a:spLocks noGrp="1"/>
           </p:cNvSpPr>
           <p:nvPr>
-            <p:ph type="body" idx="10" sz="quarter"/>
+            <p:ph type="body" idx="13" sz="quarter"/>
           </p:nvPr>
         </p:nvSpPr>
         <p:spPr/>
@@ -7434,33 +6905,336 @@
           <a:bodyPr wrap="square"/>
           <a:lstStyle/>
           <a:p>
-            <a:pPr algn="ctr"/>
-            <a:r>
-              <a:rPr sz="1300" b="1">
+            <a:r>
+              <a:t>Resumen ejecutivo</a:t>
+            </a:r>
+          </a:p>
+        </p:txBody>
+      </p:sp>
+      <p:sp>
+        <p:nvSpPr>
+          <p:cNvPr id="3" name="Text Placeholder 2"/>
+          <p:cNvSpPr>
+            <a:spLocks noGrp="1"/>
+          </p:cNvSpPr>
+          <p:nvPr>
+            <p:ph type="body" idx="16" sz="quarter"/>
+          </p:nvPr>
+        </p:nvSpPr>
+        <p:spPr/>
+        <p:txBody>
+          <a:bodyPr/>
+          <a:lstStyle/>
+          <a:p/>
+        </p:txBody>
+      </p:sp>
+      <p:sp>
+        <p:nvSpPr>
+          <p:cNvPr id="4" name="TextBox 3"/>
+          <p:cNvSpPr txBox="1"/>
+          <p:nvPr/>
+        </p:nvSpPr>
+        <p:spPr>
+          <a:xfrm>
+            <a:off x="1051560" y="1828800"/>
+            <a:ext cx="4846320" cy="411480"/>
+          </a:xfrm>
+          <a:prstGeom prst="rect">
+            <a:avLst/>
+          </a:prstGeom>
+          <a:noFill/>
+        </p:spPr>
+        <p:txBody>
+          <a:bodyPr wrap="square">
+            <a:spAutoFit/>
+          </a:bodyPr>
+          <a:lstStyle/>
+          <a:p>
+            <a:pPr algn="l"/>
+            <a:r>
+              <a:rPr sz="1600" b="1">
                 <a:solidFill>
                   <a:srgbClr val="CD2D37"/>
                 </a:solidFill>
                 <a:latin typeface="Arial"/>
               </a:rPr>
-              <a:t>SECCIÓN 5</a:t>
-            </a:r>
-          </a:p>
-          <a:p>
-            <a:pPr algn="ctr"/>
-            <a:r>
-              <a:t>Conclusiones y aprendizajes</a:t>
-            </a:r>
-          </a:p>
-          <a:p>
-            <a:pPr algn="ctr"/>
+              <a:t>Hallazgos técnicos</a:t>
+            </a:r>
+          </a:p>
+        </p:txBody>
+      </p:sp>
+      <p:sp>
+        <p:nvSpPr>
+          <p:cNvPr id="5" name="TextBox 4"/>
+          <p:cNvSpPr txBox="1"/>
+          <p:nvPr/>
+        </p:nvSpPr>
+        <p:spPr>
+          <a:xfrm>
+            <a:off x="1051560" y="2286000"/>
+            <a:ext cx="4846320" cy="3703320"/>
+          </a:xfrm>
+          <a:prstGeom prst="rect">
+            <a:avLst/>
+          </a:prstGeom>
+          <a:noFill/>
+        </p:spPr>
+        <p:txBody>
+          <a:bodyPr wrap="square">
+            <a:spAutoFit/>
+          </a:bodyPr>
+          <a:lstStyle/>
+          <a:p>
             <a:r>
               <a:rPr sz="1600">
                 <a:solidFill>
-                  <a:srgbClr val="D6DAE2"/>
+                  <a:srgbClr val="CD2D37"/>
                 </a:solidFill>
                 <a:latin typeface="Arial"/>
               </a:rPr>
-              <a:t>Qué nos enseña el caso Carding Forums</a:t>
+              <a:t>▸  </a:t>
+            </a:r>
+            <a:r>
+              <a:rPr sz="1600">
+                <a:solidFill>
+                  <a:srgbClr val="465461"/>
+                </a:solidFill>
+                <a:latin typeface="Arial"/>
+              </a:rPr>
+              <a:t>Un dump duplicado bajo dos nombres distintos — verificar contenido, no solo el nombre del archivo</a:t>
+            </a:r>
+          </a:p>
+          <a:p>
+            <a:r>
+              <a:rPr sz="1600">
+                <a:solidFill>
+                  <a:srgbClr val="CD2D37"/>
+                </a:solidFill>
+                <a:latin typeface="Arial"/>
+              </a:rPr>
+              <a:t>▸  </a:t>
+            </a:r>
+            <a:r>
+              <a:rPr sz="1600">
+                <a:solidFill>
+                  <a:srgbClr val="465461"/>
+                </a:solidFill>
+                <a:latin typeface="Arial"/>
+              </a:rPr>
+              <a:t>Un formato flat file escondido entre dumps SQL — el auto-detect de parser es imprescindible</a:t>
+            </a:r>
+          </a:p>
+          <a:p>
+            <a:r>
+              <a:rPr sz="1600">
+                <a:solidFill>
+                  <a:srgbClr val="CD2D37"/>
+                </a:solidFill>
+                <a:latin typeface="Arial"/>
+              </a:rPr>
+              <a:t>▸  </a:t>
+            </a:r>
+            <a:r>
+              <a:rPr sz="1600">
+                <a:solidFill>
+                  <a:srgbClr val="465461"/>
+                </a:solidFill>
+                <a:latin typeface="Arial"/>
+              </a:rPr>
+              <a:t>11,113 usuarios en la componente gigante de la red, 21 comunidades vía Louvain</a:t>
+            </a:r>
+          </a:p>
+          <a:p>
+            <a:r>
+              <a:rPr sz="1600">
+                <a:solidFill>
+                  <a:srgbClr val="CD2D37"/>
+                </a:solidFill>
+                <a:latin typeface="Arial"/>
+              </a:rPr>
+              <a:t>▸  </a:t>
+            </a:r>
+            <a:r>
+              <a:rPr sz="1600">
+                <a:solidFill>
+                  <a:srgbClr val="465461"/>
+                </a:solidFill>
+                <a:latin typeface="Arial"/>
+              </a:rPr>
+              <a:t>El cruce comunidad × topic confirma especialización real del mercado, no artefacto del grafo</a:t>
+            </a:r>
+          </a:p>
+        </p:txBody>
+      </p:sp>
+      <p:sp>
+        <p:nvSpPr>
+          <p:cNvPr id="6" name="TextBox 5"/>
+          <p:cNvSpPr txBox="1"/>
+          <p:nvPr/>
+        </p:nvSpPr>
+        <p:spPr>
+          <a:xfrm>
+            <a:off x="6217920" y="1828800"/>
+            <a:ext cx="4846320" cy="411480"/>
+          </a:xfrm>
+          <a:prstGeom prst="rect">
+            <a:avLst/>
+          </a:prstGeom>
+          <a:noFill/>
+        </p:spPr>
+        <p:txBody>
+          <a:bodyPr wrap="square">
+            <a:spAutoFit/>
+          </a:bodyPr>
+          <a:lstStyle/>
+          <a:p>
+            <a:pPr algn="l"/>
+            <a:r>
+              <a:rPr sz="1600" b="1">
+                <a:solidFill>
+                  <a:srgbClr val="CD2D37"/>
+                </a:solidFill>
+                <a:latin typeface="Arial"/>
+              </a:rPr>
+              <a:t>Aprendizajes metodológicos</a:t>
+            </a:r>
+          </a:p>
+        </p:txBody>
+      </p:sp>
+      <p:sp>
+        <p:nvSpPr>
+          <p:cNvPr id="7" name="TextBox 6"/>
+          <p:cNvSpPr txBox="1"/>
+          <p:nvPr/>
+        </p:nvSpPr>
+        <p:spPr>
+          <a:xfrm>
+            <a:off x="6217920" y="2286000"/>
+            <a:ext cx="4846320" cy="3703320"/>
+          </a:xfrm>
+          <a:prstGeom prst="rect">
+            <a:avLst/>
+          </a:prstGeom>
+          <a:noFill/>
+        </p:spPr>
+        <p:txBody>
+          <a:bodyPr wrap="square">
+            <a:spAutoFit/>
+          </a:bodyPr>
+          <a:lstStyle/>
+          <a:p>
+            <a:r>
+              <a:rPr sz="1600">
+                <a:solidFill>
+                  <a:srgbClr val="CD2D37"/>
+                </a:solidFill>
+                <a:latin typeface="Arial"/>
+              </a:rPr>
+              <a:t>▸  </a:t>
+            </a:r>
+            <a:r>
+              <a:rPr sz="1600">
+                <a:solidFill>
+                  <a:srgbClr val="465461"/>
+                </a:solidFill>
+                <a:latin typeface="Arial"/>
+              </a:rPr>
+              <a:t>load_forum() con auto-detección de formato es la única forma segura de procesar un lote heterogéneo</a:t>
+            </a:r>
+          </a:p>
+          <a:p>
+            <a:r>
+              <a:rPr sz="1600">
+                <a:solidFill>
+                  <a:srgbClr val="CD2D37"/>
+                </a:solidFill>
+                <a:latin typeface="Arial"/>
+              </a:rPr>
+              <a:t>▸  </a:t>
+            </a:r>
+            <a:r>
+              <a:rPr sz="1600">
+                <a:solidFill>
+                  <a:srgbClr val="465461"/>
+                </a:solidFill>
+                <a:latin typeface="Arial"/>
+              </a:rPr>
+              <a:t>Louvain sobre k-means cuando la estructura es un grafo de conexiones, no un espacio de coordenadas</a:t>
+            </a:r>
+          </a:p>
+          <a:p>
+            <a:r>
+              <a:rPr sz="1600">
+                <a:solidFill>
+                  <a:srgbClr val="CD2D37"/>
+                </a:solidFill>
+                <a:latin typeface="Arial"/>
+              </a:rPr>
+              <a:t>▸  </a:t>
+            </a:r>
+            <a:r>
+              <a:rPr sz="1600">
+                <a:solidFill>
+                  <a:srgbClr val="465461"/>
+                </a:solidFill>
+                <a:latin typeface="Arial"/>
+              </a:rPr>
+              <a:t>Filtrar aristas triviales ANTES de detectar comunidades, no después</a:t>
+            </a:r>
+          </a:p>
+          <a:p>
+            <a:r>
+              <a:rPr sz="1600">
+                <a:solidFill>
+                  <a:srgbClr val="CD2D37"/>
+                </a:solidFill>
+                <a:latin typeface="Arial"/>
+              </a:rPr>
+              <a:t>▸  </a:t>
+            </a:r>
+            <a:r>
+              <a:rPr sz="1600">
+                <a:solidFill>
+                  <a:srgbClr val="465461"/>
+                </a:solidFill>
+                <a:latin typeface="Arial"/>
+              </a:rPr>
+              <a:t>Cruzar señales independientes (red + contenido) confirma un hallazgo en vez de asumirlo</a:t>
+            </a:r>
+          </a:p>
+        </p:txBody>
+      </p:sp>
+      <p:sp>
+        <p:nvSpPr>
+          <p:cNvPr id="8" name="TextBox 7"/>
+          <p:cNvSpPr txBox="1"/>
+          <p:nvPr/>
+        </p:nvSpPr>
+        <p:spPr>
+          <a:xfrm>
+            <a:off x="1051560" y="5760720"/>
+            <a:ext cx="10058400" cy="365760"/>
+          </a:xfrm>
+          <a:prstGeom prst="rect">
+            <a:avLst/>
+          </a:prstGeom>
+          <a:noFill/>
+        </p:spPr>
+        <p:txBody>
+          <a:bodyPr wrap="square">
+            <a:spAutoFit/>
+          </a:bodyPr>
+          <a:lstStyle/>
+          <a:p>
+            <a:pPr algn="l"/>
+            <a:r>
+              <a:rPr sz="1100" b="0">
+                <a:solidFill>
+                  <a:srgbClr val="707888"/>
+                </a:solidFill>
+                <a:latin typeface="Arial"/>
+              </a:rPr>
+              <a:t>ℹ  Todo el pipeline corre sin mandar un solo post a una API externa.</a:t>
             </a:r>
           </a:p>
         </p:txBody>
@@ -7500,7 +7274,7 @@
           <a:p>
             <a:pPr algn="ctr"/>
             <a:r>
-              <a:rPr sz="1300" b="1">
+              <a:rPr sz="1700" b="1">
                 <a:solidFill>
                   <a:srgbClr val="CD2D37"/>
                 </a:solidFill>
@@ -7563,7 +7337,7 @@
           <a:lstStyle/>
           <a:p>
             <a:r>
-              <a:t>Resumen ejecutivo</a:t>
+              <a:t>¿Por qué este caso importa?</a:t>
             </a:r>
           </a:p>
         </p:txBody>
@@ -7577,300 +7351,18 @@
           <p:nvPr>
             <p:ph type="body" idx="16" sz="quarter"/>
           </p:nvPr>
-        </p:nvSpPr>
-        <p:spPr/>
-        <p:txBody>
-          <a:bodyPr/>
-          <a:lstStyle/>
-          <a:p/>
-        </p:txBody>
-      </p:sp>
-      <p:sp>
-        <p:nvSpPr>
-          <p:cNvPr id="4" name="TextBox 3"/>
-          <p:cNvSpPr txBox="1"/>
-          <p:nvPr/>
         </p:nvSpPr>
         <p:spPr>
           <a:xfrm>
-            <a:off x="1051560" y="1691640"/>
-            <a:ext cx="4846320" cy="411480"/>
+            <a:off x="1073427" y="2214736"/>
+            <a:ext cx="10084904" cy="3370138"/>
           </a:xfrm>
-          <a:prstGeom prst="rect">
-            <a:avLst/>
-          </a:prstGeom>
-          <a:noFill/>
         </p:spPr>
-        <p:txBody>
-          <a:bodyPr wrap="square">
-            <a:spAutoFit/>
-          </a:bodyPr>
-          <a:lstStyle/>
-          <a:p>
-            <a:pPr algn="l"/>
-            <a:r>
-              <a:rPr sz="1600" b="1">
-                <a:solidFill>
-                  <a:srgbClr val="CD2D37"/>
-                </a:solidFill>
-                <a:latin typeface="Arial"/>
-              </a:rPr>
-              <a:t>Hallazgos técnicos</a:t>
-            </a:r>
-          </a:p>
-        </p:txBody>
-      </p:sp>
-      <p:sp>
-        <p:nvSpPr>
-          <p:cNvPr id="5" name="TextBox 4"/>
-          <p:cNvSpPr txBox="1"/>
-          <p:nvPr/>
-        </p:nvSpPr>
-        <p:spPr>
-          <a:xfrm>
-            <a:off x="1051560" y="2148840"/>
-            <a:ext cx="4846320" cy="3840480"/>
-          </a:xfrm>
-          <a:prstGeom prst="rect">
-            <a:avLst/>
-          </a:prstGeom>
-          <a:noFill/>
-        </p:spPr>
-        <p:txBody>
-          <a:bodyPr wrap="square">
-            <a:spAutoFit/>
-          </a:bodyPr>
-          <a:lstStyle/>
-          <a:p>
-            <a:r>
-              <a:rPr sz="1600">
-                <a:solidFill>
-                  <a:srgbClr val="465461"/>
-                </a:solidFill>
-                <a:latin typeface="Arial"/>
-              </a:rPr>
-              <a:t>▸  Un dump duplicado bajo dos nombres distintos — verificar contenido, no solo el nombre del archivo</a:t>
-            </a:r>
-          </a:p>
-          <a:p>
-            <a:r>
-              <a:rPr sz="1600">
-                <a:solidFill>
-                  <a:srgbClr val="465461"/>
-                </a:solidFill>
-                <a:latin typeface="Arial"/>
-              </a:rPr>
-              <a:t>▸  Un formato flat file escondido entre dumps SQL — el auto-detect de parser es imprescindible</a:t>
-            </a:r>
-          </a:p>
-          <a:p>
-            <a:r>
-              <a:rPr sz="1600">
-                <a:solidFill>
-                  <a:srgbClr val="465461"/>
-                </a:solidFill>
-                <a:latin typeface="Arial"/>
-              </a:rPr>
-              <a:t>▸  178K registros con timestamp inválido — el patrón epoch-0 aparece en todos los casos del curso</a:t>
-            </a:r>
-          </a:p>
-          <a:p>
-            <a:r>
-              <a:rPr sz="1600">
-                <a:solidFill>
-                  <a:srgbClr val="465461"/>
-                </a:solidFill>
-                <a:latin typeface="Arial"/>
-              </a:rPr>
-              <a:t>▸  11,113 usuarios en la componente gigante de la red, 21 comunidades vía Louvain</a:t>
-            </a:r>
-          </a:p>
-          <a:p>
-            <a:r>
-              <a:rPr sz="1600">
-                <a:solidFill>
-                  <a:srgbClr val="465461"/>
-                </a:solidFill>
-                <a:latin typeface="Arial"/>
-              </a:rPr>
-              <a:t>▸  9,550 usuarios embebidos con qwen3-embedding para clustering semántico</a:t>
-            </a:r>
-          </a:p>
-        </p:txBody>
-      </p:sp>
-      <p:sp>
-        <p:nvSpPr>
-          <p:cNvPr id="6" name="TextBox 5"/>
-          <p:cNvSpPr txBox="1"/>
-          <p:nvPr/>
-        </p:nvSpPr>
-        <p:spPr>
-          <a:xfrm>
-            <a:off x="6217920" y="1691640"/>
-            <a:ext cx="4846320" cy="411480"/>
-          </a:xfrm>
-          <a:prstGeom prst="rect">
-            <a:avLst/>
-          </a:prstGeom>
-          <a:noFill/>
-        </p:spPr>
-        <p:txBody>
-          <a:bodyPr wrap="square">
-            <a:spAutoFit/>
-          </a:bodyPr>
-          <a:lstStyle/>
-          <a:p>
-            <a:pPr algn="l"/>
-            <a:r>
-              <a:rPr sz="1600" b="1">
-                <a:solidFill>
-                  <a:srgbClr val="CD2D37"/>
-                </a:solidFill>
-                <a:latin typeface="Arial"/>
-              </a:rPr>
-              <a:t>Aprendizajes metodológicos</a:t>
-            </a:r>
-          </a:p>
-        </p:txBody>
-      </p:sp>
-      <p:sp>
-        <p:nvSpPr>
-          <p:cNvPr id="7" name="TextBox 6"/>
-          <p:cNvSpPr txBox="1"/>
-          <p:nvPr/>
-        </p:nvSpPr>
-        <p:spPr>
-          <a:xfrm>
-            <a:off x="6217920" y="2148840"/>
-            <a:ext cx="4846320" cy="3840480"/>
-          </a:xfrm>
-          <a:prstGeom prst="rect">
-            <a:avLst/>
-          </a:prstGeom>
-          <a:noFill/>
-        </p:spPr>
-        <p:txBody>
-          <a:bodyPr wrap="square">
-            <a:spAutoFit/>
-          </a:bodyPr>
-          <a:lstStyle/>
-          <a:p>
-            <a:r>
-              <a:rPr sz="1600">
-                <a:solidFill>
-                  <a:srgbClr val="465461"/>
-                </a:solidFill>
-                <a:latin typeface="Arial"/>
-              </a:rPr>
-              <a:t>▸  load_forum() con auto-detección de formato es la única forma segura de procesar un lote heterogéneo</a:t>
-            </a:r>
-          </a:p>
-          <a:p>
-            <a:r>
-              <a:rPr sz="1600">
-                <a:solidFill>
-                  <a:srgbClr val="465461"/>
-                </a:solidFill>
-                <a:latin typeface="Arial"/>
-              </a:rPr>
-              <a:t>▸  Validar rango de fechas y deduplicar antes de cualquier análisis temporal o de red</a:t>
-            </a:r>
-          </a:p>
-          <a:p>
-            <a:r>
-              <a:rPr sz="1600">
-                <a:solidFill>
-                  <a:srgbClr val="465461"/>
-                </a:solidFill>
-                <a:latin typeface="Arial"/>
-              </a:rPr>
-              <a:t>▸  Un contador de actividad del sistema origen no sustituye contar directamente sobre los datos limpios</a:t>
-            </a:r>
-          </a:p>
-          <a:p>
-            <a:r>
-              <a:rPr sz="1600">
-                <a:solidFill>
-                  <a:srgbClr val="465461"/>
-                </a:solidFill>
-                <a:latin typeface="Arial"/>
-              </a:rPr>
-              <a:t>▸  El LLM local puede perfilar roles, pero la confianza reportada depende de la calidad del input</a:t>
-            </a:r>
-          </a:p>
-          <a:p>
-            <a:r>
-              <a:rPr sz="1600">
-                <a:solidFill>
-                  <a:srgbClr val="465461"/>
-                </a:solidFill>
-                <a:latin typeface="Arial"/>
-              </a:rPr>
-              <a:t>▸  Todo el pipeline corre sin mandar un solo post a una API externa</a:t>
-            </a:r>
-          </a:p>
-        </p:txBody>
-      </p:sp>
-    </p:spTree>
-  </p:cSld>
-  <p:clrMapOvr>
-    <a:masterClrMapping/>
-  </p:clrMapOvr>
-</p:sld>
-</file>
-
-<file path=ppt/slides/slide21.xml><?xml version="1.0" encoding="utf-8"?>
-<p:sld xmlns:a="http://schemas.openxmlformats.org/drawingml/2006/main" xmlns:p="http://schemas.openxmlformats.org/presentationml/2006/main" xmlns:r="http://schemas.openxmlformats.org/officeDocument/2006/relationships">
-  <p:cSld>
-    <p:spTree>
-      <p:nvGrpSpPr>
-        <p:cNvPr id="1" name=""/>
-        <p:cNvGrpSpPr/>
-        <p:nvPr/>
-      </p:nvGrpSpPr>
-      <p:grpSpPr/>
-      <p:sp>
-        <p:nvSpPr>
-          <p:cNvPr id="2" name="Text Placeholder 1"/>
-          <p:cNvSpPr>
-            <a:spLocks noGrp="1"/>
-          </p:cNvSpPr>
-          <p:nvPr>
-            <p:ph type="body" idx="13" sz="quarter"/>
-          </p:nvPr>
-        </p:nvSpPr>
-        <p:spPr/>
         <p:txBody>
           <a:bodyPr wrap="square"/>
           <a:lstStyle/>
           <a:p>
             <a:r>
-              <a:t>¿Por qué este caso importa?</a:t>
-            </a:r>
-          </a:p>
-        </p:txBody>
-      </p:sp>
-      <p:sp>
-        <p:nvSpPr>
-          <p:cNvPr id="3" name="Text Placeholder 2"/>
-          <p:cNvSpPr>
-            <a:spLocks noGrp="1"/>
-          </p:cNvSpPr>
-          <p:nvPr>
-            <p:ph type="body" idx="16" sz="quarter"/>
-          </p:nvPr>
-        </p:nvSpPr>
-        <p:spPr>
-          <a:xfrm>
-            <a:off x="1073427" y="2077576"/>
-            <a:ext cx="10084904" cy="3507298"/>
-          </a:xfrm>
-        </p:spPr>
-        <p:txBody>
-          <a:bodyPr wrap="square"/>
-          <a:lstStyle/>
-          <a:p>
-            <a:r>
               <a:t>Es el caso más grande en volumen de usuarios del curso — pone a prueba el pipeline a escala</a:t>
             </a:r>
           </a:p>
@@ -7886,7 +7378,7 @@
           </a:p>
           <a:p>
             <a:r>
-              <a:t>El perfilado de roles con LLM local muestra tanto el potencial como los límites de inferir comportamiento desde metadatos incompletos</a:t>
+              <a:t>Muestra cómo mapear la anatomía completa de un mercado sin necesitar perfilar a cada actor individualmente</a:t>
             </a:r>
           </a:p>
         </p:txBody>
@@ -7956,7 +7448,7 @@
           <p:nvPr/>
         </p:nvGraphicFramePr>
         <p:xfrm>
-          <a:off x="1051560" y="1645920"/>
+          <a:off x="1051560" y="1783080"/>
           <a:ext cx="10058400" cy="4023360"/>
         </p:xfrm>
         <a:graphic>
@@ -8500,7 +7992,7 @@
                           </a:solidFill>
                           <a:latin typeface="Arial"/>
                         </a:rPr>
-                        <a:t>Encoding cp1251 (cirílico)</a:t>
+                        <a:t>Foro ruso, encoding cp1251</a:t>
                       </a:r>
                     </a:p>
                   </a:txBody>
@@ -8860,7 +8352,7 @@
                           </a:solidFill>
                           <a:latin typeface="Arial"/>
                         </a:rPr>
-                        <a:t>Ver siguiente slide</a:t>
+                        <a:t>Mismo leak que Cardmafia.cc</a:t>
                       </a:r>
                     </a:p>
                   </a:txBody>
@@ -8950,7 +8442,7 @@
                           </a:solidFill>
                           <a:latin typeface="Arial"/>
                         </a:rPr>
-                        <a:t>Ver siguiente slide</a:t>
+                        <a:t>Mismo leak que CardingMafia</a:t>
                       </a:r>
                     </a:p>
                   </a:txBody>
@@ -8973,7 +8465,7 @@
         </p:nvSpPr>
         <p:spPr>
           <a:xfrm>
-            <a:off x="1051560" y="5806440"/>
+            <a:off x="1051560" y="5943600"/>
             <a:ext cx="10058400" cy="320040"/>
           </a:xfrm>
           <a:prstGeom prst="rect">
@@ -9034,7 +8526,7 @@
           <a:lstStyle/>
           <a:p>
             <a:r>
-              <a:t>El bug que no esperabas — un dump subido dos veces</a:t>
+              <a:t>Dos bugs de entrada — gancho antes de analizar nada</a:t>
             </a:r>
           </a:p>
         </p:txBody>
@@ -9051,8 +8543,8 @@
         </p:nvSpPr>
         <p:spPr>
           <a:xfrm>
-            <a:off x="1073427" y="2077576"/>
-            <a:ext cx="10084904" cy="3507298"/>
+            <a:off x="1073427" y="2717656"/>
+            <a:ext cx="10084904" cy="2867218"/>
           </a:xfrm>
         </p:spPr>
         <p:txBody>
@@ -9060,27 +8552,12 @@
           <a:lstStyle/>
           <a:p>
             <a:r>
-              <a:t>list_forums() devuelve 10 archivos .zip, pero el reconocimiento inicial documentaba 9 foros</a:t>
-            </a:r>
-          </a:p>
-          <a:p>
-            <a:r>
-              <a:t>Diagnóstico: CardingMafia_2021.03.zip y Cardmafia.cc_2021.03.zip pesan exactamente 175,674,160 bytes</a:t>
-            </a:r>
-          </a:p>
-          <a:p>
-            <a:r>
-              <a:t>Verificación byte a byte: mismo INSERT INTO user, mismas 296,909 filas, mismo contenido</a:t>
-            </a:r>
-          </a:p>
-          <a:p>
-            <a:r>
-              <a:t>Es el mismo leak subido dos veces bajo nombres distintos — no dos foros diferentes</a:t>
-            </a:r>
-          </a:p>
-          <a:p>
-            <a:r>
-              <a:t>Ninguno de los dos incluye tabla post: el leak solo contiene el registro de usuarios</a:t>
+              <a:t>list_forums() devolvía 10 archivos para 9 foros esperados: CardingMafia y Cardmafia.cc son el mismo leak subido dos veces (mismo tamaño en bytes, mismo contenido verificado)</a:t>
+            </a:r>
+          </a:p>
+          <a:p>
+            <a:r>
+              <a:t>Cardingmafia.ws no es SQL: es un flat file colon-delimited que el parser vBulletin ignoraba con 0 filas, sin error visible</a:t>
             </a:r>
           </a:p>
           <a:p>
@@ -9094,7 +8571,7 @@
                 </a:solidFill>
                 <a:latin typeface="Arial"/>
               </a:rPr>
-              <a:t>·  Lección: nunca asumas que archivo distinto = fuente distinta — verificá tamaño y contenido</a:t>
+              <a:t>·  Fix único para ambos: load_forum() auto-detecta formato antes de elegir parser — el detalle completo está en el notebook 00</a:t>
             </a:r>
           </a:p>
         </p:txBody>
@@ -9124,7 +8601,7 @@
             <a:spLocks noGrp="1"/>
           </p:cNvSpPr>
           <p:nvPr>
-            <p:ph type="body" idx="13" sz="quarter"/>
+            <p:ph type="body" idx="10" sz="quarter"/>
           </p:nvPr>
         </p:nvSpPr>
         <p:spPr/>
@@ -9132,68 +8609,33 @@
           <a:bodyPr wrap="square"/>
           <a:lstStyle/>
           <a:p>
-            <a:r>
-              <a:t>Un formato que no es SQL — Cardingmafia.ws</a:t>
-            </a:r>
-          </a:p>
-        </p:txBody>
-      </p:sp>
-      <p:sp>
-        <p:nvSpPr>
-          <p:cNvPr id="3" name="Text Placeholder 2"/>
-          <p:cNvSpPr>
-            <a:spLocks noGrp="1"/>
-          </p:cNvSpPr>
-          <p:nvPr>
-            <p:ph type="body" idx="16" sz="quarter"/>
-          </p:nvPr>
-        </p:nvSpPr>
-        <p:spPr>
-          <a:xfrm>
-            <a:off x="1073427" y="2077576"/>
-            <a:ext cx="10084904" cy="3507298"/>
-          </a:xfrm>
-        </p:spPr>
-        <p:txBody>
-          <a:bodyPr wrap="square"/>
-          <a:lstStyle/>
-          <a:p>
-            <a:r>
-              <a:t>load_forum() devolvía 0 filas para Cardingmafia.ws con el parser vBulletin</a:t>
-            </a:r>
-          </a:p>
-          <a:p>
-            <a:r>
-              <a:t>El zip contiene un único archivo Dump_cardingmafia.txt — no un dump SQL</a:t>
-            </a:r>
-          </a:p>
-          <a:p>
-            <a:r>
-              <a:t>Formato real: texto plano delimitado por ':' — userid:username:email:ipaddress:...</a:t>
-            </a:r>
-          </a:p>
-          <a:p>
-            <a:r>
-              <a:t>El proyecto ya tenía un parser para este formato exacto (src/parsers/flat.py)</a:t>
-            </a:r>
-          </a:p>
-          <a:p>
-            <a:r>
-              <a:t>Fix: load_forum() en src/utils.py auto-detecta flat/MyBB/IPS/vBulletin antes de elegir parser</a:t>
-            </a:r>
-          </a:p>
-          <a:p>
-            <a:pPr lvl="1" marL="274320" indent="-228600">
-              <a:buNone/>
-            </a:pPr>
-            <a:r>
-              <a:rPr sz="1500" b="0">
+            <a:pPr algn="ctr"/>
+            <a:r>
+              <a:rPr sz="1700" b="1">
                 <a:solidFill>
-                  <a:srgbClr val="707888"/>
+                  <a:srgbClr val="CD2D37"/>
                 </a:solidFill>
                 <a:latin typeface="Arial"/>
               </a:rPr>
-              <a:t>·  177,938 usuarios recuperados de un archivo que el parser vBulletin ignoraba por completo</a:t>
+              <a:t>SECCIÓN 2</a:t>
+            </a:r>
+          </a:p>
+          <a:p>
+            <a:pPr algn="ctr"/>
+            <a:r>
+              <a:t>Reconocimiento y limpieza</a:t>
+            </a:r>
+          </a:p>
+          <a:p>
+            <a:pPr algn="ctr"/>
+            <a:r>
+              <a:rPr sz="1600">
+                <a:solidFill>
+                  <a:srgbClr val="D6DAE2"/>
+                </a:solidFill>
+                <a:latin typeface="Arial"/>
+              </a:rPr>
+              <a:t>Notebooks 00 y 01 — de dump crudo a datos confiables</a:t>
             </a:r>
           </a:p>
         </p:txBody>
@@ -9223,7 +8665,7 @@
             <a:spLocks noGrp="1"/>
           </p:cNvSpPr>
           <p:nvPr>
-            <p:ph type="body" idx="10" sz="quarter"/>
+            <p:ph type="body" idx="13" sz="quarter"/>
           </p:nvPr>
         </p:nvSpPr>
         <p:spPr/>
@@ -9231,33 +8673,49 @@
           <a:bodyPr wrap="square"/>
           <a:lstStyle/>
           <a:p>
-            <a:pPr algn="ctr"/>
-            <a:r>
-              <a:rPr sz="1300" b="1">
-                <a:solidFill>
-                  <a:srgbClr val="CD2D37"/>
-                </a:solidFill>
-                <a:latin typeface="Arial"/>
-              </a:rPr>
-              <a:t>SECCIÓN 2</a:t>
-            </a:r>
-          </a:p>
-          <a:p>
-            <a:pPr algn="ctr"/>
-            <a:r>
-              <a:t>Reconocimiento y limpieza</a:t>
-            </a:r>
-          </a:p>
-          <a:p>
-            <a:pPr algn="ctr"/>
-            <a:r>
-              <a:rPr sz="1600">
-                <a:solidFill>
-                  <a:srgbClr val="D6DAE2"/>
-                </a:solidFill>
-                <a:latin typeface="Arial"/>
-              </a:rPr>
-              <a:t>Notebooks 00 y 01 — de dump crudo a datos confiables</a:t>
+            <a:r>
+              <a:t>El dataset en cifras</a:t>
+            </a:r>
+          </a:p>
+        </p:txBody>
+      </p:sp>
+      <p:sp>
+        <p:nvSpPr>
+          <p:cNvPr id="3" name="Text Placeholder 2"/>
+          <p:cNvSpPr>
+            <a:spLocks noGrp="1"/>
+          </p:cNvSpPr>
+          <p:nvPr>
+            <p:ph type="body" idx="16" sz="quarter"/>
+          </p:nvPr>
+        </p:nvSpPr>
+        <p:spPr>
+          <a:xfrm>
+            <a:off x="1073427" y="1711816"/>
+            <a:ext cx="10084904" cy="3873058"/>
+          </a:xfrm>
+        </p:spPr>
+        <p:txBody>
+          <a:bodyPr wrap="square"/>
+          <a:lstStyle/>
+          <a:p>
+            <a:r>
+              <a:t>949,816 usuarios y 1,470,866 posts across 10 dumps</a:t>
+            </a:r>
+          </a:p>
+          <a:p>
+            <a:r>
+              <a:t>209,406 threads y 876,935 mensajes privados</a:t>
+            </a:r>
+          </a:p>
+          <a:p>
+            <a:r>
+              <a:t>Rango temporal: 2009 a 2016 (con timestamps corruptos que hay que filtrar antes de confiar en esto)</a:t>
+            </a:r>
+          </a:p>
+          <a:p>
+            <a:r>
+              <a:t>vBulletin es el formato dominante — mismo problema de encoding que otros casos del curso</a:t>
             </a:r>
           </a:p>
         </p:txBody>
@@ -9296,7 +8754,7 @@
           <a:lstStyle/>
           <a:p>
             <a:r>
-              <a:t>El dataset en cifras</a:t>
+              <a:t>Limpieza — los mismos problemas de siempre, otra escala</a:t>
             </a:r>
           </a:p>
         </p:txBody>
@@ -9311,33 +8769,73 @@
             <p:ph type="body" idx="16" sz="quarter"/>
           </p:nvPr>
         </p:nvSpPr>
-        <p:spPr/>
+        <p:spPr>
+          <a:xfrm>
+            <a:off x="1073427" y="2717656"/>
+            <a:ext cx="10084904" cy="2867218"/>
+          </a:xfrm>
+        </p:spPr>
         <p:txBody>
           <a:bodyPr wrap="square"/>
           <a:lstStyle/>
           <a:p>
             <a:r>
-              <a:t>949,816 usuarios y 1,470,866 posts across 10 dumps</a:t>
-            </a:r>
-          </a:p>
-          <a:p>
-            <a:r>
-              <a:t>209,406 threads y 876,935 mensajes privados</a:t>
-            </a:r>
-          </a:p>
-          <a:p>
-            <a:r>
-              <a:t>Rango temporal: 2009 a 2016 (con timestamps corruptos que hay que filtrar antes de confiar en esto)</a:t>
-            </a:r>
-          </a:p>
-          <a:p>
-            <a:r>
-              <a:t>vBulletin es el formato dominante — mismo problema de encoding que otros casos del curso</a:t>
-            </a:r>
-          </a:p>
-          <a:p>
-            <a:r>
-              <a:t>Carder.pro usa cp1251 (cirílico): el parser lo maneja, pero hay que detectarlo, no asumirlo</a:t>
+              <a:t>178,420 usuarios con joindate inválido (epoch-0 o nulo) — 18.8% del total</a:t>
+            </a:r>
+          </a:p>
+          <a:p>
+            <a:r>
+              <a:t>16,206 posts con timestamp fuera de rango (antes de 2000 o después de 2025)</a:t>
+            </a:r>
+          </a:p>
+          <a:p>
+            <a:r>
+              <a:t>58,939 posts con texto vacío o menor a 5 caracteres — posts borrados por moderación</a:t>
+            </a:r>
+          </a:p>
+          <a:p>
+            <a:r>
+              <a:t>Deduplicación por (userid, forum): filas repetidas por errores de exportación del dump</a:t>
+            </a:r>
+          </a:p>
+          <a:p>
+            <a:r>
+              <a:t>1,470,866 → 1,412,107 posts limpios — un 4% se descarta antes de cualquier análisis</a:t>
+            </a:r>
+          </a:p>
+        </p:txBody>
+      </p:sp>
+      <p:sp>
+        <p:nvSpPr>
+          <p:cNvPr id="4" name="TextBox 3"/>
+          <p:cNvSpPr txBox="1"/>
+          <p:nvPr/>
+        </p:nvSpPr>
+        <p:spPr>
+          <a:xfrm>
+            <a:off x="1051560" y="5760720"/>
+            <a:ext cx="10058400" cy="365760"/>
+          </a:xfrm>
+          <a:prstGeom prst="rect">
+            <a:avLst/>
+          </a:prstGeom>
+          <a:noFill/>
+        </p:spPr>
+        <p:txBody>
+          <a:bodyPr wrap="square">
+            <a:spAutoFit/>
+          </a:bodyPr>
+          <a:lstStyle/>
+          <a:p>
+            <a:pPr algn="l"/>
+            <a:r>
+              <a:rPr sz="1100" b="0">
+                <a:solidFill>
+                  <a:srgbClr val="707888"/>
+                </a:solidFill>
+                <a:latin typeface="Arial"/>
+              </a:rPr>
+              <a:t>ℹ  Mismo patrón epoch-0 que en HackingForums: nunca confíes en un timestamp sin validar su rango primero.</a:t>
             </a:r>
           </a:p>
         </p:txBody>
@@ -9367,7 +8865,7 @@
             <a:spLocks noGrp="1"/>
           </p:cNvSpPr>
           <p:nvPr>
-            <p:ph type="body" idx="13" sz="quarter"/>
+            <p:ph type="body" idx="10" sz="quarter"/>
           </p:nvPr>
         </p:nvSpPr>
         <p:spPr/>
@@ -9375,68 +8873,47 @@
           <a:bodyPr wrap="square"/>
           <a:lstStyle/>
           <a:p>
-            <a:r>
-              <a:t>Limpieza — los mismos problemas de siempre, otra escala</a:t>
-            </a:r>
-          </a:p>
-        </p:txBody>
-      </p:sp>
-      <p:sp>
-        <p:nvSpPr>
-          <p:cNvPr id="3" name="Text Placeholder 2"/>
-          <p:cNvSpPr>
-            <a:spLocks noGrp="1"/>
-          </p:cNvSpPr>
-          <p:nvPr>
-            <p:ph type="body" idx="16" sz="quarter"/>
-          </p:nvPr>
+            <a:pPr algn="ctr"/>
+            <a:r>
+              <a:rPr sz="1700" b="1">
+                <a:solidFill>
+                  <a:srgbClr val="CD2D37"/>
+                </a:solidFill>
+                <a:latin typeface="Arial"/>
+              </a:rPr>
+              <a:t>DEMO EN VIVO</a:t>
+            </a:r>
+          </a:p>
+          <a:p>
+            <a:pPr algn="ctr"/>
+            <a:r>
+              <a:t>Demo — reconocimiento y limpieza</a:t>
+            </a:r>
+          </a:p>
+          <a:p>
+            <a:pPr algn="ctr"/>
+            <a:r>
+              <a:rPr sz="1400">
+                <a:solidFill>
+                  <a:srgbClr val="9AA3B5"/>
+                </a:solidFill>
+                <a:latin typeface="Arial"/>
+              </a:rPr>
+              <a:t>CardingForums/00_reconocimiento.ipynb</a:t>
+            </a:r>
+          </a:p>
+        </p:txBody>
+      </p:sp>
+      <p:sp>
+        <p:nvSpPr>
+          <p:cNvPr id="3" name="TextBox 2"/>
+          <p:cNvSpPr txBox="1"/>
+          <p:nvPr/>
         </p:nvSpPr>
         <p:spPr>
           <a:xfrm>
-            <a:off x="1073427" y="2580496"/>
-            <a:ext cx="10084904" cy="3004378"/>
-          </a:xfrm>
-        </p:spPr>
-        <p:txBody>
-          <a:bodyPr wrap="square"/>
-          <a:lstStyle/>
-          <a:p>
-            <a:r>
-              <a:t>178,420 usuarios con joindate inválido (epoch-0 o nulo) — 18.8% del total</a:t>
-            </a:r>
-          </a:p>
-          <a:p>
-            <a:r>
-              <a:t>16,206 posts con timestamp fuera de rango (antes de 2000 o después de 2025)</a:t>
-            </a:r>
-          </a:p>
-          <a:p>
-            <a:r>
-              <a:t>58,939 posts con texto vacío o menor a 5 caracteres — posts borrados por moderación</a:t>
-            </a:r>
-          </a:p>
-          <a:p>
-            <a:r>
-              <a:t>Deduplicación por (userid, forum): filas repetidas por errores de exportación del dump</a:t>
-            </a:r>
-          </a:p>
-          <a:p>
-            <a:r>
-              <a:t>1,470,866 → 1,412,107 posts limpios — un 4% se descarta antes de cualquier análisis semántico</a:t>
-            </a:r>
-          </a:p>
-        </p:txBody>
-      </p:sp>
-      <p:sp>
-        <p:nvSpPr>
-          <p:cNvPr id="4" name="TextBox 3"/>
-          <p:cNvSpPr txBox="1"/>
-          <p:nvPr/>
-        </p:nvSpPr>
-        <p:spPr>
-          <a:xfrm>
-            <a:off x="1051560" y="5760720"/>
-            <a:ext cx="10058400" cy="365760"/>
+            <a:off x="2505456" y="3657600"/>
+            <a:ext cx="7168896" cy="2560320"/>
           </a:xfrm>
           <a:prstGeom prst="rect">
             <a:avLst/>
@@ -9449,15 +8926,47 @@
           </a:bodyPr>
           <a:lstStyle/>
           <a:p>
-            <a:pPr algn="l"/>
-            <a:r>
-              <a:rPr sz="1100" b="0">
+            <a:r>
+              <a:rPr sz="1600">
                 <a:solidFill>
-                  <a:srgbClr val="707888"/>
+                  <a:srgbClr val="D6DAE2"/>
                 </a:solidFill>
                 <a:latin typeface="Arial"/>
               </a:rPr>
-              <a:t>ℹ  Mismo patrón epoch-0 que en HackingForums: nunca confíes en un timestamp sin validar su rango primero.</a:t>
+              <a:t>1.  Abrir notebook 00_reconocimiento</a:t>
+            </a:r>
+          </a:p>
+          <a:p>
+            <a:r>
+              <a:rPr sz="1600">
+                <a:solidFill>
+                  <a:srgbClr val="D6DAE2"/>
+                </a:solidFill>
+                <a:latin typeface="Arial"/>
+              </a:rPr>
+              <a:t>2.  Sección 6: tabla de usuarios y posts por foro, timeline de registros</a:t>
+            </a:r>
+          </a:p>
+          <a:p>
+            <a:r>
+              <a:rPr sz="1600">
+                <a:solidFill>
+                  <a:srgbClr val="D6DAE2"/>
+                </a:solidFill>
+                <a:latin typeface="Arial"/>
+              </a:rPr>
+              <a:t>3.  Sección 7: validación de calidad — completitud de campos de contacto</a:t>
+            </a:r>
+          </a:p>
+          <a:p>
+            <a:r>
+              <a:rPr sz="1600">
+                <a:solidFill>
+                  <a:srgbClr val="D6DAE2"/>
+                </a:solidFill>
+                <a:latin typeface="Arial"/>
+              </a:rPr>
+              <a:t>4.  Notebook 01, sección 5: resumen de limpieza con conteos antes/después</a:t>
             </a:r>
           </a:p>
         </p:txBody>
@@ -9497,57 +9006,23 @@
           <a:p>
             <a:pPr algn="ctr"/>
             <a:r>
-              <a:rPr sz="1300" b="1">
+              <a:rPr sz="1700" b="1">
                 <a:solidFill>
                   <a:srgbClr val="CD2D37"/>
                 </a:solidFill>
                 <a:latin typeface="Arial"/>
               </a:rPr>
-              <a:t>DEMO EN VIVO</a:t>
+              <a:t>SECCIÓN 3</a:t>
             </a:r>
           </a:p>
           <a:p>
             <a:pPr algn="ctr"/>
             <a:r>
-              <a:t>Demo — reconocimiento y limpieza</a:t>
+              <a:t>Red de co-participación y comunidades</a:t>
             </a:r>
           </a:p>
           <a:p>
             <a:pPr algn="ctr"/>
-            <a:r>
-              <a:rPr sz="1400">
-                <a:solidFill>
-                  <a:srgbClr val="9AA3B5"/>
-                </a:solidFill>
-                <a:latin typeface="Arial"/>
-              </a:rPr>
-              <a:t>CardingForums/00_reconocimiento.ipynb</a:t>
-            </a:r>
-          </a:p>
-        </p:txBody>
-      </p:sp>
-      <p:sp>
-        <p:nvSpPr>
-          <p:cNvPr id="3" name="TextBox 2"/>
-          <p:cNvSpPr txBox="1"/>
-          <p:nvPr/>
-        </p:nvSpPr>
-        <p:spPr>
-          <a:xfrm>
-            <a:off x="2505456" y="3657600"/>
-            <a:ext cx="7168896" cy="2560320"/>
-          </a:xfrm>
-          <a:prstGeom prst="rect">
-            <a:avLst/>
-          </a:prstGeom>
-          <a:noFill/>
-        </p:spPr>
-        <p:txBody>
-          <a:bodyPr wrap="square">
-            <a:spAutoFit/>
-          </a:bodyPr>
-          <a:lstStyle/>
-          <a:p>
             <a:r>
               <a:rPr sz="1600">
                 <a:solidFill>
@@ -9555,40 +9030,7 @@
                 </a:solidFill>
                 <a:latin typeface="Arial"/>
               </a:rPr>
-              <a:t>1.  Abrir notebook 00_reconocimiento</a:t>
-            </a:r>
-          </a:p>
-          <a:p>
-            <a:r>
-              <a:rPr sz="1600">
-                <a:solidFill>
-                  <a:srgbClr val="D6DAE2"/>
-                </a:solidFill>
-                <a:latin typeface="Arial"/>
-              </a:rPr>
-              <a:t>2.  Sección 6: tabla de usuarios y posts por foro, timeline de registros</a:t>
-            </a:r>
-          </a:p>
-          <a:p>
-            <a:r>
-              <a:rPr sz="1600">
-                <a:solidFill>
-                  <a:srgbClr val="D6DAE2"/>
-                </a:solidFill>
-                <a:latin typeface="Arial"/>
-              </a:rPr>
-              <a:t>3.  Sección 7: validación de calidad — completitud de campos de contacto</a:t>
-            </a:r>
-          </a:p>
-          <a:p>
-            <a:r>
-              <a:rPr sz="1600">
-                <a:solidFill>
-                  <a:srgbClr val="D6DAE2"/>
-                </a:solidFill>
-                <a:latin typeface="Arial"/>
-              </a:rPr>
-              <a:t>4.  Notebook 01, sección 5: resumen de limpieza con conteos antes/después</a:t>
+              <a:t>Notebook 02 — cómo se reparte el trabajo en un mercado entero</a:t>
             </a:r>
           </a:p>
         </p:txBody>

</xml_diff>